<commit_message>
Repair CTA source identities and expose exact coverage gaps
</commit_message>
<xml_diff>
--- a/docs/audits/cta-source-walkthrough-20261028/slides/cta-evidence-walkthrough-expanded.pptx
+++ b/docs/audits/cta-source-walkthrough-20261028/slides/cta-evidence-walkthrough-expanded.pptx
@@ -2,33 +2,34 @@
 <file path=ppt/presentation.xml><?xml version="1.0" encoding="utf-8"?>
 <p:presentation xmlns:p="http://schemas.openxmlformats.org/presentationml/2006/main">
   <p:sldMasterIdLst>
-    <p:sldMasterId xmlns:r="http://schemas.openxmlformats.org/officeDocument/2006/relationships" id="2147483648" r:id="R5bd183c4b2324d1a"/>
+    <p:sldMasterId xmlns:r="http://schemas.openxmlformats.org/officeDocument/2006/relationships" id="2147483648" r:id="Rd9b387cbeddf441d"/>
   </p:sldMasterIdLst>
   <p:notesMasterIdLst>
-    <p:notesMasterId xmlns:r="http://schemas.openxmlformats.org/officeDocument/2006/relationships" r:id="R5290ece7fbcd4dae"/>
+    <p:notesMasterId xmlns:r="http://schemas.openxmlformats.org/officeDocument/2006/relationships" r:id="R194c95d747cf4040"/>
   </p:notesMasterIdLst>
   <p:sldIdLst>
-    <p:sldId xmlns:r="http://schemas.openxmlformats.org/officeDocument/2006/relationships" id="256" r:id="Ra955781db2f34ad9"/>
-    <p:sldId xmlns:r="http://schemas.openxmlformats.org/officeDocument/2006/relationships" id="257" r:id="R7ef7d854c6c4456f"/>
-    <p:sldId xmlns:r="http://schemas.openxmlformats.org/officeDocument/2006/relationships" id="258" r:id="Rb02f69a52ae446d2"/>
-    <p:sldId xmlns:r="http://schemas.openxmlformats.org/officeDocument/2006/relationships" id="259" r:id="Re1a0e9b44b944889"/>
-    <p:sldId xmlns:r="http://schemas.openxmlformats.org/officeDocument/2006/relationships" id="260" r:id="Rbec06897ed054bfd"/>
-    <p:sldId xmlns:r="http://schemas.openxmlformats.org/officeDocument/2006/relationships" id="261" r:id="Rea31669cb4c2496e"/>
-    <p:sldId xmlns:r="http://schemas.openxmlformats.org/officeDocument/2006/relationships" id="262" r:id="R056fe77be08d4cc9"/>
-    <p:sldId xmlns:r="http://schemas.openxmlformats.org/officeDocument/2006/relationships" id="263" r:id="R2b25b744832441d0"/>
-    <p:sldId xmlns:r="http://schemas.openxmlformats.org/officeDocument/2006/relationships" id="264" r:id="R4276b9bc851d4cb1"/>
-    <p:sldId xmlns:r="http://schemas.openxmlformats.org/officeDocument/2006/relationships" id="265" r:id="Rf1c8c574e0934676"/>
-    <p:sldId xmlns:r="http://schemas.openxmlformats.org/officeDocument/2006/relationships" id="266" r:id="R2f34e373c0b14227"/>
-    <p:sldId xmlns:r="http://schemas.openxmlformats.org/officeDocument/2006/relationships" id="267" r:id="Reafc88459a9a42a8"/>
-    <p:sldId xmlns:r="http://schemas.openxmlformats.org/officeDocument/2006/relationships" id="268" r:id="R05887c14c1ad4f71"/>
-    <p:sldId xmlns:r="http://schemas.openxmlformats.org/officeDocument/2006/relationships" id="269" r:id="R44b4358d30ad4c7c"/>
-    <p:sldId xmlns:r="http://schemas.openxmlformats.org/officeDocument/2006/relationships" id="270" r:id="Re83cc46c39ff404b"/>
-    <p:sldId xmlns:r="http://schemas.openxmlformats.org/officeDocument/2006/relationships" id="271" r:id="Re2af900b53d84c40"/>
-    <p:sldId xmlns:r="http://schemas.openxmlformats.org/officeDocument/2006/relationships" id="272" r:id="Rd5d2864c1d264824"/>
-    <p:sldId xmlns:r="http://schemas.openxmlformats.org/officeDocument/2006/relationships" id="273" r:id="R3657e466af514fbf"/>
-    <p:sldId xmlns:r="http://schemas.openxmlformats.org/officeDocument/2006/relationships" id="274" r:id="Rf6e5eaaaf2714959"/>
-    <p:sldId xmlns:r="http://schemas.openxmlformats.org/officeDocument/2006/relationships" id="275" r:id="R023f2f4fa676449d"/>
-    <p:sldId xmlns:r="http://schemas.openxmlformats.org/officeDocument/2006/relationships" id="276" r:id="Rd5cfcded8ac34f19"/>
+    <p:sldId xmlns:r="http://schemas.openxmlformats.org/officeDocument/2006/relationships" id="256" r:id="R19df4e6c8d8a4344"/>
+    <p:sldId xmlns:r="http://schemas.openxmlformats.org/officeDocument/2006/relationships" id="257" r:id="R2b6defd4064d440e"/>
+    <p:sldId xmlns:r="http://schemas.openxmlformats.org/officeDocument/2006/relationships" id="258" r:id="Rf008829f75604e24"/>
+    <p:sldId xmlns:r="http://schemas.openxmlformats.org/officeDocument/2006/relationships" id="259" r:id="R489855348a364b78"/>
+    <p:sldId xmlns:r="http://schemas.openxmlformats.org/officeDocument/2006/relationships" id="260" r:id="R91ae7734d0f54dec"/>
+    <p:sldId xmlns:r="http://schemas.openxmlformats.org/officeDocument/2006/relationships" id="261" r:id="Ra776b1b3811f44f9"/>
+    <p:sldId xmlns:r="http://schemas.openxmlformats.org/officeDocument/2006/relationships" id="262" r:id="R657afdf4e2f94c02"/>
+    <p:sldId xmlns:r="http://schemas.openxmlformats.org/officeDocument/2006/relationships" id="263" r:id="Rd2b583a1ee39402b"/>
+    <p:sldId xmlns:r="http://schemas.openxmlformats.org/officeDocument/2006/relationships" id="264" r:id="Rd5b2f41086a74b8c"/>
+    <p:sldId xmlns:r="http://schemas.openxmlformats.org/officeDocument/2006/relationships" id="265" r:id="R3fb2f52f9d98400a"/>
+    <p:sldId xmlns:r="http://schemas.openxmlformats.org/officeDocument/2006/relationships" id="266" r:id="Rfb321217cb9647d1"/>
+    <p:sldId xmlns:r="http://schemas.openxmlformats.org/officeDocument/2006/relationships" id="267" r:id="R2f34de8ee1de4f0b"/>
+    <p:sldId xmlns:r="http://schemas.openxmlformats.org/officeDocument/2006/relationships" id="268" r:id="Rd2b1a35449a7423e"/>
+    <p:sldId xmlns:r="http://schemas.openxmlformats.org/officeDocument/2006/relationships" id="269" r:id="R7ab1fb060786471c"/>
+    <p:sldId xmlns:r="http://schemas.openxmlformats.org/officeDocument/2006/relationships" id="270" r:id="R31042621b1c649c7"/>
+    <p:sldId xmlns:r="http://schemas.openxmlformats.org/officeDocument/2006/relationships" id="271" r:id="Red2f7507867b4fc4"/>
+    <p:sldId xmlns:r="http://schemas.openxmlformats.org/officeDocument/2006/relationships" id="272" r:id="R879a823fe26c4f7e"/>
+    <p:sldId xmlns:r="http://schemas.openxmlformats.org/officeDocument/2006/relationships" id="273" r:id="R9baf1e44c1da462e"/>
+    <p:sldId xmlns:r="http://schemas.openxmlformats.org/officeDocument/2006/relationships" id="274" r:id="R8e198d05a1ef4378"/>
+    <p:sldId xmlns:r="http://schemas.openxmlformats.org/officeDocument/2006/relationships" id="275" r:id="R33992839d36f4c7a"/>
+    <p:sldId xmlns:r="http://schemas.openxmlformats.org/officeDocument/2006/relationships" id="276" r:id="Rea7e7f842a784f92"/>
+    <p:sldId xmlns:r="http://schemas.openxmlformats.org/officeDocument/2006/relationships" id="277" r:id="R7c275f5c94c74ae4"/>
   </p:sldIdLst>
   <p:sldSz cx="12192000" cy="6858000"/>
   <p:notesSz cx="6858000" cy="9144000"/>
@@ -482,7 +483,7 @@
           </a:p>
           <a:p xmlns:a="http://schemas.openxmlformats.org/drawingml/2006/main">
             <a:r>
-              <a:t>Decision snapshot SHA256: e2f607d067f8cfe3ddd511ba32a8fd9bc60ab162bdae5c5656e0c593d6c50436</a:t>
+              <a:t>Decision snapshot SHA256: 56725e3c3b28dd2793a2da63d6f2222da1088d96af0a60ce30bc4966e3c636c3</a:t>
             </a:r>
           </a:p>
         </p:txBody>
@@ -572,7 +573,7 @@
           </a:p>
           <a:p xmlns:a="http://schemas.openxmlformats.org/drawingml/2006/main">
             <a:r>
-              <a:t>Decision snapshot SHA256: e2f607d067f8cfe3ddd511ba32a8fd9bc60ab162bdae5c5656e0c593d6c50436</a:t>
+              <a:t>Decision snapshot SHA256: 56725e3c3b28dd2793a2da63d6f2222da1088d96af0a60ce30bc4966e3c636c3</a:t>
             </a:r>
           </a:p>
         </p:txBody>
@@ -662,7 +663,7 @@
           </a:p>
           <a:p xmlns:a="http://schemas.openxmlformats.org/drawingml/2006/main">
             <a:r>
-              <a:t>Decision snapshot SHA256: e2f607d067f8cfe3ddd511ba32a8fd9bc60ab162bdae5c5656e0c593d6c50436</a:t>
+              <a:t>Decision snapshot SHA256: 56725e3c3b28dd2793a2da63d6f2222da1088d96af0a60ce30bc4966e3c636c3</a:t>
             </a:r>
           </a:p>
         </p:txBody>
@@ -752,7 +753,7 @@
           </a:p>
           <a:p xmlns:a="http://schemas.openxmlformats.org/drawingml/2006/main">
             <a:r>
-              <a:t>Decision snapshot SHA256: e2f607d067f8cfe3ddd511ba32a8fd9bc60ab162bdae5c5656e0c593d6c50436</a:t>
+              <a:t>Decision snapshot SHA256: 56725e3c3b28dd2793a2da63d6f2222da1088d96af0a60ce30bc4966e3c636c3</a:t>
             </a:r>
           </a:p>
         </p:txBody>
@@ -842,7 +843,7 @@
           </a:p>
           <a:p xmlns:a="http://schemas.openxmlformats.org/drawingml/2006/main">
             <a:r>
-              <a:t>Decision snapshot SHA256: e2f607d067f8cfe3ddd511ba32a8fd9bc60ab162bdae5c5656e0c593d6c50436</a:t>
+              <a:t>Decision snapshot SHA256: 56725e3c3b28dd2793a2da63d6f2222da1088d96af0a60ce30bc4966e3c636c3</a:t>
             </a:r>
           </a:p>
         </p:txBody>
@@ -932,7 +933,7 @@
           </a:p>
           <a:p xmlns:a="http://schemas.openxmlformats.org/drawingml/2006/main">
             <a:r>
-              <a:t>Decision snapshot SHA256: e2f607d067f8cfe3ddd511ba32a8fd9bc60ab162bdae5c5656e0c593d6c50436</a:t>
+              <a:t>Decision snapshot SHA256: 56725e3c3b28dd2793a2da63d6f2222da1088d96af0a60ce30bc4966e3c636c3</a:t>
             </a:r>
           </a:p>
         </p:txBody>
@@ -1022,7 +1023,7 @@
           </a:p>
           <a:p xmlns:a="http://schemas.openxmlformats.org/drawingml/2006/main">
             <a:r>
-              <a:t>Decision snapshot SHA256: e2f607d067f8cfe3ddd511ba32a8fd9bc60ab162bdae5c5656e0c593d6c50436</a:t>
+              <a:t>Decision snapshot SHA256: 56725e3c3b28dd2793a2da63d6f2222da1088d96af0a60ce30bc4966e3c636c3</a:t>
             </a:r>
           </a:p>
         </p:txBody>
@@ -1112,7 +1113,7 @@
           </a:p>
           <a:p xmlns:a="http://schemas.openxmlformats.org/drawingml/2006/main">
             <a:r>
-              <a:t>Decision snapshot SHA256: e2f607d067f8cfe3ddd511ba32a8fd9bc60ab162bdae5c5656e0c593d6c50436</a:t>
+              <a:t>Decision snapshot SHA256: 56725e3c3b28dd2793a2da63d6f2222da1088d96af0a60ce30bc4966e3c636c3</a:t>
             </a:r>
           </a:p>
         </p:txBody>
@@ -1202,7 +1203,7 @@
           </a:p>
           <a:p xmlns:a="http://schemas.openxmlformats.org/drawingml/2006/main">
             <a:r>
-              <a:t>Decision snapshot SHA256: e2f607d067f8cfe3ddd511ba32a8fd9bc60ab162bdae5c5656e0c593d6c50436</a:t>
+              <a:t>Decision snapshot SHA256: 56725e3c3b28dd2793a2da63d6f2222da1088d96af0a60ce30bc4966e3c636c3</a:t>
             </a:r>
           </a:p>
         </p:txBody>
@@ -1292,7 +1293,7 @@
           </a:p>
           <a:p xmlns:a="http://schemas.openxmlformats.org/drawingml/2006/main">
             <a:r>
-              <a:t>Decision snapshot SHA256: e2f607d067f8cfe3ddd511ba32a8fd9bc60ab162bdae5c5656e0c593d6c50436</a:t>
+              <a:t>Decision snapshot SHA256: 56725e3c3b28dd2793a2da63d6f2222da1088d96af0a60ce30bc4966e3c636c3</a:t>
             </a:r>
           </a:p>
         </p:txBody>
@@ -1362,12 +1363,12 @@
           <a:lstStyle xmlns:a="http://schemas.openxmlformats.org/drawingml/2006/main"/>
           <a:p xmlns:a="http://schemas.openxmlformats.org/drawingml/2006/main">
             <a:r>
-              <a:t>Dog evidence and integration gaps</a:t>
+              <a:t>Which sources have incomplete evidence</a:t>
             </a:r>
           </a:p>
           <a:p xmlns:a="http://schemas.openxmlformats.org/drawingml/2006/main">
             <a:r>
-              <a:t>Nemec et al. (2019) https://doi.org/10.1111/vco.12475 ; Hindriks et al. (2025) https://doi.org/10.1016/j.vetimm.2025.110946 . Issues https://github.com/pirl-unc/oncoref/issues/574 and https://github.com/pirl-unc/oncoref/issues/585 .</a:t>
+              <a:t>Source versions, complete missing tissue/cell contexts, member ENSG IDs, historical IDs, synonyms and tumor cohort coverage: https://pirl-unc.github.io/oncoref/audits/cta-source-walkthrough-20261028/coverage/ . Counts overlap and do not sum to a total.</a:t>
             </a:r>
           </a:p>
           <a:p xmlns:a="http://schemas.openxmlformats.org/drawingml/2006/main">
@@ -1382,7 +1383,7 @@
           </a:p>
           <a:p xmlns:a="http://schemas.openxmlformats.org/drawingml/2006/main">
             <a:r>
-              <a:t>Decision snapshot SHA256: e2f607d067f8cfe3ddd511ba32a8fd9bc60ab162bdae5c5656e0c593d6c50436</a:t>
+              <a:t>Decision snapshot SHA256: 56725e3c3b28dd2793a2da63d6f2222da1088d96af0a60ce30bc4966e3c636c3</a:t>
             </a:r>
           </a:p>
         </p:txBody>
@@ -1532,7 +1533,7 @@
           </a:p>
           <a:p xmlns:a="http://schemas.openxmlformats.org/drawingml/2006/main">
             <a:r>
-              <a:t>Decision snapshot SHA256: e2f607d067f8cfe3ddd511ba32a8fd9bc60ab162bdae5c5656e0c593d6c50436</a:t>
+              <a:t>Decision snapshot SHA256: 56725e3c3b28dd2793a2da63d6f2222da1088d96af0a60ce30bc4966e3c636c3</a:t>
             </a:r>
           </a:p>
         </p:txBody>
@@ -1602,12 +1603,12 @@
           <a:lstStyle xmlns:a="http://schemas.openxmlformats.org/drawingml/2006/main"/>
           <a:p xmlns:a="http://schemas.openxmlformats.org/drawingml/2006/main">
             <a:r>
-              <a:t>Curated oncofetal sources</a:t>
+              <a:t>Dog evidence and integration gaps</a:t>
             </a:r>
           </a:p>
           <a:p xmlns:a="http://schemas.openxmlformats.org/drawingml/2006/main">
             <a:r>
-              <a:t>Shaw et al. (2024) https://doi.org/10.1038/s41467-024-47649-y ; TRIM71 liver study https://pmc.ncbi.nlm.nih.gov/articles/PMC11388079/ ; Cardoso-Moreira et al. (2019) https://pmc.ncbi.nlm.nih.gov/articles/PMC6658352/ . Newly identified sources are not in current selection counts.</a:t>
+              <a:t>Nemec et al. (2019) https://doi.org/10.1111/vco.12475 ; Hindriks et al. (2025) https://doi.org/10.1016/j.vetimm.2025.110946 . Issues https://github.com/pirl-unc/oncoref/issues/574 and https://github.com/pirl-unc/oncoref/issues/585 .</a:t>
             </a:r>
           </a:p>
           <a:p xmlns:a="http://schemas.openxmlformats.org/drawingml/2006/main">
@@ -1622,7 +1623,7 @@
           </a:p>
           <a:p xmlns:a="http://schemas.openxmlformats.org/drawingml/2006/main">
             <a:r>
-              <a:t>Decision snapshot SHA256: e2f607d067f8cfe3ddd511ba32a8fd9bc60ab162bdae5c5656e0c593d6c50436</a:t>
+              <a:t>Decision snapshot SHA256: 56725e3c3b28dd2793a2da63d6f2222da1088d96af0a60ce30bc4966e3c636c3</a:t>
             </a:r>
           </a:p>
         </p:txBody>
@@ -1692,6 +1693,96 @@
           <a:lstStyle xmlns:a="http://schemas.openxmlformats.org/drawingml/2006/main"/>
           <a:p xmlns:a="http://schemas.openxmlformats.org/drawingml/2006/main">
             <a:r>
+              <a:t>Curated oncofetal sources</a:t>
+            </a:r>
+          </a:p>
+          <a:p xmlns:a="http://schemas.openxmlformats.org/drawingml/2006/main">
+            <a:r>
+              <a:t>Shaw et al. (2024) https://doi.org/10.1038/s41467-024-47649-y ; TRIM71 liver study https://pmc.ncbi.nlm.nih.gov/articles/PMC11388079/ ; Cardoso-Moreira et al. (2019) https://pmc.ncbi.nlm.nih.gov/articles/PMC6658352/ . Newly identified sources are not in current selection counts.</a:t>
+            </a:r>
+          </a:p>
+          <a:p xmlns:a="http://schemas.openxmlformats.org/drawingml/2006/main">
+            <a:r>
+              <a:t>Report: https://pirl-unc.github.io/oncoref/audits/cta-source-walkthrough-20261028/</a:t>
+            </a:r>
+          </a:p>
+          <a:p xmlns:a="http://schemas.openxmlformats.org/drawingml/2006/main">
+            <a:r>
+              <a:t>Policy: oncoref.cta-selection.2026-10-28</a:t>
+            </a:r>
+          </a:p>
+          <a:p xmlns:a="http://schemas.openxmlformats.org/drawingml/2006/main">
+            <a:r>
+              <a:t>Decision snapshot SHA256: 56725e3c3b28dd2793a2da63d6f2222da1088d96af0a60ce30bc4966e3c636c3</a:t>
+            </a:r>
+          </a:p>
+        </p:txBody>
+      </p:sp>
+      <p:sp>
+        <p:nvSpPr>
+          <p:cNvPr id="4" name="Slide Number Placeholder 3"/>
+          <p:cNvSpPr>
+            <a:spLocks xmlns:a="http://schemas.openxmlformats.org/drawingml/2006/main" noGrp="1"/>
+          </p:cNvSpPr>
+          <p:nvPr>
+            <p:ph type="sldNum" idx="5"/>
+          </p:nvPr>
+        </p:nvSpPr>
+        <p:spPr/>
+        <p:txBody>
+          <a:bodyPr xmlns:a="http://schemas.openxmlformats.org/drawingml/2006/main"/>
+          <a:lstStyle xmlns:a="http://schemas.openxmlformats.org/drawingml/2006/main"/>
+          <a:p xmlns:a="http://schemas.openxmlformats.org/drawingml/2006/main"/>
+        </p:txBody>
+      </p:sp>
+    </p:spTree>
+  </p:cSld>
+  <p:clrMapOvr>
+    <a:masterClrMapping xmlns:a="http://schemas.openxmlformats.org/drawingml/2006/main"/>
+  </p:clrMapOvr>
+</p:notes>
+</file>
+
+<file path=ppt/notesSlides/notesSlide22.xml><?xml version="1.0" encoding="utf-8"?>
+<p:notes xmlns:p="http://schemas.openxmlformats.org/presentationml/2006/main">
+  <p:cSld>
+    <p:spTree>
+      <p:nvGrpSpPr>
+        <p:cNvPr id="1" name=""/>
+        <p:cNvGrpSpPr/>
+        <p:nvPr/>
+      </p:nvGrpSpPr>
+      <p:grpSpPr>
+        <a:xfrm xmlns:a="http://schemas.openxmlformats.org/drawingml/2006/main"/>
+      </p:grpSpPr>
+      <p:sp>
+        <p:nvSpPr>
+          <p:cNvPr id="2" name="Slide Image Placeholder 1"/>
+          <p:cNvSpPr>
+            <a:spLocks xmlns:a="http://schemas.openxmlformats.org/drawingml/2006/main" noGrp="1"/>
+          </p:cNvSpPr>
+          <p:nvPr>
+            <p:ph type="sldImg" idx="0"/>
+          </p:nvPr>
+        </p:nvSpPr>
+        <p:spPr/>
+      </p:sp>
+      <p:sp>
+        <p:nvSpPr>
+          <p:cNvPr id="3" name="Notes Placeholder 2"/>
+          <p:cNvSpPr>
+            <a:spLocks xmlns:a="http://schemas.openxmlformats.org/drawingml/2006/main" noGrp="1"/>
+          </p:cNvSpPr>
+          <p:nvPr>
+            <p:ph type="body" idx="1"/>
+          </p:nvPr>
+        </p:nvSpPr>
+        <p:spPr/>
+        <p:txBody>
+          <a:bodyPr xmlns:a="http://schemas.openxmlformats.org/drawingml/2006/main"/>
+          <a:lstStyle xmlns:a="http://schemas.openxmlformats.org/drawingml/2006/main"/>
+          <a:p xmlns:a="http://schemas.openxmlformats.org/drawingml/2006/main">
+            <a:r>
               <a:t>Common API with native evidence underneath</a:t>
             </a:r>
           </a:p>
@@ -1712,7 +1803,7 @@
           </a:p>
           <a:p xmlns:a="http://schemas.openxmlformats.org/drawingml/2006/main">
             <a:r>
-              <a:t>Decision snapshot SHA256: e2f607d067f8cfe3ddd511ba32a8fd9bc60ab162bdae5c5656e0c593d6c50436</a:t>
+              <a:t>Decision snapshot SHA256: 56725e3c3b28dd2793a2da63d6f2222da1088d96af0a60ce30bc4966e3c636c3</a:t>
             </a:r>
           </a:p>
         </p:txBody>
@@ -1802,7 +1893,7 @@
           </a:p>
           <a:p xmlns:a="http://schemas.openxmlformats.org/drawingml/2006/main">
             <a:r>
-              <a:t>Decision snapshot SHA256: e2f607d067f8cfe3ddd511ba32a8fd9bc60ab162bdae5c5656e0c593d6c50436</a:t>
+              <a:t>Decision snapshot SHA256: 56725e3c3b28dd2793a2da63d6f2222da1088d96af0a60ce30bc4966e3c636c3</a:t>
             </a:r>
           </a:p>
         </p:txBody>
@@ -1892,7 +1983,7 @@
           </a:p>
           <a:p xmlns:a="http://schemas.openxmlformats.org/drawingml/2006/main">
             <a:r>
-              <a:t>Decision snapshot SHA256: e2f607d067f8cfe3ddd511ba32a8fd9bc60ab162bdae5c5656e0c593d6c50436</a:t>
+              <a:t>Decision snapshot SHA256: 56725e3c3b28dd2793a2da63d6f2222da1088d96af0a60ce30bc4966e3c636c3</a:t>
             </a:r>
           </a:p>
         </p:txBody>
@@ -1982,7 +2073,7 @@
           </a:p>
           <a:p xmlns:a="http://schemas.openxmlformats.org/drawingml/2006/main">
             <a:r>
-              <a:t>Decision snapshot SHA256: e2f607d067f8cfe3ddd511ba32a8fd9bc60ab162bdae5c5656e0c593d6c50436</a:t>
+              <a:t>Decision snapshot SHA256: 56725e3c3b28dd2793a2da63d6f2222da1088d96af0a60ce30bc4966e3c636c3</a:t>
             </a:r>
           </a:p>
         </p:txBody>
@@ -2072,7 +2163,7 @@
           </a:p>
           <a:p xmlns:a="http://schemas.openxmlformats.org/drawingml/2006/main">
             <a:r>
-              <a:t>Decision snapshot SHA256: e2f607d067f8cfe3ddd511ba32a8fd9bc60ab162bdae5c5656e0c593d6c50436</a:t>
+              <a:t>Decision snapshot SHA256: 56725e3c3b28dd2793a2da63d6f2222da1088d96af0a60ce30bc4966e3c636c3</a:t>
             </a:r>
           </a:p>
         </p:txBody>
@@ -2162,7 +2253,7 @@
           </a:p>
           <a:p xmlns:a="http://schemas.openxmlformats.org/drawingml/2006/main">
             <a:r>
-              <a:t>Decision snapshot SHA256: e2f607d067f8cfe3ddd511ba32a8fd9bc60ab162bdae5c5656e0c593d6c50436</a:t>
+              <a:t>Decision snapshot SHA256: 56725e3c3b28dd2793a2da63d6f2222da1088d96af0a60ce30bc4966e3c636c3</a:t>
             </a:r>
           </a:p>
         </p:txBody>
@@ -2252,7 +2343,7 @@
           </a:p>
           <a:p xmlns:a="http://schemas.openxmlformats.org/drawingml/2006/main">
             <a:r>
-              <a:t>Decision snapshot SHA256: e2f607d067f8cfe3ddd511ba32a8fd9bc60ab162bdae5c5656e0c593d6c50436</a:t>
+              <a:t>Decision snapshot SHA256: 56725e3c3b28dd2793a2da63d6f2222da1088d96af0a60ce30bc4966e3c636c3</a:t>
             </a:r>
           </a:p>
         </p:txBody>
@@ -2342,7 +2433,7 @@
           </a:p>
           <a:p xmlns:a="http://schemas.openxmlformats.org/drawingml/2006/main">
             <a:r>
-              <a:t>Decision snapshot SHA256: e2f607d067f8cfe3ddd511ba32a8fd9bc60ab162bdae5c5656e0c593d6c50436</a:t>
+              <a:t>Decision snapshot SHA256: 56725e3c3b28dd2793a2da63d6f2222da1088d96af0a60ce30bc4966e3c636c3</a:t>
             </a:r>
           </a:p>
         </p:txBody>
@@ -2389,7 +2480,7 @@
           <p:cNvPr id="3" name="Title">
             <a:extLst xmlns:a="http://schemas.openxmlformats.org/drawingml/2006/main">
               <a:ext uri="{FF2B5EF4-FFF2-40B4-BE49-F238E27FC236}">
-                <a16:creationId xmlns:a16="http://schemas.microsoft.com/office/drawing/2014/main" id="{5291D9C3-3D0C-49E0-8C68-8DFB66B69FDC}"/>
+                <a16:creationId xmlns:a16="http://schemas.microsoft.com/office/drawing/2014/main" id="{8AF72547-8A25-4AE3-9527-F38EAE8AB577}"/>
               </a:ext>
             </a:extLst>
           </p:cNvPr>
@@ -2618,7 +2709,7 @@
           <p:cNvPr id="2" name="Subtitle">
             <a:extLst xmlns:a="http://schemas.openxmlformats.org/drawingml/2006/main">
               <a:ext uri="{FF2B5EF4-FFF2-40B4-BE49-F238E27FC236}">
-                <a16:creationId xmlns:a16="http://schemas.microsoft.com/office/drawing/2014/main" id="{E76735D6-62A6-49C4-9713-AACDAC9B3E12}"/>
+                <a16:creationId xmlns:a16="http://schemas.microsoft.com/office/drawing/2014/main" id="{08A44BDC-A6B7-4DB9-A7D8-46359994124E}"/>
               </a:ext>
             </a:extLst>
           </p:cNvPr>
@@ -2864,7 +2955,7 @@
           <p:cNvPr id="2" name="Section title">
             <a:extLst xmlns:a="http://schemas.openxmlformats.org/drawingml/2006/main">
               <a:ext uri="{FF2B5EF4-FFF2-40B4-BE49-F238E27FC236}">
-                <a16:creationId xmlns:a16="http://schemas.microsoft.com/office/drawing/2014/main" id="{E160D55E-DFC2-4BF7-8A6E-9BF61580F78C}"/>
+                <a16:creationId xmlns:a16="http://schemas.microsoft.com/office/drawing/2014/main" id="{A33A552B-0662-4E54-9656-9EE8FB35DDEB}"/>
               </a:ext>
             </a:extLst>
           </p:cNvPr>
@@ -3110,7 +3201,7 @@
           <p:cNvPr id="3" name="Title">
             <a:extLst xmlns:a="http://schemas.openxmlformats.org/drawingml/2006/main">
               <a:ext uri="{FF2B5EF4-FFF2-40B4-BE49-F238E27FC236}">
-                <a16:creationId xmlns:a16="http://schemas.microsoft.com/office/drawing/2014/main" id="{FC16089A-0AE2-444A-8868-7E416203E41E}"/>
+                <a16:creationId xmlns:a16="http://schemas.microsoft.com/office/drawing/2014/main" id="{B2FB2777-F8D0-4881-A134-88909F60537A}"/>
               </a:ext>
             </a:extLst>
           </p:cNvPr>
@@ -3339,7 +3430,7 @@
           <p:cNvPr id="2" name="Body">
             <a:extLst xmlns:a="http://schemas.openxmlformats.org/drawingml/2006/main">
               <a:ext uri="{FF2B5EF4-FFF2-40B4-BE49-F238E27FC236}">
-                <a16:creationId xmlns:a16="http://schemas.microsoft.com/office/drawing/2014/main" id="{48B77064-8069-4BAC-B687-C8553A96C5B3}"/>
+                <a16:creationId xmlns:a16="http://schemas.microsoft.com/office/drawing/2014/main" id="{3D2DF937-E05B-481C-B11C-082137292151}"/>
               </a:ext>
             </a:extLst>
           </p:cNvPr>
@@ -3585,7 +3676,7 @@
           <p:cNvPr id="4" name="Title">
             <a:extLst xmlns:a="http://schemas.openxmlformats.org/drawingml/2006/main">
               <a:ext uri="{FF2B5EF4-FFF2-40B4-BE49-F238E27FC236}">
-                <a16:creationId xmlns:a16="http://schemas.microsoft.com/office/drawing/2014/main" id="{D5A51E2E-7195-491D-AC11-D33A811E1A49}"/>
+                <a16:creationId xmlns:a16="http://schemas.microsoft.com/office/drawing/2014/main" id="{48DBA6E2-716B-4F91-94CC-443D5C12A95B}"/>
               </a:ext>
             </a:extLst>
           </p:cNvPr>
@@ -3814,7 +3905,7 @@
           <p:cNvPr id="2" name="Left column">
             <a:extLst xmlns:a="http://schemas.openxmlformats.org/drawingml/2006/main">
               <a:ext uri="{FF2B5EF4-FFF2-40B4-BE49-F238E27FC236}">
-                <a16:creationId xmlns:a16="http://schemas.microsoft.com/office/drawing/2014/main" id="{82E4F04F-083A-46B4-AAB9-6BEF07F78144}"/>
+                <a16:creationId xmlns:a16="http://schemas.microsoft.com/office/drawing/2014/main" id="{5517F1EE-952D-49CA-92C2-0D9D9FF03C2C}"/>
               </a:ext>
             </a:extLst>
           </p:cNvPr>
@@ -4043,7 +4134,7 @@
           <p:cNvPr id="3" name="Right column">
             <a:extLst xmlns:a="http://schemas.openxmlformats.org/drawingml/2006/main">
               <a:ext uri="{FF2B5EF4-FFF2-40B4-BE49-F238E27FC236}">
-                <a16:creationId xmlns:a16="http://schemas.microsoft.com/office/drawing/2014/main" id="{A89107FA-B90E-4BA3-97B3-5C7A841E3391}"/>
+                <a16:creationId xmlns:a16="http://schemas.microsoft.com/office/drawing/2014/main" id="{AE3350DE-215D-4792-ABC4-F10CE8C877A2}"/>
               </a:ext>
             </a:extLst>
           </p:cNvPr>
@@ -4289,7 +4380,7 @@
           <p:cNvPr id="3" name="Title">
             <a:extLst xmlns:a="http://schemas.openxmlformats.org/drawingml/2006/main">
               <a:ext uri="{FF2B5EF4-FFF2-40B4-BE49-F238E27FC236}">
-                <a16:creationId xmlns:a16="http://schemas.microsoft.com/office/drawing/2014/main" id="{18C05A39-98F7-4BE3-ADAF-611540EF8681}"/>
+                <a16:creationId xmlns:a16="http://schemas.microsoft.com/office/drawing/2014/main" id="{6A422A33-FC99-4CFE-A9E0-F7EA2D42624D}"/>
               </a:ext>
             </a:extLst>
           </p:cNvPr>
@@ -4518,7 +4609,7 @@
           <p:cNvPr id="2" name="Left column">
             <a:extLst xmlns:a="http://schemas.openxmlformats.org/drawingml/2006/main">
               <a:ext uri="{FF2B5EF4-FFF2-40B4-BE49-F238E27FC236}">
-                <a16:creationId xmlns:a16="http://schemas.microsoft.com/office/drawing/2014/main" id="{E2259B8B-9105-4BA0-B227-455A50B733A3}"/>
+                <a16:creationId xmlns:a16="http://schemas.microsoft.com/office/drawing/2014/main" id="{DB3BA26A-BB00-4CF8-B1CA-B83D69A3762C}"/>
               </a:ext>
             </a:extLst>
           </p:cNvPr>
@@ -4785,12 +4876,12 @@
   </p:cSld>
   <p:clrMap bg1="lt1" tx1="dk1" bg2="lt2" tx2="dk2" accent1="accent1" accent2="accent2" accent3="accent3" accent4="accent4" accent5="accent5" accent6="accent6" hlink="hlink" folHlink="folHlink"/>
   <p:sldLayoutIdLst>
-    <p:sldLayoutId xmlns:r="http://schemas.openxmlformats.org/officeDocument/2006/relationships" id="2147483649" r:id="Re05508f85f674bd2"/>
-    <p:sldLayoutId xmlns:r="http://schemas.openxmlformats.org/officeDocument/2006/relationships" id="2147483650" r:id="Ra4bbcf4bb9ec40dc"/>
-    <p:sldLayoutId xmlns:r="http://schemas.openxmlformats.org/officeDocument/2006/relationships" id="2147483651" r:id="R4b5eb6d20aa54de3"/>
-    <p:sldLayoutId xmlns:r="http://schemas.openxmlformats.org/officeDocument/2006/relationships" id="2147483652" r:id="R832c4a94cc4d40d7"/>
-    <p:sldLayoutId xmlns:r="http://schemas.openxmlformats.org/officeDocument/2006/relationships" id="2147483653" r:id="R2684ddf6b36549bc"/>
-    <p:sldLayoutId xmlns:r="http://schemas.openxmlformats.org/officeDocument/2006/relationships" id="2147483654" r:id="R85fa6b50e7cb4f92"/>
+    <p:sldLayoutId xmlns:r="http://schemas.openxmlformats.org/officeDocument/2006/relationships" id="2147483649" r:id="R56fef54bc3254012"/>
+    <p:sldLayoutId xmlns:r="http://schemas.openxmlformats.org/officeDocument/2006/relationships" id="2147483650" r:id="R7ed9919a69034517"/>
+    <p:sldLayoutId xmlns:r="http://schemas.openxmlformats.org/officeDocument/2006/relationships" id="2147483651" r:id="R4f05ee486e4b4c1d"/>
+    <p:sldLayoutId xmlns:r="http://schemas.openxmlformats.org/officeDocument/2006/relationships" id="2147483652" r:id="R3663beaf57fb4680"/>
+    <p:sldLayoutId xmlns:r="http://schemas.openxmlformats.org/officeDocument/2006/relationships" id="2147483653" r:id="Rb53188220a5c43a5"/>
+    <p:sldLayoutId xmlns:r="http://schemas.openxmlformats.org/officeDocument/2006/relationships" id="2147483654" r:id="R2a51fbb9f81640cb"/>
   </p:sldLayoutIdLst>
   <p:txStyles>
     <p:titleStyle>
@@ -5428,13 +5519,13 @@
                   <c:v>3192</c:v>
                 </c:pt>
                 <c:pt idx="11">
-                  <c:v>3282</c:v>
+                  <c:v>3284</c:v>
                 </c:pt>
                 <c:pt idx="12">
-                  <c:v>12132</c:v>
+                  <c:v>12135</c:v>
                 </c:pt>
                 <c:pt idx="13">
-                  <c:v>12139</c:v>
+                  <c:v>12141</c:v>
                 </c:pt>
               </c:numCache>
             </c:numRef>
@@ -5770,13 +5861,13 @@
                   <c:v>6577</c:v>
                 </c:pt>
                 <c:pt idx="11">
-                  <c:v>6487</c:v>
+                  <c:v>6485</c:v>
                 </c:pt>
                 <c:pt idx="12">
-                  <c:v>7731</c:v>
+                  <c:v>7728</c:v>
                 </c:pt>
                 <c:pt idx="13">
-                  <c:v>7724</c:v>
+                  <c:v>7722</c:v>
                 </c:pt>
               </c:numCache>
             </c:numRef>
@@ -5949,7 +6040,7 @@
           <p:cNvPr id="9" name="">
             <a:extLst xmlns:a="http://schemas.openxmlformats.org/drawingml/2006/main">
               <a:ext uri="{FF2B5EF4-FFF2-40B4-BE49-F238E27FC236}">
-                <a16:creationId xmlns:a16="http://schemas.microsoft.com/office/drawing/2014/main" id="{AEC47304-9AAB-43BC-ACBE-043EB5959E1B}"/>
+                <a16:creationId xmlns:a16="http://schemas.microsoft.com/office/drawing/2014/main" id="{102CB986-9396-4FCC-B547-85A76B187E8C}"/>
               </a:ext>
             </a:extLst>
           </p:cNvPr>
@@ -6105,7 +6196,7 @@
           <p:cNvPr id="2" name="">
             <a:extLst xmlns:a="http://schemas.openxmlformats.org/drawingml/2006/main">
               <a:ext uri="{FF2B5EF4-FFF2-40B4-BE49-F238E27FC236}">
-                <a16:creationId xmlns:a16="http://schemas.microsoft.com/office/drawing/2014/main" id="{86E3F479-557B-4D2F-A82E-78BCBEBB88AF}"/>
+                <a16:creationId xmlns:a16="http://schemas.microsoft.com/office/drawing/2014/main" id="{324671DA-88A2-4FC8-9F62-1200B39D2CA0}"/>
               </a:ext>
             </a:extLst>
           </p:cNvPr>
@@ -6261,7 +6352,7 @@
           <p:cNvPr id="3" name="">
             <a:extLst xmlns:a="http://schemas.openxmlformats.org/drawingml/2006/main">
               <a:ext uri="{FF2B5EF4-FFF2-40B4-BE49-F238E27FC236}">
-                <a16:creationId xmlns:a16="http://schemas.microsoft.com/office/drawing/2014/main" id="{5B7F4FA7-C6FE-47F1-889F-2E87090CCC37}"/>
+                <a16:creationId xmlns:a16="http://schemas.microsoft.com/office/drawing/2014/main" id="{F0CD3AAA-FA34-41B7-9A48-5539F580903F}"/>
               </a:ext>
             </a:extLst>
           </p:cNvPr>
@@ -6417,7 +6508,7 @@
           <p:cNvPr id="4" name="">
             <a:extLst xmlns:a="http://schemas.openxmlformats.org/drawingml/2006/main">
               <a:ext uri="{FF2B5EF4-FFF2-40B4-BE49-F238E27FC236}">
-                <a16:creationId xmlns:a16="http://schemas.microsoft.com/office/drawing/2014/main" id="{CF58CC2E-D905-481E-A2A8-367975739000}"/>
+                <a16:creationId xmlns:a16="http://schemas.microsoft.com/office/drawing/2014/main" id="{C52DC29B-2330-43A6-9501-933D04EA7EF2}"/>
               </a:ext>
             </a:extLst>
           </p:cNvPr>
@@ -6573,7 +6664,7 @@
           <p:cNvPr id="5" name="">
             <a:extLst xmlns:a="http://schemas.openxmlformats.org/drawingml/2006/main">
               <a:ext uri="{FF2B5EF4-FFF2-40B4-BE49-F238E27FC236}">
-                <a16:creationId xmlns:a16="http://schemas.microsoft.com/office/drawing/2014/main" id="{9C4E51FB-72A1-4DD0-BF1B-3B717A307EE8}"/>
+                <a16:creationId xmlns:a16="http://schemas.microsoft.com/office/drawing/2014/main" id="{E56351A9-6BF1-440A-AEDB-D4CBAA9E9E48}"/>
               </a:ext>
             </a:extLst>
           </p:cNvPr>
@@ -6729,7 +6820,7 @@
           <p:cNvPr id="6" name="">
             <a:extLst xmlns:a="http://schemas.openxmlformats.org/drawingml/2006/main">
               <a:ext uri="{FF2B5EF4-FFF2-40B4-BE49-F238E27FC236}">
-                <a16:creationId xmlns:a16="http://schemas.microsoft.com/office/drawing/2014/main" id="{91F2AC11-0B77-4B52-8AD0-44B860E3F503}"/>
+                <a16:creationId xmlns:a16="http://schemas.microsoft.com/office/drawing/2014/main" id="{1715655A-E9C0-4771-AEE5-E6AE05782D96}"/>
               </a:ext>
             </a:extLst>
           </p:cNvPr>
@@ -6885,7 +6976,7 @@
           <p:cNvPr id="7" name="">
             <a:extLst xmlns:a="http://schemas.openxmlformats.org/drawingml/2006/main">
               <a:ext uri="{FF2B5EF4-FFF2-40B4-BE49-F238E27FC236}">
-                <a16:creationId xmlns:a16="http://schemas.microsoft.com/office/drawing/2014/main" id="{830B5679-2ACE-4684-A99A-0FA2BBA0B81E}"/>
+                <a16:creationId xmlns:a16="http://schemas.microsoft.com/office/drawing/2014/main" id="{6A79C1AE-E7D7-4AE8-9F63-88E2DD0E567C}"/>
               </a:ext>
             </a:extLst>
           </p:cNvPr>
@@ -7041,7 +7132,7 @@
           <p:cNvPr id="8" name="">
             <a:extLst xmlns:a="http://schemas.openxmlformats.org/drawingml/2006/main">
               <a:ext uri="{FF2B5EF4-FFF2-40B4-BE49-F238E27FC236}">
-                <a16:creationId xmlns:a16="http://schemas.microsoft.com/office/drawing/2014/main" id="{55BB50C7-B3C8-401E-A5E0-4CF98C3C1D69}"/>
+                <a16:creationId xmlns:a16="http://schemas.microsoft.com/office/drawing/2014/main" id="{1A178FFF-9A1D-4308-BEE6-0AD73274455C}"/>
               </a:ext>
             </a:extLst>
           </p:cNvPr>
@@ -7195,7 +7286,7 @@
     </p:spTree>
     <p:extLst>
       <p:ext uri="{BB962C8B-B14F-4D97-AF65-F5344CB8AC3E}">
-        <p14:creationId xmlns:p14="http://schemas.microsoft.com/office/powerpoint/2010/main" val="947654721"/>
+        <p14:creationId xmlns:p14="http://schemas.microsoft.com/office/powerpoint/2010/main" val="1297122681"/>
       </p:ext>
     </p:extLst>
   </p:cSld>
@@ -7226,7 +7317,7 @@
           <p:cNvPr id="7" name="">
             <a:extLst xmlns:a="http://schemas.openxmlformats.org/drawingml/2006/main">
               <a:ext uri="{FF2B5EF4-FFF2-40B4-BE49-F238E27FC236}">
-                <a16:creationId xmlns:a16="http://schemas.microsoft.com/office/drawing/2014/main" id="{4C3E48F8-8FC8-4990-8F2D-97B30EA3245F}"/>
+                <a16:creationId xmlns:a16="http://schemas.microsoft.com/office/drawing/2014/main" id="{3CD82163-1D90-4840-9E5E-4C118F4DBAF4}"/>
               </a:ext>
             </a:extLst>
           </p:cNvPr>
@@ -7382,7 +7473,7 @@
           <p:cNvPr id="2" name="">
             <a:extLst xmlns:a="http://schemas.openxmlformats.org/drawingml/2006/main">
               <a:ext uri="{FF2B5EF4-FFF2-40B4-BE49-F238E27FC236}">
-                <a16:creationId xmlns:a16="http://schemas.microsoft.com/office/drawing/2014/main" id="{062BE797-A4C4-4996-AA0C-3A98DFCB4859}"/>
+                <a16:creationId xmlns:a16="http://schemas.microsoft.com/office/drawing/2014/main" id="{D3E21BE9-E872-4BCE-9DA2-7B3E6D28534A}"/>
               </a:ext>
             </a:extLst>
           </p:cNvPr>
@@ -7538,7 +7629,7 @@
           <p:cNvPr id="3" name="">
             <a:extLst xmlns:a="http://schemas.openxmlformats.org/drawingml/2006/main">
               <a:ext uri="{FF2B5EF4-FFF2-40B4-BE49-F238E27FC236}">
-                <a16:creationId xmlns:a16="http://schemas.microsoft.com/office/drawing/2014/main" id="{A748B751-7120-4A9B-8D90-387F7F1A8A15}"/>
+                <a16:creationId xmlns:a16="http://schemas.microsoft.com/office/drawing/2014/main" id="{362B3166-F707-49F9-8F71-C84A67F8A4F7}"/>
               </a:ext>
             </a:extLst>
           </p:cNvPr>
@@ -7694,7 +7785,7 @@
           <p:cNvPr id="4" name="">
             <a:extLst xmlns:a="http://schemas.openxmlformats.org/drawingml/2006/main">
               <a:ext uri="{FF2B5EF4-FFF2-40B4-BE49-F238E27FC236}">
-                <a16:creationId xmlns:a16="http://schemas.microsoft.com/office/drawing/2014/main" id="{D2C69430-B2E0-476D-915D-3AA0D9AD508F}"/>
+                <a16:creationId xmlns:a16="http://schemas.microsoft.com/office/drawing/2014/main" id="{BA9F0EF1-290A-4835-BFF2-47F631C3C92E}"/>
               </a:ext>
             </a:extLst>
           </p:cNvPr>
@@ -7850,7 +7941,7 @@
           <p:cNvPr id="5" name="">
             <a:extLst xmlns:a="http://schemas.openxmlformats.org/drawingml/2006/main">
               <a:ext uri="{FF2B5EF4-FFF2-40B4-BE49-F238E27FC236}">
-                <a16:creationId xmlns:a16="http://schemas.microsoft.com/office/drawing/2014/main" id="{9798131F-BB45-40F5-8FD9-438A2F751AAE}"/>
+                <a16:creationId xmlns:a16="http://schemas.microsoft.com/office/drawing/2014/main" id="{7ECA2C32-76B4-466F-9B8A-A620E975A166}"/>
               </a:ext>
             </a:extLst>
           </p:cNvPr>
@@ -8104,7 +8195,7 @@
                           <a:ea typeface="Helvetica Neue"/>
                           <a:cs typeface="Helvetica Neue"/>
                         </a:rPr>
-                        <a:t>7,724</a:t>
+                        <a:t>7,722</a:t>
                       </a:r>
                     </a:p>
                   </a:txBody>
@@ -8140,7 +8231,7 @@
                           <a:ea typeface="Helvetica Neue"/>
                           <a:cs typeface="Helvetica Neue"/>
                         </a:rPr>
-                        <a:t>12,139</a:t>
+                        <a:t>12,141</a:t>
                       </a:r>
                     </a:p>
                   </a:txBody>
@@ -8256,7 +8347,7 @@
                           <a:ea typeface="Helvetica Neue"/>
                           <a:cs typeface="Helvetica Neue"/>
                         </a:rPr>
-                        <a:t>7</a:t>
+                        <a:t>6</a:t>
                       </a:r>
                     </a:p>
                   </a:txBody>
@@ -8292,7 +8383,7 @@
                           <a:ea typeface="Helvetica Neue"/>
                           <a:cs typeface="Helvetica Neue"/>
                         </a:rPr>
-                        <a:t>12,132</a:t>
+                        <a:t>12,135</a:t>
                       </a:r>
                     </a:p>
                   </a:txBody>
@@ -8408,7 +8499,7 @@
                           <a:ea typeface="Helvetica Neue"/>
                           <a:cs typeface="Helvetica Neue"/>
                         </a:rPr>
-                        <a:t>8,850</a:t>
+                        <a:t>8,851</a:t>
                       </a:r>
                     </a:p>
                   </a:txBody>
@@ -8444,7 +8535,7 @@
                           <a:ea typeface="Helvetica Neue"/>
                           <a:cs typeface="Helvetica Neue"/>
                         </a:rPr>
-                        <a:t>3,282</a:t>
+                        <a:t>3,284</a:t>
                       </a:r>
                     </a:p>
                   </a:txBody>
@@ -8560,7 +8651,7 @@
                           <a:ea typeface="Helvetica Neue"/>
                           <a:cs typeface="Helvetica Neue"/>
                         </a:rPr>
-                        <a:t>90</a:t>
+                        <a:t>92</a:t>
                       </a:r>
                     </a:p>
                   </a:txBody>
@@ -10184,7 +10275,7 @@
           <p:cNvPr id="6" name="">
             <a:extLst xmlns:a="http://schemas.openxmlformats.org/drawingml/2006/main">
               <a:ext uri="{FF2B5EF4-FFF2-40B4-BE49-F238E27FC236}">
-                <a16:creationId xmlns:a16="http://schemas.microsoft.com/office/drawing/2014/main" id="{871417F7-0920-469B-8740-E56466887955}"/>
+                <a16:creationId xmlns:a16="http://schemas.microsoft.com/office/drawing/2014/main" id="{6DC79659-0155-483C-BC06-9573FE6B9913}"/>
               </a:ext>
             </a:extLst>
           </p:cNvPr>
@@ -10338,7 +10429,7 @@
     </p:spTree>
     <p:extLst>
       <p:ext uri="{BB962C8B-B14F-4D97-AF65-F5344CB8AC3E}">
-        <p14:creationId xmlns:p14="http://schemas.microsoft.com/office/powerpoint/2010/main" val="938640511"/>
+        <p14:creationId xmlns:p14="http://schemas.microsoft.com/office/powerpoint/2010/main" val="580899672"/>
       </p:ext>
     </p:extLst>
   </p:cSld>
@@ -10369,7 +10460,7 @@
           <p:cNvPr id="7" name="">
             <a:extLst xmlns:a="http://schemas.openxmlformats.org/drawingml/2006/main">
               <a:ext uri="{FF2B5EF4-FFF2-40B4-BE49-F238E27FC236}">
-                <a16:creationId xmlns:a16="http://schemas.microsoft.com/office/drawing/2014/main" id="{6B9375AB-543D-48FA-9703-06B853F95C36}"/>
+                <a16:creationId xmlns:a16="http://schemas.microsoft.com/office/drawing/2014/main" id="{0910EDCA-2FD2-4498-9EB3-D299BB96A604}"/>
               </a:ext>
             </a:extLst>
           </p:cNvPr>
@@ -10525,7 +10616,7 @@
           <p:cNvPr id="2" name="">
             <a:extLst xmlns:a="http://schemas.openxmlformats.org/drawingml/2006/main">
               <a:ext uri="{FF2B5EF4-FFF2-40B4-BE49-F238E27FC236}">
-                <a16:creationId xmlns:a16="http://schemas.microsoft.com/office/drawing/2014/main" id="{26613955-675A-432E-827B-FBD53E5B117C}"/>
+                <a16:creationId xmlns:a16="http://schemas.microsoft.com/office/drawing/2014/main" id="{FA0F5A81-F6D2-480C-9737-FC2EAAADEB71}"/>
               </a:ext>
             </a:extLst>
           </p:cNvPr>
@@ -10681,7 +10772,7 @@
           <p:cNvPr id="3" name="">
             <a:extLst xmlns:a="http://schemas.openxmlformats.org/drawingml/2006/main">
               <a:ext uri="{FF2B5EF4-FFF2-40B4-BE49-F238E27FC236}">
-                <a16:creationId xmlns:a16="http://schemas.microsoft.com/office/drawing/2014/main" id="{90A3AAA0-2BC4-4F2D-ADE0-8B8DE9139B7E}"/>
+                <a16:creationId xmlns:a16="http://schemas.microsoft.com/office/drawing/2014/main" id="{51A1CCA8-100F-4783-9DB8-DC88F9B7951B}"/>
               </a:ext>
             </a:extLst>
           </p:cNvPr>
@@ -10837,7 +10928,7 @@
           <p:cNvPr id="4" name="">
             <a:extLst xmlns:a="http://schemas.openxmlformats.org/drawingml/2006/main">
               <a:ext uri="{FF2B5EF4-FFF2-40B4-BE49-F238E27FC236}">
-                <a16:creationId xmlns:a16="http://schemas.microsoft.com/office/drawing/2014/main" id="{96EFD9F4-F71D-4758-A151-9C74A0340EB4}"/>
+                <a16:creationId xmlns:a16="http://schemas.microsoft.com/office/drawing/2014/main" id="{B56525AB-0F44-4311-B4E7-F54DF446C27C}"/>
               </a:ext>
             </a:extLst>
           </p:cNvPr>
@@ -10993,7 +11084,7 @@
           <p:cNvPr id="5" name="">
             <a:extLst xmlns:a="http://schemas.openxmlformats.org/drawingml/2006/main">
               <a:ext uri="{FF2B5EF4-FFF2-40B4-BE49-F238E27FC236}">
-                <a16:creationId xmlns:a16="http://schemas.microsoft.com/office/drawing/2014/main" id="{B0E37E5D-2629-4E02-AEC1-6807146FDD8D}"/>
+                <a16:creationId xmlns:a16="http://schemas.microsoft.com/office/drawing/2014/main" id="{5469B4BC-9390-4C91-8A6C-F335197AF351}"/>
               </a:ext>
             </a:extLst>
           </p:cNvPr>
@@ -11433,7 +11524,7 @@
           <p:cNvPr id="6" name="">
             <a:extLst xmlns:a="http://schemas.openxmlformats.org/drawingml/2006/main">
               <a:ext uri="{FF2B5EF4-FFF2-40B4-BE49-F238E27FC236}">
-                <a16:creationId xmlns:a16="http://schemas.microsoft.com/office/drawing/2014/main" id="{5BD341DD-5C37-438B-BDCB-0E83299517FB}"/>
+                <a16:creationId xmlns:a16="http://schemas.microsoft.com/office/drawing/2014/main" id="{A33CEA57-76CC-490E-A042-C36945FCCFE9}"/>
               </a:ext>
             </a:extLst>
           </p:cNvPr>
@@ -11587,7 +11678,7 @@
     </p:spTree>
     <p:extLst>
       <p:ext uri="{BB962C8B-B14F-4D97-AF65-F5344CB8AC3E}">
-        <p14:creationId xmlns:p14="http://schemas.microsoft.com/office/powerpoint/2010/main" val="1726962164"/>
+        <p14:creationId xmlns:p14="http://schemas.microsoft.com/office/powerpoint/2010/main" val="598736206"/>
       </p:ext>
     </p:extLst>
   </p:cSld>
@@ -11615,10 +11706,10 @@
       </p:grpSpPr>
       <p:sp>
         <p:nvSpPr>
-          <p:cNvPr id="6" name="">
+          <p:cNvPr id="7" name="">
             <a:extLst xmlns:a="http://schemas.openxmlformats.org/drawingml/2006/main">
               <a:ext uri="{FF2B5EF4-FFF2-40B4-BE49-F238E27FC236}">
-                <a16:creationId xmlns:a16="http://schemas.microsoft.com/office/drawing/2014/main" id="{15D0F441-C22B-448F-922C-A329E0CBF240}"/>
+                <a16:creationId xmlns:a16="http://schemas.microsoft.com/office/drawing/2014/main" id="{E95AD38C-E9C4-4EC6-81F5-1E631EEFEF0A}"/>
               </a:ext>
             </a:extLst>
           </p:cNvPr>
@@ -11774,7 +11865,7 @@
           <p:cNvPr id="2" name="">
             <a:extLst xmlns:a="http://schemas.openxmlformats.org/drawingml/2006/main">
               <a:ext uri="{FF2B5EF4-FFF2-40B4-BE49-F238E27FC236}">
-                <a16:creationId xmlns:a16="http://schemas.microsoft.com/office/drawing/2014/main" id="{611BCD33-C140-48B0-A62E-FC03BBBAD870}"/>
+                <a16:creationId xmlns:a16="http://schemas.microsoft.com/office/drawing/2014/main" id="{602CD5B3-1739-4B19-AF5C-C30CB9E1FCA9}"/>
               </a:ext>
             </a:extLst>
           </p:cNvPr>
@@ -11930,7 +12021,7 @@
           <p:cNvPr id="3" name="">
             <a:extLst xmlns:a="http://schemas.openxmlformats.org/drawingml/2006/main">
               <a:ext uri="{FF2B5EF4-FFF2-40B4-BE49-F238E27FC236}">
-                <a16:creationId xmlns:a16="http://schemas.microsoft.com/office/drawing/2014/main" id="{C20A6E09-3A44-46BD-8B93-55D6F32F47C2}"/>
+                <a16:creationId xmlns:a16="http://schemas.microsoft.com/office/drawing/2014/main" id="{91C298CD-A5B2-48DC-AF71-B2390612CAE3}"/>
               </a:ext>
             </a:extLst>
           </p:cNvPr>
@@ -12086,7 +12177,7 @@
           <p:cNvPr id="4" name="">
             <a:extLst xmlns:a="http://schemas.openxmlformats.org/drawingml/2006/main">
               <a:ext uri="{FF2B5EF4-FFF2-40B4-BE49-F238E27FC236}">
-                <a16:creationId xmlns:a16="http://schemas.microsoft.com/office/drawing/2014/main" id="{2026F2AA-1DE2-4E46-8F6A-54C6720C2621}"/>
+                <a16:creationId xmlns:a16="http://schemas.microsoft.com/office/drawing/2014/main" id="{85591E0B-AA24-4929-9B42-82A976238CBE}"/>
               </a:ext>
             </a:extLst>
           </p:cNvPr>
@@ -12242,7 +12333,7 @@
           <p:cNvPr id="5" name="">
             <a:extLst xmlns:a="http://schemas.openxmlformats.org/drawingml/2006/main">
               <a:ext uri="{FF2B5EF4-FFF2-40B4-BE49-F238E27FC236}">
-                <a16:creationId xmlns:a16="http://schemas.microsoft.com/office/drawing/2014/main" id="{4A06589B-8EF1-4409-B1CB-E7BEAF59193D}"/>
+                <a16:creationId xmlns:a16="http://schemas.microsoft.com/office/drawing/2014/main" id="{0963CE0F-AA82-4478-8727-B5EA50B7B4F1}"/>
               </a:ext>
             </a:extLst>
           </p:cNvPr>
@@ -12252,7 +12343,7 @@
           <p:nvPr/>
         </p:nvPicPr>
         <p:blipFill>
-          <a:blip xmlns:r="http://schemas.openxmlformats.org/officeDocument/2006/relationships" xmlns:a="http://schemas.openxmlformats.org/drawingml/2006/main" r:embed="Rcf15bf58a98c4f44"/>
+          <a:blip xmlns:r="http://schemas.openxmlformats.org/officeDocument/2006/relationships" xmlns:a="http://schemas.openxmlformats.org/drawingml/2006/main" r:embed="Rba8b55caf4464943"/>
           <a:stretch xmlns:a="http://schemas.openxmlformats.org/drawingml/2006/main"/>
         </p:blipFill>
         <p:spPr>
@@ -12265,10 +12356,166 @@
           </a:prstGeom>
         </p:spPr>
       </p:pic>
+      <p:sp>
+        <p:nvSpPr>
+          <p:cNvPr id="6" name="">
+            <a:extLst xmlns:a="http://schemas.openxmlformats.org/drawingml/2006/main">
+              <a:ext uri="{FF2B5EF4-FFF2-40B4-BE49-F238E27FC236}">
+                <a16:creationId xmlns:a16="http://schemas.microsoft.com/office/drawing/2014/main" id="{81B2B9E6-EE80-46BC-860F-87DFB0599811}"/>
+              </a:ext>
+            </a:extLst>
+          </p:cNvPr>
+          <p:cNvSpPr>
+            <a:spLocks xmlns:a="http://schemas.openxmlformats.org/drawingml/2006/main" noGrp="1"/>
+          </p:cNvSpPr>
+          <p:nvPr/>
+        </p:nvSpPr>
+        <p:spPr>
+          <a:xfrm xmlns:a="http://schemas.openxmlformats.org/drawingml/2006/main">
+            <a:off x="609600" y="6086475"/>
+            <a:ext cx="10972800" cy="238125"/>
+          </a:xfrm>
+          <a:prstGeom xmlns:a="http://schemas.openxmlformats.org/drawingml/2006/main" prst="rect">
+            <a:avLst/>
+          </a:prstGeom>
+          <a:noFill xmlns:a="http://schemas.openxmlformats.org/drawingml/2006/main"/>
+          <a:ln xmlns:a="http://schemas.openxmlformats.org/drawingml/2006/main" w="0">
+            <a:noFill/>
+          </a:ln>
+        </p:spPr>
+        <p:txBody>
+          <a:bodyPr xmlns:a="http://schemas.openxmlformats.org/drawingml/2006/main" lIns="0" tIns="0" rIns="0" bIns="0"/>
+          <a:lstStyle xmlns:a="http://schemas.openxmlformats.org/drawingml/2006/main">
+            <a:defPPr>
+              <a:defRPr sz="1200" b="0">
+                <a:solidFill>
+                  <a:srgbClr val="536675"/>
+                </a:solidFill>
+                <a:latin typeface="Helvetica Neue"/>
+                <a:ea typeface="Helvetica Neue"/>
+                <a:cs typeface="Helvetica Neue"/>
+              </a:defRPr>
+            </a:defPPr>
+            <a:lvl1pPr>
+              <a:defRPr sz="1200" b="0">
+                <a:solidFill>
+                  <a:srgbClr val="536675"/>
+                </a:solidFill>
+                <a:latin typeface="Helvetica Neue"/>
+                <a:ea typeface="Helvetica Neue"/>
+                <a:cs typeface="Helvetica Neue"/>
+              </a:defRPr>
+            </a:lvl1pPr>
+            <a:lvl2pPr>
+              <a:defRPr sz="1200" b="0">
+                <a:solidFill>
+                  <a:srgbClr val="536675"/>
+                </a:solidFill>
+                <a:latin typeface="Helvetica Neue"/>
+                <a:ea typeface="Helvetica Neue"/>
+                <a:cs typeface="Helvetica Neue"/>
+              </a:defRPr>
+            </a:lvl2pPr>
+            <a:lvl3pPr>
+              <a:defRPr sz="1200" b="0">
+                <a:solidFill>
+                  <a:srgbClr val="536675"/>
+                </a:solidFill>
+                <a:latin typeface="Helvetica Neue"/>
+                <a:ea typeface="Helvetica Neue"/>
+                <a:cs typeface="Helvetica Neue"/>
+              </a:defRPr>
+            </a:lvl3pPr>
+            <a:lvl4pPr>
+              <a:defRPr sz="1200" b="0">
+                <a:solidFill>
+                  <a:srgbClr val="536675"/>
+                </a:solidFill>
+                <a:latin typeface="Helvetica Neue"/>
+                <a:ea typeface="Helvetica Neue"/>
+                <a:cs typeface="Helvetica Neue"/>
+              </a:defRPr>
+            </a:lvl4pPr>
+            <a:lvl5pPr>
+              <a:defRPr sz="1200" b="0">
+                <a:solidFill>
+                  <a:srgbClr val="536675"/>
+                </a:solidFill>
+                <a:latin typeface="Helvetica Neue"/>
+                <a:ea typeface="Helvetica Neue"/>
+                <a:cs typeface="Helvetica Neue"/>
+              </a:defRPr>
+            </a:lvl5pPr>
+            <a:lvl6pPr>
+              <a:defRPr sz="1200" b="0">
+                <a:solidFill>
+                  <a:srgbClr val="536675"/>
+                </a:solidFill>
+                <a:latin typeface="Helvetica Neue"/>
+                <a:ea typeface="Helvetica Neue"/>
+                <a:cs typeface="Helvetica Neue"/>
+              </a:defRPr>
+            </a:lvl6pPr>
+            <a:lvl7pPr>
+              <a:defRPr sz="1200" b="0">
+                <a:solidFill>
+                  <a:srgbClr val="536675"/>
+                </a:solidFill>
+                <a:latin typeface="Helvetica Neue"/>
+                <a:ea typeface="Helvetica Neue"/>
+                <a:cs typeface="Helvetica Neue"/>
+              </a:defRPr>
+            </a:lvl7pPr>
+            <a:lvl8pPr>
+              <a:defRPr sz="1200" b="0">
+                <a:solidFill>
+                  <a:srgbClr val="536675"/>
+                </a:solidFill>
+                <a:latin typeface="Helvetica Neue"/>
+                <a:ea typeface="Helvetica Neue"/>
+                <a:cs typeface="Helvetica Neue"/>
+              </a:defRPr>
+            </a:lvl8pPr>
+            <a:lvl9pPr>
+              <a:defRPr sz="1200" b="0">
+                <a:solidFill>
+                  <a:srgbClr val="536675"/>
+                </a:solidFill>
+                <a:latin typeface="Helvetica Neue"/>
+                <a:ea typeface="Helvetica Neue"/>
+                <a:cs typeface="Helvetica Neue"/>
+              </a:defRPr>
+            </a:lvl9pPr>
+          </a:lstStyle>
+          <a:p xmlns:a="http://schemas.openxmlformats.org/drawingml/2006/main">
+            <a:pPr>
+              <a:defRPr sz="1200" b="0">
+                <a:solidFill>
+                  <a:srgbClr val="536675"/>
+                </a:solidFill>
+                <a:latin typeface="Helvetica Neue"/>
+                <a:ea typeface="Helvetica Neue"/>
+                <a:cs typeface="Helvetica Neue"/>
+              </a:defRPr>
+            </a:pPr>
+            <a:r>
+              <a:rPr sz="1200" b="0">
+                <a:solidFill>
+                  <a:srgbClr val="536675"/>
+                </a:solidFill>
+                <a:latin typeface="Helvetica Neue"/>
+                <a:ea typeface="Helvetica Neue"/>
+                <a:cs typeface="Helvetica Neue"/>
+              </a:rPr>
+              <a:t>Gray: healthy measurement unavailable. The lower band has no embryonic-expression value.</a:t>
+            </a:r>
+          </a:p>
+        </p:txBody>
+      </p:sp>
     </p:spTree>
     <p:extLst>
       <p:ext uri="{BB962C8B-B14F-4D97-AF65-F5344CB8AC3E}">
-        <p14:creationId xmlns:p14="http://schemas.microsoft.com/office/powerpoint/2010/main" val="386281356"/>
+        <p14:creationId xmlns:p14="http://schemas.microsoft.com/office/powerpoint/2010/main" val="1212886930"/>
       </p:ext>
     </p:extLst>
   </p:cSld>
@@ -12296,10 +12543,10 @@
       </p:grpSpPr>
       <p:sp>
         <p:nvSpPr>
-          <p:cNvPr id="6" name="">
+          <p:cNvPr id="7" name="">
             <a:extLst xmlns:a="http://schemas.openxmlformats.org/drawingml/2006/main">
               <a:ext uri="{FF2B5EF4-FFF2-40B4-BE49-F238E27FC236}">
-                <a16:creationId xmlns:a16="http://schemas.microsoft.com/office/drawing/2014/main" id="{D9E7ACD2-9437-4DBB-9180-364DDDC4ADE9}"/>
+                <a16:creationId xmlns:a16="http://schemas.microsoft.com/office/drawing/2014/main" id="{78A20067-6CA1-420F-BF0E-7B414CF2B810}"/>
               </a:ext>
             </a:extLst>
           </p:cNvPr>
@@ -12455,7 +12702,7 @@
           <p:cNvPr id="2" name="">
             <a:extLst xmlns:a="http://schemas.openxmlformats.org/drawingml/2006/main">
               <a:ext uri="{FF2B5EF4-FFF2-40B4-BE49-F238E27FC236}">
-                <a16:creationId xmlns:a16="http://schemas.microsoft.com/office/drawing/2014/main" id="{7501CE4B-405C-4493-AC6B-FFFFADC4B773}"/>
+                <a16:creationId xmlns:a16="http://schemas.microsoft.com/office/drawing/2014/main" id="{6760AC31-0CF1-4E8E-AC8C-68D5B21E301F}"/>
               </a:ext>
             </a:extLst>
           </p:cNvPr>
@@ -12611,7 +12858,7 @@
           <p:cNvPr id="3" name="">
             <a:extLst xmlns:a="http://schemas.openxmlformats.org/drawingml/2006/main">
               <a:ext uri="{FF2B5EF4-FFF2-40B4-BE49-F238E27FC236}">
-                <a16:creationId xmlns:a16="http://schemas.microsoft.com/office/drawing/2014/main" id="{72614F79-EF24-415E-94E2-1BB36875A033}"/>
+                <a16:creationId xmlns:a16="http://schemas.microsoft.com/office/drawing/2014/main" id="{69528EEA-2A6C-4366-BA1E-C4CB985692EE}"/>
               </a:ext>
             </a:extLst>
           </p:cNvPr>
@@ -12767,7 +13014,7 @@
           <p:cNvPr id="4" name="">
             <a:extLst xmlns:a="http://schemas.openxmlformats.org/drawingml/2006/main">
               <a:ext uri="{FF2B5EF4-FFF2-40B4-BE49-F238E27FC236}">
-                <a16:creationId xmlns:a16="http://schemas.microsoft.com/office/drawing/2014/main" id="{E9B7811D-4755-4A0A-8AF8-26A74E81D844}"/>
+                <a16:creationId xmlns:a16="http://schemas.microsoft.com/office/drawing/2014/main" id="{FE5EE15B-2C01-4AEF-8493-AE805A082708}"/>
               </a:ext>
             </a:extLst>
           </p:cNvPr>
@@ -12923,7 +13170,7 @@
           <p:cNvPr id="5" name="">
             <a:extLst xmlns:a="http://schemas.openxmlformats.org/drawingml/2006/main">
               <a:ext uri="{FF2B5EF4-FFF2-40B4-BE49-F238E27FC236}">
-                <a16:creationId xmlns:a16="http://schemas.microsoft.com/office/drawing/2014/main" id="{046ACC41-900B-49F8-8E04-7763CFE0F013}"/>
+                <a16:creationId xmlns:a16="http://schemas.microsoft.com/office/drawing/2014/main" id="{1E1E40F0-C8DB-4D9C-ABAA-8A840A5452C0}"/>
               </a:ext>
             </a:extLst>
           </p:cNvPr>
@@ -12933,7 +13180,7 @@
           <p:nvPr/>
         </p:nvPicPr>
         <p:blipFill>
-          <a:blip xmlns:r="http://schemas.openxmlformats.org/officeDocument/2006/relationships" xmlns:a="http://schemas.openxmlformats.org/drawingml/2006/main" r:embed="R8f08778202904af8"/>
+          <a:blip xmlns:r="http://schemas.openxmlformats.org/officeDocument/2006/relationships" xmlns:a="http://schemas.openxmlformats.org/drawingml/2006/main" r:embed="Rab9c61d51aa04b27"/>
           <a:stretch xmlns:a="http://schemas.openxmlformats.org/drawingml/2006/main"/>
         </p:blipFill>
         <p:spPr>
@@ -12946,10 +13193,166 @@
           </a:prstGeom>
         </p:spPr>
       </p:pic>
+      <p:sp>
+        <p:nvSpPr>
+          <p:cNvPr id="6" name="">
+            <a:extLst xmlns:a="http://schemas.openxmlformats.org/drawingml/2006/main">
+              <a:ext uri="{FF2B5EF4-FFF2-40B4-BE49-F238E27FC236}">
+                <a16:creationId xmlns:a16="http://schemas.microsoft.com/office/drawing/2014/main" id="{087AB6C8-177F-4B15-B543-F959203E8094}"/>
+              </a:ext>
+            </a:extLst>
+          </p:cNvPr>
+          <p:cNvSpPr>
+            <a:spLocks xmlns:a="http://schemas.openxmlformats.org/drawingml/2006/main" noGrp="1"/>
+          </p:cNvSpPr>
+          <p:nvPr/>
+        </p:nvSpPr>
+        <p:spPr>
+          <a:xfrm xmlns:a="http://schemas.openxmlformats.org/drawingml/2006/main">
+            <a:off x="609600" y="6086475"/>
+            <a:ext cx="10972800" cy="238125"/>
+          </a:xfrm>
+          <a:prstGeom xmlns:a="http://schemas.openxmlformats.org/drawingml/2006/main" prst="rect">
+            <a:avLst/>
+          </a:prstGeom>
+          <a:noFill xmlns:a="http://schemas.openxmlformats.org/drawingml/2006/main"/>
+          <a:ln xmlns:a="http://schemas.openxmlformats.org/drawingml/2006/main" w="0">
+            <a:noFill/>
+          </a:ln>
+        </p:spPr>
+        <p:txBody>
+          <a:bodyPr xmlns:a="http://schemas.openxmlformats.org/drawingml/2006/main" lIns="0" tIns="0" rIns="0" bIns="0"/>
+          <a:lstStyle xmlns:a="http://schemas.openxmlformats.org/drawingml/2006/main">
+            <a:defPPr>
+              <a:defRPr sz="1200" b="0">
+                <a:solidFill>
+                  <a:srgbClr val="536675"/>
+                </a:solidFill>
+                <a:latin typeface="Helvetica Neue"/>
+                <a:ea typeface="Helvetica Neue"/>
+                <a:cs typeface="Helvetica Neue"/>
+              </a:defRPr>
+            </a:defPPr>
+            <a:lvl1pPr>
+              <a:defRPr sz="1200" b="0">
+                <a:solidFill>
+                  <a:srgbClr val="536675"/>
+                </a:solidFill>
+                <a:latin typeface="Helvetica Neue"/>
+                <a:ea typeface="Helvetica Neue"/>
+                <a:cs typeface="Helvetica Neue"/>
+              </a:defRPr>
+            </a:lvl1pPr>
+            <a:lvl2pPr>
+              <a:defRPr sz="1200" b="0">
+                <a:solidFill>
+                  <a:srgbClr val="536675"/>
+                </a:solidFill>
+                <a:latin typeface="Helvetica Neue"/>
+                <a:ea typeface="Helvetica Neue"/>
+                <a:cs typeface="Helvetica Neue"/>
+              </a:defRPr>
+            </a:lvl2pPr>
+            <a:lvl3pPr>
+              <a:defRPr sz="1200" b="0">
+                <a:solidFill>
+                  <a:srgbClr val="536675"/>
+                </a:solidFill>
+                <a:latin typeface="Helvetica Neue"/>
+                <a:ea typeface="Helvetica Neue"/>
+                <a:cs typeface="Helvetica Neue"/>
+              </a:defRPr>
+            </a:lvl3pPr>
+            <a:lvl4pPr>
+              <a:defRPr sz="1200" b="0">
+                <a:solidFill>
+                  <a:srgbClr val="536675"/>
+                </a:solidFill>
+                <a:latin typeface="Helvetica Neue"/>
+                <a:ea typeface="Helvetica Neue"/>
+                <a:cs typeface="Helvetica Neue"/>
+              </a:defRPr>
+            </a:lvl4pPr>
+            <a:lvl5pPr>
+              <a:defRPr sz="1200" b="0">
+                <a:solidFill>
+                  <a:srgbClr val="536675"/>
+                </a:solidFill>
+                <a:latin typeface="Helvetica Neue"/>
+                <a:ea typeface="Helvetica Neue"/>
+                <a:cs typeface="Helvetica Neue"/>
+              </a:defRPr>
+            </a:lvl5pPr>
+            <a:lvl6pPr>
+              <a:defRPr sz="1200" b="0">
+                <a:solidFill>
+                  <a:srgbClr val="536675"/>
+                </a:solidFill>
+                <a:latin typeface="Helvetica Neue"/>
+                <a:ea typeface="Helvetica Neue"/>
+                <a:cs typeface="Helvetica Neue"/>
+              </a:defRPr>
+            </a:lvl6pPr>
+            <a:lvl7pPr>
+              <a:defRPr sz="1200" b="0">
+                <a:solidFill>
+                  <a:srgbClr val="536675"/>
+                </a:solidFill>
+                <a:latin typeface="Helvetica Neue"/>
+                <a:ea typeface="Helvetica Neue"/>
+                <a:cs typeface="Helvetica Neue"/>
+              </a:defRPr>
+            </a:lvl7pPr>
+            <a:lvl8pPr>
+              <a:defRPr sz="1200" b="0">
+                <a:solidFill>
+                  <a:srgbClr val="536675"/>
+                </a:solidFill>
+                <a:latin typeface="Helvetica Neue"/>
+                <a:ea typeface="Helvetica Neue"/>
+                <a:cs typeface="Helvetica Neue"/>
+              </a:defRPr>
+            </a:lvl8pPr>
+            <a:lvl9pPr>
+              <a:defRPr sz="1200" b="0">
+                <a:solidFill>
+                  <a:srgbClr val="536675"/>
+                </a:solidFill>
+                <a:latin typeface="Helvetica Neue"/>
+                <a:ea typeface="Helvetica Neue"/>
+                <a:cs typeface="Helvetica Neue"/>
+              </a:defRPr>
+            </a:lvl9pPr>
+          </a:lstStyle>
+          <a:p xmlns:a="http://schemas.openxmlformats.org/drawingml/2006/main">
+            <a:pPr>
+              <a:defRPr sz="1200" b="0">
+                <a:solidFill>
+                  <a:srgbClr val="536675"/>
+                </a:solidFill>
+                <a:latin typeface="Helvetica Neue"/>
+                <a:ea typeface="Helvetica Neue"/>
+                <a:cs typeface="Helvetica Neue"/>
+              </a:defRPr>
+            </a:pPr>
+            <a:r>
+              <a:rPr sz="1200" b="0">
+                <a:solidFill>
+                  <a:srgbClr val="536675"/>
+                </a:solidFill>
+                <a:latin typeface="Helvetica Neue"/>
+                <a:ea typeface="Helvetica Neue"/>
+                <a:cs typeface="Helvetica Neue"/>
+              </a:rPr>
+              <a:t>Gray: healthy measurement unavailable. The lower band has no embryonic-expression value.</a:t>
+            </a:r>
+          </a:p>
+        </p:txBody>
+      </p:sp>
     </p:spTree>
     <p:extLst>
       <p:ext uri="{BB962C8B-B14F-4D97-AF65-F5344CB8AC3E}">
-        <p14:creationId xmlns:p14="http://schemas.microsoft.com/office/powerpoint/2010/main" val="1428967496"/>
+        <p14:creationId xmlns:p14="http://schemas.microsoft.com/office/powerpoint/2010/main" val="963474852"/>
       </p:ext>
     </p:extLst>
   </p:cSld>
@@ -12977,10 +13380,10 @@
       </p:grpSpPr>
       <p:sp>
         <p:nvSpPr>
-          <p:cNvPr id="6" name="">
+          <p:cNvPr id="7" name="">
             <a:extLst xmlns:a="http://schemas.openxmlformats.org/drawingml/2006/main">
               <a:ext uri="{FF2B5EF4-FFF2-40B4-BE49-F238E27FC236}">
-                <a16:creationId xmlns:a16="http://schemas.microsoft.com/office/drawing/2014/main" id="{0460A5F2-3D57-4C36-AC69-C4E4AB97ADF5}"/>
+                <a16:creationId xmlns:a16="http://schemas.microsoft.com/office/drawing/2014/main" id="{9D6FF308-3626-4463-9460-3B2FF8616885}"/>
               </a:ext>
             </a:extLst>
           </p:cNvPr>
@@ -13136,7 +13539,7 @@
           <p:cNvPr id="2" name="">
             <a:extLst xmlns:a="http://schemas.openxmlformats.org/drawingml/2006/main">
               <a:ext uri="{FF2B5EF4-FFF2-40B4-BE49-F238E27FC236}">
-                <a16:creationId xmlns:a16="http://schemas.microsoft.com/office/drawing/2014/main" id="{7100C55B-3228-4BA4-B6ED-075C25864918}"/>
+                <a16:creationId xmlns:a16="http://schemas.microsoft.com/office/drawing/2014/main" id="{ED244399-B771-41DB-8B0A-5FEB0BF128F1}"/>
               </a:ext>
             </a:extLst>
           </p:cNvPr>
@@ -13292,7 +13695,7 @@
           <p:cNvPr id="3" name="">
             <a:extLst xmlns:a="http://schemas.openxmlformats.org/drawingml/2006/main">
               <a:ext uri="{FF2B5EF4-FFF2-40B4-BE49-F238E27FC236}">
-                <a16:creationId xmlns:a16="http://schemas.microsoft.com/office/drawing/2014/main" id="{79D4DD6A-3AE9-41E1-A539-CDB9C3EDF3EB}"/>
+                <a16:creationId xmlns:a16="http://schemas.microsoft.com/office/drawing/2014/main" id="{65244DB1-8B69-4AD4-A71D-2A3392D06AE6}"/>
               </a:ext>
             </a:extLst>
           </p:cNvPr>
@@ -13448,7 +13851,7 @@
           <p:cNvPr id="4" name="">
             <a:extLst xmlns:a="http://schemas.openxmlformats.org/drawingml/2006/main">
               <a:ext uri="{FF2B5EF4-FFF2-40B4-BE49-F238E27FC236}">
-                <a16:creationId xmlns:a16="http://schemas.microsoft.com/office/drawing/2014/main" id="{091D7DC3-2708-4AAC-BF62-C8A716E2766C}"/>
+                <a16:creationId xmlns:a16="http://schemas.microsoft.com/office/drawing/2014/main" id="{A50C2136-E818-46ED-8886-E34F3474FF7F}"/>
               </a:ext>
             </a:extLst>
           </p:cNvPr>
@@ -13604,7 +14007,7 @@
           <p:cNvPr id="5" name="">
             <a:extLst xmlns:a="http://schemas.openxmlformats.org/drawingml/2006/main">
               <a:ext uri="{FF2B5EF4-FFF2-40B4-BE49-F238E27FC236}">
-                <a16:creationId xmlns:a16="http://schemas.microsoft.com/office/drawing/2014/main" id="{D37F2C71-DFCA-4F63-A67C-47F45F3F742B}"/>
+                <a16:creationId xmlns:a16="http://schemas.microsoft.com/office/drawing/2014/main" id="{E9D5562E-7CD3-4494-BD22-9B6296220610}"/>
               </a:ext>
             </a:extLst>
           </p:cNvPr>
@@ -13614,7 +14017,7 @@
           <p:nvPr/>
         </p:nvPicPr>
         <p:blipFill>
-          <a:blip xmlns:r="http://schemas.openxmlformats.org/officeDocument/2006/relationships" xmlns:a="http://schemas.openxmlformats.org/drawingml/2006/main" r:embed="R4b3ba4d3d1184c07"/>
+          <a:blip xmlns:r="http://schemas.openxmlformats.org/officeDocument/2006/relationships" xmlns:a="http://schemas.openxmlformats.org/drawingml/2006/main" r:embed="R5a553ce6daaf4f1d"/>
           <a:stretch xmlns:a="http://schemas.openxmlformats.org/drawingml/2006/main"/>
         </p:blipFill>
         <p:spPr>
@@ -13627,10 +14030,166 @@
           </a:prstGeom>
         </p:spPr>
       </p:pic>
+      <p:sp>
+        <p:nvSpPr>
+          <p:cNvPr id="6" name="">
+            <a:extLst xmlns:a="http://schemas.openxmlformats.org/drawingml/2006/main">
+              <a:ext uri="{FF2B5EF4-FFF2-40B4-BE49-F238E27FC236}">
+                <a16:creationId xmlns:a16="http://schemas.microsoft.com/office/drawing/2014/main" id="{634A00A3-69E9-484F-B198-4016CEAE46A7}"/>
+              </a:ext>
+            </a:extLst>
+          </p:cNvPr>
+          <p:cNvSpPr>
+            <a:spLocks xmlns:a="http://schemas.openxmlformats.org/drawingml/2006/main" noGrp="1"/>
+          </p:cNvSpPr>
+          <p:nvPr/>
+        </p:nvSpPr>
+        <p:spPr>
+          <a:xfrm xmlns:a="http://schemas.openxmlformats.org/drawingml/2006/main">
+            <a:off x="609600" y="6086475"/>
+            <a:ext cx="10972800" cy="238125"/>
+          </a:xfrm>
+          <a:prstGeom xmlns:a="http://schemas.openxmlformats.org/drawingml/2006/main" prst="rect">
+            <a:avLst/>
+          </a:prstGeom>
+          <a:noFill xmlns:a="http://schemas.openxmlformats.org/drawingml/2006/main"/>
+          <a:ln xmlns:a="http://schemas.openxmlformats.org/drawingml/2006/main" w="0">
+            <a:noFill/>
+          </a:ln>
+        </p:spPr>
+        <p:txBody>
+          <a:bodyPr xmlns:a="http://schemas.openxmlformats.org/drawingml/2006/main" lIns="0" tIns="0" rIns="0" bIns="0"/>
+          <a:lstStyle xmlns:a="http://schemas.openxmlformats.org/drawingml/2006/main">
+            <a:defPPr>
+              <a:defRPr sz="1200" b="0">
+                <a:solidFill>
+                  <a:srgbClr val="536675"/>
+                </a:solidFill>
+                <a:latin typeface="Helvetica Neue"/>
+                <a:ea typeface="Helvetica Neue"/>
+                <a:cs typeface="Helvetica Neue"/>
+              </a:defRPr>
+            </a:defPPr>
+            <a:lvl1pPr>
+              <a:defRPr sz="1200" b="0">
+                <a:solidFill>
+                  <a:srgbClr val="536675"/>
+                </a:solidFill>
+                <a:latin typeface="Helvetica Neue"/>
+                <a:ea typeface="Helvetica Neue"/>
+                <a:cs typeface="Helvetica Neue"/>
+              </a:defRPr>
+            </a:lvl1pPr>
+            <a:lvl2pPr>
+              <a:defRPr sz="1200" b="0">
+                <a:solidFill>
+                  <a:srgbClr val="536675"/>
+                </a:solidFill>
+                <a:latin typeface="Helvetica Neue"/>
+                <a:ea typeface="Helvetica Neue"/>
+                <a:cs typeface="Helvetica Neue"/>
+              </a:defRPr>
+            </a:lvl2pPr>
+            <a:lvl3pPr>
+              <a:defRPr sz="1200" b="0">
+                <a:solidFill>
+                  <a:srgbClr val="536675"/>
+                </a:solidFill>
+                <a:latin typeface="Helvetica Neue"/>
+                <a:ea typeface="Helvetica Neue"/>
+                <a:cs typeface="Helvetica Neue"/>
+              </a:defRPr>
+            </a:lvl3pPr>
+            <a:lvl4pPr>
+              <a:defRPr sz="1200" b="0">
+                <a:solidFill>
+                  <a:srgbClr val="536675"/>
+                </a:solidFill>
+                <a:latin typeface="Helvetica Neue"/>
+                <a:ea typeface="Helvetica Neue"/>
+                <a:cs typeface="Helvetica Neue"/>
+              </a:defRPr>
+            </a:lvl4pPr>
+            <a:lvl5pPr>
+              <a:defRPr sz="1200" b="0">
+                <a:solidFill>
+                  <a:srgbClr val="536675"/>
+                </a:solidFill>
+                <a:latin typeface="Helvetica Neue"/>
+                <a:ea typeface="Helvetica Neue"/>
+                <a:cs typeface="Helvetica Neue"/>
+              </a:defRPr>
+            </a:lvl5pPr>
+            <a:lvl6pPr>
+              <a:defRPr sz="1200" b="0">
+                <a:solidFill>
+                  <a:srgbClr val="536675"/>
+                </a:solidFill>
+                <a:latin typeface="Helvetica Neue"/>
+                <a:ea typeface="Helvetica Neue"/>
+                <a:cs typeface="Helvetica Neue"/>
+              </a:defRPr>
+            </a:lvl6pPr>
+            <a:lvl7pPr>
+              <a:defRPr sz="1200" b="0">
+                <a:solidFill>
+                  <a:srgbClr val="536675"/>
+                </a:solidFill>
+                <a:latin typeface="Helvetica Neue"/>
+                <a:ea typeface="Helvetica Neue"/>
+                <a:cs typeface="Helvetica Neue"/>
+              </a:defRPr>
+            </a:lvl7pPr>
+            <a:lvl8pPr>
+              <a:defRPr sz="1200" b="0">
+                <a:solidFill>
+                  <a:srgbClr val="536675"/>
+                </a:solidFill>
+                <a:latin typeface="Helvetica Neue"/>
+                <a:ea typeface="Helvetica Neue"/>
+                <a:cs typeface="Helvetica Neue"/>
+              </a:defRPr>
+            </a:lvl8pPr>
+            <a:lvl9pPr>
+              <a:defRPr sz="1200" b="0">
+                <a:solidFill>
+                  <a:srgbClr val="536675"/>
+                </a:solidFill>
+                <a:latin typeface="Helvetica Neue"/>
+                <a:ea typeface="Helvetica Neue"/>
+                <a:cs typeface="Helvetica Neue"/>
+              </a:defRPr>
+            </a:lvl9pPr>
+          </a:lstStyle>
+          <a:p xmlns:a="http://schemas.openxmlformats.org/drawingml/2006/main">
+            <a:pPr>
+              <a:defRPr sz="1200" b="0">
+                <a:solidFill>
+                  <a:srgbClr val="536675"/>
+                </a:solidFill>
+                <a:latin typeface="Helvetica Neue"/>
+                <a:ea typeface="Helvetica Neue"/>
+                <a:cs typeface="Helvetica Neue"/>
+              </a:defRPr>
+            </a:pPr>
+            <a:r>
+              <a:rPr sz="1200" b="0">
+                <a:solidFill>
+                  <a:srgbClr val="536675"/>
+                </a:solidFill>
+                <a:latin typeface="Helvetica Neue"/>
+                <a:ea typeface="Helvetica Neue"/>
+                <a:cs typeface="Helvetica Neue"/>
+              </a:rPr>
+              <a:t>Gray: healthy measurement unavailable. The lower band has no embryonic-expression value.</a:t>
+            </a:r>
+          </a:p>
+        </p:txBody>
+      </p:sp>
     </p:spTree>
     <p:extLst>
       <p:ext uri="{BB962C8B-B14F-4D97-AF65-F5344CB8AC3E}">
-        <p14:creationId xmlns:p14="http://schemas.microsoft.com/office/powerpoint/2010/main" val="1219354900"/>
+        <p14:creationId xmlns:p14="http://schemas.microsoft.com/office/powerpoint/2010/main" val="1769854255"/>
       </p:ext>
     </p:extLst>
   </p:cSld>
@@ -13661,7 +14220,7 @@
           <p:cNvPr id="7" name="">
             <a:extLst xmlns:a="http://schemas.openxmlformats.org/drawingml/2006/main">
               <a:ext uri="{FF2B5EF4-FFF2-40B4-BE49-F238E27FC236}">
-                <a16:creationId xmlns:a16="http://schemas.microsoft.com/office/drawing/2014/main" id="{18550CA9-55B1-43E2-88DD-3575637322EF}"/>
+                <a16:creationId xmlns:a16="http://schemas.microsoft.com/office/drawing/2014/main" id="{E2915159-A3BD-4D20-A8E1-8119A52FC88E}"/>
               </a:ext>
             </a:extLst>
           </p:cNvPr>
@@ -13817,7 +14376,7 @@
           <p:cNvPr id="2" name="">
             <a:extLst xmlns:a="http://schemas.openxmlformats.org/drawingml/2006/main">
               <a:ext uri="{FF2B5EF4-FFF2-40B4-BE49-F238E27FC236}">
-                <a16:creationId xmlns:a16="http://schemas.microsoft.com/office/drawing/2014/main" id="{B34EF94A-FA87-40D8-A062-6B71B96034FD}"/>
+                <a16:creationId xmlns:a16="http://schemas.microsoft.com/office/drawing/2014/main" id="{F366D6ED-7975-4701-96AE-314DAC6568DF}"/>
               </a:ext>
             </a:extLst>
           </p:cNvPr>
@@ -13973,7 +14532,7 @@
           <p:cNvPr id="3" name="">
             <a:extLst xmlns:a="http://schemas.openxmlformats.org/drawingml/2006/main">
               <a:ext uri="{FF2B5EF4-FFF2-40B4-BE49-F238E27FC236}">
-                <a16:creationId xmlns:a16="http://schemas.microsoft.com/office/drawing/2014/main" id="{98460FAE-0F4A-4886-BD9E-48388ABE8679}"/>
+                <a16:creationId xmlns:a16="http://schemas.microsoft.com/office/drawing/2014/main" id="{BB362399-5B60-42FD-AEA3-7A1F1E59CD3D}"/>
               </a:ext>
             </a:extLst>
           </p:cNvPr>
@@ -14129,7 +14688,7 @@
           <p:cNvPr id="4" name="">
             <a:extLst xmlns:a="http://schemas.openxmlformats.org/drawingml/2006/main">
               <a:ext uri="{FF2B5EF4-FFF2-40B4-BE49-F238E27FC236}">
-                <a16:creationId xmlns:a16="http://schemas.microsoft.com/office/drawing/2014/main" id="{1868BFA1-85BC-4AB2-B595-3FF1303E8F7C}"/>
+                <a16:creationId xmlns:a16="http://schemas.microsoft.com/office/drawing/2014/main" id="{484B4E23-BCB3-4A7F-BAB7-B8F39AE3735C}"/>
               </a:ext>
             </a:extLst>
           </p:cNvPr>
@@ -14285,7 +14844,7 @@
           <p:cNvPr id="5" name="">
             <a:extLst xmlns:a="http://schemas.openxmlformats.org/drawingml/2006/main">
               <a:ext uri="{FF2B5EF4-FFF2-40B4-BE49-F238E27FC236}">
-                <a16:creationId xmlns:a16="http://schemas.microsoft.com/office/drawing/2014/main" id="{C1631273-59B3-43F4-985E-B5C5CC3F38A3}"/>
+                <a16:creationId xmlns:a16="http://schemas.microsoft.com/office/drawing/2014/main" id="{BE9B5052-EC33-42ED-8AA7-A7F30EE3E35C}"/>
               </a:ext>
             </a:extLst>
           </p:cNvPr>
@@ -15028,7 +15587,7 @@
           <p:cNvPr id="6" name="">
             <a:extLst xmlns:a="http://schemas.openxmlformats.org/drawingml/2006/main">
               <a:ext uri="{FF2B5EF4-FFF2-40B4-BE49-F238E27FC236}">
-                <a16:creationId xmlns:a16="http://schemas.microsoft.com/office/drawing/2014/main" id="{DE31AE62-9E2B-4B8E-A774-399E77526036}"/>
+                <a16:creationId xmlns:a16="http://schemas.microsoft.com/office/drawing/2014/main" id="{26E62C86-36DC-42BF-90D2-F7B3CE9DE3D0}"/>
               </a:ext>
             </a:extLst>
           </p:cNvPr>
@@ -15182,7 +15741,7 @@
     </p:spTree>
     <p:extLst>
       <p:ext uri="{BB962C8B-B14F-4D97-AF65-F5344CB8AC3E}">
-        <p14:creationId xmlns:p14="http://schemas.microsoft.com/office/powerpoint/2010/main" val="221487393"/>
+        <p14:creationId xmlns:p14="http://schemas.microsoft.com/office/powerpoint/2010/main" val="912651980"/>
       </p:ext>
     </p:extLst>
   </p:cSld>
@@ -15213,7 +15772,7 @@
           <p:cNvPr id="6" name="">
             <a:extLst xmlns:a="http://schemas.openxmlformats.org/drawingml/2006/main">
               <a:ext uri="{FF2B5EF4-FFF2-40B4-BE49-F238E27FC236}">
-                <a16:creationId xmlns:a16="http://schemas.microsoft.com/office/drawing/2014/main" id="{85E72D6A-5418-49F7-A490-BA82A4D275EA}"/>
+                <a16:creationId xmlns:a16="http://schemas.microsoft.com/office/drawing/2014/main" id="{ED3B6588-1E28-4451-A7A7-8EA4E143676A}"/>
               </a:ext>
             </a:extLst>
           </p:cNvPr>
@@ -15369,7 +15928,7 @@
           <p:cNvPr id="2" name="">
             <a:extLst xmlns:a="http://schemas.openxmlformats.org/drawingml/2006/main">
               <a:ext uri="{FF2B5EF4-FFF2-40B4-BE49-F238E27FC236}">
-                <a16:creationId xmlns:a16="http://schemas.microsoft.com/office/drawing/2014/main" id="{0FAA53C3-2DD7-49F4-8416-F4E3585CF0D7}"/>
+                <a16:creationId xmlns:a16="http://schemas.microsoft.com/office/drawing/2014/main" id="{C16019FE-C6B4-42E7-994A-089CA85D2D55}"/>
               </a:ext>
             </a:extLst>
           </p:cNvPr>
@@ -15525,7 +16084,7 @@
           <p:cNvPr id="3" name="">
             <a:extLst xmlns:a="http://schemas.openxmlformats.org/drawingml/2006/main">
               <a:ext uri="{FF2B5EF4-FFF2-40B4-BE49-F238E27FC236}">
-                <a16:creationId xmlns:a16="http://schemas.microsoft.com/office/drawing/2014/main" id="{AFA42334-38A9-4488-A893-3332C69F3D81}"/>
+                <a16:creationId xmlns:a16="http://schemas.microsoft.com/office/drawing/2014/main" id="{A86E3F0A-1372-4920-8F62-0B5BBF21B7CA}"/>
               </a:ext>
             </a:extLst>
           </p:cNvPr>
@@ -15681,7 +16240,7 @@
           <p:cNvPr id="4" name="">
             <a:extLst xmlns:a="http://schemas.openxmlformats.org/drawingml/2006/main">
               <a:ext uri="{FF2B5EF4-FFF2-40B4-BE49-F238E27FC236}">
-                <a16:creationId xmlns:a16="http://schemas.microsoft.com/office/drawing/2014/main" id="{73E0FD3E-9C83-4A7F-95A2-EE4469803D1D}"/>
+                <a16:creationId xmlns:a16="http://schemas.microsoft.com/office/drawing/2014/main" id="{7ACC744D-4E33-4751-B9C7-F3A0449C6A2F}"/>
               </a:ext>
             </a:extLst>
           </p:cNvPr>
@@ -15837,7 +16396,7 @@
           <p:cNvPr id="5" name="">
             <a:extLst xmlns:a="http://schemas.openxmlformats.org/drawingml/2006/main">
               <a:ext uri="{FF2B5EF4-FFF2-40B4-BE49-F238E27FC236}">
-                <a16:creationId xmlns:a16="http://schemas.microsoft.com/office/drawing/2014/main" id="{1C468250-4B58-4885-A520-6F8DCE444327}"/>
+                <a16:creationId xmlns:a16="http://schemas.microsoft.com/office/drawing/2014/main" id="{BA21E3A8-F83F-447D-B3E9-5F0FD7DC3FC0}"/>
               </a:ext>
             </a:extLst>
           </p:cNvPr>
@@ -15847,7 +16406,7 @@
           <p:nvPr/>
         </p:nvPicPr>
         <p:blipFill>
-          <a:blip xmlns:r="http://schemas.openxmlformats.org/officeDocument/2006/relationships" xmlns:a="http://schemas.openxmlformats.org/drawingml/2006/main" r:embed="Rc09b96d6ac934c04"/>
+          <a:blip xmlns:r="http://schemas.openxmlformats.org/officeDocument/2006/relationships" xmlns:a="http://schemas.openxmlformats.org/drawingml/2006/main" r:embed="R777a4d3e6e224aff"/>
           <a:stretch xmlns:a="http://schemas.openxmlformats.org/drawingml/2006/main"/>
         </p:blipFill>
         <p:spPr>
@@ -15863,7 +16422,7 @@
     </p:spTree>
     <p:extLst>
       <p:ext uri="{BB962C8B-B14F-4D97-AF65-F5344CB8AC3E}">
-        <p14:creationId xmlns:p14="http://schemas.microsoft.com/office/powerpoint/2010/main" val="381168038"/>
+        <p14:creationId xmlns:p14="http://schemas.microsoft.com/office/powerpoint/2010/main" val="1574642692"/>
       </p:ext>
     </p:extLst>
   </p:cSld>
@@ -15894,7 +16453,7 @@
           <p:cNvPr id="6" name="">
             <a:extLst xmlns:a="http://schemas.openxmlformats.org/drawingml/2006/main">
               <a:ext uri="{FF2B5EF4-FFF2-40B4-BE49-F238E27FC236}">
-                <a16:creationId xmlns:a16="http://schemas.microsoft.com/office/drawing/2014/main" id="{DC0F710F-407D-473F-B7F4-BE0A7A3DC2C6}"/>
+                <a16:creationId xmlns:a16="http://schemas.microsoft.com/office/drawing/2014/main" id="{AA44431C-DE0C-4418-A71F-BDC99CCE0002}"/>
               </a:ext>
             </a:extLst>
           </p:cNvPr>
@@ -16050,7 +16609,7 @@
           <p:cNvPr id="2" name="">
             <a:extLst xmlns:a="http://schemas.openxmlformats.org/drawingml/2006/main">
               <a:ext uri="{FF2B5EF4-FFF2-40B4-BE49-F238E27FC236}">
-                <a16:creationId xmlns:a16="http://schemas.microsoft.com/office/drawing/2014/main" id="{28AB7C10-925A-497A-B721-A9D7E33CC455}"/>
+                <a16:creationId xmlns:a16="http://schemas.microsoft.com/office/drawing/2014/main" id="{02E6ABB6-B062-46CF-94A0-D39507F815EB}"/>
               </a:ext>
             </a:extLst>
           </p:cNvPr>
@@ -16206,7 +16765,7 @@
           <p:cNvPr id="3" name="">
             <a:extLst xmlns:a="http://schemas.openxmlformats.org/drawingml/2006/main">
               <a:ext uri="{FF2B5EF4-FFF2-40B4-BE49-F238E27FC236}">
-                <a16:creationId xmlns:a16="http://schemas.microsoft.com/office/drawing/2014/main" id="{39A6D2DC-5E71-469B-B3D6-686C894A264A}"/>
+                <a16:creationId xmlns:a16="http://schemas.microsoft.com/office/drawing/2014/main" id="{0BA7D412-3E1E-4DB9-9DFA-8E173FDEE2BA}"/>
               </a:ext>
             </a:extLst>
           </p:cNvPr>
@@ -16362,7 +16921,7 @@
           <p:cNvPr id="4" name="">
             <a:extLst xmlns:a="http://schemas.openxmlformats.org/drawingml/2006/main">
               <a:ext uri="{FF2B5EF4-FFF2-40B4-BE49-F238E27FC236}">
-                <a16:creationId xmlns:a16="http://schemas.microsoft.com/office/drawing/2014/main" id="{BD296183-3D2F-4576-AAD2-0620B0382CE0}"/>
+                <a16:creationId xmlns:a16="http://schemas.microsoft.com/office/drawing/2014/main" id="{9E274A00-CD3C-4998-B101-496AF1EA10E0}"/>
               </a:ext>
             </a:extLst>
           </p:cNvPr>
@@ -16518,7 +17077,7 @@
           <p:cNvPr id="5" name="">
             <a:extLst xmlns:a="http://schemas.openxmlformats.org/drawingml/2006/main">
               <a:ext uri="{FF2B5EF4-FFF2-40B4-BE49-F238E27FC236}">
-                <a16:creationId xmlns:a16="http://schemas.microsoft.com/office/drawing/2014/main" id="{D7B68617-1D5F-41F8-A15A-B42FBE2E35AC}"/>
+                <a16:creationId xmlns:a16="http://schemas.microsoft.com/office/drawing/2014/main" id="{8AC86A67-8372-45F1-82F2-A910B08B003A}"/>
               </a:ext>
             </a:extLst>
           </p:cNvPr>
@@ -16528,7 +17087,7 @@
           <p:nvPr/>
         </p:nvPicPr>
         <p:blipFill>
-          <a:blip xmlns:r="http://schemas.openxmlformats.org/officeDocument/2006/relationships" xmlns:a="http://schemas.openxmlformats.org/drawingml/2006/main" r:embed="Rd1ded80d06a543e0"/>
+          <a:blip xmlns:r="http://schemas.openxmlformats.org/officeDocument/2006/relationships" xmlns:a="http://schemas.openxmlformats.org/drawingml/2006/main" r:embed="R044275a9b5a64f55"/>
           <a:stretch xmlns:a="http://schemas.openxmlformats.org/drawingml/2006/main"/>
         </p:blipFill>
         <p:spPr>
@@ -16544,7 +17103,7 @@
     </p:spTree>
     <p:extLst>
       <p:ext uri="{BB962C8B-B14F-4D97-AF65-F5344CB8AC3E}">
-        <p14:creationId xmlns:p14="http://schemas.microsoft.com/office/powerpoint/2010/main" val="845857875"/>
+        <p14:creationId xmlns:p14="http://schemas.microsoft.com/office/powerpoint/2010/main" val="535188968"/>
       </p:ext>
     </p:extLst>
   </p:cSld>
@@ -16575,7 +17134,7 @@
           <p:cNvPr id="7" name="">
             <a:extLst xmlns:a="http://schemas.openxmlformats.org/drawingml/2006/main">
               <a:ext uri="{FF2B5EF4-FFF2-40B4-BE49-F238E27FC236}">
-                <a16:creationId xmlns:a16="http://schemas.microsoft.com/office/drawing/2014/main" id="{A7E5AAEB-E645-4356-AA8E-D76146EE4A38}"/>
+                <a16:creationId xmlns:a16="http://schemas.microsoft.com/office/drawing/2014/main" id="{658FA574-B812-4E92-AD8A-9A5C09DDB7D6}"/>
               </a:ext>
             </a:extLst>
           </p:cNvPr>
@@ -16731,7 +17290,7 @@
           <p:cNvPr id="2" name="">
             <a:extLst xmlns:a="http://schemas.openxmlformats.org/drawingml/2006/main">
               <a:ext uri="{FF2B5EF4-FFF2-40B4-BE49-F238E27FC236}">
-                <a16:creationId xmlns:a16="http://schemas.microsoft.com/office/drawing/2014/main" id="{9F0D036C-D0B2-4190-B72F-3ED787D06EA0}"/>
+                <a16:creationId xmlns:a16="http://schemas.microsoft.com/office/drawing/2014/main" id="{36A9D16A-C327-4CF2-B259-FA5BB3F87BEA}"/>
               </a:ext>
             </a:extLst>
           </p:cNvPr>
@@ -16887,7 +17446,7 @@
           <p:cNvPr id="3" name="">
             <a:extLst xmlns:a="http://schemas.openxmlformats.org/drawingml/2006/main">
               <a:ext uri="{FF2B5EF4-FFF2-40B4-BE49-F238E27FC236}">
-                <a16:creationId xmlns:a16="http://schemas.microsoft.com/office/drawing/2014/main" id="{448FA0FC-2084-4219-91F6-295692E8509E}"/>
+                <a16:creationId xmlns:a16="http://schemas.microsoft.com/office/drawing/2014/main" id="{BA74AB4B-93A9-409C-9AB5-871192B5CB34}"/>
               </a:ext>
             </a:extLst>
           </p:cNvPr>
@@ -17043,7 +17602,7 @@
           <p:cNvPr id="4" name="">
             <a:extLst xmlns:a="http://schemas.openxmlformats.org/drawingml/2006/main">
               <a:ext uri="{FF2B5EF4-FFF2-40B4-BE49-F238E27FC236}">
-                <a16:creationId xmlns:a16="http://schemas.microsoft.com/office/drawing/2014/main" id="{346769F5-A554-4A0A-81F7-A9C8860A9B1B}"/>
+                <a16:creationId xmlns:a16="http://schemas.microsoft.com/office/drawing/2014/main" id="{A43D118F-139E-4D0A-AC46-BF244E1C7170}"/>
               </a:ext>
             </a:extLst>
           </p:cNvPr>
@@ -17199,7 +17758,7 @@
           <p:cNvPr id="5" name="">
             <a:extLst xmlns:a="http://schemas.openxmlformats.org/drawingml/2006/main">
               <a:ext uri="{FF2B5EF4-FFF2-40B4-BE49-F238E27FC236}">
-                <a16:creationId xmlns:a16="http://schemas.microsoft.com/office/drawing/2014/main" id="{A2258E60-18DB-4A5B-9527-B908BBAC2D20}"/>
+                <a16:creationId xmlns:a16="http://schemas.microsoft.com/office/drawing/2014/main" id="{1A90243F-2AFB-4538-AB32-13233D9559CC}"/>
               </a:ext>
             </a:extLst>
           </p:cNvPr>
@@ -17562,7 +18121,7 @@
                           <a:ea typeface="Helvetica Neue"/>
                           <a:cs typeface="Helvetica Neue"/>
                         </a:rPr>
-                        <a:t>1,329</a:t>
+                        <a:t>1,325</a:t>
                       </a:r>
                     </a:p>
                   </a:txBody>
@@ -17678,7 +18237,7 @@
                           <a:ea typeface="Helvetica Neue"/>
                           <a:cs typeface="Helvetica Neue"/>
                         </a:rPr>
-                        <a:t>333</a:t>
+                        <a:t>337</a:t>
                       </a:r>
                     </a:p>
                   </a:txBody>
@@ -17826,7 +18385,7 @@
           <p:cNvPr id="6" name="">
             <a:extLst xmlns:a="http://schemas.openxmlformats.org/drawingml/2006/main">
               <a:ext uri="{FF2B5EF4-FFF2-40B4-BE49-F238E27FC236}">
-                <a16:creationId xmlns:a16="http://schemas.microsoft.com/office/drawing/2014/main" id="{FE21338E-5D15-49BE-8522-C2FA3214CF7E}"/>
+                <a16:creationId xmlns:a16="http://schemas.microsoft.com/office/drawing/2014/main" id="{B548BD3E-1960-4D2D-B3EB-1BA9B5047D17}"/>
               </a:ext>
             </a:extLst>
           </p:cNvPr>
@@ -17980,7 +18539,7 @@
     </p:spTree>
     <p:extLst>
       <p:ext uri="{BB962C8B-B14F-4D97-AF65-F5344CB8AC3E}">
-        <p14:creationId xmlns:p14="http://schemas.microsoft.com/office/powerpoint/2010/main" val="30976330"/>
+        <p14:creationId xmlns:p14="http://schemas.microsoft.com/office/powerpoint/2010/main" val="579894721"/>
       </p:ext>
     </p:extLst>
   </p:cSld>
@@ -18011,7 +18570,7 @@
           <p:cNvPr id="7" name="">
             <a:extLst xmlns:a="http://schemas.openxmlformats.org/drawingml/2006/main">
               <a:ext uri="{FF2B5EF4-FFF2-40B4-BE49-F238E27FC236}">
-                <a16:creationId xmlns:a16="http://schemas.microsoft.com/office/drawing/2014/main" id="{330AFFF2-9359-4365-A115-D04718584DCE}"/>
+                <a16:creationId xmlns:a16="http://schemas.microsoft.com/office/drawing/2014/main" id="{02208BF7-96DD-4AEE-91CC-F69D626BA4D2}"/>
               </a:ext>
             </a:extLst>
           </p:cNvPr>
@@ -18157,7 +18716,7 @@
                 <a:ea typeface="Helvetica Neue"/>
                 <a:cs typeface="Helvetica Neue"/>
               </a:rPr>
-              <a:t>SPECIES-SPECIFIC EVIDENCE</a:t>
+              <a:t>COVERAGE AUDIT</a:t>
             </a:r>
           </a:p>
         </p:txBody>
@@ -18167,7 +18726,7 @@
           <p:cNvPr id="2" name="">
             <a:extLst xmlns:a="http://schemas.openxmlformats.org/drawingml/2006/main">
               <a:ext uri="{FF2B5EF4-FFF2-40B4-BE49-F238E27FC236}">
-                <a16:creationId xmlns:a16="http://schemas.microsoft.com/office/drawing/2014/main" id="{C88D8098-5AFF-45D9-8507-3DA921D959AF}"/>
+                <a16:creationId xmlns:a16="http://schemas.microsoft.com/office/drawing/2014/main" id="{2E4BCD0D-A603-4392-A289-ACCC830DEA66}"/>
               </a:ext>
             </a:extLst>
           </p:cNvPr>
@@ -18313,7 +18872,7 @@
                 <a:ea typeface="Helvetica Neue"/>
                 <a:cs typeface="Helvetica Neue"/>
               </a:rPr>
-              <a:t>Dog evidence and integration gaps</a:t>
+              <a:t>Which sources have incomplete evidence</a:t>
             </a:r>
           </a:p>
         </p:txBody>
@@ -18323,7 +18882,7 @@
           <p:cNvPr id="3" name="">
             <a:extLst xmlns:a="http://schemas.openxmlformats.org/drawingml/2006/main">
               <a:ext uri="{FF2B5EF4-FFF2-40B4-BE49-F238E27FC236}">
-                <a16:creationId xmlns:a16="http://schemas.microsoft.com/office/drawing/2014/main" id="{483E3C05-1D89-46F0-9951-F67E25572729}"/>
+                <a16:creationId xmlns:a16="http://schemas.microsoft.com/office/drawing/2014/main" id="{D6360032-E2EE-4E5C-8171-9D15CCBCEF28}"/>
               </a:ext>
             </a:extLst>
           </p:cNvPr>
@@ -18479,7 +19038,7 @@
           <p:cNvPr id="4" name="">
             <a:extLst xmlns:a="http://schemas.openxmlformats.org/drawingml/2006/main">
               <a:ext uri="{FF2B5EF4-FFF2-40B4-BE49-F238E27FC236}">
-                <a16:creationId xmlns:a16="http://schemas.microsoft.com/office/drawing/2014/main" id="{5F08ACA3-FE7E-487B-9641-0FE284CF4C8D}"/>
+                <a16:creationId xmlns:a16="http://schemas.microsoft.com/office/drawing/2014/main" id="{E226544B-3BAB-432F-B41D-233890B602AC}"/>
               </a:ext>
             </a:extLst>
           </p:cNvPr>
@@ -18635,7 +19194,7 @@
           <p:cNvPr id="5" name="">
             <a:extLst xmlns:a="http://schemas.openxmlformats.org/drawingml/2006/main">
               <a:ext uri="{FF2B5EF4-FFF2-40B4-BE49-F238E27FC236}">
-                <a16:creationId xmlns:a16="http://schemas.microsoft.com/office/drawing/2014/main" id="{A8DF3386-F74F-4262-822E-483EED1C6339}"/>
+                <a16:creationId xmlns:a16="http://schemas.microsoft.com/office/drawing/2014/main" id="{7756196A-70CD-45E3-BA23-311234F9518E}"/>
               </a:ext>
             </a:extLst>
           </p:cNvPr>
@@ -18644,24 +19203,24 @@
         </p:nvGraphicFramePr>
         <p:xfrm>
           <a:off xmlns:a="http://schemas.openxmlformats.org/drawingml/2006/main" x="609600" y="1619250"/>
-          <a:ext xmlns:a="http://schemas.openxmlformats.org/drawingml/2006/main" cx="10972800" cy="3714750"/>
+          <a:ext xmlns:a="http://schemas.openxmlformats.org/drawingml/2006/main" cx="10972800" cy="3762375"/>
         </p:xfrm>
         <a:graphic xmlns:a="http://schemas.openxmlformats.org/drawingml/2006/main">
           <a:graphicData uri="http://schemas.openxmlformats.org/drawingml/2006/table">
             <a:tbl>
               <a:tblPr/>
               <a:tblGrid>
-                <a:gridCol w="2762250"/>
-                <a:gridCol w="8210550"/>
+                <a:gridCol w="9239250"/>
+                <a:gridCol w="1733550"/>
               </a:tblGrid>
-              <a:tr h="530679">
+              <a:tr h="418042">
                 <a:tc>
                   <a:txBody>
                     <a:bodyPr/>
                     <a:lstStyle/>
                     <a:p>
                       <a:r>
-                        <a:rPr sz="1800" b="1">
+                        <a:rPr sz="1650" b="1">
                           <a:solidFill>
                             <a:srgbClr val="FFFFFF"/>
                           </a:solidFill>
@@ -18669,7 +19228,7 @@
                           <a:ea typeface="Helvetica Neue"/>
                           <a:cs typeface="Helvetica Neue"/>
                         </a:rPr>
-                        <a:t>Layer</a:t>
+                        <a:t>Source or unresolved evidence</a:t>
                       </a:r>
                     </a:p>
                   </a:txBody>
@@ -18709,7 +19268,7 @@
                     <a:lstStyle/>
                     <a:p>
                       <a:r>
-                        <a:rPr sz="1800" b="1">
+                        <a:rPr sz="1650" b="1">
                           <a:solidFill>
                             <a:srgbClr val="FFFFFF"/>
                           </a:solidFill>
@@ -18717,7 +19276,7 @@
                           <a:ea typeface="Helvetica Neue"/>
                           <a:cs typeface="Helvetica Neue"/>
                         </a:rPr>
-                        <a:t>Available evidence / remaining gap</a:t>
+                        <a:t>Groups</a:t>
                       </a:r>
                     </a:p>
                   </a:txBody>
@@ -18746,14 +19305,14 @@
                   </a:tcPr>
                 </a:tc>
               </a:tr>
-              <a:tr h="530679">
+              <a:tr h="418042">
                 <a:tc>
                   <a:txBody>
                     <a:bodyPr/>
                     <a:lstStyle/>
                     <a:p>
                       <a:r>
-                        <a:rPr sz="1800" b="1">
+                        <a:rPr sz="1650" b="1">
                           <a:solidFill>
                             <a:srgbClr val="173B55"/>
                           </a:solidFill>
@@ -18761,7 +19320,7 @@
                           <a:ea typeface="Helvetica Neue"/>
                           <a:cs typeface="Helvetica Neue"/>
                         </a:rPr>
-                        <a:t>Nominations</a:t>
+                        <a:t>HPA v23 consensus bulk</a:t>
                       </a:r>
                     </a:p>
                   </a:txBody>
@@ -18795,7 +19354,7 @@
                     <a:lstStyle/>
                     <a:p>
                       <a:r>
-                        <a:rPr sz="1800" b="0">
+                        <a:rPr sz="1650" b="0">
                           <a:solidFill>
                             <a:srgbClr val="173B55"/>
                           </a:solidFill>
@@ -18803,7 +19362,7 @@
                           <a:ea typeface="Helvetica Neue"/>
                           <a:cs typeface="Helvetica Neue"/>
                         </a:rPr>
-                        <a:t>5 + 10 − 1 shared = 14 native nominations</a:t>
+                        <a:t>574</a:t>
                       </a:r>
                     </a:p>
                   </a:txBody>
@@ -18826,14 +19385,14 @@
                   </a:tcPr>
                 </a:tc>
               </a:tr>
-              <a:tr h="530679">
+              <a:tr h="418042">
                 <a:tc>
                   <a:txBody>
                     <a:bodyPr/>
                     <a:lstStyle/>
                     <a:p>
                       <a:r>
-                        <a:rPr sz="1800" b="1">
+                        <a:rPr sz="1650" b="1">
                           <a:solidFill>
                             <a:srgbClr val="173B55"/>
                           </a:solidFill>
@@ -18841,7 +19400,7 @@
                           <a:ea typeface="Helvetica Neue"/>
                           <a:cs typeface="Helvetica Neue"/>
                         </a:rPr>
-                        <a:t>Identity</a:t>
+                        <a:t>HPA v23 tissue-cell clusters</a:t>
                       </a:r>
                     </a:p>
                   </a:txBody>
@@ -18875,7 +19434,7 @@
                     <a:lstStyle/>
                     <a:p>
                       <a:r>
-                        <a:rPr sz="1800" b="0">
+                        <a:rPr sz="1650" b="0">
                           <a:solidFill>
                             <a:srgbClr val="173B55"/>
                           </a:solidFill>
@@ -18883,7 +19442,7 @@
                           <a:ea typeface="Helvetica Neue"/>
                           <a:cs typeface="Helvetica Neue"/>
                         </a:rPr>
-                        <a:t>13 unique mappings; one ambiguous MAGE-family assay</a:t>
+                        <a:t>352</a:t>
                       </a:r>
                     </a:p>
                   </a:txBody>
@@ -18906,14 +19465,14 @@
                   </a:tcPr>
                 </a:tc>
               </a:tr>
-              <a:tr h="530679">
+              <a:tr h="418042">
                 <a:tc>
                   <a:txBody>
                     <a:bodyPr/>
                     <a:lstStyle/>
                     <a:p>
                       <a:r>
-                        <a:rPr sz="1800" b="1">
+                        <a:rPr sz="1650" b="1">
                           <a:solidFill>
                             <a:srgbClr val="173B55"/>
                           </a:solidFill>
@@ -18921,7 +19480,7 @@
                           <a:ea typeface="Helvetica Neue"/>
                           <a:cs typeface="Helvetica Neue"/>
                         </a:rPr>
-                        <a:t>Normal / developmental RNA</a:t>
+                        <a:t>HPA v23 immune cells</a:t>
                       </a:r>
                     </a:p>
                   </a:txBody>
@@ -18955,7 +19514,7 @@
                     <a:lstStyle/>
                     <a:p>
                       <a:r>
-                        <a:rPr sz="1800" b="0">
+                        <a:rPr sz="1650" b="0">
                           <a:solidFill>
                             <a:srgbClr val="173B55"/>
                           </a:solidFill>
@@ -18963,7 +19522,7 @@
                           <a:ea typeface="Helvetica Neue"/>
                           <a:cs typeface="Helvetica Neue"/>
                         </a:rPr>
-                        <a:t>Bgee TPM and BarkBase TMM-CPM need reference reconciliation</a:t>
+                        <a:t>312</a:t>
                       </a:r>
                     </a:p>
                   </a:txBody>
@@ -18986,14 +19545,14 @@
                   </a:tcPr>
                 </a:tc>
               </a:tr>
-              <a:tr h="530679">
+              <a:tr h="418042">
                 <a:tc>
                   <a:txBody>
                     <a:bodyPr/>
                     <a:lstStyle/>
                     <a:p>
                       <a:r>
-                        <a:rPr sz="1800" b="1">
+                        <a:rPr sz="1650" b="1">
                           <a:solidFill>
                             <a:srgbClr val="173B55"/>
                           </a:solidFill>
@@ -19001,7 +19560,7 @@
                           <a:ea typeface="Helvetica Neue"/>
                           <a:cs typeface="Helvetica Neue"/>
                         </a:rPr>
-                        <a:t>Tumor RNA</a:t>
+                        <a:t>Monaco immune cells via HPA v23</a:t>
                       </a:r>
                     </a:p>
                   </a:txBody>
@@ -19035,7 +19594,7 @@
                     <a:lstStyle/>
                     <a:p>
                       <a:r>
-                        <a:rPr sz="1800" b="0">
+                        <a:rPr sz="1650" b="0">
                           <a:solidFill>
                             <a:srgbClr val="173B55"/>
                           </a:solidFill>
@@ -19043,7 +19602,7 @@
                           <a:ea typeface="Helvetica Neue"/>
                           <a:cs typeface="Helvetica Neue"/>
                         </a:rPr>
-                        <a:t>GSE304066 count/FPKM and reference conflicts remain unresolved</a:t>
+                        <a:t>312</a:t>
                       </a:r>
                     </a:p>
                   </a:txBody>
@@ -19066,14 +19625,14 @@
                   </a:tcPr>
                 </a:tc>
               </a:tr>
-              <a:tr h="530679">
+              <a:tr h="418042">
                 <a:tc>
                   <a:txBody>
                     <a:bodyPr/>
                     <a:lstStyle/>
                     <a:p>
                       <a:r>
-                        <a:rPr sz="1800" b="1">
+                        <a:rPr sz="1650" b="1">
                           <a:solidFill>
                             <a:srgbClr val="173B55"/>
                           </a:solidFill>
@@ -19081,7 +19640,7 @@
                           <a:ea typeface="Helvetica Neue"/>
                           <a:cs typeface="Helvetica Neue"/>
                         </a:rPr>
-                        <a:t>Normal protein</a:t>
+                        <a:t>Tyser E-MTAB-9388 filtered TPM</a:t>
                       </a:r>
                     </a:p>
                   </a:txBody>
@@ -19115,7 +19674,7 @@
                     <a:lstStyle/>
                     <a:p>
                       <a:r>
-                        <a:rPr sz="1800" b="0">
+                        <a:rPr sz="1650" b="0">
                           <a:solidFill>
                             <a:srgbClr val="173B55"/>
                           </a:solidFill>
@@ -19123,7 +19682,7 @@
                           <a:ea typeface="Helvetica Neue"/>
                           <a:cs typeface="Helvetica Neue"/>
                         </a:rPr>
-                        <a:t>Limited study IHC; Pfizer pooled iBAQ is not cell-resolved IHC</a:t>
+                        <a:t>1006</a:t>
                       </a:r>
                     </a:p>
                   </a:txBody>
@@ -19146,14 +19705,14 @@
                   </a:tcPr>
                 </a:tc>
               </a:tr>
-              <a:tr h="530679">
+              <a:tr h="418042">
                 <a:tc>
                   <a:txBody>
                     <a:bodyPr/>
                     <a:lstStyle/>
                     <a:p>
                       <a:r>
-                        <a:rPr sz="1800" b="1">
+                        <a:rPr sz="1650" b="1">
                           <a:solidFill>
                             <a:srgbClr val="173B55"/>
                           </a:solidFill>
@@ -19161,7 +19720,7 @@
                           <a:ea typeface="Helvetica Neue"/>
                           <a:cs typeface="Helvetica Neue"/>
                         </a:rPr>
-                        <a:t>Selection</a:t>
+                        <a:t>No tumor measurement: OncoRef + HPA</a:t>
                       </a:r>
                     </a:p>
                   </a:txBody>
@@ -19195,7 +19754,7 @@
                     <a:lstStyle/>
                     <a:p>
                       <a:r>
-                        <a:rPr sz="1800" b="0">
+                        <a:rPr sz="1650" b="0">
                           <a:solidFill>
                             <a:srgbClr val="173B55"/>
                           </a:solidFill>
@@ -19203,7 +19762,167 @@
                           <a:ea typeface="Helvetica Neue"/>
                           <a:cs typeface="Helvetica Neue"/>
                         </a:rPr>
-                        <a:t>All 14 unassigned / unassessed; no canine quantitative policy</a:t>
+                        <a:t>37</a:t>
+                      </a:r>
+                    </a:p>
+                  </a:txBody>
+                  <a:tcPr marL="95250" marR="95250" marT="19050" marB="19050">
+                    <a:lnR w="4763">
+                      <a:solidFill>
+                        <a:srgbClr val="D9E2E8"/>
+                      </a:solidFill>
+                      <a:prstDash val="solid"/>
+                    </a:lnR>
+                    <a:lnB w="4763">
+                      <a:solidFill>
+                        <a:srgbClr val="D9E2E8"/>
+                      </a:solidFill>
+                      <a:prstDash val="solid"/>
+                    </a:lnB>
+                    <a:solidFill>
+                      <a:srgbClr val="F3F6F8"/>
+                    </a:solidFill>
+                  </a:tcPr>
+                </a:tc>
+              </a:tr>
+              <a:tr h="418042">
+                <a:tc>
+                  <a:txBody>
+                    <a:bodyPr/>
+                    <a:lstStyle/>
+                    <a:p>
+                      <a:r>
+                        <a:rPr sz="1650" b="1">
+                          <a:solidFill>
+                            <a:srgbClr val="173B55"/>
+                          </a:solidFill>
+                          <a:latin typeface="Helvetica Neue"/>
+                          <a:ea typeface="Helvetica Neue"/>
+                          <a:cs typeface="Helvetica Neue"/>
+                        </a:rPr>
+                        <a:t>Measured tumor, incomplete group profile</a:t>
+                      </a:r>
+                    </a:p>
+                  </a:txBody>
+                  <a:tcPr marL="95250" marR="95250" marT="19050" marB="19050">
+                    <a:lnL w="4763">
+                      <a:solidFill>
+                        <a:srgbClr val="D9E2E8"/>
+                      </a:solidFill>
+                      <a:prstDash val="solid"/>
+                    </a:lnL>
+                    <a:lnR w="4763">
+                      <a:solidFill>
+                        <a:srgbClr val="D9E2E8"/>
+                      </a:solidFill>
+                      <a:prstDash val="solid"/>
+                    </a:lnR>
+                    <a:lnB w="4763">
+                      <a:solidFill>
+                        <a:srgbClr val="D9E2E8"/>
+                      </a:solidFill>
+                      <a:prstDash val="solid"/>
+                    </a:lnB>
+                    <a:solidFill>
+                      <a:srgbClr val="FFFFFF"/>
+                    </a:solidFill>
+                  </a:tcPr>
+                </a:tc>
+                <a:tc>
+                  <a:txBody>
+                    <a:bodyPr/>
+                    <a:lstStyle/>
+                    <a:p>
+                      <a:r>
+                        <a:rPr sz="1650" b="0">
+                          <a:solidFill>
+                            <a:srgbClr val="173B55"/>
+                          </a:solidFill>
+                          <a:latin typeface="Helvetica Neue"/>
+                          <a:ea typeface="Helvetica Neue"/>
+                          <a:cs typeface="Helvetica Neue"/>
+                        </a:rPr>
+                        <a:t>30</a:t>
+                      </a:r>
+                    </a:p>
+                  </a:txBody>
+                  <a:tcPr marL="95250" marR="95250" marT="19050" marB="19050">
+                    <a:lnR w="4763">
+                      <a:solidFill>
+                        <a:srgbClr val="D9E2E8"/>
+                      </a:solidFill>
+                      <a:prstDash val="solid"/>
+                    </a:lnR>
+                    <a:lnB w="4763">
+                      <a:solidFill>
+                        <a:srgbClr val="D9E2E8"/>
+                      </a:solidFill>
+                      <a:prstDash val="solid"/>
+                    </a:lnB>
+                    <a:solidFill>
+                      <a:srgbClr val="FFFFFF"/>
+                    </a:solidFill>
+                  </a:tcPr>
+                </a:tc>
+              </a:tr>
+              <a:tr h="418042">
+                <a:tc>
+                  <a:txBody>
+                    <a:bodyPr/>
+                    <a:lstStyle/>
+                    <a:p>
+                      <a:r>
+                        <a:rPr sz="1650" b="1">
+                          <a:solidFill>
+                            <a:srgbClr val="173B55"/>
+                          </a:solidFill>
+                          <a:latin typeface="Helvetica Neue"/>
+                          <a:ea typeface="Helvetica Neue"/>
+                          <a:cs typeface="Helvetica Neue"/>
+                        </a:rPr>
+                        <a:t>HPA v23 Uncertain normal-tissue IHC</a:t>
+                      </a:r>
+                    </a:p>
+                  </a:txBody>
+                  <a:tcPr marL="95250" marR="95250" marT="19050" marB="19050">
+                    <a:lnL w="4763">
+                      <a:solidFill>
+                        <a:srgbClr val="D9E2E8"/>
+                      </a:solidFill>
+                      <a:prstDash val="solid"/>
+                    </a:lnL>
+                    <a:lnR w="4763">
+                      <a:solidFill>
+                        <a:srgbClr val="D9E2E8"/>
+                      </a:solidFill>
+                      <a:prstDash val="solid"/>
+                    </a:lnR>
+                    <a:lnB w="4763">
+                      <a:solidFill>
+                        <a:srgbClr val="D9E2E8"/>
+                      </a:solidFill>
+                      <a:prstDash val="solid"/>
+                    </a:lnB>
+                    <a:solidFill>
+                      <a:srgbClr val="F3F6F8"/>
+                    </a:solidFill>
+                  </a:tcPr>
+                </a:tc>
+                <a:tc>
+                  <a:txBody>
+                    <a:bodyPr/>
+                    <a:lstStyle/>
+                    <a:p>
+                      <a:r>
+                        <a:rPr sz="1650" b="0">
+                          <a:solidFill>
+                            <a:srgbClr val="173B55"/>
+                          </a:solidFill>
+                          <a:latin typeface="Helvetica Neue"/>
+                          <a:ea typeface="Helvetica Neue"/>
+                          <a:cs typeface="Helvetica Neue"/>
+                        </a:rPr>
+                        <a:t>33</a:t>
                       </a:r>
                     </a:p>
                   </a:txBody>
@@ -19235,7 +19954,7 @@
           <p:cNvPr id="6" name="">
             <a:extLst xmlns:a="http://schemas.openxmlformats.org/drawingml/2006/main">
               <a:ext uri="{FF2B5EF4-FFF2-40B4-BE49-F238E27FC236}">
-                <a16:creationId xmlns:a16="http://schemas.microsoft.com/office/drawing/2014/main" id="{632890CC-0093-4F63-B037-468C3BC5113F}"/>
+                <a16:creationId xmlns:a16="http://schemas.microsoft.com/office/drawing/2014/main" id="{291411A1-6834-47B3-828A-1D46BF3F703B}"/>
               </a:ext>
             </a:extLst>
           </p:cNvPr>
@@ -19246,7 +19965,7 @@
         </p:nvSpPr>
         <p:spPr>
           <a:xfrm xmlns:a="http://schemas.openxmlformats.org/drawingml/2006/main">
-            <a:off x="609600" y="5762625"/>
+            <a:off x="609600" y="5715000"/>
             <a:ext cx="10972800" cy="590550"/>
           </a:xfrm>
           <a:prstGeom xmlns:a="http://schemas.openxmlformats.org/drawingml/2006/main" prst="rect">
@@ -19381,7 +20100,7 @@
                 <a:ea typeface="Helvetica Neue"/>
                 <a:cs typeface="Helvetica Neue"/>
               </a:rPr>
-              <a:t>Human thresholds, antibody grades and normal-tissue absence never transfer by orthology.</a:t>
+              <a:t>Overlapping gaps within 1,325 unassigned groups. DICE and corneal coverage are optional.</a:t>
             </a:r>
           </a:p>
         </p:txBody>
@@ -19389,7 +20108,7 @@
     </p:spTree>
     <p:extLst>
       <p:ext uri="{BB962C8B-B14F-4D97-AF65-F5344CB8AC3E}">
-        <p14:creationId xmlns:p14="http://schemas.microsoft.com/office/powerpoint/2010/main" val="862848513"/>
+        <p14:creationId xmlns:p14="http://schemas.microsoft.com/office/powerpoint/2010/main" val="146145387"/>
       </p:ext>
     </p:extLst>
   </p:cSld>
@@ -19420,7 +20139,7 @@
           <p:cNvPr id="7" name="">
             <a:extLst xmlns:a="http://schemas.openxmlformats.org/drawingml/2006/main">
               <a:ext uri="{FF2B5EF4-FFF2-40B4-BE49-F238E27FC236}">
-                <a16:creationId xmlns:a16="http://schemas.microsoft.com/office/drawing/2014/main" id="{EE26A8C4-A2C3-4DAA-B2E0-68D2EB7A8002}"/>
+                <a16:creationId xmlns:a16="http://schemas.microsoft.com/office/drawing/2014/main" id="{F7099BC8-DD7E-4B60-A79C-5A58393FBCC3}"/>
               </a:ext>
             </a:extLst>
           </p:cNvPr>
@@ -19576,7 +20295,7 @@
           <p:cNvPr id="2" name="">
             <a:extLst xmlns:a="http://schemas.openxmlformats.org/drawingml/2006/main">
               <a:ext uri="{FF2B5EF4-FFF2-40B4-BE49-F238E27FC236}">
-                <a16:creationId xmlns:a16="http://schemas.microsoft.com/office/drawing/2014/main" id="{B1B29AB9-31AB-4F22-88E8-59C0445111D4}"/>
+                <a16:creationId xmlns:a16="http://schemas.microsoft.com/office/drawing/2014/main" id="{5195156E-2DDB-4D03-81B0-0B4B782893C5}"/>
               </a:ext>
             </a:extLst>
           </p:cNvPr>
@@ -19732,7 +20451,7 @@
           <p:cNvPr id="3" name="">
             <a:extLst xmlns:a="http://schemas.openxmlformats.org/drawingml/2006/main">
               <a:ext uri="{FF2B5EF4-FFF2-40B4-BE49-F238E27FC236}">
-                <a16:creationId xmlns:a16="http://schemas.microsoft.com/office/drawing/2014/main" id="{5E0EA9AD-9459-4748-A914-CA3AACA22515}"/>
+                <a16:creationId xmlns:a16="http://schemas.microsoft.com/office/drawing/2014/main" id="{F0BDC9EB-0D1E-4583-ADF9-6573A62A7AD9}"/>
               </a:ext>
             </a:extLst>
           </p:cNvPr>
@@ -19888,7 +20607,7 @@
           <p:cNvPr id="4" name="">
             <a:extLst xmlns:a="http://schemas.openxmlformats.org/drawingml/2006/main">
               <a:ext uri="{FF2B5EF4-FFF2-40B4-BE49-F238E27FC236}">
-                <a16:creationId xmlns:a16="http://schemas.microsoft.com/office/drawing/2014/main" id="{A8A49727-EF49-4F6B-B34C-E23F890E6A0B}"/>
+                <a16:creationId xmlns:a16="http://schemas.microsoft.com/office/drawing/2014/main" id="{02D61C90-4298-470B-8BBC-67C88589377E}"/>
               </a:ext>
             </a:extLst>
           </p:cNvPr>
@@ -20044,7 +20763,7 @@
           <p:cNvPr id="5" name="">
             <a:extLst xmlns:a="http://schemas.openxmlformats.org/drawingml/2006/main">
               <a:ext uri="{FF2B5EF4-FFF2-40B4-BE49-F238E27FC236}">
-                <a16:creationId xmlns:a16="http://schemas.microsoft.com/office/drawing/2014/main" id="{31E46558-A241-4CDB-B189-8B211E9ACCAB}"/>
+                <a16:creationId xmlns:a16="http://schemas.microsoft.com/office/drawing/2014/main" id="{9EA25F8B-A11C-447D-B4E0-DBC5CACA73D0}"/>
               </a:ext>
             </a:extLst>
           </p:cNvPr>
@@ -23248,7 +23967,7 @@
           <p:cNvPr id="6" name="">
             <a:extLst xmlns:a="http://schemas.openxmlformats.org/drawingml/2006/main">
               <a:ext uri="{FF2B5EF4-FFF2-40B4-BE49-F238E27FC236}">
-                <a16:creationId xmlns:a16="http://schemas.microsoft.com/office/drawing/2014/main" id="{9B6DBDF2-0416-45E5-90B0-0B50EC54CC22}"/>
+                <a16:creationId xmlns:a16="http://schemas.microsoft.com/office/drawing/2014/main" id="{859F8A9B-1D6B-4114-97B8-1E2094823A21}"/>
               </a:ext>
             </a:extLst>
           </p:cNvPr>
@@ -23402,7 +24121,7 @@
     </p:spTree>
     <p:extLst>
       <p:ext uri="{BB962C8B-B14F-4D97-AF65-F5344CB8AC3E}">
-        <p14:creationId xmlns:p14="http://schemas.microsoft.com/office/powerpoint/2010/main" val="1937502134"/>
+        <p14:creationId xmlns:p14="http://schemas.microsoft.com/office/powerpoint/2010/main" val="1788212212"/>
       </p:ext>
     </p:extLst>
   </p:cSld>
@@ -23433,7 +24152,7 @@
           <p:cNvPr id="7" name="">
             <a:extLst xmlns:a="http://schemas.openxmlformats.org/drawingml/2006/main">
               <a:ext uri="{FF2B5EF4-FFF2-40B4-BE49-F238E27FC236}">
-                <a16:creationId xmlns:a16="http://schemas.microsoft.com/office/drawing/2014/main" id="{0BD2AF7A-F721-4C3C-9035-F346B0FB843B}"/>
+                <a16:creationId xmlns:a16="http://schemas.microsoft.com/office/drawing/2014/main" id="{EB595ACF-2FD4-4B80-B515-C3C58B8BF71E}"/>
               </a:ext>
             </a:extLst>
           </p:cNvPr>
@@ -23579,7 +24298,7 @@
                 <a:ea typeface="Helvetica Neue"/>
                 <a:cs typeface="Helvetica Neue"/>
               </a:rPr>
-              <a:t>DEVELOPMENTAL NOMINATIONS</a:t>
+              <a:t>SPECIES-SPECIFIC EVIDENCE</a:t>
             </a:r>
           </a:p>
         </p:txBody>
@@ -23589,7 +24308,7 @@
           <p:cNvPr id="2" name="">
             <a:extLst xmlns:a="http://schemas.openxmlformats.org/drawingml/2006/main">
               <a:ext uri="{FF2B5EF4-FFF2-40B4-BE49-F238E27FC236}">
-                <a16:creationId xmlns:a16="http://schemas.microsoft.com/office/drawing/2014/main" id="{73D34498-5929-4396-9F55-A9A9DEE4AA8F}"/>
+                <a16:creationId xmlns:a16="http://schemas.microsoft.com/office/drawing/2014/main" id="{77FA9234-614B-4D7E-880A-E54FA7BA008D}"/>
               </a:ext>
             </a:extLst>
           </p:cNvPr>
@@ -23735,7 +24454,7 @@
                 <a:ea typeface="Helvetica Neue"/>
                 <a:cs typeface="Helvetica Neue"/>
               </a:rPr>
-              <a:t>Curated oncofetal sources</a:t>
+              <a:t>Dog evidence and integration gaps</a:t>
             </a:r>
           </a:p>
         </p:txBody>
@@ -23745,7 +24464,7 @@
           <p:cNvPr id="3" name="">
             <a:extLst xmlns:a="http://schemas.openxmlformats.org/drawingml/2006/main">
               <a:ext uri="{FF2B5EF4-FFF2-40B4-BE49-F238E27FC236}">
-                <a16:creationId xmlns:a16="http://schemas.microsoft.com/office/drawing/2014/main" id="{B2DD9ED9-E8A3-4212-BD9A-E4F704B3633F}"/>
+                <a16:creationId xmlns:a16="http://schemas.microsoft.com/office/drawing/2014/main" id="{16B54BE2-E2C7-4E5D-B688-960D2DBA4989}"/>
               </a:ext>
             </a:extLst>
           </p:cNvPr>
@@ -23901,7 +24620,7 @@
           <p:cNvPr id="4" name="">
             <a:extLst xmlns:a="http://schemas.openxmlformats.org/drawingml/2006/main">
               <a:ext uri="{FF2B5EF4-FFF2-40B4-BE49-F238E27FC236}">
-                <a16:creationId xmlns:a16="http://schemas.microsoft.com/office/drawing/2014/main" id="{DBEEBBE5-2BC6-4AC1-8F6E-E3C1B6BFA85F}"/>
+                <a16:creationId xmlns:a16="http://schemas.microsoft.com/office/drawing/2014/main" id="{6234CFD8-CA0F-4320-AA01-F772508A08A9}"/>
               </a:ext>
             </a:extLst>
           </p:cNvPr>
@@ -24057,7 +24776,1416 @@
           <p:cNvPr id="5" name="">
             <a:extLst xmlns:a="http://schemas.openxmlformats.org/drawingml/2006/main">
               <a:ext uri="{FF2B5EF4-FFF2-40B4-BE49-F238E27FC236}">
-                <a16:creationId xmlns:a16="http://schemas.microsoft.com/office/drawing/2014/main" id="{687146C4-9984-4838-970F-531037D84251}"/>
+                <a16:creationId xmlns:a16="http://schemas.microsoft.com/office/drawing/2014/main" id="{17670DE5-6845-4FE6-ACB3-BC6B159598DE}"/>
+              </a:ext>
+            </a:extLst>
+          </p:cNvPr>
+          <p:cNvGraphicFramePr/>
+          <p:nvPr/>
+        </p:nvGraphicFramePr>
+        <p:xfrm>
+          <a:off xmlns:a="http://schemas.openxmlformats.org/drawingml/2006/main" x="609600" y="1619250"/>
+          <a:ext xmlns:a="http://schemas.openxmlformats.org/drawingml/2006/main" cx="10972800" cy="3714750"/>
+        </p:xfrm>
+        <a:graphic xmlns:a="http://schemas.openxmlformats.org/drawingml/2006/main">
+          <a:graphicData uri="http://schemas.openxmlformats.org/drawingml/2006/table">
+            <a:tbl>
+              <a:tblPr/>
+              <a:tblGrid>
+                <a:gridCol w="2762250"/>
+                <a:gridCol w="8210550"/>
+              </a:tblGrid>
+              <a:tr h="530679">
+                <a:tc>
+                  <a:txBody>
+                    <a:bodyPr/>
+                    <a:lstStyle/>
+                    <a:p>
+                      <a:r>
+                        <a:rPr sz="1800" b="1">
+                          <a:solidFill>
+                            <a:srgbClr val="FFFFFF"/>
+                          </a:solidFill>
+                          <a:latin typeface="Helvetica Neue"/>
+                          <a:ea typeface="Helvetica Neue"/>
+                          <a:cs typeface="Helvetica Neue"/>
+                        </a:rPr>
+                        <a:t>Layer</a:t>
+                      </a:r>
+                    </a:p>
+                  </a:txBody>
+                  <a:tcPr marL="95250" marR="95250" marT="19050" marB="19050">
+                    <a:lnL w="4763">
+                      <a:solidFill>
+                        <a:srgbClr val="D9E2E8"/>
+                      </a:solidFill>
+                      <a:prstDash val="solid"/>
+                    </a:lnL>
+                    <a:lnR w="4763">
+                      <a:solidFill>
+                        <a:srgbClr val="D9E2E8"/>
+                      </a:solidFill>
+                      <a:prstDash val="solid"/>
+                    </a:lnR>
+                    <a:lnT w="4763">
+                      <a:solidFill>
+                        <a:srgbClr val="D9E2E8"/>
+                      </a:solidFill>
+                      <a:prstDash val="solid"/>
+                    </a:lnT>
+                    <a:lnB w="4763">
+                      <a:solidFill>
+                        <a:srgbClr val="D9E2E8"/>
+                      </a:solidFill>
+                      <a:prstDash val="solid"/>
+                    </a:lnB>
+                    <a:solidFill>
+                      <a:srgbClr val="173B55"/>
+                    </a:solidFill>
+                  </a:tcPr>
+                </a:tc>
+                <a:tc>
+                  <a:txBody>
+                    <a:bodyPr/>
+                    <a:lstStyle/>
+                    <a:p>
+                      <a:r>
+                        <a:rPr sz="1800" b="1">
+                          <a:solidFill>
+                            <a:srgbClr val="FFFFFF"/>
+                          </a:solidFill>
+                          <a:latin typeface="Helvetica Neue"/>
+                          <a:ea typeface="Helvetica Neue"/>
+                          <a:cs typeface="Helvetica Neue"/>
+                        </a:rPr>
+                        <a:t>Available evidence / remaining gap</a:t>
+                      </a:r>
+                    </a:p>
+                  </a:txBody>
+                  <a:tcPr marL="95250" marR="95250" marT="19050" marB="19050">
+                    <a:lnR w="4763">
+                      <a:solidFill>
+                        <a:srgbClr val="D9E2E8"/>
+                      </a:solidFill>
+                      <a:prstDash val="solid"/>
+                    </a:lnR>
+                    <a:lnT w="4763">
+                      <a:solidFill>
+                        <a:srgbClr val="D9E2E8"/>
+                      </a:solidFill>
+                      <a:prstDash val="solid"/>
+                    </a:lnT>
+                    <a:lnB w="4763">
+                      <a:solidFill>
+                        <a:srgbClr val="D9E2E8"/>
+                      </a:solidFill>
+                      <a:prstDash val="solid"/>
+                    </a:lnB>
+                    <a:solidFill>
+                      <a:srgbClr val="173B55"/>
+                    </a:solidFill>
+                  </a:tcPr>
+                </a:tc>
+              </a:tr>
+              <a:tr h="530679">
+                <a:tc>
+                  <a:txBody>
+                    <a:bodyPr/>
+                    <a:lstStyle/>
+                    <a:p>
+                      <a:r>
+                        <a:rPr sz="1800" b="1">
+                          <a:solidFill>
+                            <a:srgbClr val="173B55"/>
+                          </a:solidFill>
+                          <a:latin typeface="Helvetica Neue"/>
+                          <a:ea typeface="Helvetica Neue"/>
+                          <a:cs typeface="Helvetica Neue"/>
+                        </a:rPr>
+                        <a:t>Nominations</a:t>
+                      </a:r>
+                    </a:p>
+                  </a:txBody>
+                  <a:tcPr marL="95250" marR="95250" marT="19050" marB="19050">
+                    <a:lnL w="4763">
+                      <a:solidFill>
+                        <a:srgbClr val="D9E2E8"/>
+                      </a:solidFill>
+                      <a:prstDash val="solid"/>
+                    </a:lnL>
+                    <a:lnR w="4763">
+                      <a:solidFill>
+                        <a:srgbClr val="D9E2E8"/>
+                      </a:solidFill>
+                      <a:prstDash val="solid"/>
+                    </a:lnR>
+                    <a:lnB w="4763">
+                      <a:solidFill>
+                        <a:srgbClr val="D9E2E8"/>
+                      </a:solidFill>
+                      <a:prstDash val="solid"/>
+                    </a:lnB>
+                    <a:solidFill>
+                      <a:srgbClr val="FFFFFF"/>
+                    </a:solidFill>
+                  </a:tcPr>
+                </a:tc>
+                <a:tc>
+                  <a:txBody>
+                    <a:bodyPr/>
+                    <a:lstStyle/>
+                    <a:p>
+                      <a:r>
+                        <a:rPr sz="1800" b="0">
+                          <a:solidFill>
+                            <a:srgbClr val="173B55"/>
+                          </a:solidFill>
+                          <a:latin typeface="Helvetica Neue"/>
+                          <a:ea typeface="Helvetica Neue"/>
+                          <a:cs typeface="Helvetica Neue"/>
+                        </a:rPr>
+                        <a:t>5 + 10 − 1 shared = 14 native nominations</a:t>
+                      </a:r>
+                    </a:p>
+                  </a:txBody>
+                  <a:tcPr marL="95250" marR="95250" marT="19050" marB="19050">
+                    <a:lnR w="4763">
+                      <a:solidFill>
+                        <a:srgbClr val="D9E2E8"/>
+                      </a:solidFill>
+                      <a:prstDash val="solid"/>
+                    </a:lnR>
+                    <a:lnB w="4763">
+                      <a:solidFill>
+                        <a:srgbClr val="D9E2E8"/>
+                      </a:solidFill>
+                      <a:prstDash val="solid"/>
+                    </a:lnB>
+                    <a:solidFill>
+                      <a:srgbClr val="FFFFFF"/>
+                    </a:solidFill>
+                  </a:tcPr>
+                </a:tc>
+              </a:tr>
+              <a:tr h="530679">
+                <a:tc>
+                  <a:txBody>
+                    <a:bodyPr/>
+                    <a:lstStyle/>
+                    <a:p>
+                      <a:r>
+                        <a:rPr sz="1800" b="1">
+                          <a:solidFill>
+                            <a:srgbClr val="173B55"/>
+                          </a:solidFill>
+                          <a:latin typeface="Helvetica Neue"/>
+                          <a:ea typeface="Helvetica Neue"/>
+                          <a:cs typeface="Helvetica Neue"/>
+                        </a:rPr>
+                        <a:t>Identity</a:t>
+                      </a:r>
+                    </a:p>
+                  </a:txBody>
+                  <a:tcPr marL="95250" marR="95250" marT="19050" marB="19050">
+                    <a:lnL w="4763">
+                      <a:solidFill>
+                        <a:srgbClr val="D9E2E8"/>
+                      </a:solidFill>
+                      <a:prstDash val="solid"/>
+                    </a:lnL>
+                    <a:lnR w="4763">
+                      <a:solidFill>
+                        <a:srgbClr val="D9E2E8"/>
+                      </a:solidFill>
+                      <a:prstDash val="solid"/>
+                    </a:lnR>
+                    <a:lnB w="4763">
+                      <a:solidFill>
+                        <a:srgbClr val="D9E2E8"/>
+                      </a:solidFill>
+                      <a:prstDash val="solid"/>
+                    </a:lnB>
+                    <a:solidFill>
+                      <a:srgbClr val="F3F6F8"/>
+                    </a:solidFill>
+                  </a:tcPr>
+                </a:tc>
+                <a:tc>
+                  <a:txBody>
+                    <a:bodyPr/>
+                    <a:lstStyle/>
+                    <a:p>
+                      <a:r>
+                        <a:rPr sz="1800" b="0">
+                          <a:solidFill>
+                            <a:srgbClr val="173B55"/>
+                          </a:solidFill>
+                          <a:latin typeface="Helvetica Neue"/>
+                          <a:ea typeface="Helvetica Neue"/>
+                          <a:cs typeface="Helvetica Neue"/>
+                        </a:rPr>
+                        <a:t>13 unique mappings; one ambiguous MAGE-family assay</a:t>
+                      </a:r>
+                    </a:p>
+                  </a:txBody>
+                  <a:tcPr marL="95250" marR="95250" marT="19050" marB="19050">
+                    <a:lnR w="4763">
+                      <a:solidFill>
+                        <a:srgbClr val="D9E2E8"/>
+                      </a:solidFill>
+                      <a:prstDash val="solid"/>
+                    </a:lnR>
+                    <a:lnB w="4763">
+                      <a:solidFill>
+                        <a:srgbClr val="D9E2E8"/>
+                      </a:solidFill>
+                      <a:prstDash val="solid"/>
+                    </a:lnB>
+                    <a:solidFill>
+                      <a:srgbClr val="F3F6F8"/>
+                    </a:solidFill>
+                  </a:tcPr>
+                </a:tc>
+              </a:tr>
+              <a:tr h="530679">
+                <a:tc>
+                  <a:txBody>
+                    <a:bodyPr/>
+                    <a:lstStyle/>
+                    <a:p>
+                      <a:r>
+                        <a:rPr sz="1800" b="1">
+                          <a:solidFill>
+                            <a:srgbClr val="173B55"/>
+                          </a:solidFill>
+                          <a:latin typeface="Helvetica Neue"/>
+                          <a:ea typeface="Helvetica Neue"/>
+                          <a:cs typeface="Helvetica Neue"/>
+                        </a:rPr>
+                        <a:t>Normal / developmental RNA</a:t>
+                      </a:r>
+                    </a:p>
+                  </a:txBody>
+                  <a:tcPr marL="95250" marR="95250" marT="19050" marB="19050">
+                    <a:lnL w="4763">
+                      <a:solidFill>
+                        <a:srgbClr val="D9E2E8"/>
+                      </a:solidFill>
+                      <a:prstDash val="solid"/>
+                    </a:lnL>
+                    <a:lnR w="4763">
+                      <a:solidFill>
+                        <a:srgbClr val="D9E2E8"/>
+                      </a:solidFill>
+                      <a:prstDash val="solid"/>
+                    </a:lnR>
+                    <a:lnB w="4763">
+                      <a:solidFill>
+                        <a:srgbClr val="D9E2E8"/>
+                      </a:solidFill>
+                      <a:prstDash val="solid"/>
+                    </a:lnB>
+                    <a:solidFill>
+                      <a:srgbClr val="FFFFFF"/>
+                    </a:solidFill>
+                  </a:tcPr>
+                </a:tc>
+                <a:tc>
+                  <a:txBody>
+                    <a:bodyPr/>
+                    <a:lstStyle/>
+                    <a:p>
+                      <a:r>
+                        <a:rPr sz="1800" b="0">
+                          <a:solidFill>
+                            <a:srgbClr val="173B55"/>
+                          </a:solidFill>
+                          <a:latin typeface="Helvetica Neue"/>
+                          <a:ea typeface="Helvetica Neue"/>
+                          <a:cs typeface="Helvetica Neue"/>
+                        </a:rPr>
+                        <a:t>Bgee TPM and BarkBase TMM-CPM need reference reconciliation</a:t>
+                      </a:r>
+                    </a:p>
+                  </a:txBody>
+                  <a:tcPr marL="95250" marR="95250" marT="19050" marB="19050">
+                    <a:lnR w="4763">
+                      <a:solidFill>
+                        <a:srgbClr val="D9E2E8"/>
+                      </a:solidFill>
+                      <a:prstDash val="solid"/>
+                    </a:lnR>
+                    <a:lnB w="4763">
+                      <a:solidFill>
+                        <a:srgbClr val="D9E2E8"/>
+                      </a:solidFill>
+                      <a:prstDash val="solid"/>
+                    </a:lnB>
+                    <a:solidFill>
+                      <a:srgbClr val="FFFFFF"/>
+                    </a:solidFill>
+                  </a:tcPr>
+                </a:tc>
+              </a:tr>
+              <a:tr h="530679">
+                <a:tc>
+                  <a:txBody>
+                    <a:bodyPr/>
+                    <a:lstStyle/>
+                    <a:p>
+                      <a:r>
+                        <a:rPr sz="1800" b="1">
+                          <a:solidFill>
+                            <a:srgbClr val="173B55"/>
+                          </a:solidFill>
+                          <a:latin typeface="Helvetica Neue"/>
+                          <a:ea typeface="Helvetica Neue"/>
+                          <a:cs typeface="Helvetica Neue"/>
+                        </a:rPr>
+                        <a:t>Tumor RNA</a:t>
+                      </a:r>
+                    </a:p>
+                  </a:txBody>
+                  <a:tcPr marL="95250" marR="95250" marT="19050" marB="19050">
+                    <a:lnL w="4763">
+                      <a:solidFill>
+                        <a:srgbClr val="D9E2E8"/>
+                      </a:solidFill>
+                      <a:prstDash val="solid"/>
+                    </a:lnL>
+                    <a:lnR w="4763">
+                      <a:solidFill>
+                        <a:srgbClr val="D9E2E8"/>
+                      </a:solidFill>
+                      <a:prstDash val="solid"/>
+                    </a:lnR>
+                    <a:lnB w="4763">
+                      <a:solidFill>
+                        <a:srgbClr val="D9E2E8"/>
+                      </a:solidFill>
+                      <a:prstDash val="solid"/>
+                    </a:lnB>
+                    <a:solidFill>
+                      <a:srgbClr val="F3F6F8"/>
+                    </a:solidFill>
+                  </a:tcPr>
+                </a:tc>
+                <a:tc>
+                  <a:txBody>
+                    <a:bodyPr/>
+                    <a:lstStyle/>
+                    <a:p>
+                      <a:r>
+                        <a:rPr sz="1800" b="0">
+                          <a:solidFill>
+                            <a:srgbClr val="173B55"/>
+                          </a:solidFill>
+                          <a:latin typeface="Helvetica Neue"/>
+                          <a:ea typeface="Helvetica Neue"/>
+                          <a:cs typeface="Helvetica Neue"/>
+                        </a:rPr>
+                        <a:t>GSE304066 count/FPKM and reference conflicts remain unresolved</a:t>
+                      </a:r>
+                    </a:p>
+                  </a:txBody>
+                  <a:tcPr marL="95250" marR="95250" marT="19050" marB="19050">
+                    <a:lnR w="4763">
+                      <a:solidFill>
+                        <a:srgbClr val="D9E2E8"/>
+                      </a:solidFill>
+                      <a:prstDash val="solid"/>
+                    </a:lnR>
+                    <a:lnB w="4763">
+                      <a:solidFill>
+                        <a:srgbClr val="D9E2E8"/>
+                      </a:solidFill>
+                      <a:prstDash val="solid"/>
+                    </a:lnB>
+                    <a:solidFill>
+                      <a:srgbClr val="F3F6F8"/>
+                    </a:solidFill>
+                  </a:tcPr>
+                </a:tc>
+              </a:tr>
+              <a:tr h="530679">
+                <a:tc>
+                  <a:txBody>
+                    <a:bodyPr/>
+                    <a:lstStyle/>
+                    <a:p>
+                      <a:r>
+                        <a:rPr sz="1800" b="1">
+                          <a:solidFill>
+                            <a:srgbClr val="173B55"/>
+                          </a:solidFill>
+                          <a:latin typeface="Helvetica Neue"/>
+                          <a:ea typeface="Helvetica Neue"/>
+                          <a:cs typeface="Helvetica Neue"/>
+                        </a:rPr>
+                        <a:t>Normal protein</a:t>
+                      </a:r>
+                    </a:p>
+                  </a:txBody>
+                  <a:tcPr marL="95250" marR="95250" marT="19050" marB="19050">
+                    <a:lnL w="4763">
+                      <a:solidFill>
+                        <a:srgbClr val="D9E2E8"/>
+                      </a:solidFill>
+                      <a:prstDash val="solid"/>
+                    </a:lnL>
+                    <a:lnR w="4763">
+                      <a:solidFill>
+                        <a:srgbClr val="D9E2E8"/>
+                      </a:solidFill>
+                      <a:prstDash val="solid"/>
+                    </a:lnR>
+                    <a:lnB w="4763">
+                      <a:solidFill>
+                        <a:srgbClr val="D9E2E8"/>
+                      </a:solidFill>
+                      <a:prstDash val="solid"/>
+                    </a:lnB>
+                    <a:solidFill>
+                      <a:srgbClr val="FFFFFF"/>
+                    </a:solidFill>
+                  </a:tcPr>
+                </a:tc>
+                <a:tc>
+                  <a:txBody>
+                    <a:bodyPr/>
+                    <a:lstStyle/>
+                    <a:p>
+                      <a:r>
+                        <a:rPr sz="1800" b="0">
+                          <a:solidFill>
+                            <a:srgbClr val="173B55"/>
+                          </a:solidFill>
+                          <a:latin typeface="Helvetica Neue"/>
+                          <a:ea typeface="Helvetica Neue"/>
+                          <a:cs typeface="Helvetica Neue"/>
+                        </a:rPr>
+                        <a:t>Limited study IHC; Pfizer pooled iBAQ is not cell-resolved IHC</a:t>
+                      </a:r>
+                    </a:p>
+                  </a:txBody>
+                  <a:tcPr marL="95250" marR="95250" marT="19050" marB="19050">
+                    <a:lnR w="4763">
+                      <a:solidFill>
+                        <a:srgbClr val="D9E2E8"/>
+                      </a:solidFill>
+                      <a:prstDash val="solid"/>
+                    </a:lnR>
+                    <a:lnB w="4763">
+                      <a:solidFill>
+                        <a:srgbClr val="D9E2E8"/>
+                      </a:solidFill>
+                      <a:prstDash val="solid"/>
+                    </a:lnB>
+                    <a:solidFill>
+                      <a:srgbClr val="FFFFFF"/>
+                    </a:solidFill>
+                  </a:tcPr>
+                </a:tc>
+              </a:tr>
+              <a:tr h="530679">
+                <a:tc>
+                  <a:txBody>
+                    <a:bodyPr/>
+                    <a:lstStyle/>
+                    <a:p>
+                      <a:r>
+                        <a:rPr sz="1800" b="1">
+                          <a:solidFill>
+                            <a:srgbClr val="173B55"/>
+                          </a:solidFill>
+                          <a:latin typeface="Helvetica Neue"/>
+                          <a:ea typeface="Helvetica Neue"/>
+                          <a:cs typeface="Helvetica Neue"/>
+                        </a:rPr>
+                        <a:t>Selection</a:t>
+                      </a:r>
+                    </a:p>
+                  </a:txBody>
+                  <a:tcPr marL="95250" marR="95250" marT="19050" marB="19050">
+                    <a:lnL w="4763">
+                      <a:solidFill>
+                        <a:srgbClr val="D9E2E8"/>
+                      </a:solidFill>
+                      <a:prstDash val="solid"/>
+                    </a:lnL>
+                    <a:lnR w="4763">
+                      <a:solidFill>
+                        <a:srgbClr val="D9E2E8"/>
+                      </a:solidFill>
+                      <a:prstDash val="solid"/>
+                    </a:lnR>
+                    <a:lnB w="4763">
+                      <a:solidFill>
+                        <a:srgbClr val="D9E2E8"/>
+                      </a:solidFill>
+                      <a:prstDash val="solid"/>
+                    </a:lnB>
+                    <a:solidFill>
+                      <a:srgbClr val="F3F6F8"/>
+                    </a:solidFill>
+                  </a:tcPr>
+                </a:tc>
+                <a:tc>
+                  <a:txBody>
+                    <a:bodyPr/>
+                    <a:lstStyle/>
+                    <a:p>
+                      <a:r>
+                        <a:rPr sz="1800" b="0">
+                          <a:solidFill>
+                            <a:srgbClr val="173B55"/>
+                          </a:solidFill>
+                          <a:latin typeface="Helvetica Neue"/>
+                          <a:ea typeface="Helvetica Neue"/>
+                          <a:cs typeface="Helvetica Neue"/>
+                        </a:rPr>
+                        <a:t>All 14 unassigned / unassessed; no canine quantitative policy</a:t>
+                      </a:r>
+                    </a:p>
+                  </a:txBody>
+                  <a:tcPr marL="95250" marR="95250" marT="19050" marB="19050">
+                    <a:lnR w="4763">
+                      <a:solidFill>
+                        <a:srgbClr val="D9E2E8"/>
+                      </a:solidFill>
+                      <a:prstDash val="solid"/>
+                    </a:lnR>
+                    <a:lnB w="4763">
+                      <a:solidFill>
+                        <a:srgbClr val="D9E2E8"/>
+                      </a:solidFill>
+                      <a:prstDash val="solid"/>
+                    </a:lnB>
+                    <a:solidFill>
+                      <a:srgbClr val="F3F6F8"/>
+                    </a:solidFill>
+                  </a:tcPr>
+                </a:tc>
+              </a:tr>
+            </a:tbl>
+          </a:graphicData>
+        </a:graphic>
+      </p:graphicFrame>
+      <p:sp>
+        <p:nvSpPr>
+          <p:cNvPr id="6" name="">
+            <a:extLst xmlns:a="http://schemas.openxmlformats.org/drawingml/2006/main">
+              <a:ext uri="{FF2B5EF4-FFF2-40B4-BE49-F238E27FC236}">
+                <a16:creationId xmlns:a16="http://schemas.microsoft.com/office/drawing/2014/main" id="{7D9D9D22-A086-4DB7-9A0C-EE5FDD74C92B}"/>
+              </a:ext>
+            </a:extLst>
+          </p:cNvPr>
+          <p:cNvSpPr>
+            <a:spLocks xmlns:a="http://schemas.openxmlformats.org/drawingml/2006/main" noGrp="1"/>
+          </p:cNvSpPr>
+          <p:nvPr/>
+        </p:nvSpPr>
+        <p:spPr>
+          <a:xfrm xmlns:a="http://schemas.openxmlformats.org/drawingml/2006/main">
+            <a:off x="609600" y="5762625"/>
+            <a:ext cx="10972800" cy="590550"/>
+          </a:xfrm>
+          <a:prstGeom xmlns:a="http://schemas.openxmlformats.org/drawingml/2006/main" prst="rect">
+            <a:avLst/>
+          </a:prstGeom>
+          <a:noFill xmlns:a="http://schemas.openxmlformats.org/drawingml/2006/main"/>
+          <a:ln xmlns:a="http://schemas.openxmlformats.org/drawingml/2006/main" w="0">
+            <a:noFill/>
+          </a:ln>
+        </p:spPr>
+        <p:txBody>
+          <a:bodyPr xmlns:a="http://schemas.openxmlformats.org/drawingml/2006/main" lIns="0" tIns="0" rIns="0" bIns="0"/>
+          <a:lstStyle xmlns:a="http://schemas.openxmlformats.org/drawingml/2006/main">
+            <a:defPPr>
+              <a:defRPr sz="1800" b="0">
+                <a:solidFill>
+                  <a:srgbClr val="536675"/>
+                </a:solidFill>
+                <a:latin typeface="Helvetica Neue"/>
+                <a:ea typeface="Helvetica Neue"/>
+                <a:cs typeface="Helvetica Neue"/>
+              </a:defRPr>
+            </a:defPPr>
+            <a:lvl1pPr>
+              <a:defRPr sz="1800" b="0">
+                <a:solidFill>
+                  <a:srgbClr val="536675"/>
+                </a:solidFill>
+                <a:latin typeface="Helvetica Neue"/>
+                <a:ea typeface="Helvetica Neue"/>
+                <a:cs typeface="Helvetica Neue"/>
+              </a:defRPr>
+            </a:lvl1pPr>
+            <a:lvl2pPr>
+              <a:defRPr sz="1800" b="0">
+                <a:solidFill>
+                  <a:srgbClr val="536675"/>
+                </a:solidFill>
+                <a:latin typeface="Helvetica Neue"/>
+                <a:ea typeface="Helvetica Neue"/>
+                <a:cs typeface="Helvetica Neue"/>
+              </a:defRPr>
+            </a:lvl2pPr>
+            <a:lvl3pPr>
+              <a:defRPr sz="1800" b="0">
+                <a:solidFill>
+                  <a:srgbClr val="536675"/>
+                </a:solidFill>
+                <a:latin typeface="Helvetica Neue"/>
+                <a:ea typeface="Helvetica Neue"/>
+                <a:cs typeface="Helvetica Neue"/>
+              </a:defRPr>
+            </a:lvl3pPr>
+            <a:lvl4pPr>
+              <a:defRPr sz="1800" b="0">
+                <a:solidFill>
+                  <a:srgbClr val="536675"/>
+                </a:solidFill>
+                <a:latin typeface="Helvetica Neue"/>
+                <a:ea typeface="Helvetica Neue"/>
+                <a:cs typeface="Helvetica Neue"/>
+              </a:defRPr>
+            </a:lvl4pPr>
+            <a:lvl5pPr>
+              <a:defRPr sz="1800" b="0">
+                <a:solidFill>
+                  <a:srgbClr val="536675"/>
+                </a:solidFill>
+                <a:latin typeface="Helvetica Neue"/>
+                <a:ea typeface="Helvetica Neue"/>
+                <a:cs typeface="Helvetica Neue"/>
+              </a:defRPr>
+            </a:lvl5pPr>
+            <a:lvl6pPr>
+              <a:defRPr sz="1800" b="0">
+                <a:solidFill>
+                  <a:srgbClr val="536675"/>
+                </a:solidFill>
+                <a:latin typeface="Helvetica Neue"/>
+                <a:ea typeface="Helvetica Neue"/>
+                <a:cs typeface="Helvetica Neue"/>
+              </a:defRPr>
+            </a:lvl6pPr>
+            <a:lvl7pPr>
+              <a:defRPr sz="1800" b="0">
+                <a:solidFill>
+                  <a:srgbClr val="536675"/>
+                </a:solidFill>
+                <a:latin typeface="Helvetica Neue"/>
+                <a:ea typeface="Helvetica Neue"/>
+                <a:cs typeface="Helvetica Neue"/>
+              </a:defRPr>
+            </a:lvl7pPr>
+            <a:lvl8pPr>
+              <a:defRPr sz="1800" b="0">
+                <a:solidFill>
+                  <a:srgbClr val="536675"/>
+                </a:solidFill>
+                <a:latin typeface="Helvetica Neue"/>
+                <a:ea typeface="Helvetica Neue"/>
+                <a:cs typeface="Helvetica Neue"/>
+              </a:defRPr>
+            </a:lvl8pPr>
+            <a:lvl9pPr>
+              <a:defRPr sz="1800" b="0">
+                <a:solidFill>
+                  <a:srgbClr val="536675"/>
+                </a:solidFill>
+                <a:latin typeface="Helvetica Neue"/>
+                <a:ea typeface="Helvetica Neue"/>
+                <a:cs typeface="Helvetica Neue"/>
+              </a:defRPr>
+            </a:lvl9pPr>
+          </a:lstStyle>
+          <a:p xmlns:a="http://schemas.openxmlformats.org/drawingml/2006/main">
+            <a:pPr>
+              <a:defRPr sz="1800" b="0">
+                <a:solidFill>
+                  <a:srgbClr val="536675"/>
+                </a:solidFill>
+                <a:latin typeface="Helvetica Neue"/>
+                <a:ea typeface="Helvetica Neue"/>
+                <a:cs typeface="Helvetica Neue"/>
+              </a:defRPr>
+            </a:pPr>
+            <a:r>
+              <a:rPr sz="1800" b="0">
+                <a:solidFill>
+                  <a:srgbClr val="536675"/>
+                </a:solidFill>
+                <a:latin typeface="Helvetica Neue"/>
+                <a:ea typeface="Helvetica Neue"/>
+                <a:cs typeface="Helvetica Neue"/>
+              </a:rPr>
+              <a:t>Human thresholds, antibody grades and normal-tissue absence never transfer by orthology.</a:t>
+            </a:r>
+          </a:p>
+        </p:txBody>
+      </p:sp>
+    </p:spTree>
+    <p:extLst>
+      <p:ext uri="{BB962C8B-B14F-4D97-AF65-F5344CB8AC3E}">
+        <p14:creationId xmlns:p14="http://schemas.microsoft.com/office/powerpoint/2010/main" val="1802935681"/>
+      </p:ext>
+    </p:extLst>
+  </p:cSld>
+</p:sld>
+</file>
+
+<file path=ppt/slides/slide21.xml><?xml version="1.0" encoding="utf-8"?>
+<p:sld xmlns:p="http://schemas.openxmlformats.org/presentationml/2006/main">
+  <p:cSld>
+    <p:bg>
+      <p:bgPr>
+        <a:solidFill xmlns:a="http://schemas.openxmlformats.org/drawingml/2006/main">
+          <a:srgbClr val="FFFFFF"/>
+        </a:solidFill>
+      </p:bgPr>
+    </p:bg>
+    <p:spTree>
+      <p:nvGrpSpPr>
+        <p:cNvPr id="1" name=""/>
+        <p:cNvGrpSpPr/>
+        <p:nvPr/>
+      </p:nvGrpSpPr>
+      <p:grpSpPr>
+        <a:xfrm xmlns:a="http://schemas.openxmlformats.org/drawingml/2006/main"/>
+      </p:grpSpPr>
+      <p:sp>
+        <p:nvSpPr>
+          <p:cNvPr id="7" name="">
+            <a:extLst xmlns:a="http://schemas.openxmlformats.org/drawingml/2006/main">
+              <a:ext uri="{FF2B5EF4-FFF2-40B4-BE49-F238E27FC236}">
+                <a16:creationId xmlns:a16="http://schemas.microsoft.com/office/drawing/2014/main" id="{6725EF2F-A89A-401C-9E1E-5BE122FCC282}"/>
+              </a:ext>
+            </a:extLst>
+          </p:cNvPr>
+          <p:cNvSpPr>
+            <a:spLocks xmlns:a="http://schemas.openxmlformats.org/drawingml/2006/main" noGrp="1"/>
+          </p:cNvSpPr>
+          <p:nvPr/>
+        </p:nvSpPr>
+        <p:spPr>
+          <a:xfrm xmlns:a="http://schemas.openxmlformats.org/drawingml/2006/main">
+            <a:off x="609600" y="266700"/>
+            <a:ext cx="10972800" cy="238125"/>
+          </a:xfrm>
+          <a:prstGeom xmlns:a="http://schemas.openxmlformats.org/drawingml/2006/main" prst="rect">
+            <a:avLst/>
+          </a:prstGeom>
+          <a:noFill xmlns:a="http://schemas.openxmlformats.org/drawingml/2006/main"/>
+          <a:ln xmlns:a="http://schemas.openxmlformats.org/drawingml/2006/main" w="0">
+            <a:noFill/>
+          </a:ln>
+        </p:spPr>
+        <p:txBody>
+          <a:bodyPr xmlns:a="http://schemas.openxmlformats.org/drawingml/2006/main" lIns="0" tIns="0" rIns="0" bIns="0"/>
+          <a:lstStyle xmlns:a="http://schemas.openxmlformats.org/drawingml/2006/main">
+            <a:defPPr>
+              <a:defRPr sz="1200" b="1">
+                <a:solidFill>
+                  <a:srgbClr val="087E8B"/>
+                </a:solidFill>
+                <a:latin typeface="Helvetica Neue"/>
+                <a:ea typeface="Helvetica Neue"/>
+                <a:cs typeface="Helvetica Neue"/>
+              </a:defRPr>
+            </a:defPPr>
+            <a:lvl1pPr>
+              <a:defRPr sz="1200" b="1">
+                <a:solidFill>
+                  <a:srgbClr val="087E8B"/>
+                </a:solidFill>
+                <a:latin typeface="Helvetica Neue"/>
+                <a:ea typeface="Helvetica Neue"/>
+                <a:cs typeface="Helvetica Neue"/>
+              </a:defRPr>
+            </a:lvl1pPr>
+            <a:lvl2pPr>
+              <a:defRPr sz="1200" b="1">
+                <a:solidFill>
+                  <a:srgbClr val="087E8B"/>
+                </a:solidFill>
+                <a:latin typeface="Helvetica Neue"/>
+                <a:ea typeface="Helvetica Neue"/>
+                <a:cs typeface="Helvetica Neue"/>
+              </a:defRPr>
+            </a:lvl2pPr>
+            <a:lvl3pPr>
+              <a:defRPr sz="1200" b="1">
+                <a:solidFill>
+                  <a:srgbClr val="087E8B"/>
+                </a:solidFill>
+                <a:latin typeface="Helvetica Neue"/>
+                <a:ea typeface="Helvetica Neue"/>
+                <a:cs typeface="Helvetica Neue"/>
+              </a:defRPr>
+            </a:lvl3pPr>
+            <a:lvl4pPr>
+              <a:defRPr sz="1200" b="1">
+                <a:solidFill>
+                  <a:srgbClr val="087E8B"/>
+                </a:solidFill>
+                <a:latin typeface="Helvetica Neue"/>
+                <a:ea typeface="Helvetica Neue"/>
+                <a:cs typeface="Helvetica Neue"/>
+              </a:defRPr>
+            </a:lvl4pPr>
+            <a:lvl5pPr>
+              <a:defRPr sz="1200" b="1">
+                <a:solidFill>
+                  <a:srgbClr val="087E8B"/>
+                </a:solidFill>
+                <a:latin typeface="Helvetica Neue"/>
+                <a:ea typeface="Helvetica Neue"/>
+                <a:cs typeface="Helvetica Neue"/>
+              </a:defRPr>
+            </a:lvl5pPr>
+            <a:lvl6pPr>
+              <a:defRPr sz="1200" b="1">
+                <a:solidFill>
+                  <a:srgbClr val="087E8B"/>
+                </a:solidFill>
+                <a:latin typeface="Helvetica Neue"/>
+                <a:ea typeface="Helvetica Neue"/>
+                <a:cs typeface="Helvetica Neue"/>
+              </a:defRPr>
+            </a:lvl6pPr>
+            <a:lvl7pPr>
+              <a:defRPr sz="1200" b="1">
+                <a:solidFill>
+                  <a:srgbClr val="087E8B"/>
+                </a:solidFill>
+                <a:latin typeface="Helvetica Neue"/>
+                <a:ea typeface="Helvetica Neue"/>
+                <a:cs typeface="Helvetica Neue"/>
+              </a:defRPr>
+            </a:lvl7pPr>
+            <a:lvl8pPr>
+              <a:defRPr sz="1200" b="1">
+                <a:solidFill>
+                  <a:srgbClr val="087E8B"/>
+                </a:solidFill>
+                <a:latin typeface="Helvetica Neue"/>
+                <a:ea typeface="Helvetica Neue"/>
+                <a:cs typeface="Helvetica Neue"/>
+              </a:defRPr>
+            </a:lvl8pPr>
+            <a:lvl9pPr>
+              <a:defRPr sz="1200" b="1">
+                <a:solidFill>
+                  <a:srgbClr val="087E8B"/>
+                </a:solidFill>
+                <a:latin typeface="Helvetica Neue"/>
+                <a:ea typeface="Helvetica Neue"/>
+                <a:cs typeface="Helvetica Neue"/>
+              </a:defRPr>
+            </a:lvl9pPr>
+          </a:lstStyle>
+          <a:p xmlns:a="http://schemas.openxmlformats.org/drawingml/2006/main">
+            <a:pPr>
+              <a:defRPr sz="1200" b="1">
+                <a:solidFill>
+                  <a:srgbClr val="087E8B"/>
+                </a:solidFill>
+                <a:latin typeface="Helvetica Neue"/>
+                <a:ea typeface="Helvetica Neue"/>
+                <a:cs typeface="Helvetica Neue"/>
+              </a:defRPr>
+            </a:pPr>
+            <a:r>
+              <a:rPr sz="1200" b="1">
+                <a:solidFill>
+                  <a:srgbClr val="087E8B"/>
+                </a:solidFill>
+                <a:latin typeface="Helvetica Neue"/>
+                <a:ea typeface="Helvetica Neue"/>
+                <a:cs typeface="Helvetica Neue"/>
+              </a:rPr>
+              <a:t>DEVELOPMENTAL NOMINATIONS</a:t>
+            </a:r>
+          </a:p>
+        </p:txBody>
+      </p:sp>
+      <p:sp>
+        <p:nvSpPr>
+          <p:cNvPr id="2" name="">
+            <a:extLst xmlns:a="http://schemas.openxmlformats.org/drawingml/2006/main">
+              <a:ext uri="{FF2B5EF4-FFF2-40B4-BE49-F238E27FC236}">
+                <a16:creationId xmlns:a16="http://schemas.microsoft.com/office/drawing/2014/main" id="{D89CFC59-C009-42D3-9A79-A931755126AF}"/>
+              </a:ext>
+            </a:extLst>
+          </p:cNvPr>
+          <p:cNvSpPr>
+            <a:spLocks xmlns:a="http://schemas.openxmlformats.org/drawingml/2006/main" noGrp="1"/>
+          </p:cNvSpPr>
+          <p:nvPr/>
+        </p:nvSpPr>
+        <p:spPr>
+          <a:xfrm xmlns:a="http://schemas.openxmlformats.org/drawingml/2006/main">
+            <a:off x="609600" y="685800"/>
+            <a:ext cx="10972800" cy="809625"/>
+          </a:xfrm>
+          <a:prstGeom xmlns:a="http://schemas.openxmlformats.org/drawingml/2006/main" prst="rect">
+            <a:avLst/>
+          </a:prstGeom>
+          <a:noFill xmlns:a="http://schemas.openxmlformats.org/drawingml/2006/main"/>
+          <a:ln xmlns:a="http://schemas.openxmlformats.org/drawingml/2006/main" w="0">
+            <a:noFill/>
+          </a:ln>
+        </p:spPr>
+        <p:txBody>
+          <a:bodyPr xmlns:a="http://schemas.openxmlformats.org/drawingml/2006/main" lIns="0" tIns="0" rIns="0" bIns="0"/>
+          <a:lstStyle xmlns:a="http://schemas.openxmlformats.org/drawingml/2006/main">
+            <a:defPPr>
+              <a:defRPr sz="3150" b="1">
+                <a:solidFill>
+                  <a:srgbClr val="173B55"/>
+                </a:solidFill>
+                <a:latin typeface="Helvetica Neue"/>
+                <a:ea typeface="Helvetica Neue"/>
+                <a:cs typeface="Helvetica Neue"/>
+              </a:defRPr>
+            </a:defPPr>
+            <a:lvl1pPr>
+              <a:defRPr sz="3150" b="1">
+                <a:solidFill>
+                  <a:srgbClr val="173B55"/>
+                </a:solidFill>
+                <a:latin typeface="Helvetica Neue"/>
+                <a:ea typeface="Helvetica Neue"/>
+                <a:cs typeface="Helvetica Neue"/>
+              </a:defRPr>
+            </a:lvl1pPr>
+            <a:lvl2pPr>
+              <a:defRPr sz="3150" b="1">
+                <a:solidFill>
+                  <a:srgbClr val="173B55"/>
+                </a:solidFill>
+                <a:latin typeface="Helvetica Neue"/>
+                <a:ea typeface="Helvetica Neue"/>
+                <a:cs typeface="Helvetica Neue"/>
+              </a:defRPr>
+            </a:lvl2pPr>
+            <a:lvl3pPr>
+              <a:defRPr sz="3150" b="1">
+                <a:solidFill>
+                  <a:srgbClr val="173B55"/>
+                </a:solidFill>
+                <a:latin typeface="Helvetica Neue"/>
+                <a:ea typeface="Helvetica Neue"/>
+                <a:cs typeface="Helvetica Neue"/>
+              </a:defRPr>
+            </a:lvl3pPr>
+            <a:lvl4pPr>
+              <a:defRPr sz="3150" b="1">
+                <a:solidFill>
+                  <a:srgbClr val="173B55"/>
+                </a:solidFill>
+                <a:latin typeface="Helvetica Neue"/>
+                <a:ea typeface="Helvetica Neue"/>
+                <a:cs typeface="Helvetica Neue"/>
+              </a:defRPr>
+            </a:lvl4pPr>
+            <a:lvl5pPr>
+              <a:defRPr sz="3150" b="1">
+                <a:solidFill>
+                  <a:srgbClr val="173B55"/>
+                </a:solidFill>
+                <a:latin typeface="Helvetica Neue"/>
+                <a:ea typeface="Helvetica Neue"/>
+                <a:cs typeface="Helvetica Neue"/>
+              </a:defRPr>
+            </a:lvl5pPr>
+            <a:lvl6pPr>
+              <a:defRPr sz="3150" b="1">
+                <a:solidFill>
+                  <a:srgbClr val="173B55"/>
+                </a:solidFill>
+                <a:latin typeface="Helvetica Neue"/>
+                <a:ea typeface="Helvetica Neue"/>
+                <a:cs typeface="Helvetica Neue"/>
+              </a:defRPr>
+            </a:lvl6pPr>
+            <a:lvl7pPr>
+              <a:defRPr sz="3150" b="1">
+                <a:solidFill>
+                  <a:srgbClr val="173B55"/>
+                </a:solidFill>
+                <a:latin typeface="Helvetica Neue"/>
+                <a:ea typeface="Helvetica Neue"/>
+                <a:cs typeface="Helvetica Neue"/>
+              </a:defRPr>
+            </a:lvl7pPr>
+            <a:lvl8pPr>
+              <a:defRPr sz="3150" b="1">
+                <a:solidFill>
+                  <a:srgbClr val="173B55"/>
+                </a:solidFill>
+                <a:latin typeface="Helvetica Neue"/>
+                <a:ea typeface="Helvetica Neue"/>
+                <a:cs typeface="Helvetica Neue"/>
+              </a:defRPr>
+            </a:lvl8pPr>
+            <a:lvl9pPr>
+              <a:defRPr sz="3150" b="1">
+                <a:solidFill>
+                  <a:srgbClr val="173B55"/>
+                </a:solidFill>
+                <a:latin typeface="Helvetica Neue"/>
+                <a:ea typeface="Helvetica Neue"/>
+                <a:cs typeface="Helvetica Neue"/>
+              </a:defRPr>
+            </a:lvl9pPr>
+          </a:lstStyle>
+          <a:p xmlns:a="http://schemas.openxmlformats.org/drawingml/2006/main">
+            <a:pPr>
+              <a:defRPr sz="3150" b="1">
+                <a:solidFill>
+                  <a:srgbClr val="173B55"/>
+                </a:solidFill>
+                <a:latin typeface="Helvetica Neue"/>
+                <a:ea typeface="Helvetica Neue"/>
+                <a:cs typeface="Helvetica Neue"/>
+              </a:defRPr>
+            </a:pPr>
+            <a:r>
+              <a:rPr sz="3150" b="1">
+                <a:solidFill>
+                  <a:srgbClr val="173B55"/>
+                </a:solidFill>
+                <a:latin typeface="Helvetica Neue"/>
+                <a:ea typeface="Helvetica Neue"/>
+                <a:cs typeface="Helvetica Neue"/>
+              </a:rPr>
+              <a:t>Curated oncofetal sources</a:t>
+            </a:r>
+          </a:p>
+        </p:txBody>
+      </p:sp>
+      <p:sp>
+        <p:nvSpPr>
+          <p:cNvPr id="3" name="">
+            <a:extLst xmlns:a="http://schemas.openxmlformats.org/drawingml/2006/main">
+              <a:ext uri="{FF2B5EF4-FFF2-40B4-BE49-F238E27FC236}">
+                <a16:creationId xmlns:a16="http://schemas.microsoft.com/office/drawing/2014/main" id="{7A2BB589-F965-4B22-A209-D6DDD982EAC6}"/>
+              </a:ext>
+            </a:extLst>
+          </p:cNvPr>
+          <p:cNvSpPr>
+            <a:spLocks xmlns:a="http://schemas.openxmlformats.org/drawingml/2006/main" noGrp="1"/>
+          </p:cNvSpPr>
+          <p:nvPr/>
+        </p:nvSpPr>
+        <p:spPr>
+          <a:xfrm xmlns:a="http://schemas.openxmlformats.org/drawingml/2006/main">
+            <a:off x="609600" y="6381750"/>
+            <a:ext cx="10477500" cy="247650"/>
+          </a:xfrm>
+          <a:prstGeom xmlns:a="http://schemas.openxmlformats.org/drawingml/2006/main" prst="rect">
+            <a:avLst/>
+          </a:prstGeom>
+          <a:noFill xmlns:a="http://schemas.openxmlformats.org/drawingml/2006/main"/>
+          <a:ln xmlns:a="http://schemas.openxmlformats.org/drawingml/2006/main" w="0">
+            <a:noFill/>
+          </a:ln>
+        </p:spPr>
+        <p:txBody>
+          <a:bodyPr xmlns:a="http://schemas.openxmlformats.org/drawingml/2006/main" lIns="0" tIns="0" rIns="0" bIns="0"/>
+          <a:lstStyle xmlns:a="http://schemas.openxmlformats.org/drawingml/2006/main">
+            <a:defPPr>
+              <a:defRPr sz="1200" b="0">
+                <a:solidFill>
+                  <a:srgbClr val="536675"/>
+                </a:solidFill>
+                <a:latin typeface="Helvetica Neue"/>
+                <a:ea typeface="Helvetica Neue"/>
+                <a:cs typeface="Helvetica Neue"/>
+              </a:defRPr>
+            </a:defPPr>
+            <a:lvl1pPr>
+              <a:defRPr sz="1200" b="0">
+                <a:solidFill>
+                  <a:srgbClr val="536675"/>
+                </a:solidFill>
+                <a:latin typeface="Helvetica Neue"/>
+                <a:ea typeface="Helvetica Neue"/>
+                <a:cs typeface="Helvetica Neue"/>
+              </a:defRPr>
+            </a:lvl1pPr>
+            <a:lvl2pPr>
+              <a:defRPr sz="1200" b="0">
+                <a:solidFill>
+                  <a:srgbClr val="536675"/>
+                </a:solidFill>
+                <a:latin typeface="Helvetica Neue"/>
+                <a:ea typeface="Helvetica Neue"/>
+                <a:cs typeface="Helvetica Neue"/>
+              </a:defRPr>
+            </a:lvl2pPr>
+            <a:lvl3pPr>
+              <a:defRPr sz="1200" b="0">
+                <a:solidFill>
+                  <a:srgbClr val="536675"/>
+                </a:solidFill>
+                <a:latin typeface="Helvetica Neue"/>
+                <a:ea typeface="Helvetica Neue"/>
+                <a:cs typeface="Helvetica Neue"/>
+              </a:defRPr>
+            </a:lvl3pPr>
+            <a:lvl4pPr>
+              <a:defRPr sz="1200" b="0">
+                <a:solidFill>
+                  <a:srgbClr val="536675"/>
+                </a:solidFill>
+                <a:latin typeface="Helvetica Neue"/>
+                <a:ea typeface="Helvetica Neue"/>
+                <a:cs typeface="Helvetica Neue"/>
+              </a:defRPr>
+            </a:lvl4pPr>
+            <a:lvl5pPr>
+              <a:defRPr sz="1200" b="0">
+                <a:solidFill>
+                  <a:srgbClr val="536675"/>
+                </a:solidFill>
+                <a:latin typeface="Helvetica Neue"/>
+                <a:ea typeface="Helvetica Neue"/>
+                <a:cs typeface="Helvetica Neue"/>
+              </a:defRPr>
+            </a:lvl5pPr>
+            <a:lvl6pPr>
+              <a:defRPr sz="1200" b="0">
+                <a:solidFill>
+                  <a:srgbClr val="536675"/>
+                </a:solidFill>
+                <a:latin typeface="Helvetica Neue"/>
+                <a:ea typeface="Helvetica Neue"/>
+                <a:cs typeface="Helvetica Neue"/>
+              </a:defRPr>
+            </a:lvl6pPr>
+            <a:lvl7pPr>
+              <a:defRPr sz="1200" b="0">
+                <a:solidFill>
+                  <a:srgbClr val="536675"/>
+                </a:solidFill>
+                <a:latin typeface="Helvetica Neue"/>
+                <a:ea typeface="Helvetica Neue"/>
+                <a:cs typeface="Helvetica Neue"/>
+              </a:defRPr>
+            </a:lvl7pPr>
+            <a:lvl8pPr>
+              <a:defRPr sz="1200" b="0">
+                <a:solidFill>
+                  <a:srgbClr val="536675"/>
+                </a:solidFill>
+                <a:latin typeface="Helvetica Neue"/>
+                <a:ea typeface="Helvetica Neue"/>
+                <a:cs typeface="Helvetica Neue"/>
+              </a:defRPr>
+            </a:lvl8pPr>
+            <a:lvl9pPr>
+              <a:defRPr sz="1200" b="0">
+                <a:solidFill>
+                  <a:srgbClr val="536675"/>
+                </a:solidFill>
+                <a:latin typeface="Helvetica Neue"/>
+                <a:ea typeface="Helvetica Neue"/>
+                <a:cs typeface="Helvetica Neue"/>
+              </a:defRPr>
+            </a:lvl9pPr>
+          </a:lstStyle>
+          <a:p xmlns:a="http://schemas.openxmlformats.org/drawingml/2006/main">
+            <a:pPr>
+              <a:defRPr sz="1200" b="0">
+                <a:solidFill>
+                  <a:srgbClr val="536675"/>
+                </a:solidFill>
+                <a:latin typeface="Helvetica Neue"/>
+                <a:ea typeface="Helvetica Neue"/>
+                <a:cs typeface="Helvetica Neue"/>
+              </a:defRPr>
+            </a:pPr>
+            <a:r>
+              <a:rPr sz="1200" b="0">
+                <a:solidFill>
+                  <a:srgbClr val="536675"/>
+                </a:solidFill>
+                <a:latin typeface="Helvetica Neue"/>
+                <a:ea typeface="Helvetica Neue"/>
+                <a:cs typeface="Helvetica Neue"/>
+              </a:rPr>
+              <a:t>OncoRef CTA evidence walkthrough   •   28 October 2026</a:t>
+            </a:r>
+          </a:p>
+        </p:txBody>
+      </p:sp>
+      <p:sp>
+        <p:nvSpPr>
+          <p:cNvPr id="4" name="">
+            <a:extLst xmlns:a="http://schemas.openxmlformats.org/drawingml/2006/main">
+              <a:ext uri="{FF2B5EF4-FFF2-40B4-BE49-F238E27FC236}">
+                <a16:creationId xmlns:a16="http://schemas.microsoft.com/office/drawing/2014/main" id="{641A57C5-79EA-4C55-9546-8186167B3660}"/>
+              </a:ext>
+            </a:extLst>
+          </p:cNvPr>
+          <p:cNvSpPr>
+            <a:spLocks xmlns:a="http://schemas.openxmlformats.org/drawingml/2006/main" noGrp="1"/>
+          </p:cNvSpPr>
+          <p:nvPr/>
+        </p:nvSpPr>
+        <p:spPr>
+          <a:xfrm xmlns:a="http://schemas.openxmlformats.org/drawingml/2006/main">
+            <a:off x="11182350" y="6362700"/>
+            <a:ext cx="400050" cy="285750"/>
+          </a:xfrm>
+          <a:prstGeom xmlns:a="http://schemas.openxmlformats.org/drawingml/2006/main" prst="rect">
+            <a:avLst/>
+          </a:prstGeom>
+          <a:noFill xmlns:a="http://schemas.openxmlformats.org/drawingml/2006/main"/>
+          <a:ln xmlns:a="http://schemas.openxmlformats.org/drawingml/2006/main" w="0">
+            <a:noFill/>
+          </a:ln>
+        </p:spPr>
+        <p:txBody>
+          <a:bodyPr xmlns:a="http://schemas.openxmlformats.org/drawingml/2006/main" lIns="0" tIns="0" rIns="0" bIns="0"/>
+          <a:lstStyle xmlns:a="http://schemas.openxmlformats.org/drawingml/2006/main">
+            <a:defPPr>
+              <a:defRPr sz="1425" b="1">
+                <a:solidFill>
+                  <a:srgbClr val="536675"/>
+                </a:solidFill>
+                <a:latin typeface="Helvetica Neue"/>
+                <a:ea typeface="Helvetica Neue"/>
+                <a:cs typeface="Helvetica Neue"/>
+              </a:defRPr>
+            </a:defPPr>
+            <a:lvl1pPr>
+              <a:defRPr sz="1425" b="1">
+                <a:solidFill>
+                  <a:srgbClr val="536675"/>
+                </a:solidFill>
+                <a:latin typeface="Helvetica Neue"/>
+                <a:ea typeface="Helvetica Neue"/>
+                <a:cs typeface="Helvetica Neue"/>
+              </a:defRPr>
+            </a:lvl1pPr>
+            <a:lvl2pPr>
+              <a:defRPr sz="1425" b="1">
+                <a:solidFill>
+                  <a:srgbClr val="536675"/>
+                </a:solidFill>
+                <a:latin typeface="Helvetica Neue"/>
+                <a:ea typeface="Helvetica Neue"/>
+                <a:cs typeface="Helvetica Neue"/>
+              </a:defRPr>
+            </a:lvl2pPr>
+            <a:lvl3pPr>
+              <a:defRPr sz="1425" b="1">
+                <a:solidFill>
+                  <a:srgbClr val="536675"/>
+                </a:solidFill>
+                <a:latin typeface="Helvetica Neue"/>
+                <a:ea typeface="Helvetica Neue"/>
+                <a:cs typeface="Helvetica Neue"/>
+              </a:defRPr>
+            </a:lvl3pPr>
+            <a:lvl4pPr>
+              <a:defRPr sz="1425" b="1">
+                <a:solidFill>
+                  <a:srgbClr val="536675"/>
+                </a:solidFill>
+                <a:latin typeface="Helvetica Neue"/>
+                <a:ea typeface="Helvetica Neue"/>
+                <a:cs typeface="Helvetica Neue"/>
+              </a:defRPr>
+            </a:lvl4pPr>
+            <a:lvl5pPr>
+              <a:defRPr sz="1425" b="1">
+                <a:solidFill>
+                  <a:srgbClr val="536675"/>
+                </a:solidFill>
+                <a:latin typeface="Helvetica Neue"/>
+                <a:ea typeface="Helvetica Neue"/>
+                <a:cs typeface="Helvetica Neue"/>
+              </a:defRPr>
+            </a:lvl5pPr>
+            <a:lvl6pPr>
+              <a:defRPr sz="1425" b="1">
+                <a:solidFill>
+                  <a:srgbClr val="536675"/>
+                </a:solidFill>
+                <a:latin typeface="Helvetica Neue"/>
+                <a:ea typeface="Helvetica Neue"/>
+                <a:cs typeface="Helvetica Neue"/>
+              </a:defRPr>
+            </a:lvl6pPr>
+            <a:lvl7pPr>
+              <a:defRPr sz="1425" b="1">
+                <a:solidFill>
+                  <a:srgbClr val="536675"/>
+                </a:solidFill>
+                <a:latin typeface="Helvetica Neue"/>
+                <a:ea typeface="Helvetica Neue"/>
+                <a:cs typeface="Helvetica Neue"/>
+              </a:defRPr>
+            </a:lvl7pPr>
+            <a:lvl8pPr>
+              <a:defRPr sz="1425" b="1">
+                <a:solidFill>
+                  <a:srgbClr val="536675"/>
+                </a:solidFill>
+                <a:latin typeface="Helvetica Neue"/>
+                <a:ea typeface="Helvetica Neue"/>
+                <a:cs typeface="Helvetica Neue"/>
+              </a:defRPr>
+            </a:lvl8pPr>
+            <a:lvl9pPr>
+              <a:defRPr sz="1425" b="1">
+                <a:solidFill>
+                  <a:srgbClr val="536675"/>
+                </a:solidFill>
+                <a:latin typeface="Helvetica Neue"/>
+                <a:ea typeface="Helvetica Neue"/>
+                <a:cs typeface="Helvetica Neue"/>
+              </a:defRPr>
+            </a:lvl9pPr>
+          </a:lstStyle>
+          <a:p xmlns:a="http://schemas.openxmlformats.org/drawingml/2006/main">
+            <a:pPr>
+              <a:defRPr sz="1425" b="1">
+                <a:solidFill>
+                  <a:srgbClr val="536675"/>
+                </a:solidFill>
+                <a:latin typeface="Helvetica Neue"/>
+                <a:ea typeface="Helvetica Neue"/>
+                <a:cs typeface="Helvetica Neue"/>
+              </a:defRPr>
+            </a:pPr>
+            <a:r>
+              <a:rPr sz="1425" b="1">
+                <a:solidFill>
+                  <a:srgbClr val="536675"/>
+                </a:solidFill>
+                <a:latin typeface="Helvetica Neue"/>
+                <a:ea typeface="Helvetica Neue"/>
+                <a:cs typeface="Helvetica Neue"/>
+              </a:rPr>
+              <a:t>21</a:t>
+            </a:r>
+          </a:p>
+        </p:txBody>
+      </p:sp>
+      <p:graphicFrame>
+        <p:nvGraphicFramePr>
+          <p:cNvPr id="5" name="">
+            <a:extLst xmlns:a="http://schemas.openxmlformats.org/drawingml/2006/main">
+              <a:ext uri="{FF2B5EF4-FFF2-40B4-BE49-F238E27FC236}">
+                <a16:creationId xmlns:a16="http://schemas.microsoft.com/office/drawing/2014/main" id="{142AF869-42FA-4B4C-9CDD-D266B7692A26}"/>
               </a:ext>
             </a:extLst>
           </p:cNvPr>
@@ -24497,7 +26625,7 @@
           <p:cNvPr id="6" name="">
             <a:extLst xmlns:a="http://schemas.openxmlformats.org/drawingml/2006/main">
               <a:ext uri="{FF2B5EF4-FFF2-40B4-BE49-F238E27FC236}">
-                <a16:creationId xmlns:a16="http://schemas.microsoft.com/office/drawing/2014/main" id="{FB9226AD-2616-40CB-B6F3-D1375179E3AA}"/>
+                <a16:creationId xmlns:a16="http://schemas.microsoft.com/office/drawing/2014/main" id="{ACD4A80A-96DB-4392-AA81-CABB42AF394A}"/>
               </a:ext>
             </a:extLst>
           </p:cNvPr>
@@ -24651,14 +26779,14 @@
     </p:spTree>
     <p:extLst>
       <p:ext uri="{BB962C8B-B14F-4D97-AF65-F5344CB8AC3E}">
-        <p14:creationId xmlns:p14="http://schemas.microsoft.com/office/powerpoint/2010/main" val="1418532299"/>
+        <p14:creationId xmlns:p14="http://schemas.microsoft.com/office/powerpoint/2010/main" val="589404289"/>
       </p:ext>
     </p:extLst>
   </p:cSld>
 </p:sld>
 </file>
 
-<file path=ppt/slides/slide21.xml><?xml version="1.0" encoding="utf-8"?>
+<file path=ppt/slides/slide22.xml><?xml version="1.0" encoding="utf-8"?>
 <p:sld xmlns:p="http://schemas.openxmlformats.org/presentationml/2006/main">
   <p:cSld>
     <p:bg>
@@ -24682,7 +26810,7 @@
           <p:cNvPr id="8" name="">
             <a:extLst xmlns:a="http://schemas.openxmlformats.org/drawingml/2006/main">
               <a:ext uri="{FF2B5EF4-FFF2-40B4-BE49-F238E27FC236}">
-                <a16:creationId xmlns:a16="http://schemas.microsoft.com/office/drawing/2014/main" id="{9C37FEE9-C65E-4364-BD7E-572C1BC10269}"/>
+                <a16:creationId xmlns:a16="http://schemas.microsoft.com/office/drawing/2014/main" id="{C605947D-AFAF-4C27-9C87-889918D0CD59}"/>
               </a:ext>
             </a:extLst>
           </p:cNvPr>
@@ -24838,7 +26966,7 @@
           <p:cNvPr id="2" name="">
             <a:extLst xmlns:a="http://schemas.openxmlformats.org/drawingml/2006/main">
               <a:ext uri="{FF2B5EF4-FFF2-40B4-BE49-F238E27FC236}">
-                <a16:creationId xmlns:a16="http://schemas.microsoft.com/office/drawing/2014/main" id="{1356E128-9C09-4128-81B2-9D3F695F8487}"/>
+                <a16:creationId xmlns:a16="http://schemas.microsoft.com/office/drawing/2014/main" id="{72EE5356-A34D-4FB4-99C4-BE7B1B209A8D}"/>
               </a:ext>
             </a:extLst>
           </p:cNvPr>
@@ -24994,7 +27122,7 @@
           <p:cNvPr id="3" name="">
             <a:extLst xmlns:a="http://schemas.openxmlformats.org/drawingml/2006/main">
               <a:ext uri="{FF2B5EF4-FFF2-40B4-BE49-F238E27FC236}">
-                <a16:creationId xmlns:a16="http://schemas.microsoft.com/office/drawing/2014/main" id="{758378C8-0E76-4E9B-A646-0B8C228EBB0D}"/>
+                <a16:creationId xmlns:a16="http://schemas.microsoft.com/office/drawing/2014/main" id="{0C33272E-A1E3-453D-BFE8-AA49AEDF56DB}"/>
               </a:ext>
             </a:extLst>
           </p:cNvPr>
@@ -25150,7 +27278,7 @@
           <p:cNvPr id="4" name="">
             <a:extLst xmlns:a="http://schemas.openxmlformats.org/drawingml/2006/main">
               <a:ext uri="{FF2B5EF4-FFF2-40B4-BE49-F238E27FC236}">
-                <a16:creationId xmlns:a16="http://schemas.microsoft.com/office/drawing/2014/main" id="{D733D302-F4DB-4E01-9F34-BC9F05D3E2C9}"/>
+                <a16:creationId xmlns:a16="http://schemas.microsoft.com/office/drawing/2014/main" id="{C46AAE77-3BC0-4A19-859A-0F7D13A44489}"/>
               </a:ext>
             </a:extLst>
           </p:cNvPr>
@@ -25296,7 +27424,7 @@
                 <a:ea typeface="Helvetica Neue"/>
                 <a:cs typeface="Helvetica Neue"/>
               </a:rPr>
-              <a:t>21</a:t>
+              <a:t>22</a:t>
             </a:r>
           </a:p>
         </p:txBody>
@@ -25306,7 +27434,7 @@
           <p:cNvPr id="5" name="">
             <a:extLst xmlns:a="http://schemas.openxmlformats.org/drawingml/2006/main">
               <a:ext uri="{FF2B5EF4-FFF2-40B4-BE49-F238E27FC236}">
-                <a16:creationId xmlns:a16="http://schemas.microsoft.com/office/drawing/2014/main" id="{DC4A08CB-FFBF-4BD2-9223-A725D364D52B}"/>
+                <a16:creationId xmlns:a16="http://schemas.microsoft.com/office/drawing/2014/main" id="{30CA725F-0A66-47D1-A979-73EC406E4215}"/>
               </a:ext>
             </a:extLst>
           </p:cNvPr>
@@ -25531,7 +27659,7 @@
           <p:cNvPr id="6" name="">
             <a:extLst xmlns:a="http://schemas.openxmlformats.org/drawingml/2006/main">
               <a:ext uri="{FF2B5EF4-FFF2-40B4-BE49-F238E27FC236}">
-                <a16:creationId xmlns:a16="http://schemas.microsoft.com/office/drawing/2014/main" id="{0A55F5A6-9D34-4C88-AD75-0D1FD177E1F2}"/>
+                <a16:creationId xmlns:a16="http://schemas.microsoft.com/office/drawing/2014/main" id="{7D28B049-E8CC-4689-A088-9878541FDD69}"/>
               </a:ext>
             </a:extLst>
           </p:cNvPr>
@@ -25891,7 +28019,7 @@
           <p:cNvPr id="7" name="">
             <a:extLst xmlns:a="http://schemas.openxmlformats.org/drawingml/2006/main">
               <a:ext uri="{FF2B5EF4-FFF2-40B4-BE49-F238E27FC236}">
-                <a16:creationId xmlns:a16="http://schemas.microsoft.com/office/drawing/2014/main" id="{4F72419D-020F-400C-A3F4-DF9D88C85484}"/>
+                <a16:creationId xmlns:a16="http://schemas.microsoft.com/office/drawing/2014/main" id="{A581B7EC-8BB7-4426-9B23-60ACBADDDD03}"/>
               </a:ext>
             </a:extLst>
           </p:cNvPr>
@@ -26045,7 +28173,7 @@
     </p:spTree>
     <p:extLst>
       <p:ext uri="{BB962C8B-B14F-4D97-AF65-F5344CB8AC3E}">
-        <p14:creationId xmlns:p14="http://schemas.microsoft.com/office/powerpoint/2010/main" val="146332126"/>
+        <p14:creationId xmlns:p14="http://schemas.microsoft.com/office/powerpoint/2010/main" val="45955989"/>
       </p:ext>
     </p:extLst>
   </p:cSld>
@@ -26076,7 +28204,7 @@
           <p:cNvPr id="7" name="">
             <a:extLst xmlns:a="http://schemas.openxmlformats.org/drawingml/2006/main">
               <a:ext uri="{FF2B5EF4-FFF2-40B4-BE49-F238E27FC236}">
-                <a16:creationId xmlns:a16="http://schemas.microsoft.com/office/drawing/2014/main" id="{D3E69490-B5E3-4BA8-A4FF-881740328AA8}"/>
+                <a16:creationId xmlns:a16="http://schemas.microsoft.com/office/drawing/2014/main" id="{9B26438A-976D-41FE-B1ED-19DC55FD5A28}"/>
               </a:ext>
             </a:extLst>
           </p:cNvPr>
@@ -26232,7 +28360,7 @@
           <p:cNvPr id="2" name="">
             <a:extLst xmlns:a="http://schemas.openxmlformats.org/drawingml/2006/main">
               <a:ext uri="{FF2B5EF4-FFF2-40B4-BE49-F238E27FC236}">
-                <a16:creationId xmlns:a16="http://schemas.microsoft.com/office/drawing/2014/main" id="{9A6CDF90-D104-4988-AE74-852C33C4FD5E}"/>
+                <a16:creationId xmlns:a16="http://schemas.microsoft.com/office/drawing/2014/main" id="{89759252-6EC8-44E4-A80D-53A6AAEE77EB}"/>
               </a:ext>
             </a:extLst>
           </p:cNvPr>
@@ -26388,7 +28516,7 @@
           <p:cNvPr id="3" name="">
             <a:extLst xmlns:a="http://schemas.openxmlformats.org/drawingml/2006/main">
               <a:ext uri="{FF2B5EF4-FFF2-40B4-BE49-F238E27FC236}">
-                <a16:creationId xmlns:a16="http://schemas.microsoft.com/office/drawing/2014/main" id="{57D7FC5B-C326-4D1E-A0EE-5E65256D00A3}"/>
+                <a16:creationId xmlns:a16="http://schemas.microsoft.com/office/drawing/2014/main" id="{9718649B-FDB1-43AD-9132-20E252D9E420}"/>
               </a:ext>
             </a:extLst>
           </p:cNvPr>
@@ -26544,7 +28672,7 @@
           <p:cNvPr id="4" name="">
             <a:extLst xmlns:a="http://schemas.openxmlformats.org/drawingml/2006/main">
               <a:ext uri="{FF2B5EF4-FFF2-40B4-BE49-F238E27FC236}">
-                <a16:creationId xmlns:a16="http://schemas.microsoft.com/office/drawing/2014/main" id="{E31E36CA-CE6B-4550-BC34-68E383C52E2B}"/>
+                <a16:creationId xmlns:a16="http://schemas.microsoft.com/office/drawing/2014/main" id="{7A4944B6-C75C-499B-8272-836C05F6AA4C}"/>
               </a:ext>
             </a:extLst>
           </p:cNvPr>
@@ -26700,7 +28828,7 @@
           <p:cNvPr id="5" name="">
             <a:extLst xmlns:a="http://schemas.openxmlformats.org/drawingml/2006/main">
               <a:ext uri="{FF2B5EF4-FFF2-40B4-BE49-F238E27FC236}">
-                <a16:creationId xmlns:a16="http://schemas.microsoft.com/office/drawing/2014/main" id="{02C0BD25-C948-4AFA-BE46-A23537ACFE82}"/>
+                <a16:creationId xmlns:a16="http://schemas.microsoft.com/office/drawing/2014/main" id="{3336A66D-BD58-42CF-B8D6-9EA84DDA1C57}"/>
               </a:ext>
             </a:extLst>
           </p:cNvPr>
@@ -27362,7 +29490,7 @@
           <p:cNvPr id="6" name="">
             <a:extLst xmlns:a="http://schemas.openxmlformats.org/drawingml/2006/main">
               <a:ext uri="{FF2B5EF4-FFF2-40B4-BE49-F238E27FC236}">
-                <a16:creationId xmlns:a16="http://schemas.microsoft.com/office/drawing/2014/main" id="{35F1216B-276D-4E7A-AD9A-C23BD2DAC574}"/>
+                <a16:creationId xmlns:a16="http://schemas.microsoft.com/office/drawing/2014/main" id="{49EE8B14-1267-407F-81EB-36D13A48CE51}"/>
               </a:ext>
             </a:extLst>
           </p:cNvPr>
@@ -27516,7 +29644,7 @@
     </p:spTree>
     <p:extLst>
       <p:ext uri="{BB962C8B-B14F-4D97-AF65-F5344CB8AC3E}">
-        <p14:creationId xmlns:p14="http://schemas.microsoft.com/office/powerpoint/2010/main" val="885969663"/>
+        <p14:creationId xmlns:p14="http://schemas.microsoft.com/office/powerpoint/2010/main" val="1215831774"/>
       </p:ext>
     </p:extLst>
   </p:cSld>
@@ -27547,7 +29675,7 @@
           <p:cNvPr id="6" name="">
             <a:extLst xmlns:a="http://schemas.openxmlformats.org/drawingml/2006/main">
               <a:ext uri="{FF2B5EF4-FFF2-40B4-BE49-F238E27FC236}">
-                <a16:creationId xmlns:a16="http://schemas.microsoft.com/office/drawing/2014/main" id="{9838E72C-8C81-46BC-91A8-A81F89629614}"/>
+                <a16:creationId xmlns:a16="http://schemas.microsoft.com/office/drawing/2014/main" id="{B6AC5CD9-7EFE-4CDE-8F4E-A4ABC7EAE1C6}"/>
               </a:ext>
             </a:extLst>
           </p:cNvPr>
@@ -27703,7 +29831,7 @@
           <p:cNvPr id="2" name="">
             <a:extLst xmlns:a="http://schemas.openxmlformats.org/drawingml/2006/main">
               <a:ext uri="{FF2B5EF4-FFF2-40B4-BE49-F238E27FC236}">
-                <a16:creationId xmlns:a16="http://schemas.microsoft.com/office/drawing/2014/main" id="{CDD181BD-F017-43E3-8EDC-F15CB37646F1}"/>
+                <a16:creationId xmlns:a16="http://schemas.microsoft.com/office/drawing/2014/main" id="{F1FA0F63-5EA8-4523-810F-C831C0333C32}"/>
               </a:ext>
             </a:extLst>
           </p:cNvPr>
@@ -27859,7 +29987,7 @@
           <p:cNvPr id="3" name="">
             <a:extLst xmlns:a="http://schemas.openxmlformats.org/drawingml/2006/main">
               <a:ext uri="{FF2B5EF4-FFF2-40B4-BE49-F238E27FC236}">
-                <a16:creationId xmlns:a16="http://schemas.microsoft.com/office/drawing/2014/main" id="{D6CF9C27-8C93-434F-B9B3-E534712A27DE}"/>
+                <a16:creationId xmlns:a16="http://schemas.microsoft.com/office/drawing/2014/main" id="{E7937543-EA7E-4D2F-A204-A58DA8330ACF}"/>
               </a:ext>
             </a:extLst>
           </p:cNvPr>
@@ -28015,7 +30143,7 @@
           <p:cNvPr id="4" name="">
             <a:extLst xmlns:a="http://schemas.openxmlformats.org/drawingml/2006/main">
               <a:ext uri="{FF2B5EF4-FFF2-40B4-BE49-F238E27FC236}">
-                <a16:creationId xmlns:a16="http://schemas.microsoft.com/office/drawing/2014/main" id="{86E52337-0B4F-4156-991A-CC22564DE73D}"/>
+                <a16:creationId xmlns:a16="http://schemas.microsoft.com/office/drawing/2014/main" id="{1E67149D-B2B1-4928-9AD2-8DB0D69DF425}"/>
               </a:ext>
             </a:extLst>
           </p:cNvPr>
@@ -28171,7 +30299,7 @@
           <p:cNvPr id="5" name="">
             <a:extLst xmlns:a="http://schemas.openxmlformats.org/drawingml/2006/main">
               <a:ext uri="{FF2B5EF4-FFF2-40B4-BE49-F238E27FC236}">
-                <a16:creationId xmlns:a16="http://schemas.microsoft.com/office/drawing/2014/main" id="{19303CE0-3364-4EF7-9B6C-0068CB159CDA}"/>
+                <a16:creationId xmlns:a16="http://schemas.microsoft.com/office/drawing/2014/main" id="{9A9E3D05-3ED8-453C-BBD5-C8ECAAD0AFAF}"/>
               </a:ext>
             </a:extLst>
           </p:cNvPr>
@@ -28181,7 +30309,7 @@
           <p:nvPr/>
         </p:nvPicPr>
         <p:blipFill>
-          <a:blip xmlns:r="http://schemas.openxmlformats.org/officeDocument/2006/relationships" xmlns:a="http://schemas.openxmlformats.org/drawingml/2006/main" r:embed="Rc83ddc9ae0e946e1"/>
+          <a:blip xmlns:r="http://schemas.openxmlformats.org/officeDocument/2006/relationships" xmlns:a="http://schemas.openxmlformats.org/drawingml/2006/main" r:embed="R7828a8f8ee8d4930"/>
           <a:stretch xmlns:a="http://schemas.openxmlformats.org/drawingml/2006/main"/>
         </p:blipFill>
         <p:spPr>
@@ -28197,7 +30325,7 @@
     </p:spTree>
     <p:extLst>
       <p:ext uri="{BB962C8B-B14F-4D97-AF65-F5344CB8AC3E}">
-        <p14:creationId xmlns:p14="http://schemas.microsoft.com/office/powerpoint/2010/main" val="1411076646"/>
+        <p14:creationId xmlns:p14="http://schemas.microsoft.com/office/powerpoint/2010/main" val="392499562"/>
       </p:ext>
     </p:extLst>
   </p:cSld>
@@ -28228,7 +30356,7 @@
           <p:cNvPr id="8" name="">
             <a:extLst xmlns:a="http://schemas.openxmlformats.org/drawingml/2006/main">
               <a:ext uri="{FF2B5EF4-FFF2-40B4-BE49-F238E27FC236}">
-                <a16:creationId xmlns:a16="http://schemas.microsoft.com/office/drawing/2014/main" id="{7FEF11D9-1F38-4975-B849-1EED8B724196}"/>
+                <a16:creationId xmlns:a16="http://schemas.microsoft.com/office/drawing/2014/main" id="{3931AEAB-214F-430C-B98B-5EB0CC7B827D}"/>
               </a:ext>
             </a:extLst>
           </p:cNvPr>
@@ -28384,7 +30512,7 @@
           <p:cNvPr id="2" name="">
             <a:extLst xmlns:a="http://schemas.openxmlformats.org/drawingml/2006/main">
               <a:ext uri="{FF2B5EF4-FFF2-40B4-BE49-F238E27FC236}">
-                <a16:creationId xmlns:a16="http://schemas.microsoft.com/office/drawing/2014/main" id="{D3F856BC-FAA5-4E03-8F4C-94694EE40AB3}"/>
+                <a16:creationId xmlns:a16="http://schemas.microsoft.com/office/drawing/2014/main" id="{F15D32EF-CE07-43FE-BB07-110C2A766ED8}"/>
               </a:ext>
             </a:extLst>
           </p:cNvPr>
@@ -28540,7 +30668,7 @@
           <p:cNvPr id="3" name="">
             <a:extLst xmlns:a="http://schemas.openxmlformats.org/drawingml/2006/main">
               <a:ext uri="{FF2B5EF4-FFF2-40B4-BE49-F238E27FC236}">
-                <a16:creationId xmlns:a16="http://schemas.microsoft.com/office/drawing/2014/main" id="{299E3E9C-E12E-46FF-A07C-959CE36C86CD}"/>
+                <a16:creationId xmlns:a16="http://schemas.microsoft.com/office/drawing/2014/main" id="{DA2C8C39-F6BC-41DD-8221-41986B01AB9F}"/>
               </a:ext>
             </a:extLst>
           </p:cNvPr>
@@ -28696,7 +30824,7 @@
           <p:cNvPr id="4" name="">
             <a:extLst xmlns:a="http://schemas.openxmlformats.org/drawingml/2006/main">
               <a:ext uri="{FF2B5EF4-FFF2-40B4-BE49-F238E27FC236}">
-                <a16:creationId xmlns:a16="http://schemas.microsoft.com/office/drawing/2014/main" id="{126E1734-3150-4116-9F06-7010CB306B5F}"/>
+                <a16:creationId xmlns:a16="http://schemas.microsoft.com/office/drawing/2014/main" id="{8904E68A-AE8D-414D-A22A-CBC73C3F91D8}"/>
               </a:ext>
             </a:extLst>
           </p:cNvPr>
@@ -28852,7 +30980,7 @@
           <p:cNvPr id="5" name="">
             <a:extLst xmlns:a="http://schemas.openxmlformats.org/drawingml/2006/main">
               <a:ext uri="{FF2B5EF4-FFF2-40B4-BE49-F238E27FC236}">
-                <a16:creationId xmlns:a16="http://schemas.microsoft.com/office/drawing/2014/main" id="{7A6C0003-CA42-4D76-8A27-2711C59D3C7A}"/>
+                <a16:creationId xmlns:a16="http://schemas.microsoft.com/office/drawing/2014/main" id="{E43001A0-D05F-4B0C-BB6E-1EB6A5FC08EC}"/>
               </a:ext>
             </a:extLst>
           </p:cNvPr>
@@ -29063,7 +31191,7 @@
                           <a:ea typeface="Helvetica Neue"/>
                           <a:cs typeface="Helvetica Neue"/>
                         </a:rPr>
-                        <a:t>1,231</a:t>
+                        <a:t>1,230</a:t>
                       </a:r>
                     </a:p>
                   </a:txBody>
@@ -29179,7 +31307,7 @@
                           <a:ea typeface="Helvetica Neue"/>
                           <a:cs typeface="Helvetica Neue"/>
                         </a:rPr>
-                        <a:t>9,481</a:t>
+                        <a:t>9,483</a:t>
                       </a:r>
                     </a:p>
                   </a:txBody>
@@ -29295,7 +31423,7 @@
                           <a:ea typeface="Helvetica Neue"/>
                           <a:cs typeface="Helvetica Neue"/>
                         </a:rPr>
-                        <a:t>1,427</a:t>
+                        <a:t>1,428</a:t>
                       </a:r>
                     </a:p>
                   </a:txBody>
@@ -29363,7 +31491,7 @@
           <p:cNvPr id="6" name="">
             <a:extLst xmlns:a="http://schemas.openxmlformats.org/drawingml/2006/main">
               <a:ext uri="{FF2B5EF4-FFF2-40B4-BE49-F238E27FC236}">
-                <a16:creationId xmlns:a16="http://schemas.microsoft.com/office/drawing/2014/main" id="{AE5420E0-F838-4562-B66C-852018F6BE0B}"/>
+                <a16:creationId xmlns:a16="http://schemas.microsoft.com/office/drawing/2014/main" id="{F8E4167D-51C5-48ED-B5C7-E953D2AA6768}"/>
               </a:ext>
             </a:extLst>
           </p:cNvPr>
@@ -29519,7 +31647,7 @@
           <p:cNvPr id="7" name="">
             <a:extLst xmlns:a="http://schemas.openxmlformats.org/drawingml/2006/main">
               <a:ext uri="{FF2B5EF4-FFF2-40B4-BE49-F238E27FC236}">
-                <a16:creationId xmlns:a16="http://schemas.microsoft.com/office/drawing/2014/main" id="{5F103097-9427-4927-9EDC-52579A16B7CB}"/>
+                <a16:creationId xmlns:a16="http://schemas.microsoft.com/office/drawing/2014/main" id="{9BABBB6E-4E16-4AAC-BC0E-F8437298ABA7}"/>
               </a:ext>
             </a:extLst>
           </p:cNvPr>
@@ -29673,7 +31801,7 @@
     </p:spTree>
     <p:extLst>
       <p:ext uri="{BB962C8B-B14F-4D97-AF65-F5344CB8AC3E}">
-        <p14:creationId xmlns:p14="http://schemas.microsoft.com/office/powerpoint/2010/main" val="1679079176"/>
+        <p14:creationId xmlns:p14="http://schemas.microsoft.com/office/powerpoint/2010/main" val="1959189334"/>
       </p:ext>
     </p:extLst>
   </p:cSld>
@@ -29704,7 +31832,7 @@
           <p:cNvPr id="7" name="">
             <a:extLst xmlns:a="http://schemas.openxmlformats.org/drawingml/2006/main">
               <a:ext uri="{FF2B5EF4-FFF2-40B4-BE49-F238E27FC236}">
-                <a16:creationId xmlns:a16="http://schemas.microsoft.com/office/drawing/2014/main" id="{50338D31-7123-41F4-8801-BCB9DA38BEA9}"/>
+                <a16:creationId xmlns:a16="http://schemas.microsoft.com/office/drawing/2014/main" id="{1324F278-B5D5-4731-B7A5-EE4BF6693915}"/>
               </a:ext>
             </a:extLst>
           </p:cNvPr>
@@ -29860,7 +31988,7 @@
           <p:cNvPr id="2" name="">
             <a:extLst xmlns:a="http://schemas.openxmlformats.org/drawingml/2006/main">
               <a:ext uri="{FF2B5EF4-FFF2-40B4-BE49-F238E27FC236}">
-                <a16:creationId xmlns:a16="http://schemas.microsoft.com/office/drawing/2014/main" id="{43147DD5-3E6E-4B35-8890-65DE3C9D6717}"/>
+                <a16:creationId xmlns:a16="http://schemas.microsoft.com/office/drawing/2014/main" id="{82E9FC30-ED8B-4049-8D71-9B02E4CFCD92}"/>
               </a:ext>
             </a:extLst>
           </p:cNvPr>
@@ -30016,7 +32144,7 @@
           <p:cNvPr id="3" name="">
             <a:extLst xmlns:a="http://schemas.openxmlformats.org/drawingml/2006/main">
               <a:ext uri="{FF2B5EF4-FFF2-40B4-BE49-F238E27FC236}">
-                <a16:creationId xmlns:a16="http://schemas.microsoft.com/office/drawing/2014/main" id="{381ED808-51C0-4A11-ABF5-C1F435CC36C0}"/>
+                <a16:creationId xmlns:a16="http://schemas.microsoft.com/office/drawing/2014/main" id="{861031B7-A482-4185-906A-8CDC2AE3D43D}"/>
               </a:ext>
             </a:extLst>
           </p:cNvPr>
@@ -30172,7 +32300,7 @@
           <p:cNvPr id="4" name="">
             <a:extLst xmlns:a="http://schemas.openxmlformats.org/drawingml/2006/main">
               <a:ext uri="{FF2B5EF4-FFF2-40B4-BE49-F238E27FC236}">
-                <a16:creationId xmlns:a16="http://schemas.microsoft.com/office/drawing/2014/main" id="{94588F71-2461-4519-8178-83094DFB8BF6}"/>
+                <a16:creationId xmlns:a16="http://schemas.microsoft.com/office/drawing/2014/main" id="{5902DF8E-5498-4309-B3D5-72AEF01A4988}"/>
               </a:ext>
             </a:extLst>
           </p:cNvPr>
@@ -30328,7 +32456,7 @@
           <p:cNvPr id="5" name="">
             <a:extLst xmlns:a="http://schemas.openxmlformats.org/drawingml/2006/main">
               <a:ext uri="{FF2B5EF4-FFF2-40B4-BE49-F238E27FC236}">
-                <a16:creationId xmlns:a16="http://schemas.microsoft.com/office/drawing/2014/main" id="{2A530CEA-2D44-4D3D-B7C0-06ABFE5D73B1}"/>
+                <a16:creationId xmlns:a16="http://schemas.microsoft.com/office/drawing/2014/main" id="{297802CD-22C0-4200-88F7-DEAFB1CE7C75}"/>
               </a:ext>
             </a:extLst>
           </p:cNvPr>
@@ -31303,7 +33431,7 @@
           <p:cNvPr id="6" name="">
             <a:extLst xmlns:a="http://schemas.openxmlformats.org/drawingml/2006/main">
               <a:ext uri="{FF2B5EF4-FFF2-40B4-BE49-F238E27FC236}">
-                <a16:creationId xmlns:a16="http://schemas.microsoft.com/office/drawing/2014/main" id="{1158489B-A68C-4CB1-9D94-E069A2F43840}"/>
+                <a16:creationId xmlns:a16="http://schemas.microsoft.com/office/drawing/2014/main" id="{CCDDA50B-EC3F-4476-869B-0868627A7569}"/>
               </a:ext>
             </a:extLst>
           </p:cNvPr>
@@ -31457,7 +33585,7 @@
     </p:spTree>
     <p:extLst>
       <p:ext uri="{BB962C8B-B14F-4D97-AF65-F5344CB8AC3E}">
-        <p14:creationId xmlns:p14="http://schemas.microsoft.com/office/powerpoint/2010/main" val="1461775565"/>
+        <p14:creationId xmlns:p14="http://schemas.microsoft.com/office/powerpoint/2010/main" val="85805773"/>
       </p:ext>
     </p:extLst>
   </p:cSld>
@@ -31488,7 +33616,7 @@
           <p:cNvPr id="8" name="">
             <a:extLst xmlns:a="http://schemas.openxmlformats.org/drawingml/2006/main">
               <a:ext uri="{FF2B5EF4-FFF2-40B4-BE49-F238E27FC236}">
-                <a16:creationId xmlns:a16="http://schemas.microsoft.com/office/drawing/2014/main" id="{D976C719-C35A-48AE-A88C-520A71B75C25}"/>
+                <a16:creationId xmlns:a16="http://schemas.microsoft.com/office/drawing/2014/main" id="{AFFDDC66-0F8D-4B2B-B8D7-6B74FAF6430A}"/>
               </a:ext>
             </a:extLst>
           </p:cNvPr>
@@ -31644,7 +33772,7 @@
           <p:cNvPr id="2" name="">
             <a:extLst xmlns:a="http://schemas.openxmlformats.org/drawingml/2006/main">
               <a:ext uri="{FF2B5EF4-FFF2-40B4-BE49-F238E27FC236}">
-                <a16:creationId xmlns:a16="http://schemas.microsoft.com/office/drawing/2014/main" id="{3002736E-0B19-4D0F-959F-657227C81E76}"/>
+                <a16:creationId xmlns:a16="http://schemas.microsoft.com/office/drawing/2014/main" id="{78D10C50-1FBA-481B-8B62-F725BB0D3FFC}"/>
               </a:ext>
             </a:extLst>
           </p:cNvPr>
@@ -31800,7 +33928,7 @@
           <p:cNvPr id="3" name="">
             <a:extLst xmlns:a="http://schemas.openxmlformats.org/drawingml/2006/main">
               <a:ext uri="{FF2B5EF4-FFF2-40B4-BE49-F238E27FC236}">
-                <a16:creationId xmlns:a16="http://schemas.microsoft.com/office/drawing/2014/main" id="{093E2C9A-9B38-40A8-9421-0A4CCB5AE400}"/>
+                <a16:creationId xmlns:a16="http://schemas.microsoft.com/office/drawing/2014/main" id="{888858A2-1788-47D7-A26D-7E1FCDFC3FCF}"/>
               </a:ext>
             </a:extLst>
           </p:cNvPr>
@@ -31956,7 +34084,7 @@
           <p:cNvPr id="4" name="">
             <a:extLst xmlns:a="http://schemas.openxmlformats.org/drawingml/2006/main">
               <a:ext uri="{FF2B5EF4-FFF2-40B4-BE49-F238E27FC236}">
-                <a16:creationId xmlns:a16="http://schemas.microsoft.com/office/drawing/2014/main" id="{05EF68B3-5301-43D2-B866-A9BD0B10FEDC}"/>
+                <a16:creationId xmlns:a16="http://schemas.microsoft.com/office/drawing/2014/main" id="{274228CA-B8E1-4236-8321-0467EC1FE575}"/>
               </a:ext>
             </a:extLst>
           </p:cNvPr>
@@ -32112,7 +34240,7 @@
           <p:cNvPr id="5" name="">
             <a:extLst xmlns:a="http://schemas.openxmlformats.org/drawingml/2006/main">
               <a:ext uri="{FF2B5EF4-FFF2-40B4-BE49-F238E27FC236}">
-                <a16:creationId xmlns:a16="http://schemas.microsoft.com/office/drawing/2014/main" id="{5D7161F7-7A4E-46C4-A62A-D4960F54FB01}"/>
+                <a16:creationId xmlns:a16="http://schemas.microsoft.com/office/drawing/2014/main" id="{4E9D80BF-9414-442E-ADFD-3BBDC578283A}"/>
               </a:ext>
             </a:extLst>
           </p:cNvPr>
@@ -32925,7 +35053,7 @@
           <p:cNvPr id="6" name="">
             <a:extLst xmlns:a="http://schemas.openxmlformats.org/drawingml/2006/main">
               <a:ext uri="{FF2B5EF4-FFF2-40B4-BE49-F238E27FC236}">
-                <a16:creationId xmlns:a16="http://schemas.microsoft.com/office/drawing/2014/main" id="{FB262160-D838-41FA-94C5-4DA95EEE5275}"/>
+                <a16:creationId xmlns:a16="http://schemas.microsoft.com/office/drawing/2014/main" id="{5E0C557A-494F-48EA-BA09-1179C232AD91}"/>
               </a:ext>
             </a:extLst>
           </p:cNvPr>
@@ -33081,7 +35209,7 @@
           <p:cNvPr id="7" name="">
             <a:extLst xmlns:a="http://schemas.openxmlformats.org/drawingml/2006/main">
               <a:ext uri="{FF2B5EF4-FFF2-40B4-BE49-F238E27FC236}">
-                <a16:creationId xmlns:a16="http://schemas.microsoft.com/office/drawing/2014/main" id="{A14F915A-8EA9-4621-9780-F5FD7D9B2560}"/>
+                <a16:creationId xmlns:a16="http://schemas.microsoft.com/office/drawing/2014/main" id="{48D2886D-1E60-4B79-999F-4D5633CAA0BC}"/>
               </a:ext>
             </a:extLst>
           </p:cNvPr>
@@ -33235,7 +35363,7 @@
     </p:spTree>
     <p:extLst>
       <p:ext uri="{BB962C8B-B14F-4D97-AF65-F5344CB8AC3E}">
-        <p14:creationId xmlns:p14="http://schemas.microsoft.com/office/powerpoint/2010/main" val="1964628875"/>
+        <p14:creationId xmlns:p14="http://schemas.microsoft.com/office/powerpoint/2010/main" val="130955244"/>
       </p:ext>
     </p:extLst>
   </p:cSld>
@@ -33266,7 +35394,7 @@
           <p:cNvPr id="7" name="">
             <a:extLst xmlns:a="http://schemas.openxmlformats.org/drawingml/2006/main">
               <a:ext uri="{FF2B5EF4-FFF2-40B4-BE49-F238E27FC236}">
-                <a16:creationId xmlns:a16="http://schemas.microsoft.com/office/drawing/2014/main" id="{90A242EC-2F16-4E1F-94CC-112DA87BE968}"/>
+                <a16:creationId xmlns:a16="http://schemas.microsoft.com/office/drawing/2014/main" id="{1E4C8598-04ED-4B0A-81A5-D582980D7C6E}"/>
               </a:ext>
             </a:extLst>
           </p:cNvPr>
@@ -33422,7 +35550,7 @@
           <p:cNvPr id="2" name="">
             <a:extLst xmlns:a="http://schemas.openxmlformats.org/drawingml/2006/main">
               <a:ext uri="{FF2B5EF4-FFF2-40B4-BE49-F238E27FC236}">
-                <a16:creationId xmlns:a16="http://schemas.microsoft.com/office/drawing/2014/main" id="{C9247616-9D81-4D55-BB7C-C6DCC58BEC8F}"/>
+                <a16:creationId xmlns:a16="http://schemas.microsoft.com/office/drawing/2014/main" id="{40E99E08-6E49-4679-B2D9-87705C0959A7}"/>
               </a:ext>
             </a:extLst>
           </p:cNvPr>
@@ -33578,7 +35706,7 @@
           <p:cNvPr id="3" name="">
             <a:extLst xmlns:a="http://schemas.openxmlformats.org/drawingml/2006/main">
               <a:ext uri="{FF2B5EF4-FFF2-40B4-BE49-F238E27FC236}">
-                <a16:creationId xmlns:a16="http://schemas.microsoft.com/office/drawing/2014/main" id="{39E43311-2DBE-44BC-B39B-20000F9E1ECE}"/>
+                <a16:creationId xmlns:a16="http://schemas.microsoft.com/office/drawing/2014/main" id="{4DBC6CFB-48D0-42CE-9CAE-C01B3651CE58}"/>
               </a:ext>
             </a:extLst>
           </p:cNvPr>
@@ -33734,7 +35862,7 @@
           <p:cNvPr id="4" name="">
             <a:extLst xmlns:a="http://schemas.openxmlformats.org/drawingml/2006/main">
               <a:ext uri="{FF2B5EF4-FFF2-40B4-BE49-F238E27FC236}">
-                <a16:creationId xmlns:a16="http://schemas.microsoft.com/office/drawing/2014/main" id="{3E5F0422-7634-4D1F-B1BF-B719CF3DA1A6}"/>
+                <a16:creationId xmlns:a16="http://schemas.microsoft.com/office/drawing/2014/main" id="{EDFE5716-2443-4220-9F3A-B7ACEB8657CF}"/>
               </a:ext>
             </a:extLst>
           </p:cNvPr>
@@ -33890,7 +36018,7 @@
           <p:cNvPr id="5" name="">
             <a:extLst xmlns:a="http://schemas.openxmlformats.org/drawingml/2006/main">
               <a:ext uri="{FF2B5EF4-FFF2-40B4-BE49-F238E27FC236}">
-                <a16:creationId xmlns:a16="http://schemas.microsoft.com/office/drawing/2014/main" id="{0683EC20-626D-448C-8A65-209FB477B3CA}"/>
+                <a16:creationId xmlns:a16="http://schemas.microsoft.com/office/drawing/2014/main" id="{1A3B926A-13E2-437C-9A09-47BB0555CB82}"/>
               </a:ext>
             </a:extLst>
           </p:cNvPr>
@@ -34285,7 +36413,7 @@
           <p:cNvPr id="6" name="">
             <a:extLst xmlns:a="http://schemas.openxmlformats.org/drawingml/2006/main">
               <a:ext uri="{FF2B5EF4-FFF2-40B4-BE49-F238E27FC236}">
-                <a16:creationId xmlns:a16="http://schemas.microsoft.com/office/drawing/2014/main" id="{95119BAE-1137-49A4-A29F-9B6D57C7E443}"/>
+                <a16:creationId xmlns:a16="http://schemas.microsoft.com/office/drawing/2014/main" id="{3C7C858D-72EE-4B44-B1A6-69F1029916F9}"/>
               </a:ext>
             </a:extLst>
           </p:cNvPr>
@@ -34439,7 +36567,7 @@
     </p:spTree>
     <p:extLst>
       <p:ext uri="{BB962C8B-B14F-4D97-AF65-F5344CB8AC3E}">
-        <p14:creationId xmlns:p14="http://schemas.microsoft.com/office/powerpoint/2010/main" val="1544996347"/>
+        <p14:creationId xmlns:p14="http://schemas.microsoft.com/office/powerpoint/2010/main" val="676349780"/>
       </p:ext>
     </p:extLst>
   </p:cSld>
@@ -34470,7 +36598,7 @@
           <p:cNvPr id="7" name="">
             <a:extLst xmlns:a="http://schemas.openxmlformats.org/drawingml/2006/main">
               <a:ext uri="{FF2B5EF4-FFF2-40B4-BE49-F238E27FC236}">
-                <a16:creationId xmlns:a16="http://schemas.microsoft.com/office/drawing/2014/main" id="{0E757467-0A7F-496B-BA92-BA7ABDCD03C1}"/>
+                <a16:creationId xmlns:a16="http://schemas.microsoft.com/office/drawing/2014/main" id="{93B21A6B-804E-49C1-8879-B91D5FE8C886}"/>
               </a:ext>
             </a:extLst>
           </p:cNvPr>
@@ -34626,7 +36754,7 @@
           <p:cNvPr id="2" name="">
             <a:extLst xmlns:a="http://schemas.openxmlformats.org/drawingml/2006/main">
               <a:ext uri="{FF2B5EF4-FFF2-40B4-BE49-F238E27FC236}">
-                <a16:creationId xmlns:a16="http://schemas.microsoft.com/office/drawing/2014/main" id="{921D7AC4-423E-4B09-934D-D70361B50414}"/>
+                <a16:creationId xmlns:a16="http://schemas.microsoft.com/office/drawing/2014/main" id="{C0627A5F-ED5F-484E-9D69-61D75A3668AE}"/>
               </a:ext>
             </a:extLst>
           </p:cNvPr>
@@ -34782,7 +36910,7 @@
           <p:cNvPr id="3" name="">
             <a:extLst xmlns:a="http://schemas.openxmlformats.org/drawingml/2006/main">
               <a:ext uri="{FF2B5EF4-FFF2-40B4-BE49-F238E27FC236}">
-                <a16:creationId xmlns:a16="http://schemas.microsoft.com/office/drawing/2014/main" id="{A0F334E0-22DD-48AA-927A-BDC46CED34E0}"/>
+                <a16:creationId xmlns:a16="http://schemas.microsoft.com/office/drawing/2014/main" id="{BAC3E31C-B442-44CE-B685-C6BB2AC9B54E}"/>
               </a:ext>
             </a:extLst>
           </p:cNvPr>
@@ -34938,7 +37066,7 @@
           <p:cNvPr id="4" name="">
             <a:extLst xmlns:a="http://schemas.openxmlformats.org/drawingml/2006/main">
               <a:ext uri="{FF2B5EF4-FFF2-40B4-BE49-F238E27FC236}">
-                <a16:creationId xmlns:a16="http://schemas.microsoft.com/office/drawing/2014/main" id="{622D4772-13ED-4E1E-A19E-E732C3522086}"/>
+                <a16:creationId xmlns:a16="http://schemas.microsoft.com/office/drawing/2014/main" id="{CB3B11F4-D317-48C6-B13D-9848E543D518}"/>
               </a:ext>
             </a:extLst>
           </p:cNvPr>
@@ -35094,7 +37222,7 @@
           <p:cNvPr id="5" name="Chart">
             <a:extLst xmlns:a="http://schemas.openxmlformats.org/drawingml/2006/main">
               <a:ext uri="{FF2B5EF4-FFF2-40B4-BE49-F238E27FC236}">
-                <a16:creationId xmlns:a16="http://schemas.microsoft.com/office/drawing/2014/main" id="{D969B16E-A215-4F21-9428-8F7B7E712D46}"/>
+                <a16:creationId xmlns:a16="http://schemas.microsoft.com/office/drawing/2014/main" id="{541D8AE3-0A8B-4436-8BA3-7B310A44FF9B}"/>
               </a:ext>
             </a:extLst>
           </p:cNvPr>
@@ -35107,7 +37235,7 @@
         </p:xfrm>
         <a:graphic xmlns:a="http://schemas.openxmlformats.org/drawingml/2006/main">
           <a:graphicData uri="http://schemas.openxmlformats.org/drawingml/2006/chart">
-            <c:chart xmlns:r="http://schemas.openxmlformats.org/officeDocument/2006/relationships" xmlns:c="http://schemas.openxmlformats.org/drawingml/2006/chart" r:id="R7186aa86224b4bb7"/>
+            <c:chart xmlns:r="http://schemas.openxmlformats.org/officeDocument/2006/relationships" xmlns:c="http://schemas.openxmlformats.org/drawingml/2006/chart" r:id="Rb6b21bab454a457a"/>
           </a:graphicData>
         </a:graphic>
       </p:graphicFrame>
@@ -35116,7 +37244,7 @@
           <p:cNvPr id="6" name="">
             <a:extLst xmlns:a="http://schemas.openxmlformats.org/drawingml/2006/main">
               <a:ext uri="{FF2B5EF4-FFF2-40B4-BE49-F238E27FC236}">
-                <a16:creationId xmlns:a16="http://schemas.microsoft.com/office/drawing/2014/main" id="{03EFE88C-A3AC-49EA-84D9-2EB6FE9FB1E7}"/>
+                <a16:creationId xmlns:a16="http://schemas.microsoft.com/office/drawing/2014/main" id="{5E7371B0-449A-42C9-9385-9C15B1217475}"/>
               </a:ext>
             </a:extLst>
           </p:cNvPr>
@@ -35270,7 +37398,7 @@
     </p:spTree>
     <p:extLst>
       <p:ext uri="{BB962C8B-B14F-4D97-AF65-F5344CB8AC3E}">
-        <p14:creationId xmlns:p14="http://schemas.microsoft.com/office/powerpoint/2010/main" val="738103301"/>
+        <p14:creationId xmlns:p14="http://schemas.microsoft.com/office/powerpoint/2010/main" val="648025362"/>
       </p:ext>
     </p:extLst>
   </p:cSld>

</xml_diff>

<commit_message>
Keep association and restriction distinct throughout report prose and slides
</commit_message>
<xml_diff>
--- a/docs/audits/cta-source-walkthrough-20261028/slides/cta-evidence-walkthrough-expanded.pptx
+++ b/docs/audits/cta-source-walkthrough-20261028/slides/cta-evidence-walkthrough-expanded.pptx
@@ -2,40 +2,40 @@
 <file path=ppt/presentation.xml><?xml version="1.0" encoding="utf-8"?>
 <p:presentation xmlns:p="http://schemas.openxmlformats.org/presentationml/2006/main">
   <p:sldMasterIdLst>
-    <p:sldMasterId xmlns:r="http://schemas.openxmlformats.org/officeDocument/2006/relationships" id="2147483648" r:id="Ref854f3e1b884500"/>
+    <p:sldMasterId xmlns:r="http://schemas.openxmlformats.org/officeDocument/2006/relationships" id="2147483648" r:id="Rf6473c4b1bd74b27"/>
   </p:sldMasterIdLst>
   <p:notesMasterIdLst>
-    <p:notesMasterId xmlns:r="http://schemas.openxmlformats.org/officeDocument/2006/relationships" r:id="R19f0d1e08b6c4c7e"/>
+    <p:notesMasterId xmlns:r="http://schemas.openxmlformats.org/officeDocument/2006/relationships" r:id="Rb2ec5469d9fa446c"/>
   </p:notesMasterIdLst>
   <p:sldIdLst>
-    <p:sldId xmlns:r="http://schemas.openxmlformats.org/officeDocument/2006/relationships" id="256" r:id="Ra359f0005bc34047"/>
-    <p:sldId xmlns:r="http://schemas.openxmlformats.org/officeDocument/2006/relationships" id="257" r:id="R38668671f748428d"/>
-    <p:sldId xmlns:r="http://schemas.openxmlformats.org/officeDocument/2006/relationships" id="258" r:id="R701d97252dce4ac2"/>
-    <p:sldId xmlns:r="http://schemas.openxmlformats.org/officeDocument/2006/relationships" id="259" r:id="R5cffdfdf900448b3"/>
-    <p:sldId xmlns:r="http://schemas.openxmlformats.org/officeDocument/2006/relationships" id="260" r:id="R4edf82acb01b4677"/>
-    <p:sldId xmlns:r="http://schemas.openxmlformats.org/officeDocument/2006/relationships" id="261" r:id="R0b67e75b37664055"/>
-    <p:sldId xmlns:r="http://schemas.openxmlformats.org/officeDocument/2006/relationships" id="262" r:id="R518a3c31f5b04ce3"/>
-    <p:sldId xmlns:r="http://schemas.openxmlformats.org/officeDocument/2006/relationships" id="263" r:id="Rd19f3334ca05487e"/>
-    <p:sldId xmlns:r="http://schemas.openxmlformats.org/officeDocument/2006/relationships" id="264" r:id="R2ebcdd9e6a8b406e"/>
-    <p:sldId xmlns:r="http://schemas.openxmlformats.org/officeDocument/2006/relationships" id="265" r:id="Rf002e50c0105440e"/>
-    <p:sldId xmlns:r="http://schemas.openxmlformats.org/officeDocument/2006/relationships" id="266" r:id="Ra8b41566e1fa49c3"/>
-    <p:sldId xmlns:r="http://schemas.openxmlformats.org/officeDocument/2006/relationships" id="267" r:id="R3d74dc6f44504deb"/>
-    <p:sldId xmlns:r="http://schemas.openxmlformats.org/officeDocument/2006/relationships" id="268" r:id="R8a62baf27e4747e5"/>
-    <p:sldId xmlns:r="http://schemas.openxmlformats.org/officeDocument/2006/relationships" id="269" r:id="Rd1dd8fe10aca462f"/>
-    <p:sldId xmlns:r="http://schemas.openxmlformats.org/officeDocument/2006/relationships" id="270" r:id="R131a11d389f446c7"/>
-    <p:sldId xmlns:r="http://schemas.openxmlformats.org/officeDocument/2006/relationships" id="271" r:id="Rc9d82358c62440c4"/>
-    <p:sldId xmlns:r="http://schemas.openxmlformats.org/officeDocument/2006/relationships" id="272" r:id="R18af5292175e4fa5"/>
-    <p:sldId xmlns:r="http://schemas.openxmlformats.org/officeDocument/2006/relationships" id="273" r:id="Rdab32a0df9d54967"/>
-    <p:sldId xmlns:r="http://schemas.openxmlformats.org/officeDocument/2006/relationships" id="274" r:id="R21312245c801401d"/>
-    <p:sldId xmlns:r="http://schemas.openxmlformats.org/officeDocument/2006/relationships" id="275" r:id="R387c6706815e45fe"/>
-    <p:sldId xmlns:r="http://schemas.openxmlformats.org/officeDocument/2006/relationships" id="276" r:id="R702743c1fb304219"/>
-    <p:sldId xmlns:r="http://schemas.openxmlformats.org/officeDocument/2006/relationships" id="277" r:id="R30878878dcfa466b"/>
-    <p:sldId xmlns:r="http://schemas.openxmlformats.org/officeDocument/2006/relationships" id="278" r:id="R12b9fa24f0474a53"/>
-    <p:sldId xmlns:r="http://schemas.openxmlformats.org/officeDocument/2006/relationships" id="279" r:id="Rb50053d29f6a41b3"/>
-    <p:sldId xmlns:r="http://schemas.openxmlformats.org/officeDocument/2006/relationships" id="280" r:id="Rb6e37a91c56d4f7b"/>
-    <p:sldId xmlns:r="http://schemas.openxmlformats.org/officeDocument/2006/relationships" id="281" r:id="R5c8ab4affce04fb2"/>
-    <p:sldId xmlns:r="http://schemas.openxmlformats.org/officeDocument/2006/relationships" id="282" r:id="R33ecbfbe82a44eb8"/>
-    <p:sldId xmlns:r="http://schemas.openxmlformats.org/officeDocument/2006/relationships" id="283" r:id="R6cb0b3fee9fd4882"/>
+    <p:sldId xmlns:r="http://schemas.openxmlformats.org/officeDocument/2006/relationships" id="256" r:id="Rabec717ea97243e5"/>
+    <p:sldId xmlns:r="http://schemas.openxmlformats.org/officeDocument/2006/relationships" id="257" r:id="R082219745e004c73"/>
+    <p:sldId xmlns:r="http://schemas.openxmlformats.org/officeDocument/2006/relationships" id="258" r:id="Rdff4d1386b564bf7"/>
+    <p:sldId xmlns:r="http://schemas.openxmlformats.org/officeDocument/2006/relationships" id="259" r:id="Ra578d6a42d8d4181"/>
+    <p:sldId xmlns:r="http://schemas.openxmlformats.org/officeDocument/2006/relationships" id="260" r:id="Rf850d08871bd4047"/>
+    <p:sldId xmlns:r="http://schemas.openxmlformats.org/officeDocument/2006/relationships" id="261" r:id="R274764ea4c094073"/>
+    <p:sldId xmlns:r="http://schemas.openxmlformats.org/officeDocument/2006/relationships" id="262" r:id="R470b80071bf449eb"/>
+    <p:sldId xmlns:r="http://schemas.openxmlformats.org/officeDocument/2006/relationships" id="263" r:id="R49e78a83a98a40fc"/>
+    <p:sldId xmlns:r="http://schemas.openxmlformats.org/officeDocument/2006/relationships" id="264" r:id="R488e5c77e33d4f91"/>
+    <p:sldId xmlns:r="http://schemas.openxmlformats.org/officeDocument/2006/relationships" id="265" r:id="R97341441e2754c2e"/>
+    <p:sldId xmlns:r="http://schemas.openxmlformats.org/officeDocument/2006/relationships" id="266" r:id="R2395ec0c466443ab"/>
+    <p:sldId xmlns:r="http://schemas.openxmlformats.org/officeDocument/2006/relationships" id="267" r:id="R254f675291314c92"/>
+    <p:sldId xmlns:r="http://schemas.openxmlformats.org/officeDocument/2006/relationships" id="268" r:id="R75b8dd11eda94b5a"/>
+    <p:sldId xmlns:r="http://schemas.openxmlformats.org/officeDocument/2006/relationships" id="269" r:id="Rc6edd2a722e94f03"/>
+    <p:sldId xmlns:r="http://schemas.openxmlformats.org/officeDocument/2006/relationships" id="270" r:id="Rba97818ac31a4b9b"/>
+    <p:sldId xmlns:r="http://schemas.openxmlformats.org/officeDocument/2006/relationships" id="271" r:id="R1e017b4b2c534603"/>
+    <p:sldId xmlns:r="http://schemas.openxmlformats.org/officeDocument/2006/relationships" id="272" r:id="Rb64a4b7c2a0d4393"/>
+    <p:sldId xmlns:r="http://schemas.openxmlformats.org/officeDocument/2006/relationships" id="273" r:id="R32a3dc5573d14eb7"/>
+    <p:sldId xmlns:r="http://schemas.openxmlformats.org/officeDocument/2006/relationships" id="274" r:id="Rdcb31b119d2e48da"/>
+    <p:sldId xmlns:r="http://schemas.openxmlformats.org/officeDocument/2006/relationships" id="275" r:id="R0c281c6f0d20492a"/>
+    <p:sldId xmlns:r="http://schemas.openxmlformats.org/officeDocument/2006/relationships" id="276" r:id="R5a48c153110940b3"/>
+    <p:sldId xmlns:r="http://schemas.openxmlformats.org/officeDocument/2006/relationships" id="277" r:id="Ra2008e1fc9274fc1"/>
+    <p:sldId xmlns:r="http://schemas.openxmlformats.org/officeDocument/2006/relationships" id="278" r:id="R3c936e7a0b604aae"/>
+    <p:sldId xmlns:r="http://schemas.openxmlformats.org/officeDocument/2006/relationships" id="279" r:id="R6f2483c733ec4045"/>
+    <p:sldId xmlns:r="http://schemas.openxmlformats.org/officeDocument/2006/relationships" id="280" r:id="Re59c608804864ccf"/>
+    <p:sldId xmlns:r="http://schemas.openxmlformats.org/officeDocument/2006/relationships" id="281" r:id="R557c0394a4c043e6"/>
+    <p:sldId xmlns:r="http://schemas.openxmlformats.org/officeDocument/2006/relationships" id="282" r:id="R0c34c4296a884658"/>
+    <p:sldId xmlns:r="http://schemas.openxmlformats.org/officeDocument/2006/relationships" id="283" r:id="Rdef423c87ef6438e"/>
   </p:sldIdLst>
   <p:sldSz cx="12192000" cy="6858000"/>
   <p:notesSz cx="6858000" cy="9144000"/>
@@ -3021,7 +3021,7 @@
           <p:cNvPr id="3" name="Title">
             <a:extLst xmlns:a="http://schemas.openxmlformats.org/drawingml/2006/main">
               <a:ext uri="{FF2B5EF4-FFF2-40B4-BE49-F238E27FC236}">
-                <a16:creationId xmlns:a16="http://schemas.microsoft.com/office/drawing/2014/main" id="{68A1ADA2-8AE0-4722-9175-D599C9E31843}"/>
+                <a16:creationId xmlns:a16="http://schemas.microsoft.com/office/drawing/2014/main" id="{213675BA-ED3F-41E6-9ADF-4734686B60B0}"/>
               </a:ext>
             </a:extLst>
           </p:cNvPr>
@@ -3250,7 +3250,7 @@
           <p:cNvPr id="2" name="Subtitle">
             <a:extLst xmlns:a="http://schemas.openxmlformats.org/drawingml/2006/main">
               <a:ext uri="{FF2B5EF4-FFF2-40B4-BE49-F238E27FC236}">
-                <a16:creationId xmlns:a16="http://schemas.microsoft.com/office/drawing/2014/main" id="{D8A6923E-A42F-42EF-BF1F-8DEE32F52A8B}"/>
+                <a16:creationId xmlns:a16="http://schemas.microsoft.com/office/drawing/2014/main" id="{A453DD48-5F89-46A2-9D62-575CC051D4C4}"/>
               </a:ext>
             </a:extLst>
           </p:cNvPr>
@@ -3496,7 +3496,7 @@
           <p:cNvPr id="2" name="Section title">
             <a:extLst xmlns:a="http://schemas.openxmlformats.org/drawingml/2006/main">
               <a:ext uri="{FF2B5EF4-FFF2-40B4-BE49-F238E27FC236}">
-                <a16:creationId xmlns:a16="http://schemas.microsoft.com/office/drawing/2014/main" id="{F500A575-1218-499D-98E9-71541B387FF5}"/>
+                <a16:creationId xmlns:a16="http://schemas.microsoft.com/office/drawing/2014/main" id="{CA93C000-0475-4EFF-B332-C1215C6B9D12}"/>
               </a:ext>
             </a:extLst>
           </p:cNvPr>
@@ -3742,7 +3742,7 @@
           <p:cNvPr id="3" name="Title">
             <a:extLst xmlns:a="http://schemas.openxmlformats.org/drawingml/2006/main">
               <a:ext uri="{FF2B5EF4-FFF2-40B4-BE49-F238E27FC236}">
-                <a16:creationId xmlns:a16="http://schemas.microsoft.com/office/drawing/2014/main" id="{43EF9FA1-8E13-49FC-97B4-97D38D321F6C}"/>
+                <a16:creationId xmlns:a16="http://schemas.microsoft.com/office/drawing/2014/main" id="{EA776D0D-C8DB-481D-8BD5-82FDDDFF1868}"/>
               </a:ext>
             </a:extLst>
           </p:cNvPr>
@@ -3971,7 +3971,7 @@
           <p:cNvPr id="2" name="Body">
             <a:extLst xmlns:a="http://schemas.openxmlformats.org/drawingml/2006/main">
               <a:ext uri="{FF2B5EF4-FFF2-40B4-BE49-F238E27FC236}">
-                <a16:creationId xmlns:a16="http://schemas.microsoft.com/office/drawing/2014/main" id="{2E7E38F5-58DC-4CD8-A4CE-2D30E1508935}"/>
+                <a16:creationId xmlns:a16="http://schemas.microsoft.com/office/drawing/2014/main" id="{D16647EC-CFE0-4613-898C-1C431CDF82EB}"/>
               </a:ext>
             </a:extLst>
           </p:cNvPr>
@@ -4217,7 +4217,7 @@
           <p:cNvPr id="4" name="Title">
             <a:extLst xmlns:a="http://schemas.openxmlformats.org/drawingml/2006/main">
               <a:ext uri="{FF2B5EF4-FFF2-40B4-BE49-F238E27FC236}">
-                <a16:creationId xmlns:a16="http://schemas.microsoft.com/office/drawing/2014/main" id="{831DF39F-EE67-45B5-A57D-326CE6C5E15A}"/>
+                <a16:creationId xmlns:a16="http://schemas.microsoft.com/office/drawing/2014/main" id="{C5B462FB-8F1C-43A2-9B55-D0382E64A0CB}"/>
               </a:ext>
             </a:extLst>
           </p:cNvPr>
@@ -4446,7 +4446,7 @@
           <p:cNvPr id="2" name="Left column">
             <a:extLst xmlns:a="http://schemas.openxmlformats.org/drawingml/2006/main">
               <a:ext uri="{FF2B5EF4-FFF2-40B4-BE49-F238E27FC236}">
-                <a16:creationId xmlns:a16="http://schemas.microsoft.com/office/drawing/2014/main" id="{88BDA84F-919B-4EC2-B90A-4C95076B94DF}"/>
+                <a16:creationId xmlns:a16="http://schemas.microsoft.com/office/drawing/2014/main" id="{7F7E2960-887F-4FCE-87DE-37B7251E6B87}"/>
               </a:ext>
             </a:extLst>
           </p:cNvPr>
@@ -4675,7 +4675,7 @@
           <p:cNvPr id="3" name="Right column">
             <a:extLst xmlns:a="http://schemas.openxmlformats.org/drawingml/2006/main">
               <a:ext uri="{FF2B5EF4-FFF2-40B4-BE49-F238E27FC236}">
-                <a16:creationId xmlns:a16="http://schemas.microsoft.com/office/drawing/2014/main" id="{B35FD290-B2BE-43E1-99CD-5DB37357D4BE}"/>
+                <a16:creationId xmlns:a16="http://schemas.microsoft.com/office/drawing/2014/main" id="{7BEE1BFA-68DF-4A82-A375-404B71ADB88E}"/>
               </a:ext>
             </a:extLst>
           </p:cNvPr>
@@ -4921,7 +4921,7 @@
           <p:cNvPr id="3" name="Title">
             <a:extLst xmlns:a="http://schemas.openxmlformats.org/drawingml/2006/main">
               <a:ext uri="{FF2B5EF4-FFF2-40B4-BE49-F238E27FC236}">
-                <a16:creationId xmlns:a16="http://schemas.microsoft.com/office/drawing/2014/main" id="{9D9DB41D-1821-471C-9699-2838B1DCDA60}"/>
+                <a16:creationId xmlns:a16="http://schemas.microsoft.com/office/drawing/2014/main" id="{A6B7651C-CA3F-4FC2-AE7C-36FC410CC55E}"/>
               </a:ext>
             </a:extLst>
           </p:cNvPr>
@@ -5150,7 +5150,7 @@
           <p:cNvPr id="2" name="Left column">
             <a:extLst xmlns:a="http://schemas.openxmlformats.org/drawingml/2006/main">
               <a:ext uri="{FF2B5EF4-FFF2-40B4-BE49-F238E27FC236}">
-                <a16:creationId xmlns:a16="http://schemas.microsoft.com/office/drawing/2014/main" id="{A9A5A5A3-940D-452D-8EF1-A590909D6D6D}"/>
+                <a16:creationId xmlns:a16="http://schemas.microsoft.com/office/drawing/2014/main" id="{ED0E24A2-6DF9-4B2B-BAF9-50A7D9E923F8}"/>
               </a:ext>
             </a:extLst>
           </p:cNvPr>
@@ -5417,12 +5417,12 @@
   </p:cSld>
   <p:clrMap bg1="lt1" tx1="dk1" bg2="lt2" tx2="dk2" accent1="accent1" accent2="accent2" accent3="accent3" accent4="accent4" accent5="accent5" accent6="accent6" hlink="hlink" folHlink="folHlink"/>
   <p:sldLayoutIdLst>
-    <p:sldLayoutId xmlns:r="http://schemas.openxmlformats.org/officeDocument/2006/relationships" id="2147483649" r:id="Rc622a7f61c464879"/>
-    <p:sldLayoutId xmlns:r="http://schemas.openxmlformats.org/officeDocument/2006/relationships" id="2147483650" r:id="R4f4ae5929fbb49fa"/>
-    <p:sldLayoutId xmlns:r="http://schemas.openxmlformats.org/officeDocument/2006/relationships" id="2147483651" r:id="Rd1e7bcce25cd43a8"/>
-    <p:sldLayoutId xmlns:r="http://schemas.openxmlformats.org/officeDocument/2006/relationships" id="2147483652" r:id="R56b1c2c3872848de"/>
-    <p:sldLayoutId xmlns:r="http://schemas.openxmlformats.org/officeDocument/2006/relationships" id="2147483653" r:id="R15a7debafdc745ac"/>
-    <p:sldLayoutId xmlns:r="http://schemas.openxmlformats.org/officeDocument/2006/relationships" id="2147483654" r:id="Raccf07c979a44415"/>
+    <p:sldLayoutId xmlns:r="http://schemas.openxmlformats.org/officeDocument/2006/relationships" id="2147483649" r:id="R7f5c18e54be94e46"/>
+    <p:sldLayoutId xmlns:r="http://schemas.openxmlformats.org/officeDocument/2006/relationships" id="2147483650" r:id="R432195baa9204e8f"/>
+    <p:sldLayoutId xmlns:r="http://schemas.openxmlformats.org/officeDocument/2006/relationships" id="2147483651" r:id="R16db7098f5464ed8"/>
+    <p:sldLayoutId xmlns:r="http://schemas.openxmlformats.org/officeDocument/2006/relationships" id="2147483652" r:id="Rd0a71d3c46724d31"/>
+    <p:sldLayoutId xmlns:r="http://schemas.openxmlformats.org/officeDocument/2006/relationships" id="2147483653" r:id="R3c1fe6c615a74b76"/>
+    <p:sldLayoutId xmlns:r="http://schemas.openxmlformats.org/officeDocument/2006/relationships" id="2147483654" r:id="R7871c7afdbc04c84"/>
   </p:sldLayoutIdLst>
   <p:txStyles>
     <p:titleStyle>
@@ -6605,7 +6605,7 @@
           <p:cNvPr id="9" name="">
             <a:extLst xmlns:a="http://schemas.openxmlformats.org/drawingml/2006/main">
               <a:ext uri="{FF2B5EF4-FFF2-40B4-BE49-F238E27FC236}">
-                <a16:creationId xmlns:a16="http://schemas.microsoft.com/office/drawing/2014/main" id="{939B569C-51F2-4651-A240-2C6C181046F7}"/>
+                <a16:creationId xmlns:a16="http://schemas.microsoft.com/office/drawing/2014/main" id="{F5F76CD7-E8B6-48BA-A4E7-5B93081859D9}"/>
               </a:ext>
             </a:extLst>
           </p:cNvPr>
@@ -6761,7 +6761,7 @@
           <p:cNvPr id="2" name="">
             <a:extLst xmlns:a="http://schemas.openxmlformats.org/drawingml/2006/main">
               <a:ext uri="{FF2B5EF4-FFF2-40B4-BE49-F238E27FC236}">
-                <a16:creationId xmlns:a16="http://schemas.microsoft.com/office/drawing/2014/main" id="{1DB9AEA4-E9D8-40A2-B6E4-48F79883424F}"/>
+                <a16:creationId xmlns:a16="http://schemas.microsoft.com/office/drawing/2014/main" id="{9B69D672-BE90-46F9-81AF-D5CE4F423647}"/>
               </a:ext>
             </a:extLst>
           </p:cNvPr>
@@ -6917,7 +6917,7 @@
           <p:cNvPr id="3" name="">
             <a:extLst xmlns:a="http://schemas.openxmlformats.org/drawingml/2006/main">
               <a:ext uri="{FF2B5EF4-FFF2-40B4-BE49-F238E27FC236}">
-                <a16:creationId xmlns:a16="http://schemas.microsoft.com/office/drawing/2014/main" id="{EDE8D2B6-908C-48A7-A7FC-F1570BEE195B}"/>
+                <a16:creationId xmlns:a16="http://schemas.microsoft.com/office/drawing/2014/main" id="{6FDFEE41-EC3C-4DA2-BA6D-0363C7E88379}"/>
               </a:ext>
             </a:extLst>
           </p:cNvPr>
@@ -7073,7 +7073,7 @@
           <p:cNvPr id="4" name="">
             <a:extLst xmlns:a="http://schemas.openxmlformats.org/drawingml/2006/main">
               <a:ext uri="{FF2B5EF4-FFF2-40B4-BE49-F238E27FC236}">
-                <a16:creationId xmlns:a16="http://schemas.microsoft.com/office/drawing/2014/main" id="{D1295A6B-4E11-4F93-8AC0-882C56AE4C1E}"/>
+                <a16:creationId xmlns:a16="http://schemas.microsoft.com/office/drawing/2014/main" id="{019F3F03-5F1D-4387-849F-A069659A446F}"/>
               </a:ext>
             </a:extLst>
           </p:cNvPr>
@@ -7229,7 +7229,7 @@
           <p:cNvPr id="5" name="">
             <a:extLst xmlns:a="http://schemas.openxmlformats.org/drawingml/2006/main">
               <a:ext uri="{FF2B5EF4-FFF2-40B4-BE49-F238E27FC236}">
-                <a16:creationId xmlns:a16="http://schemas.microsoft.com/office/drawing/2014/main" id="{5707A72B-1185-4399-8507-7A004A96AEB2}"/>
+                <a16:creationId xmlns:a16="http://schemas.microsoft.com/office/drawing/2014/main" id="{79D5B0DF-672C-4CF7-834C-906553D49F5F}"/>
               </a:ext>
             </a:extLst>
           </p:cNvPr>
@@ -7385,7 +7385,7 @@
           <p:cNvPr id="6" name="">
             <a:extLst xmlns:a="http://schemas.openxmlformats.org/drawingml/2006/main">
               <a:ext uri="{FF2B5EF4-FFF2-40B4-BE49-F238E27FC236}">
-                <a16:creationId xmlns:a16="http://schemas.microsoft.com/office/drawing/2014/main" id="{CCAA0C12-5D04-45F0-BB12-1AD385655CF6}"/>
+                <a16:creationId xmlns:a16="http://schemas.microsoft.com/office/drawing/2014/main" id="{F3D4F0A7-76ED-4CAB-8AA5-49576728B09C}"/>
               </a:ext>
             </a:extLst>
           </p:cNvPr>
@@ -7541,7 +7541,7 @@
           <p:cNvPr id="7" name="">
             <a:extLst xmlns:a="http://schemas.openxmlformats.org/drawingml/2006/main">
               <a:ext uri="{FF2B5EF4-FFF2-40B4-BE49-F238E27FC236}">
-                <a16:creationId xmlns:a16="http://schemas.microsoft.com/office/drawing/2014/main" id="{CECD0810-1BE1-4872-BCED-07647D4E96AB}"/>
+                <a16:creationId xmlns:a16="http://schemas.microsoft.com/office/drawing/2014/main" id="{96ED8A4C-B430-45DA-9AE0-9DD3979EC225}"/>
               </a:ext>
             </a:extLst>
           </p:cNvPr>
@@ -7697,7 +7697,7 @@
           <p:cNvPr id="8" name="">
             <a:extLst xmlns:a="http://schemas.openxmlformats.org/drawingml/2006/main">
               <a:ext uri="{FF2B5EF4-FFF2-40B4-BE49-F238E27FC236}">
-                <a16:creationId xmlns:a16="http://schemas.microsoft.com/office/drawing/2014/main" id="{81C19107-6F20-4FFC-941D-10B091734528}"/>
+                <a16:creationId xmlns:a16="http://schemas.microsoft.com/office/drawing/2014/main" id="{75D57E8C-3A02-49DC-BB33-D18B5D38EDBF}"/>
               </a:ext>
             </a:extLst>
           </p:cNvPr>
@@ -7851,7 +7851,7 @@
     </p:spTree>
     <p:extLst>
       <p:ext uri="{BB962C8B-B14F-4D97-AF65-F5344CB8AC3E}">
-        <p14:creationId xmlns:p14="http://schemas.microsoft.com/office/powerpoint/2010/main" val="1045124614"/>
+        <p14:creationId xmlns:p14="http://schemas.microsoft.com/office/powerpoint/2010/main" val="238547838"/>
       </p:ext>
     </p:extLst>
   </p:cSld>
@@ -7882,7 +7882,7 @@
           <p:cNvPr id="7" name="">
             <a:extLst xmlns:a="http://schemas.openxmlformats.org/drawingml/2006/main">
               <a:ext uri="{FF2B5EF4-FFF2-40B4-BE49-F238E27FC236}">
-                <a16:creationId xmlns:a16="http://schemas.microsoft.com/office/drawing/2014/main" id="{3D89448E-FC15-4E7B-B57D-FAE2931AD1A1}"/>
+                <a16:creationId xmlns:a16="http://schemas.microsoft.com/office/drawing/2014/main" id="{7153A7B6-23AC-4304-A115-2BE82FBA9BAD}"/>
               </a:ext>
             </a:extLst>
           </p:cNvPr>
@@ -8038,7 +8038,7 @@
           <p:cNvPr id="2" name="">
             <a:extLst xmlns:a="http://schemas.openxmlformats.org/drawingml/2006/main">
               <a:ext uri="{FF2B5EF4-FFF2-40B4-BE49-F238E27FC236}">
-                <a16:creationId xmlns:a16="http://schemas.microsoft.com/office/drawing/2014/main" id="{D7486603-A2E9-4405-B4A5-502C3BD8977B}"/>
+                <a16:creationId xmlns:a16="http://schemas.microsoft.com/office/drawing/2014/main" id="{9A6F7862-D7E2-4FB7-8250-3B474CD14538}"/>
               </a:ext>
             </a:extLst>
           </p:cNvPr>
@@ -8194,7 +8194,7 @@
           <p:cNvPr id="3" name="">
             <a:extLst xmlns:a="http://schemas.openxmlformats.org/drawingml/2006/main">
               <a:ext uri="{FF2B5EF4-FFF2-40B4-BE49-F238E27FC236}">
-                <a16:creationId xmlns:a16="http://schemas.microsoft.com/office/drawing/2014/main" id="{6DA5BAE5-AAC4-4495-9946-8AE538B5CCDF}"/>
+                <a16:creationId xmlns:a16="http://schemas.microsoft.com/office/drawing/2014/main" id="{A2B9C155-2F3C-4E4E-B884-ABFDC18F3FFA}"/>
               </a:ext>
             </a:extLst>
           </p:cNvPr>
@@ -8350,7 +8350,7 @@
           <p:cNvPr id="4" name="">
             <a:extLst xmlns:a="http://schemas.openxmlformats.org/drawingml/2006/main">
               <a:ext uri="{FF2B5EF4-FFF2-40B4-BE49-F238E27FC236}">
-                <a16:creationId xmlns:a16="http://schemas.microsoft.com/office/drawing/2014/main" id="{79038A48-609C-4CA8-B7CC-BD9953008C46}"/>
+                <a16:creationId xmlns:a16="http://schemas.microsoft.com/office/drawing/2014/main" id="{E04C738B-7138-4E11-8A95-D9ED9A54324C}"/>
               </a:ext>
             </a:extLst>
           </p:cNvPr>
@@ -8506,7 +8506,7 @@
           <p:cNvPr id="5" name="">
             <a:extLst xmlns:a="http://schemas.openxmlformats.org/drawingml/2006/main">
               <a:ext uri="{FF2B5EF4-FFF2-40B4-BE49-F238E27FC236}">
-                <a16:creationId xmlns:a16="http://schemas.microsoft.com/office/drawing/2014/main" id="{B500DA19-5864-41EF-8FCB-8966A27AEE2E}"/>
+                <a16:creationId xmlns:a16="http://schemas.microsoft.com/office/drawing/2014/main" id="{CF505367-A217-4441-8998-2EF76A756D66}"/>
               </a:ext>
             </a:extLst>
           </p:cNvPr>
@@ -8901,7 +8901,7 @@
           <p:cNvPr id="6" name="">
             <a:extLst xmlns:a="http://schemas.openxmlformats.org/drawingml/2006/main">
               <a:ext uri="{FF2B5EF4-FFF2-40B4-BE49-F238E27FC236}">
-                <a16:creationId xmlns:a16="http://schemas.microsoft.com/office/drawing/2014/main" id="{73C8BA8E-50FA-4CAF-B51E-80B5A2084E71}"/>
+                <a16:creationId xmlns:a16="http://schemas.microsoft.com/office/drawing/2014/main" id="{F2703A8C-C73A-432E-8FFD-D4A4E9A9C904}"/>
               </a:ext>
             </a:extLst>
           </p:cNvPr>
@@ -9055,7 +9055,7 @@
     </p:spTree>
     <p:extLst>
       <p:ext uri="{BB962C8B-B14F-4D97-AF65-F5344CB8AC3E}">
-        <p14:creationId xmlns:p14="http://schemas.microsoft.com/office/powerpoint/2010/main" val="69642545"/>
+        <p14:creationId xmlns:p14="http://schemas.microsoft.com/office/powerpoint/2010/main" val="2023124857"/>
       </p:ext>
     </p:extLst>
   </p:cSld>
@@ -9086,7 +9086,7 @@
           <p:cNvPr id="7" name="">
             <a:extLst xmlns:a="http://schemas.openxmlformats.org/drawingml/2006/main">
               <a:ext uri="{FF2B5EF4-FFF2-40B4-BE49-F238E27FC236}">
-                <a16:creationId xmlns:a16="http://schemas.microsoft.com/office/drawing/2014/main" id="{333EB60E-F17D-4B08-ABD3-5D171CE0B02A}"/>
+                <a16:creationId xmlns:a16="http://schemas.microsoft.com/office/drawing/2014/main" id="{E222C5BC-2B72-428C-A95F-A5C972EB42D7}"/>
               </a:ext>
             </a:extLst>
           </p:cNvPr>
@@ -9242,7 +9242,7 @@
           <p:cNvPr id="2" name="">
             <a:extLst xmlns:a="http://schemas.openxmlformats.org/drawingml/2006/main">
               <a:ext uri="{FF2B5EF4-FFF2-40B4-BE49-F238E27FC236}">
-                <a16:creationId xmlns:a16="http://schemas.microsoft.com/office/drawing/2014/main" id="{181EA205-5ECF-4D59-9F82-28D5FB43C68F}"/>
+                <a16:creationId xmlns:a16="http://schemas.microsoft.com/office/drawing/2014/main" id="{FD305A82-AA9A-41AE-BE3F-EC093A5DA219}"/>
               </a:ext>
             </a:extLst>
           </p:cNvPr>
@@ -9398,7 +9398,7 @@
           <p:cNvPr id="3" name="">
             <a:extLst xmlns:a="http://schemas.openxmlformats.org/drawingml/2006/main">
               <a:ext uri="{FF2B5EF4-FFF2-40B4-BE49-F238E27FC236}">
-                <a16:creationId xmlns:a16="http://schemas.microsoft.com/office/drawing/2014/main" id="{8F905F6D-1267-43E7-9BFF-453BF814E401}"/>
+                <a16:creationId xmlns:a16="http://schemas.microsoft.com/office/drawing/2014/main" id="{910FA07D-0931-4ED6-9FAF-8AC92BA8314E}"/>
               </a:ext>
             </a:extLst>
           </p:cNvPr>
@@ -9554,7 +9554,7 @@
           <p:cNvPr id="4" name="">
             <a:extLst xmlns:a="http://schemas.openxmlformats.org/drawingml/2006/main">
               <a:ext uri="{FF2B5EF4-FFF2-40B4-BE49-F238E27FC236}">
-                <a16:creationId xmlns:a16="http://schemas.microsoft.com/office/drawing/2014/main" id="{659A1057-B442-4EFC-92AC-E9E3F9754100}"/>
+                <a16:creationId xmlns:a16="http://schemas.microsoft.com/office/drawing/2014/main" id="{D98E481E-78D6-41A2-A50E-A042DCF223C4}"/>
               </a:ext>
             </a:extLst>
           </p:cNvPr>
@@ -9710,7 +9710,7 @@
           <p:cNvPr id="5" name="Chart">
             <a:extLst xmlns:a="http://schemas.openxmlformats.org/drawingml/2006/main">
               <a:ext uri="{FF2B5EF4-FFF2-40B4-BE49-F238E27FC236}">
-                <a16:creationId xmlns:a16="http://schemas.microsoft.com/office/drawing/2014/main" id="{AD51778D-1C00-4D87-B129-4E57438800E6}"/>
+                <a16:creationId xmlns:a16="http://schemas.microsoft.com/office/drawing/2014/main" id="{DAF11A04-0959-4751-89C2-0C6C55266F34}"/>
               </a:ext>
             </a:extLst>
           </p:cNvPr>
@@ -9723,7 +9723,7 @@
         </p:xfrm>
         <a:graphic xmlns:a="http://schemas.openxmlformats.org/drawingml/2006/main">
           <a:graphicData uri="http://schemas.openxmlformats.org/drawingml/2006/chart">
-            <c:chart xmlns:r="http://schemas.openxmlformats.org/officeDocument/2006/relationships" xmlns:c="http://schemas.openxmlformats.org/drawingml/2006/chart" r:id="R2ca5d5dc7b7f4c9e"/>
+            <c:chart xmlns:r="http://schemas.openxmlformats.org/officeDocument/2006/relationships" xmlns:c="http://schemas.openxmlformats.org/drawingml/2006/chart" r:id="R694a56f02236485b"/>
           </a:graphicData>
         </a:graphic>
       </p:graphicFrame>
@@ -9732,7 +9732,7 @@
           <p:cNvPr id="6" name="">
             <a:extLst xmlns:a="http://schemas.openxmlformats.org/drawingml/2006/main">
               <a:ext uri="{FF2B5EF4-FFF2-40B4-BE49-F238E27FC236}">
-                <a16:creationId xmlns:a16="http://schemas.microsoft.com/office/drawing/2014/main" id="{4C51AAE5-3250-4585-B8FB-3D6E6C38F7F7}"/>
+                <a16:creationId xmlns:a16="http://schemas.microsoft.com/office/drawing/2014/main" id="{DF09F2DC-511E-48D7-9E9F-356D691A1BB4}"/>
               </a:ext>
             </a:extLst>
           </p:cNvPr>
@@ -9886,7 +9886,7 @@
     </p:spTree>
     <p:extLst>
       <p:ext uri="{BB962C8B-B14F-4D97-AF65-F5344CB8AC3E}">
-        <p14:creationId xmlns:p14="http://schemas.microsoft.com/office/powerpoint/2010/main" val="1409336781"/>
+        <p14:creationId xmlns:p14="http://schemas.microsoft.com/office/powerpoint/2010/main" val="1922984482"/>
       </p:ext>
     </p:extLst>
   </p:cSld>
@@ -9917,7 +9917,7 @@
           <p:cNvPr id="7" name="">
             <a:extLst xmlns:a="http://schemas.openxmlformats.org/drawingml/2006/main">
               <a:ext uri="{FF2B5EF4-FFF2-40B4-BE49-F238E27FC236}">
-                <a16:creationId xmlns:a16="http://schemas.microsoft.com/office/drawing/2014/main" id="{D9092E4E-932B-4861-A8E1-4F2385FC145F}"/>
+                <a16:creationId xmlns:a16="http://schemas.microsoft.com/office/drawing/2014/main" id="{9BC5B131-657F-4B91-82C9-45C8E033BD6C}"/>
               </a:ext>
             </a:extLst>
           </p:cNvPr>
@@ -10073,7 +10073,7 @@
           <p:cNvPr id="2" name="">
             <a:extLst xmlns:a="http://schemas.openxmlformats.org/drawingml/2006/main">
               <a:ext uri="{FF2B5EF4-FFF2-40B4-BE49-F238E27FC236}">
-                <a16:creationId xmlns:a16="http://schemas.microsoft.com/office/drawing/2014/main" id="{E9DE39A0-B283-411C-8231-2077179B1F81}"/>
+                <a16:creationId xmlns:a16="http://schemas.microsoft.com/office/drawing/2014/main" id="{D8D117F7-5323-43C3-B5FC-491A22EE1AA0}"/>
               </a:ext>
             </a:extLst>
           </p:cNvPr>
@@ -10229,7 +10229,7 @@
           <p:cNvPr id="3" name="">
             <a:extLst xmlns:a="http://schemas.openxmlformats.org/drawingml/2006/main">
               <a:ext uri="{FF2B5EF4-FFF2-40B4-BE49-F238E27FC236}">
-                <a16:creationId xmlns:a16="http://schemas.microsoft.com/office/drawing/2014/main" id="{D66EAFA0-1ED2-424A-89AD-C0F83524F6E9}"/>
+                <a16:creationId xmlns:a16="http://schemas.microsoft.com/office/drawing/2014/main" id="{AECAB481-3A1A-4248-AAA4-7C079F02FFA4}"/>
               </a:ext>
             </a:extLst>
           </p:cNvPr>
@@ -10385,7 +10385,7 @@
           <p:cNvPr id="4" name="">
             <a:extLst xmlns:a="http://schemas.openxmlformats.org/drawingml/2006/main">
               <a:ext uri="{FF2B5EF4-FFF2-40B4-BE49-F238E27FC236}">
-                <a16:creationId xmlns:a16="http://schemas.microsoft.com/office/drawing/2014/main" id="{35730801-D6A0-43D9-945F-829BD738E0E7}"/>
+                <a16:creationId xmlns:a16="http://schemas.microsoft.com/office/drawing/2014/main" id="{78BEA491-1EEB-41EE-A64B-EA0316F18A24}"/>
               </a:ext>
             </a:extLst>
           </p:cNvPr>
@@ -10541,7 +10541,7 @@
           <p:cNvPr id="5" name="">
             <a:extLst xmlns:a="http://schemas.openxmlformats.org/drawingml/2006/main">
               <a:ext uri="{FF2B5EF4-FFF2-40B4-BE49-F238E27FC236}">
-                <a16:creationId xmlns:a16="http://schemas.microsoft.com/office/drawing/2014/main" id="{9712B7BC-8476-497D-A451-DE878A8C4996}"/>
+                <a16:creationId xmlns:a16="http://schemas.microsoft.com/office/drawing/2014/main" id="{5ABDDD7C-84EE-40D3-8280-20C31737A05D}"/>
               </a:ext>
             </a:extLst>
           </p:cNvPr>
@@ -13027,7 +13027,7 @@
           <p:cNvPr id="6" name="">
             <a:extLst xmlns:a="http://schemas.openxmlformats.org/drawingml/2006/main">
               <a:ext uri="{FF2B5EF4-FFF2-40B4-BE49-F238E27FC236}">
-                <a16:creationId xmlns:a16="http://schemas.microsoft.com/office/drawing/2014/main" id="{8B795D86-5FF0-454C-A39A-C37EC2BEECB8}"/>
+                <a16:creationId xmlns:a16="http://schemas.microsoft.com/office/drawing/2014/main" id="{984E3995-071A-48BC-BD3F-EF1F37A23EF7}"/>
               </a:ext>
             </a:extLst>
           </p:cNvPr>
@@ -13181,7 +13181,7 @@
     </p:spTree>
     <p:extLst>
       <p:ext uri="{BB962C8B-B14F-4D97-AF65-F5344CB8AC3E}">
-        <p14:creationId xmlns:p14="http://schemas.microsoft.com/office/powerpoint/2010/main" val="1598861342"/>
+        <p14:creationId xmlns:p14="http://schemas.microsoft.com/office/powerpoint/2010/main" val="256994570"/>
       </p:ext>
     </p:extLst>
   </p:cSld>
@@ -13212,7 +13212,7 @@
           <p:cNvPr id="7" name="">
             <a:extLst xmlns:a="http://schemas.openxmlformats.org/drawingml/2006/main">
               <a:ext uri="{FF2B5EF4-FFF2-40B4-BE49-F238E27FC236}">
-                <a16:creationId xmlns:a16="http://schemas.microsoft.com/office/drawing/2014/main" id="{6276B303-E47A-486D-BDA3-93E21CEA2405}"/>
+                <a16:creationId xmlns:a16="http://schemas.microsoft.com/office/drawing/2014/main" id="{91EE24CA-9B9E-4639-97AB-013C2402321E}"/>
               </a:ext>
             </a:extLst>
           </p:cNvPr>
@@ -13368,7 +13368,7 @@
           <p:cNvPr id="2" name="">
             <a:extLst xmlns:a="http://schemas.openxmlformats.org/drawingml/2006/main">
               <a:ext uri="{FF2B5EF4-FFF2-40B4-BE49-F238E27FC236}">
-                <a16:creationId xmlns:a16="http://schemas.microsoft.com/office/drawing/2014/main" id="{B20CBF22-5DB7-46B4-A4F1-524B5ABB7F80}"/>
+                <a16:creationId xmlns:a16="http://schemas.microsoft.com/office/drawing/2014/main" id="{0E89FB50-68A0-4322-95AB-61B5A99AF702}"/>
               </a:ext>
             </a:extLst>
           </p:cNvPr>
@@ -13524,7 +13524,7 @@
           <p:cNvPr id="3" name="">
             <a:extLst xmlns:a="http://schemas.openxmlformats.org/drawingml/2006/main">
               <a:ext uri="{FF2B5EF4-FFF2-40B4-BE49-F238E27FC236}">
-                <a16:creationId xmlns:a16="http://schemas.microsoft.com/office/drawing/2014/main" id="{F90D97E7-CCBE-4B29-8098-85EBD23C2931}"/>
+                <a16:creationId xmlns:a16="http://schemas.microsoft.com/office/drawing/2014/main" id="{C30EF850-D901-4698-BE79-EC24E68B436F}"/>
               </a:ext>
             </a:extLst>
           </p:cNvPr>
@@ -13680,7 +13680,7 @@
           <p:cNvPr id="4" name="">
             <a:extLst xmlns:a="http://schemas.openxmlformats.org/drawingml/2006/main">
               <a:ext uri="{FF2B5EF4-FFF2-40B4-BE49-F238E27FC236}">
-                <a16:creationId xmlns:a16="http://schemas.microsoft.com/office/drawing/2014/main" id="{59FB5829-5C38-4190-B07B-10F05CE8E0F3}"/>
+                <a16:creationId xmlns:a16="http://schemas.microsoft.com/office/drawing/2014/main" id="{452A9D6D-91E2-417A-A266-72E920B8D45B}"/>
               </a:ext>
             </a:extLst>
           </p:cNvPr>
@@ -13836,7 +13836,7 @@
           <p:cNvPr id="5" name="">
             <a:extLst xmlns:a="http://schemas.openxmlformats.org/drawingml/2006/main">
               <a:ext uri="{FF2B5EF4-FFF2-40B4-BE49-F238E27FC236}">
-                <a16:creationId xmlns:a16="http://schemas.microsoft.com/office/drawing/2014/main" id="{89FDCB9B-0542-466D-A7F7-EBB7A7FF92C0}"/>
+                <a16:creationId xmlns:a16="http://schemas.microsoft.com/office/drawing/2014/main" id="{58FA22A0-652E-4F90-93A0-2472D4F8BBF7}"/>
               </a:ext>
             </a:extLst>
           </p:cNvPr>
@@ -14276,7 +14276,7 @@
           <p:cNvPr id="6" name="">
             <a:extLst xmlns:a="http://schemas.openxmlformats.org/drawingml/2006/main">
               <a:ext uri="{FF2B5EF4-FFF2-40B4-BE49-F238E27FC236}">
-                <a16:creationId xmlns:a16="http://schemas.microsoft.com/office/drawing/2014/main" id="{2267BE9F-C067-4DC0-9829-DC891C1A7294}"/>
+                <a16:creationId xmlns:a16="http://schemas.microsoft.com/office/drawing/2014/main" id="{CAB97643-D0D1-4B97-9039-ADDFC5BE41E2}"/>
               </a:ext>
             </a:extLst>
           </p:cNvPr>
@@ -14430,7 +14430,7 @@
     </p:spTree>
     <p:extLst>
       <p:ext uri="{BB962C8B-B14F-4D97-AF65-F5344CB8AC3E}">
-        <p14:creationId xmlns:p14="http://schemas.microsoft.com/office/powerpoint/2010/main" val="2122326250"/>
+        <p14:creationId xmlns:p14="http://schemas.microsoft.com/office/powerpoint/2010/main" val="1165832816"/>
       </p:ext>
     </p:extLst>
   </p:cSld>
@@ -14461,7 +14461,7 @@
           <p:cNvPr id="7" name="">
             <a:extLst xmlns:a="http://schemas.openxmlformats.org/drawingml/2006/main">
               <a:ext uri="{FF2B5EF4-FFF2-40B4-BE49-F238E27FC236}">
-                <a16:creationId xmlns:a16="http://schemas.microsoft.com/office/drawing/2014/main" id="{FE158361-B55B-4F32-896D-6A7738C94A5E}"/>
+                <a16:creationId xmlns:a16="http://schemas.microsoft.com/office/drawing/2014/main" id="{AE3DC7E5-6586-443B-8201-3151A62863E7}"/>
               </a:ext>
             </a:extLst>
           </p:cNvPr>
@@ -14617,7 +14617,7 @@
           <p:cNvPr id="2" name="">
             <a:extLst xmlns:a="http://schemas.openxmlformats.org/drawingml/2006/main">
               <a:ext uri="{FF2B5EF4-FFF2-40B4-BE49-F238E27FC236}">
-                <a16:creationId xmlns:a16="http://schemas.microsoft.com/office/drawing/2014/main" id="{1A7E2180-6733-4BBA-90CC-A2B587DEC363}"/>
+                <a16:creationId xmlns:a16="http://schemas.microsoft.com/office/drawing/2014/main" id="{301673B2-AF5B-4FEF-A1AA-A1CF09D8B2F6}"/>
               </a:ext>
             </a:extLst>
           </p:cNvPr>
@@ -14773,7 +14773,7 @@
           <p:cNvPr id="3" name="">
             <a:extLst xmlns:a="http://schemas.openxmlformats.org/drawingml/2006/main">
               <a:ext uri="{FF2B5EF4-FFF2-40B4-BE49-F238E27FC236}">
-                <a16:creationId xmlns:a16="http://schemas.microsoft.com/office/drawing/2014/main" id="{4332B9FE-C137-455F-80C2-4C28F32A80F3}"/>
+                <a16:creationId xmlns:a16="http://schemas.microsoft.com/office/drawing/2014/main" id="{9C87502E-8159-403C-A0DE-6068C82C3E6C}"/>
               </a:ext>
             </a:extLst>
           </p:cNvPr>
@@ -14929,7 +14929,7 @@
           <p:cNvPr id="4" name="">
             <a:extLst xmlns:a="http://schemas.openxmlformats.org/drawingml/2006/main">
               <a:ext uri="{FF2B5EF4-FFF2-40B4-BE49-F238E27FC236}">
-                <a16:creationId xmlns:a16="http://schemas.microsoft.com/office/drawing/2014/main" id="{80D85755-C0FA-4E27-AE31-BA4D6D313CD3}"/>
+                <a16:creationId xmlns:a16="http://schemas.microsoft.com/office/drawing/2014/main" id="{98C4C318-20AC-443B-AF32-5E99AAD70952}"/>
               </a:ext>
             </a:extLst>
           </p:cNvPr>
@@ -15085,7 +15085,7 @@
           <p:cNvPr id="5" name="">
             <a:extLst xmlns:a="http://schemas.openxmlformats.org/drawingml/2006/main">
               <a:ext uri="{FF2B5EF4-FFF2-40B4-BE49-F238E27FC236}">
-                <a16:creationId xmlns:a16="http://schemas.microsoft.com/office/drawing/2014/main" id="{A712D55B-8CCE-48FF-AA7D-2CC55CFC4388}"/>
+                <a16:creationId xmlns:a16="http://schemas.microsoft.com/office/drawing/2014/main" id="{ACF41009-4620-4AE9-8CFA-1AE02C586F9E}"/>
               </a:ext>
             </a:extLst>
           </p:cNvPr>
@@ -15095,7 +15095,7 @@
           <p:nvPr/>
         </p:nvPicPr>
         <p:blipFill>
-          <a:blip xmlns:r="http://schemas.openxmlformats.org/officeDocument/2006/relationships" xmlns:a="http://schemas.openxmlformats.org/drawingml/2006/main" r:embed="R31e37d5f12454fc5"/>
+          <a:blip xmlns:r="http://schemas.openxmlformats.org/officeDocument/2006/relationships" xmlns:a="http://schemas.openxmlformats.org/drawingml/2006/main" r:embed="R1332f1eb607e4dfd"/>
           <a:stretch xmlns:a="http://schemas.openxmlformats.org/drawingml/2006/main"/>
         </p:blipFill>
         <p:spPr>
@@ -15113,7 +15113,7 @@
           <p:cNvPr id="6" name="">
             <a:extLst xmlns:a="http://schemas.openxmlformats.org/drawingml/2006/main">
               <a:ext uri="{FF2B5EF4-FFF2-40B4-BE49-F238E27FC236}">
-                <a16:creationId xmlns:a16="http://schemas.microsoft.com/office/drawing/2014/main" id="{DB0F00AF-7A37-467F-BA3E-4EB5D25CAE27}"/>
+                <a16:creationId xmlns:a16="http://schemas.microsoft.com/office/drawing/2014/main" id="{3F2EEFC1-1EC2-40A4-95AC-A2047B1191D8}"/>
               </a:ext>
             </a:extLst>
           </p:cNvPr>
@@ -15267,7 +15267,7 @@
     </p:spTree>
     <p:extLst>
       <p:ext uri="{BB962C8B-B14F-4D97-AF65-F5344CB8AC3E}">
-        <p14:creationId xmlns:p14="http://schemas.microsoft.com/office/powerpoint/2010/main" val="171254615"/>
+        <p14:creationId xmlns:p14="http://schemas.microsoft.com/office/powerpoint/2010/main" val="1040999911"/>
       </p:ext>
     </p:extLst>
   </p:cSld>
@@ -15298,7 +15298,7 @@
           <p:cNvPr id="7" name="">
             <a:extLst xmlns:a="http://schemas.openxmlformats.org/drawingml/2006/main">
               <a:ext uri="{FF2B5EF4-FFF2-40B4-BE49-F238E27FC236}">
-                <a16:creationId xmlns:a16="http://schemas.microsoft.com/office/drawing/2014/main" id="{A5ADBC8E-8CB6-4B6C-B522-E994BE695C21}"/>
+                <a16:creationId xmlns:a16="http://schemas.microsoft.com/office/drawing/2014/main" id="{F9782ADE-85A4-443A-A24D-BB73941230E7}"/>
               </a:ext>
             </a:extLst>
           </p:cNvPr>
@@ -15454,7 +15454,7 @@
           <p:cNvPr id="2" name="">
             <a:extLst xmlns:a="http://schemas.openxmlformats.org/drawingml/2006/main">
               <a:ext uri="{FF2B5EF4-FFF2-40B4-BE49-F238E27FC236}">
-                <a16:creationId xmlns:a16="http://schemas.microsoft.com/office/drawing/2014/main" id="{1F458D91-2233-4D45-BF69-C4983A1CEC63}"/>
+                <a16:creationId xmlns:a16="http://schemas.microsoft.com/office/drawing/2014/main" id="{AC565D80-7AA2-46D9-AE60-03BB3AF25F35}"/>
               </a:ext>
             </a:extLst>
           </p:cNvPr>
@@ -15610,7 +15610,7 @@
           <p:cNvPr id="3" name="">
             <a:extLst xmlns:a="http://schemas.openxmlformats.org/drawingml/2006/main">
               <a:ext uri="{FF2B5EF4-FFF2-40B4-BE49-F238E27FC236}">
-                <a16:creationId xmlns:a16="http://schemas.microsoft.com/office/drawing/2014/main" id="{DEF03AB9-8102-43C7-B24F-67CB611DA762}"/>
+                <a16:creationId xmlns:a16="http://schemas.microsoft.com/office/drawing/2014/main" id="{91B7C56D-09A1-43FB-B320-04737F3DA01D}"/>
               </a:ext>
             </a:extLst>
           </p:cNvPr>
@@ -15766,7 +15766,7 @@
           <p:cNvPr id="4" name="">
             <a:extLst xmlns:a="http://schemas.openxmlformats.org/drawingml/2006/main">
               <a:ext uri="{FF2B5EF4-FFF2-40B4-BE49-F238E27FC236}">
-                <a16:creationId xmlns:a16="http://schemas.microsoft.com/office/drawing/2014/main" id="{DDFE86CA-632B-456B-864B-2326C7C922A2}"/>
+                <a16:creationId xmlns:a16="http://schemas.microsoft.com/office/drawing/2014/main" id="{36859978-FB8F-453A-9DE0-FE597B8A3BA5}"/>
               </a:ext>
             </a:extLst>
           </p:cNvPr>
@@ -15922,7 +15922,7 @@
           <p:cNvPr id="5" name="">
             <a:extLst xmlns:a="http://schemas.openxmlformats.org/drawingml/2006/main">
               <a:ext uri="{FF2B5EF4-FFF2-40B4-BE49-F238E27FC236}">
-                <a16:creationId xmlns:a16="http://schemas.microsoft.com/office/drawing/2014/main" id="{D4B4E0A2-5758-4E63-ABBB-1F9E0057A76D}"/>
+                <a16:creationId xmlns:a16="http://schemas.microsoft.com/office/drawing/2014/main" id="{538A0E46-AE73-4AD4-A2FA-C8B50F411E9E}"/>
               </a:ext>
             </a:extLst>
           </p:cNvPr>
@@ -15932,7 +15932,7 @@
           <p:nvPr/>
         </p:nvPicPr>
         <p:blipFill>
-          <a:blip xmlns:r="http://schemas.openxmlformats.org/officeDocument/2006/relationships" xmlns:a="http://schemas.openxmlformats.org/drawingml/2006/main" r:embed="Ra4510532fa544d04"/>
+          <a:blip xmlns:r="http://schemas.openxmlformats.org/officeDocument/2006/relationships" xmlns:a="http://schemas.openxmlformats.org/drawingml/2006/main" r:embed="R5634ba21e5b046c0"/>
           <a:stretch xmlns:a="http://schemas.openxmlformats.org/drawingml/2006/main"/>
         </p:blipFill>
         <p:spPr>
@@ -15950,7 +15950,7 @@
           <p:cNvPr id="6" name="">
             <a:extLst xmlns:a="http://schemas.openxmlformats.org/drawingml/2006/main">
               <a:ext uri="{FF2B5EF4-FFF2-40B4-BE49-F238E27FC236}">
-                <a16:creationId xmlns:a16="http://schemas.microsoft.com/office/drawing/2014/main" id="{E9C49F51-D41E-4CF7-9913-4149119F586B}"/>
+                <a16:creationId xmlns:a16="http://schemas.microsoft.com/office/drawing/2014/main" id="{020425D9-A0CB-4EFB-8614-4F80800772E4}"/>
               </a:ext>
             </a:extLst>
           </p:cNvPr>
@@ -16104,7 +16104,7 @@
     </p:spTree>
     <p:extLst>
       <p:ext uri="{BB962C8B-B14F-4D97-AF65-F5344CB8AC3E}">
-        <p14:creationId xmlns:p14="http://schemas.microsoft.com/office/powerpoint/2010/main" val="1417312064"/>
+        <p14:creationId xmlns:p14="http://schemas.microsoft.com/office/powerpoint/2010/main" val="1690229054"/>
       </p:ext>
     </p:extLst>
   </p:cSld>
@@ -16135,7 +16135,7 @@
           <p:cNvPr id="7" name="">
             <a:extLst xmlns:a="http://schemas.openxmlformats.org/drawingml/2006/main">
               <a:ext uri="{FF2B5EF4-FFF2-40B4-BE49-F238E27FC236}">
-                <a16:creationId xmlns:a16="http://schemas.microsoft.com/office/drawing/2014/main" id="{50451921-D115-45D7-BEF6-1FC925B6AE7B}"/>
+                <a16:creationId xmlns:a16="http://schemas.microsoft.com/office/drawing/2014/main" id="{43597855-4640-4996-B02A-03F9615156B0}"/>
               </a:ext>
             </a:extLst>
           </p:cNvPr>
@@ -16291,7 +16291,7 @@
           <p:cNvPr id="2" name="">
             <a:extLst xmlns:a="http://schemas.openxmlformats.org/drawingml/2006/main">
               <a:ext uri="{FF2B5EF4-FFF2-40B4-BE49-F238E27FC236}">
-                <a16:creationId xmlns:a16="http://schemas.microsoft.com/office/drawing/2014/main" id="{22C667B6-4293-426A-A194-C30D1448ED05}"/>
+                <a16:creationId xmlns:a16="http://schemas.microsoft.com/office/drawing/2014/main" id="{ED8BAD29-5DC8-40C5-8AFC-B0C7D6F0A1B4}"/>
               </a:ext>
             </a:extLst>
           </p:cNvPr>
@@ -16447,7 +16447,7 @@
           <p:cNvPr id="3" name="">
             <a:extLst xmlns:a="http://schemas.openxmlformats.org/drawingml/2006/main">
               <a:ext uri="{FF2B5EF4-FFF2-40B4-BE49-F238E27FC236}">
-                <a16:creationId xmlns:a16="http://schemas.microsoft.com/office/drawing/2014/main" id="{C4435D49-6652-442C-938B-DD4C1F97B186}"/>
+                <a16:creationId xmlns:a16="http://schemas.microsoft.com/office/drawing/2014/main" id="{5F819A22-FCB7-43F9-AC73-3F650BAA1D52}"/>
               </a:ext>
             </a:extLst>
           </p:cNvPr>
@@ -16603,7 +16603,7 @@
           <p:cNvPr id="4" name="">
             <a:extLst xmlns:a="http://schemas.openxmlformats.org/drawingml/2006/main">
               <a:ext uri="{FF2B5EF4-FFF2-40B4-BE49-F238E27FC236}">
-                <a16:creationId xmlns:a16="http://schemas.microsoft.com/office/drawing/2014/main" id="{F2F2E26B-4105-4B55-9335-DA3B1D5AB277}"/>
+                <a16:creationId xmlns:a16="http://schemas.microsoft.com/office/drawing/2014/main" id="{339CF2E5-B483-47A0-BD39-A4C074386EE3}"/>
               </a:ext>
             </a:extLst>
           </p:cNvPr>
@@ -16759,7 +16759,7 @@
           <p:cNvPr id="5" name="">
             <a:extLst xmlns:a="http://schemas.openxmlformats.org/drawingml/2006/main">
               <a:ext uri="{FF2B5EF4-FFF2-40B4-BE49-F238E27FC236}">
-                <a16:creationId xmlns:a16="http://schemas.microsoft.com/office/drawing/2014/main" id="{7789213F-3F66-432C-BE4D-3B29F8159EBF}"/>
+                <a16:creationId xmlns:a16="http://schemas.microsoft.com/office/drawing/2014/main" id="{8B9832E8-A10F-40CF-8E02-3389A233019B}"/>
               </a:ext>
             </a:extLst>
           </p:cNvPr>
@@ -16769,7 +16769,7 @@
           <p:nvPr/>
         </p:nvPicPr>
         <p:blipFill>
-          <a:blip xmlns:r="http://schemas.openxmlformats.org/officeDocument/2006/relationships" xmlns:a="http://schemas.openxmlformats.org/drawingml/2006/main" r:embed="Rbc39c0c0095f4dfa"/>
+          <a:blip xmlns:r="http://schemas.openxmlformats.org/officeDocument/2006/relationships" xmlns:a="http://schemas.openxmlformats.org/drawingml/2006/main" r:embed="R89be4d8881e24320"/>
           <a:stretch xmlns:a="http://schemas.openxmlformats.org/drawingml/2006/main"/>
         </p:blipFill>
         <p:spPr>
@@ -16787,7 +16787,7 @@
           <p:cNvPr id="6" name="">
             <a:extLst xmlns:a="http://schemas.openxmlformats.org/drawingml/2006/main">
               <a:ext uri="{FF2B5EF4-FFF2-40B4-BE49-F238E27FC236}">
-                <a16:creationId xmlns:a16="http://schemas.microsoft.com/office/drawing/2014/main" id="{80CCF3BC-CEA0-42EF-B4A9-C4640A9B652E}"/>
+                <a16:creationId xmlns:a16="http://schemas.microsoft.com/office/drawing/2014/main" id="{6DA48E8A-298F-4F21-9637-CEDD8652899E}"/>
               </a:ext>
             </a:extLst>
           </p:cNvPr>
@@ -16941,7 +16941,7 @@
     </p:spTree>
     <p:extLst>
       <p:ext uri="{BB962C8B-B14F-4D97-AF65-F5344CB8AC3E}">
-        <p14:creationId xmlns:p14="http://schemas.microsoft.com/office/powerpoint/2010/main" val="1588990209"/>
+        <p14:creationId xmlns:p14="http://schemas.microsoft.com/office/powerpoint/2010/main" val="925828058"/>
       </p:ext>
     </p:extLst>
   </p:cSld>
@@ -16972,7 +16972,7 @@
           <p:cNvPr id="6" name="">
             <a:extLst xmlns:a="http://schemas.openxmlformats.org/drawingml/2006/main">
               <a:ext uri="{FF2B5EF4-FFF2-40B4-BE49-F238E27FC236}">
-                <a16:creationId xmlns:a16="http://schemas.microsoft.com/office/drawing/2014/main" id="{211228E9-0AC2-4E32-840E-D634EB187825}"/>
+                <a16:creationId xmlns:a16="http://schemas.microsoft.com/office/drawing/2014/main" id="{324E8EFD-84CE-4C81-9FFD-98D7C4C9A652}"/>
               </a:ext>
             </a:extLst>
           </p:cNvPr>
@@ -17128,7 +17128,7 @@
           <p:cNvPr id="2" name="">
             <a:extLst xmlns:a="http://schemas.openxmlformats.org/drawingml/2006/main">
               <a:ext uri="{FF2B5EF4-FFF2-40B4-BE49-F238E27FC236}">
-                <a16:creationId xmlns:a16="http://schemas.microsoft.com/office/drawing/2014/main" id="{469F3479-1A4C-4387-A4F3-601CCC51A44F}"/>
+                <a16:creationId xmlns:a16="http://schemas.microsoft.com/office/drawing/2014/main" id="{6DCC2470-1A7B-415B-9B68-BA7826252884}"/>
               </a:ext>
             </a:extLst>
           </p:cNvPr>
@@ -17284,7 +17284,7 @@
           <p:cNvPr id="3" name="">
             <a:extLst xmlns:a="http://schemas.openxmlformats.org/drawingml/2006/main">
               <a:ext uri="{FF2B5EF4-FFF2-40B4-BE49-F238E27FC236}">
-                <a16:creationId xmlns:a16="http://schemas.microsoft.com/office/drawing/2014/main" id="{5288B72C-3915-42F7-AFB5-3EEB705F8692}"/>
+                <a16:creationId xmlns:a16="http://schemas.microsoft.com/office/drawing/2014/main" id="{3F2A734A-6573-4D90-B339-3FDEE6A69637}"/>
               </a:ext>
             </a:extLst>
           </p:cNvPr>
@@ -17440,7 +17440,7 @@
           <p:cNvPr id="4" name="">
             <a:extLst xmlns:a="http://schemas.openxmlformats.org/drawingml/2006/main">
               <a:ext uri="{FF2B5EF4-FFF2-40B4-BE49-F238E27FC236}">
-                <a16:creationId xmlns:a16="http://schemas.microsoft.com/office/drawing/2014/main" id="{1860A064-9720-4F3C-AF68-240313D4D324}"/>
+                <a16:creationId xmlns:a16="http://schemas.microsoft.com/office/drawing/2014/main" id="{999E1C14-785F-48D9-9B28-B8C1FE939BD5}"/>
               </a:ext>
             </a:extLst>
           </p:cNvPr>
@@ -17596,7 +17596,7 @@
           <p:cNvPr id="5" name="">
             <a:extLst xmlns:a="http://schemas.openxmlformats.org/drawingml/2006/main">
               <a:ext uri="{FF2B5EF4-FFF2-40B4-BE49-F238E27FC236}">
-                <a16:creationId xmlns:a16="http://schemas.microsoft.com/office/drawing/2014/main" id="{DF62043D-FF4C-4F83-A95D-217B75BDC863}"/>
+                <a16:creationId xmlns:a16="http://schemas.microsoft.com/office/drawing/2014/main" id="{E3F194AF-127E-405C-B752-55383E454DB1}"/>
               </a:ext>
             </a:extLst>
           </p:cNvPr>
@@ -17606,7 +17606,7 @@
           <p:nvPr/>
         </p:nvPicPr>
         <p:blipFill>
-          <a:blip xmlns:r="http://schemas.openxmlformats.org/officeDocument/2006/relationships" xmlns:a="http://schemas.openxmlformats.org/drawingml/2006/main" r:embed="Rf2d17e87df0b4222"/>
+          <a:blip xmlns:r="http://schemas.openxmlformats.org/officeDocument/2006/relationships" xmlns:a="http://schemas.openxmlformats.org/drawingml/2006/main" r:embed="R044c2298100b47a1"/>
           <a:stretch xmlns:a="http://schemas.openxmlformats.org/drawingml/2006/main"/>
         </p:blipFill>
         <p:spPr>
@@ -17622,7 +17622,7 @@
     </p:spTree>
     <p:extLst>
       <p:ext uri="{BB962C8B-B14F-4D97-AF65-F5344CB8AC3E}">
-        <p14:creationId xmlns:p14="http://schemas.microsoft.com/office/powerpoint/2010/main" val="2085464556"/>
+        <p14:creationId xmlns:p14="http://schemas.microsoft.com/office/powerpoint/2010/main" val="1655454305"/>
       </p:ext>
     </p:extLst>
   </p:cSld>
@@ -17653,7 +17653,7 @@
           <p:cNvPr id="6" name="">
             <a:extLst xmlns:a="http://schemas.openxmlformats.org/drawingml/2006/main">
               <a:ext uri="{FF2B5EF4-FFF2-40B4-BE49-F238E27FC236}">
-                <a16:creationId xmlns:a16="http://schemas.microsoft.com/office/drawing/2014/main" id="{5C010397-54E3-4615-809B-AF036F4FFBAE}"/>
+                <a16:creationId xmlns:a16="http://schemas.microsoft.com/office/drawing/2014/main" id="{1C273756-81B7-418B-90A2-4798EE666858}"/>
               </a:ext>
             </a:extLst>
           </p:cNvPr>
@@ -17809,7 +17809,7 @@
           <p:cNvPr id="2" name="">
             <a:extLst xmlns:a="http://schemas.openxmlformats.org/drawingml/2006/main">
               <a:ext uri="{FF2B5EF4-FFF2-40B4-BE49-F238E27FC236}">
-                <a16:creationId xmlns:a16="http://schemas.microsoft.com/office/drawing/2014/main" id="{48461F7D-C112-495E-9FF6-79649DC78497}"/>
+                <a16:creationId xmlns:a16="http://schemas.microsoft.com/office/drawing/2014/main" id="{CA03ABCE-8225-40E7-8E68-1E52FB9F709C}"/>
               </a:ext>
             </a:extLst>
           </p:cNvPr>
@@ -17965,7 +17965,7 @@
           <p:cNvPr id="3" name="">
             <a:extLst xmlns:a="http://schemas.openxmlformats.org/drawingml/2006/main">
               <a:ext uri="{FF2B5EF4-FFF2-40B4-BE49-F238E27FC236}">
-                <a16:creationId xmlns:a16="http://schemas.microsoft.com/office/drawing/2014/main" id="{0F24FD17-57DC-4839-907D-2A8443F632CF}"/>
+                <a16:creationId xmlns:a16="http://schemas.microsoft.com/office/drawing/2014/main" id="{7814B977-91D2-4DD4-870D-39835FD1AC87}"/>
               </a:ext>
             </a:extLst>
           </p:cNvPr>
@@ -18121,7 +18121,7 @@
           <p:cNvPr id="4" name="">
             <a:extLst xmlns:a="http://schemas.openxmlformats.org/drawingml/2006/main">
               <a:ext uri="{FF2B5EF4-FFF2-40B4-BE49-F238E27FC236}">
-                <a16:creationId xmlns:a16="http://schemas.microsoft.com/office/drawing/2014/main" id="{8DBAD3B2-5758-4B1E-8A42-C9B4B08B68CB}"/>
+                <a16:creationId xmlns:a16="http://schemas.microsoft.com/office/drawing/2014/main" id="{BBAAB150-9284-4702-8970-3FEFCDF879B1}"/>
               </a:ext>
             </a:extLst>
           </p:cNvPr>
@@ -18277,7 +18277,7 @@
           <p:cNvPr id="5" name="">
             <a:extLst xmlns:a="http://schemas.openxmlformats.org/drawingml/2006/main">
               <a:ext uri="{FF2B5EF4-FFF2-40B4-BE49-F238E27FC236}">
-                <a16:creationId xmlns:a16="http://schemas.microsoft.com/office/drawing/2014/main" id="{125A1BE5-2B26-4A37-B9F8-00789DAAA0D1}"/>
+                <a16:creationId xmlns:a16="http://schemas.microsoft.com/office/drawing/2014/main" id="{79335598-36A5-443F-9FAC-16A948492C2E}"/>
               </a:ext>
             </a:extLst>
           </p:cNvPr>
@@ -18287,7 +18287,7 @@
           <p:nvPr/>
         </p:nvPicPr>
         <p:blipFill>
-          <a:blip xmlns:r="http://schemas.openxmlformats.org/officeDocument/2006/relationships" xmlns:a="http://schemas.openxmlformats.org/drawingml/2006/main" r:embed="Rcac4557a1fee4181"/>
+          <a:blip xmlns:r="http://schemas.openxmlformats.org/officeDocument/2006/relationships" xmlns:a="http://schemas.openxmlformats.org/drawingml/2006/main" r:embed="Ra05287565a2c42ed"/>
           <a:stretch xmlns:a="http://schemas.openxmlformats.org/drawingml/2006/main"/>
         </p:blipFill>
         <p:spPr>
@@ -18303,7 +18303,7 @@
     </p:spTree>
     <p:extLst>
       <p:ext uri="{BB962C8B-B14F-4D97-AF65-F5344CB8AC3E}">
-        <p14:creationId xmlns:p14="http://schemas.microsoft.com/office/powerpoint/2010/main" val="1091215303"/>
+        <p14:creationId xmlns:p14="http://schemas.microsoft.com/office/powerpoint/2010/main" val="1214510907"/>
       </p:ext>
     </p:extLst>
   </p:cSld>
@@ -18334,7 +18334,7 @@
           <p:cNvPr id="6" name="">
             <a:extLst xmlns:a="http://schemas.openxmlformats.org/drawingml/2006/main">
               <a:ext uri="{FF2B5EF4-FFF2-40B4-BE49-F238E27FC236}">
-                <a16:creationId xmlns:a16="http://schemas.microsoft.com/office/drawing/2014/main" id="{88667A17-105C-4966-934E-179B057D893C}"/>
+                <a16:creationId xmlns:a16="http://schemas.microsoft.com/office/drawing/2014/main" id="{BFC5E232-3BD5-4CC5-A742-B52E3A4903C6}"/>
               </a:ext>
             </a:extLst>
           </p:cNvPr>
@@ -18490,7 +18490,7 @@
           <p:cNvPr id="2" name="">
             <a:extLst xmlns:a="http://schemas.openxmlformats.org/drawingml/2006/main">
               <a:ext uri="{FF2B5EF4-FFF2-40B4-BE49-F238E27FC236}">
-                <a16:creationId xmlns:a16="http://schemas.microsoft.com/office/drawing/2014/main" id="{A71ACA7E-A208-4911-91C4-586D3965E554}"/>
+                <a16:creationId xmlns:a16="http://schemas.microsoft.com/office/drawing/2014/main" id="{5482E72F-A5BA-4974-B35A-A1FAFC725425}"/>
               </a:ext>
             </a:extLst>
           </p:cNvPr>
@@ -18646,7 +18646,7 @@
           <p:cNvPr id="3" name="">
             <a:extLst xmlns:a="http://schemas.openxmlformats.org/drawingml/2006/main">
               <a:ext uri="{FF2B5EF4-FFF2-40B4-BE49-F238E27FC236}">
-                <a16:creationId xmlns:a16="http://schemas.microsoft.com/office/drawing/2014/main" id="{866E98F0-FFEE-4EF6-ADB7-285983E23A64}"/>
+                <a16:creationId xmlns:a16="http://schemas.microsoft.com/office/drawing/2014/main" id="{B0BB3A4A-2E9A-40D9-B427-1497C607D521}"/>
               </a:ext>
             </a:extLst>
           </p:cNvPr>
@@ -18802,7 +18802,7 @@
           <p:cNvPr id="4" name="">
             <a:extLst xmlns:a="http://schemas.openxmlformats.org/drawingml/2006/main">
               <a:ext uri="{FF2B5EF4-FFF2-40B4-BE49-F238E27FC236}">
-                <a16:creationId xmlns:a16="http://schemas.microsoft.com/office/drawing/2014/main" id="{6EE91CF1-FD33-4EC9-B816-10AF435A340B}"/>
+                <a16:creationId xmlns:a16="http://schemas.microsoft.com/office/drawing/2014/main" id="{2CE6490B-9B8C-4325-80E0-C962A3585D6F}"/>
               </a:ext>
             </a:extLst>
           </p:cNvPr>
@@ -18958,7 +18958,7 @@
           <p:cNvPr id="5" name="">
             <a:extLst xmlns:a="http://schemas.openxmlformats.org/drawingml/2006/main">
               <a:ext uri="{FF2B5EF4-FFF2-40B4-BE49-F238E27FC236}">
-                <a16:creationId xmlns:a16="http://schemas.microsoft.com/office/drawing/2014/main" id="{28DE5F54-EE00-46A3-9F11-7ADEA90EAD9A}"/>
+                <a16:creationId xmlns:a16="http://schemas.microsoft.com/office/drawing/2014/main" id="{6EC75169-7315-488F-B03A-D092EC5868B3}"/>
               </a:ext>
             </a:extLst>
           </p:cNvPr>
@@ -18968,7 +18968,7 @@
           <p:nvPr/>
         </p:nvPicPr>
         <p:blipFill>
-          <a:blip xmlns:r="http://schemas.openxmlformats.org/officeDocument/2006/relationships" xmlns:a="http://schemas.openxmlformats.org/drawingml/2006/main" r:embed="R135013ebffbb4e27"/>
+          <a:blip xmlns:r="http://schemas.openxmlformats.org/officeDocument/2006/relationships" xmlns:a="http://schemas.openxmlformats.org/drawingml/2006/main" r:embed="R41565deddf424e9f"/>
           <a:stretch xmlns:a="http://schemas.openxmlformats.org/drawingml/2006/main"/>
         </p:blipFill>
         <p:spPr>
@@ -18984,7 +18984,7 @@
     </p:spTree>
     <p:extLst>
       <p:ext uri="{BB962C8B-B14F-4D97-AF65-F5344CB8AC3E}">
-        <p14:creationId xmlns:p14="http://schemas.microsoft.com/office/powerpoint/2010/main" val="1641243064"/>
+        <p14:creationId xmlns:p14="http://schemas.microsoft.com/office/powerpoint/2010/main" val="1252360384"/>
       </p:ext>
     </p:extLst>
   </p:cSld>
@@ -19015,7 +19015,7 @@
           <p:cNvPr id="7" name="">
             <a:extLst xmlns:a="http://schemas.openxmlformats.org/drawingml/2006/main">
               <a:ext uri="{FF2B5EF4-FFF2-40B4-BE49-F238E27FC236}">
-                <a16:creationId xmlns:a16="http://schemas.microsoft.com/office/drawing/2014/main" id="{6392991B-2DF9-462F-A184-6D52A093B41D}"/>
+                <a16:creationId xmlns:a16="http://schemas.microsoft.com/office/drawing/2014/main" id="{028DB067-30F2-4877-B578-ECE50A00BBE2}"/>
               </a:ext>
             </a:extLst>
           </p:cNvPr>
@@ -19171,7 +19171,7 @@
           <p:cNvPr id="2" name="">
             <a:extLst xmlns:a="http://schemas.openxmlformats.org/drawingml/2006/main">
               <a:ext uri="{FF2B5EF4-FFF2-40B4-BE49-F238E27FC236}">
-                <a16:creationId xmlns:a16="http://schemas.microsoft.com/office/drawing/2014/main" id="{CC8A3031-C3EE-4421-9D03-8401D0CFBEA5}"/>
+                <a16:creationId xmlns:a16="http://schemas.microsoft.com/office/drawing/2014/main" id="{1206AFAA-8A8B-43D8-8758-1B9855584417}"/>
               </a:ext>
             </a:extLst>
           </p:cNvPr>
@@ -19327,7 +19327,7 @@
           <p:cNvPr id="3" name="">
             <a:extLst xmlns:a="http://schemas.openxmlformats.org/drawingml/2006/main">
               <a:ext uri="{FF2B5EF4-FFF2-40B4-BE49-F238E27FC236}">
-                <a16:creationId xmlns:a16="http://schemas.microsoft.com/office/drawing/2014/main" id="{2F7A7E87-4A2F-40F5-90F1-FF73FB73299A}"/>
+                <a16:creationId xmlns:a16="http://schemas.microsoft.com/office/drawing/2014/main" id="{4DA3E27B-39D4-4CF4-B9E3-757671EC38C4}"/>
               </a:ext>
             </a:extLst>
           </p:cNvPr>
@@ -19483,7 +19483,7 @@
           <p:cNvPr id="4" name="">
             <a:extLst xmlns:a="http://schemas.openxmlformats.org/drawingml/2006/main">
               <a:ext uri="{FF2B5EF4-FFF2-40B4-BE49-F238E27FC236}">
-                <a16:creationId xmlns:a16="http://schemas.microsoft.com/office/drawing/2014/main" id="{B46419A5-512B-459E-A551-204B0E46E83B}"/>
+                <a16:creationId xmlns:a16="http://schemas.microsoft.com/office/drawing/2014/main" id="{6210606A-5D63-4490-A5BB-D94C64EA4C59}"/>
               </a:ext>
             </a:extLst>
           </p:cNvPr>
@@ -19639,7 +19639,7 @@
           <p:cNvPr id="5" name="">
             <a:extLst xmlns:a="http://schemas.openxmlformats.org/drawingml/2006/main">
               <a:ext uri="{FF2B5EF4-FFF2-40B4-BE49-F238E27FC236}">
-                <a16:creationId xmlns:a16="http://schemas.microsoft.com/office/drawing/2014/main" id="{1E7D177E-A4A5-48A0-B443-A98CF1E55DF5}"/>
+                <a16:creationId xmlns:a16="http://schemas.microsoft.com/office/drawing/2014/main" id="{2366220A-6D4C-4D68-89C4-3A734AD84658}"/>
               </a:ext>
             </a:extLst>
           </p:cNvPr>
@@ -20266,7 +20266,7 @@
           <p:cNvPr id="6" name="">
             <a:extLst xmlns:a="http://schemas.openxmlformats.org/drawingml/2006/main">
               <a:ext uri="{FF2B5EF4-FFF2-40B4-BE49-F238E27FC236}">
-                <a16:creationId xmlns:a16="http://schemas.microsoft.com/office/drawing/2014/main" id="{357EAF3C-D96E-4690-B3A3-D58A379F19DD}"/>
+                <a16:creationId xmlns:a16="http://schemas.microsoft.com/office/drawing/2014/main" id="{D9322852-1739-4E7F-BACB-2D6935E853F2}"/>
               </a:ext>
             </a:extLst>
           </p:cNvPr>
@@ -20420,7 +20420,7 @@
     </p:spTree>
     <p:extLst>
       <p:ext uri="{BB962C8B-B14F-4D97-AF65-F5344CB8AC3E}">
-        <p14:creationId xmlns:p14="http://schemas.microsoft.com/office/powerpoint/2010/main" val="731499602"/>
+        <p14:creationId xmlns:p14="http://schemas.microsoft.com/office/powerpoint/2010/main" val="1564318571"/>
       </p:ext>
     </p:extLst>
   </p:cSld>
@@ -20451,7 +20451,7 @@
           <p:cNvPr id="8" name="">
             <a:extLst xmlns:a="http://schemas.openxmlformats.org/drawingml/2006/main">
               <a:ext uri="{FF2B5EF4-FFF2-40B4-BE49-F238E27FC236}">
-                <a16:creationId xmlns:a16="http://schemas.microsoft.com/office/drawing/2014/main" id="{88BCA6D1-5A64-42C2-A1E4-CE2634382686}"/>
+                <a16:creationId xmlns:a16="http://schemas.microsoft.com/office/drawing/2014/main" id="{610724CF-4419-4747-99E8-DB2412E3BECA}"/>
               </a:ext>
             </a:extLst>
           </p:cNvPr>
@@ -20607,7 +20607,7 @@
           <p:cNvPr id="2" name="">
             <a:extLst xmlns:a="http://schemas.openxmlformats.org/drawingml/2006/main">
               <a:ext uri="{FF2B5EF4-FFF2-40B4-BE49-F238E27FC236}">
-                <a16:creationId xmlns:a16="http://schemas.microsoft.com/office/drawing/2014/main" id="{F52FBAC3-64C2-49C5-A91D-E3C61DB7120B}"/>
+                <a16:creationId xmlns:a16="http://schemas.microsoft.com/office/drawing/2014/main" id="{25F1EF73-E9BA-4784-A1F0-E17E457F9A97}"/>
               </a:ext>
             </a:extLst>
           </p:cNvPr>
@@ -20763,7 +20763,7 @@
           <p:cNvPr id="3" name="">
             <a:extLst xmlns:a="http://schemas.openxmlformats.org/drawingml/2006/main">
               <a:ext uri="{FF2B5EF4-FFF2-40B4-BE49-F238E27FC236}">
-                <a16:creationId xmlns:a16="http://schemas.microsoft.com/office/drawing/2014/main" id="{19410AFD-5B07-4584-B08C-FA1089BA6C1D}"/>
+                <a16:creationId xmlns:a16="http://schemas.microsoft.com/office/drawing/2014/main" id="{2C537A66-3EEF-46E2-ACC8-9350B75EF4AD}"/>
               </a:ext>
             </a:extLst>
           </p:cNvPr>
@@ -20919,7 +20919,7 @@
           <p:cNvPr id="4" name="">
             <a:extLst xmlns:a="http://schemas.openxmlformats.org/drawingml/2006/main">
               <a:ext uri="{FF2B5EF4-FFF2-40B4-BE49-F238E27FC236}">
-                <a16:creationId xmlns:a16="http://schemas.microsoft.com/office/drawing/2014/main" id="{E3199329-905B-4AD0-92E3-1056C5F324E8}"/>
+                <a16:creationId xmlns:a16="http://schemas.microsoft.com/office/drawing/2014/main" id="{D3038F15-AF60-4AA5-8B15-462542075409}"/>
               </a:ext>
             </a:extLst>
           </p:cNvPr>
@@ -21075,7 +21075,7 @@
           <p:cNvPr id="5" name="">
             <a:extLst xmlns:a="http://schemas.openxmlformats.org/drawingml/2006/main">
               <a:ext uri="{FF2B5EF4-FFF2-40B4-BE49-F238E27FC236}">
-                <a16:creationId xmlns:a16="http://schemas.microsoft.com/office/drawing/2014/main" id="{B0072D8A-7C25-43D2-9279-89980B028AF0}"/>
+                <a16:creationId xmlns:a16="http://schemas.microsoft.com/office/drawing/2014/main" id="{5E815E03-09AC-469E-82E3-EDB7A7DB581D}"/>
               </a:ext>
             </a:extLst>
           </p:cNvPr>
@@ -21586,7 +21586,7 @@
           <p:cNvPr id="6" name="">
             <a:extLst xmlns:a="http://schemas.openxmlformats.org/drawingml/2006/main">
               <a:ext uri="{FF2B5EF4-FFF2-40B4-BE49-F238E27FC236}">
-                <a16:creationId xmlns:a16="http://schemas.microsoft.com/office/drawing/2014/main" id="{A65E1028-1E54-4981-9896-2A87F38C50D1}"/>
+                <a16:creationId xmlns:a16="http://schemas.microsoft.com/office/drawing/2014/main" id="{D9B1A859-5506-4BC7-947A-7515394C87D0}"/>
               </a:ext>
             </a:extLst>
           </p:cNvPr>
@@ -21742,7 +21742,7 @@
           <p:cNvPr id="7" name="">
             <a:extLst xmlns:a="http://schemas.openxmlformats.org/drawingml/2006/main">
               <a:ext uri="{FF2B5EF4-FFF2-40B4-BE49-F238E27FC236}">
-                <a16:creationId xmlns:a16="http://schemas.microsoft.com/office/drawing/2014/main" id="{5604EB0D-A2DA-40D0-AC73-5357B36922F5}"/>
+                <a16:creationId xmlns:a16="http://schemas.microsoft.com/office/drawing/2014/main" id="{C0C0701C-1495-4987-8F91-56A7A00CE3D0}"/>
               </a:ext>
             </a:extLst>
           </p:cNvPr>
@@ -21896,7 +21896,7 @@
     </p:spTree>
     <p:extLst>
       <p:ext uri="{BB962C8B-B14F-4D97-AF65-F5344CB8AC3E}">
-        <p14:creationId xmlns:p14="http://schemas.microsoft.com/office/powerpoint/2010/main" val="1135484870"/>
+        <p14:creationId xmlns:p14="http://schemas.microsoft.com/office/powerpoint/2010/main" val="1090517123"/>
       </p:ext>
     </p:extLst>
   </p:cSld>
@@ -21927,7 +21927,7 @@
           <p:cNvPr id="6" name="">
             <a:extLst xmlns:a="http://schemas.openxmlformats.org/drawingml/2006/main">
               <a:ext uri="{FF2B5EF4-FFF2-40B4-BE49-F238E27FC236}">
-                <a16:creationId xmlns:a16="http://schemas.microsoft.com/office/drawing/2014/main" id="{A409D146-555B-4637-BAB2-1AD39C8156E4}"/>
+                <a16:creationId xmlns:a16="http://schemas.microsoft.com/office/drawing/2014/main" id="{E233C0F7-9C90-4735-9E93-67B45DEC982A}"/>
               </a:ext>
             </a:extLst>
           </p:cNvPr>
@@ -22083,7 +22083,7 @@
           <p:cNvPr id="2" name="">
             <a:extLst xmlns:a="http://schemas.openxmlformats.org/drawingml/2006/main">
               <a:ext uri="{FF2B5EF4-FFF2-40B4-BE49-F238E27FC236}">
-                <a16:creationId xmlns:a16="http://schemas.microsoft.com/office/drawing/2014/main" id="{200F5938-C26F-4EED-96AE-C0C5E337D639}"/>
+                <a16:creationId xmlns:a16="http://schemas.microsoft.com/office/drawing/2014/main" id="{B6196CA2-EBE4-4D61-B5EF-357D58C930E8}"/>
               </a:ext>
             </a:extLst>
           </p:cNvPr>
@@ -22239,7 +22239,7 @@
           <p:cNvPr id="3" name="">
             <a:extLst xmlns:a="http://schemas.openxmlformats.org/drawingml/2006/main">
               <a:ext uri="{FF2B5EF4-FFF2-40B4-BE49-F238E27FC236}">
-                <a16:creationId xmlns:a16="http://schemas.microsoft.com/office/drawing/2014/main" id="{4AF7D1C9-CBF3-4AF0-90B8-33074D163AE5}"/>
+                <a16:creationId xmlns:a16="http://schemas.microsoft.com/office/drawing/2014/main" id="{15B01B30-FFAF-4870-B6EB-B33EAC17C9F3}"/>
               </a:ext>
             </a:extLst>
           </p:cNvPr>
@@ -22395,7 +22395,7 @@
           <p:cNvPr id="4" name="">
             <a:extLst xmlns:a="http://schemas.openxmlformats.org/drawingml/2006/main">
               <a:ext uri="{FF2B5EF4-FFF2-40B4-BE49-F238E27FC236}">
-                <a16:creationId xmlns:a16="http://schemas.microsoft.com/office/drawing/2014/main" id="{6F2A7466-3469-42FA-A75B-71D7E95C9189}"/>
+                <a16:creationId xmlns:a16="http://schemas.microsoft.com/office/drawing/2014/main" id="{75E0A0DB-394E-4BD3-9710-63F63EF1A6B9}"/>
               </a:ext>
             </a:extLst>
           </p:cNvPr>
@@ -22551,7 +22551,7 @@
           <p:cNvPr id="5" name="">
             <a:extLst xmlns:a="http://schemas.openxmlformats.org/drawingml/2006/main">
               <a:ext uri="{FF2B5EF4-FFF2-40B4-BE49-F238E27FC236}">
-                <a16:creationId xmlns:a16="http://schemas.microsoft.com/office/drawing/2014/main" id="{3961BBFA-FE24-42B1-9B9E-AF52DD8EB254}"/>
+                <a16:creationId xmlns:a16="http://schemas.microsoft.com/office/drawing/2014/main" id="{B89BEC73-B9FC-485D-97C2-74609DBCB98B}"/>
               </a:ext>
             </a:extLst>
           </p:cNvPr>
@@ -22561,7 +22561,7 @@
           <p:nvPr/>
         </p:nvPicPr>
         <p:blipFill>
-          <a:blip xmlns:r="http://schemas.openxmlformats.org/officeDocument/2006/relationships" xmlns:a="http://schemas.openxmlformats.org/drawingml/2006/main" r:embed="Ra3af9f4bb85a48b3"/>
+          <a:blip xmlns:r="http://schemas.openxmlformats.org/officeDocument/2006/relationships" xmlns:a="http://schemas.openxmlformats.org/drawingml/2006/main" r:embed="Ra5c03b45982b4878"/>
           <a:stretch xmlns:a="http://schemas.openxmlformats.org/drawingml/2006/main"/>
         </p:blipFill>
         <p:spPr>
@@ -22577,7 +22577,7 @@
     </p:spTree>
     <p:extLst>
       <p:ext uri="{BB962C8B-B14F-4D97-AF65-F5344CB8AC3E}">
-        <p14:creationId xmlns:p14="http://schemas.microsoft.com/office/powerpoint/2010/main" val="870924322"/>
+        <p14:creationId xmlns:p14="http://schemas.microsoft.com/office/powerpoint/2010/main" val="2066016994"/>
       </p:ext>
     </p:extLst>
   </p:cSld>
@@ -22608,7 +22608,7 @@
           <p:cNvPr id="6" name="">
             <a:extLst xmlns:a="http://schemas.openxmlformats.org/drawingml/2006/main">
               <a:ext uri="{FF2B5EF4-FFF2-40B4-BE49-F238E27FC236}">
-                <a16:creationId xmlns:a16="http://schemas.microsoft.com/office/drawing/2014/main" id="{467BE93C-5E98-4FF0-8032-8A3BDC938500}"/>
+                <a16:creationId xmlns:a16="http://schemas.microsoft.com/office/drawing/2014/main" id="{44E07CBC-18D6-49B1-8C70-1D0D21851668}"/>
               </a:ext>
             </a:extLst>
           </p:cNvPr>
@@ -22764,7 +22764,7 @@
           <p:cNvPr id="2" name="">
             <a:extLst xmlns:a="http://schemas.openxmlformats.org/drawingml/2006/main">
               <a:ext uri="{FF2B5EF4-FFF2-40B4-BE49-F238E27FC236}">
-                <a16:creationId xmlns:a16="http://schemas.microsoft.com/office/drawing/2014/main" id="{ADAF0673-38A7-4E8F-AD7A-BC04A6B00D85}"/>
+                <a16:creationId xmlns:a16="http://schemas.microsoft.com/office/drawing/2014/main" id="{22038C98-90F0-4D17-A443-055633F26E1F}"/>
               </a:ext>
             </a:extLst>
           </p:cNvPr>
@@ -22920,7 +22920,7 @@
           <p:cNvPr id="3" name="">
             <a:extLst xmlns:a="http://schemas.openxmlformats.org/drawingml/2006/main">
               <a:ext uri="{FF2B5EF4-FFF2-40B4-BE49-F238E27FC236}">
-                <a16:creationId xmlns:a16="http://schemas.microsoft.com/office/drawing/2014/main" id="{9D2D3463-3951-4D28-9302-7A86874B192D}"/>
+                <a16:creationId xmlns:a16="http://schemas.microsoft.com/office/drawing/2014/main" id="{E68EBE42-567C-4341-B314-31D0A0660789}"/>
               </a:ext>
             </a:extLst>
           </p:cNvPr>
@@ -23076,7 +23076,7 @@
           <p:cNvPr id="4" name="">
             <a:extLst xmlns:a="http://schemas.openxmlformats.org/drawingml/2006/main">
               <a:ext uri="{FF2B5EF4-FFF2-40B4-BE49-F238E27FC236}">
-                <a16:creationId xmlns:a16="http://schemas.microsoft.com/office/drawing/2014/main" id="{298BEE3B-4232-47EF-89E3-F509750B02B3}"/>
+                <a16:creationId xmlns:a16="http://schemas.microsoft.com/office/drawing/2014/main" id="{3B2C683B-F790-4F87-8B4F-0A2140062E35}"/>
               </a:ext>
             </a:extLst>
           </p:cNvPr>
@@ -23232,7 +23232,7 @@
           <p:cNvPr id="5" name="">
             <a:extLst xmlns:a="http://schemas.openxmlformats.org/drawingml/2006/main">
               <a:ext uri="{FF2B5EF4-FFF2-40B4-BE49-F238E27FC236}">
-                <a16:creationId xmlns:a16="http://schemas.microsoft.com/office/drawing/2014/main" id="{4FC150D8-894A-4396-A3EB-6D0E4E1AC087}"/>
+                <a16:creationId xmlns:a16="http://schemas.microsoft.com/office/drawing/2014/main" id="{709AA9EF-9B4F-4714-BD76-CCB8C79EA622}"/>
               </a:ext>
             </a:extLst>
           </p:cNvPr>
@@ -23242,7 +23242,7 @@
           <p:nvPr/>
         </p:nvPicPr>
         <p:blipFill>
-          <a:blip xmlns:r="http://schemas.openxmlformats.org/officeDocument/2006/relationships" xmlns:a="http://schemas.openxmlformats.org/drawingml/2006/main" r:embed="R08c5bb21f1df4051"/>
+          <a:blip xmlns:r="http://schemas.openxmlformats.org/officeDocument/2006/relationships" xmlns:a="http://schemas.openxmlformats.org/drawingml/2006/main" r:embed="Rf658285d467c4e50"/>
           <a:stretch xmlns:a="http://schemas.openxmlformats.org/drawingml/2006/main"/>
         </p:blipFill>
         <p:spPr>
@@ -23258,7 +23258,7 @@
     </p:spTree>
     <p:extLst>
       <p:ext uri="{BB962C8B-B14F-4D97-AF65-F5344CB8AC3E}">
-        <p14:creationId xmlns:p14="http://schemas.microsoft.com/office/powerpoint/2010/main" val="435749843"/>
+        <p14:creationId xmlns:p14="http://schemas.microsoft.com/office/powerpoint/2010/main" val="769330731"/>
       </p:ext>
     </p:extLst>
   </p:cSld>
@@ -23289,7 +23289,7 @@
           <p:cNvPr id="7" name="">
             <a:extLst xmlns:a="http://schemas.openxmlformats.org/drawingml/2006/main">
               <a:ext uri="{FF2B5EF4-FFF2-40B4-BE49-F238E27FC236}">
-                <a16:creationId xmlns:a16="http://schemas.microsoft.com/office/drawing/2014/main" id="{D143D6CD-611A-4C0E-A317-7AF643EB7E65}"/>
+                <a16:creationId xmlns:a16="http://schemas.microsoft.com/office/drawing/2014/main" id="{C633A9DC-94E7-4432-B2DD-FD52F94664E9}"/>
               </a:ext>
             </a:extLst>
           </p:cNvPr>
@@ -23445,7 +23445,7 @@
           <p:cNvPr id="2" name="">
             <a:extLst xmlns:a="http://schemas.openxmlformats.org/drawingml/2006/main">
               <a:ext uri="{FF2B5EF4-FFF2-40B4-BE49-F238E27FC236}">
-                <a16:creationId xmlns:a16="http://schemas.microsoft.com/office/drawing/2014/main" id="{98462237-CE8B-47DD-BAA7-2B2EA5B2C812}"/>
+                <a16:creationId xmlns:a16="http://schemas.microsoft.com/office/drawing/2014/main" id="{9E7EE66A-5058-4E4B-B0A1-D6D9FCB81374}"/>
               </a:ext>
             </a:extLst>
           </p:cNvPr>
@@ -23601,7 +23601,7 @@
           <p:cNvPr id="3" name="">
             <a:extLst xmlns:a="http://schemas.openxmlformats.org/drawingml/2006/main">
               <a:ext uri="{FF2B5EF4-FFF2-40B4-BE49-F238E27FC236}">
-                <a16:creationId xmlns:a16="http://schemas.microsoft.com/office/drawing/2014/main" id="{782B9465-24EA-4EF9-BBB8-542738C77C0C}"/>
+                <a16:creationId xmlns:a16="http://schemas.microsoft.com/office/drawing/2014/main" id="{93C72673-18CD-4837-B17A-119CBAC8AF5D}"/>
               </a:ext>
             </a:extLst>
           </p:cNvPr>
@@ -23757,7 +23757,7 @@
           <p:cNvPr id="4" name="">
             <a:extLst xmlns:a="http://schemas.openxmlformats.org/drawingml/2006/main">
               <a:ext uri="{FF2B5EF4-FFF2-40B4-BE49-F238E27FC236}">
-                <a16:creationId xmlns:a16="http://schemas.microsoft.com/office/drawing/2014/main" id="{EC970036-A975-4091-86ED-FD2496623F48}"/>
+                <a16:creationId xmlns:a16="http://schemas.microsoft.com/office/drawing/2014/main" id="{4E37B8D1-1AB0-4942-BC7E-A7FB8F8C8CFF}"/>
               </a:ext>
             </a:extLst>
           </p:cNvPr>
@@ -23913,7 +23913,7 @@
           <p:cNvPr id="5" name="">
             <a:extLst xmlns:a="http://schemas.openxmlformats.org/drawingml/2006/main">
               <a:ext uri="{FF2B5EF4-FFF2-40B4-BE49-F238E27FC236}">
-                <a16:creationId xmlns:a16="http://schemas.microsoft.com/office/drawing/2014/main" id="{5281C06F-A5DE-41FD-A98A-A1924607A5E5}"/>
+                <a16:creationId xmlns:a16="http://schemas.microsoft.com/office/drawing/2014/main" id="{D02BCFCF-330D-4C4B-BFE5-1320163CEDDC}"/>
               </a:ext>
             </a:extLst>
           </p:cNvPr>
@@ -24540,7 +24540,7 @@
           <p:cNvPr id="6" name="">
             <a:extLst xmlns:a="http://schemas.openxmlformats.org/drawingml/2006/main">
               <a:ext uri="{FF2B5EF4-FFF2-40B4-BE49-F238E27FC236}">
-                <a16:creationId xmlns:a16="http://schemas.microsoft.com/office/drawing/2014/main" id="{B2E14433-DDD8-4686-A3BA-BC5431B14AF5}"/>
+                <a16:creationId xmlns:a16="http://schemas.microsoft.com/office/drawing/2014/main" id="{FAF11B9B-232C-44AF-B6AB-BF0A0A393205}"/>
               </a:ext>
             </a:extLst>
           </p:cNvPr>
@@ -24694,7 +24694,7 @@
     </p:spTree>
     <p:extLst>
       <p:ext uri="{BB962C8B-B14F-4D97-AF65-F5344CB8AC3E}">
-        <p14:creationId xmlns:p14="http://schemas.microsoft.com/office/powerpoint/2010/main" val="498238063"/>
+        <p14:creationId xmlns:p14="http://schemas.microsoft.com/office/powerpoint/2010/main" val="901912262"/>
       </p:ext>
     </p:extLst>
   </p:cSld>
@@ -24725,7 +24725,7 @@
           <p:cNvPr id="7" name="">
             <a:extLst xmlns:a="http://schemas.openxmlformats.org/drawingml/2006/main">
               <a:ext uri="{FF2B5EF4-FFF2-40B4-BE49-F238E27FC236}">
-                <a16:creationId xmlns:a16="http://schemas.microsoft.com/office/drawing/2014/main" id="{ECCD33BA-49AA-4408-A137-165E53C49227}"/>
+                <a16:creationId xmlns:a16="http://schemas.microsoft.com/office/drawing/2014/main" id="{1F6BBEEA-4542-4068-B0D8-7CBBF14039D7}"/>
               </a:ext>
             </a:extLst>
           </p:cNvPr>
@@ -24881,7 +24881,7 @@
           <p:cNvPr id="2" name="">
             <a:extLst xmlns:a="http://schemas.openxmlformats.org/drawingml/2006/main">
               <a:ext uri="{FF2B5EF4-FFF2-40B4-BE49-F238E27FC236}">
-                <a16:creationId xmlns:a16="http://schemas.microsoft.com/office/drawing/2014/main" id="{5B374718-97ED-4DFF-949F-C8153302A07F}"/>
+                <a16:creationId xmlns:a16="http://schemas.microsoft.com/office/drawing/2014/main" id="{4BC42401-2A0C-4A88-AE16-41C4ADFD32F6}"/>
               </a:ext>
             </a:extLst>
           </p:cNvPr>
@@ -25037,7 +25037,7 @@
           <p:cNvPr id="3" name="">
             <a:extLst xmlns:a="http://schemas.openxmlformats.org/drawingml/2006/main">
               <a:ext uri="{FF2B5EF4-FFF2-40B4-BE49-F238E27FC236}">
-                <a16:creationId xmlns:a16="http://schemas.microsoft.com/office/drawing/2014/main" id="{5EA8750B-010C-4438-BD11-BFB9E239F05E}"/>
+                <a16:creationId xmlns:a16="http://schemas.microsoft.com/office/drawing/2014/main" id="{7E4464DE-299C-457F-AC7A-84B233A85E40}"/>
               </a:ext>
             </a:extLst>
           </p:cNvPr>
@@ -25193,7 +25193,7 @@
           <p:cNvPr id="4" name="">
             <a:extLst xmlns:a="http://schemas.openxmlformats.org/drawingml/2006/main">
               <a:ext uri="{FF2B5EF4-FFF2-40B4-BE49-F238E27FC236}">
-                <a16:creationId xmlns:a16="http://schemas.microsoft.com/office/drawing/2014/main" id="{B51A183C-0C79-4ACF-A048-3A7972F5D8E6}"/>
+                <a16:creationId xmlns:a16="http://schemas.microsoft.com/office/drawing/2014/main" id="{5028CD50-153B-45F7-8127-9A6085450DA3}"/>
               </a:ext>
             </a:extLst>
           </p:cNvPr>
@@ -25349,7 +25349,7 @@
           <p:cNvPr id="5" name="">
             <a:extLst xmlns:a="http://schemas.openxmlformats.org/drawingml/2006/main">
               <a:ext uri="{FF2B5EF4-FFF2-40B4-BE49-F238E27FC236}">
-                <a16:creationId xmlns:a16="http://schemas.microsoft.com/office/drawing/2014/main" id="{8B65DE2F-3D7D-4A5B-AA8C-8D841AF7C60B}"/>
+                <a16:creationId xmlns:a16="http://schemas.microsoft.com/office/drawing/2014/main" id="{4CF24E25-84AA-49F8-807D-CE5225DA77FC}"/>
               </a:ext>
             </a:extLst>
           </p:cNvPr>
@@ -26189,7 +26189,7 @@
           <p:cNvPr id="6" name="">
             <a:extLst xmlns:a="http://schemas.openxmlformats.org/drawingml/2006/main">
               <a:ext uri="{FF2B5EF4-FFF2-40B4-BE49-F238E27FC236}">
-                <a16:creationId xmlns:a16="http://schemas.microsoft.com/office/drawing/2014/main" id="{71C6D17D-CCED-4428-AD3D-373F2BBADBA8}"/>
+                <a16:creationId xmlns:a16="http://schemas.microsoft.com/office/drawing/2014/main" id="{17EAB855-5250-4E3F-8976-748C28C2376C}"/>
               </a:ext>
             </a:extLst>
           </p:cNvPr>
@@ -26343,7 +26343,7 @@
     </p:spTree>
     <p:extLst>
       <p:ext uri="{BB962C8B-B14F-4D97-AF65-F5344CB8AC3E}">
-        <p14:creationId xmlns:p14="http://schemas.microsoft.com/office/powerpoint/2010/main" val="2066703613"/>
+        <p14:creationId xmlns:p14="http://schemas.microsoft.com/office/powerpoint/2010/main" val="326997014"/>
       </p:ext>
     </p:extLst>
   </p:cSld>
@@ -26374,7 +26374,7 @@
           <p:cNvPr id="7" name="">
             <a:extLst xmlns:a="http://schemas.openxmlformats.org/drawingml/2006/main">
               <a:ext uri="{FF2B5EF4-FFF2-40B4-BE49-F238E27FC236}">
-                <a16:creationId xmlns:a16="http://schemas.microsoft.com/office/drawing/2014/main" id="{541846EF-93E5-49E9-B88D-5147685014D9}"/>
+                <a16:creationId xmlns:a16="http://schemas.microsoft.com/office/drawing/2014/main" id="{F6762BDE-4EC8-4839-86FF-F341484251A7}"/>
               </a:ext>
             </a:extLst>
           </p:cNvPr>
@@ -26530,7 +26530,7 @@
           <p:cNvPr id="2" name="">
             <a:extLst xmlns:a="http://schemas.openxmlformats.org/drawingml/2006/main">
               <a:ext uri="{FF2B5EF4-FFF2-40B4-BE49-F238E27FC236}">
-                <a16:creationId xmlns:a16="http://schemas.microsoft.com/office/drawing/2014/main" id="{5B9AD961-4F1F-4A9B-B544-80A6D08FF82F}"/>
+                <a16:creationId xmlns:a16="http://schemas.microsoft.com/office/drawing/2014/main" id="{915058BF-96E4-4820-91B1-A04E91D26585}"/>
               </a:ext>
             </a:extLst>
           </p:cNvPr>
@@ -26686,7 +26686,7 @@
           <p:cNvPr id="3" name="">
             <a:extLst xmlns:a="http://schemas.openxmlformats.org/drawingml/2006/main">
               <a:ext uri="{FF2B5EF4-FFF2-40B4-BE49-F238E27FC236}">
-                <a16:creationId xmlns:a16="http://schemas.microsoft.com/office/drawing/2014/main" id="{DF5AAFCA-1059-40FC-AB0F-52E862381DDD}"/>
+                <a16:creationId xmlns:a16="http://schemas.microsoft.com/office/drawing/2014/main" id="{02186158-363A-4FE2-84FA-A8C5BFF73DF4}"/>
               </a:ext>
             </a:extLst>
           </p:cNvPr>
@@ -26842,7 +26842,7 @@
           <p:cNvPr id="4" name="">
             <a:extLst xmlns:a="http://schemas.openxmlformats.org/drawingml/2006/main">
               <a:ext uri="{FF2B5EF4-FFF2-40B4-BE49-F238E27FC236}">
-                <a16:creationId xmlns:a16="http://schemas.microsoft.com/office/drawing/2014/main" id="{AA8DEF36-56E2-4C63-8189-0D6EDEEC5E0B}"/>
+                <a16:creationId xmlns:a16="http://schemas.microsoft.com/office/drawing/2014/main" id="{D86FC197-3B41-47B2-A2EE-850DC4789E1F}"/>
               </a:ext>
             </a:extLst>
           </p:cNvPr>
@@ -26998,7 +26998,7 @@
           <p:cNvPr id="5" name="">
             <a:extLst xmlns:a="http://schemas.openxmlformats.org/drawingml/2006/main">
               <a:ext uri="{FF2B5EF4-FFF2-40B4-BE49-F238E27FC236}">
-                <a16:creationId xmlns:a16="http://schemas.microsoft.com/office/drawing/2014/main" id="{18754284-DA60-49D5-8D94-4942F1C3C55A}"/>
+                <a16:creationId xmlns:a16="http://schemas.microsoft.com/office/drawing/2014/main" id="{7A8FBC45-D624-44A8-A7EF-558B8C11ACB2}"/>
               </a:ext>
             </a:extLst>
           </p:cNvPr>
@@ -27598,7 +27598,7 @@
           <p:cNvPr id="6" name="">
             <a:extLst xmlns:a="http://schemas.openxmlformats.org/drawingml/2006/main">
               <a:ext uri="{FF2B5EF4-FFF2-40B4-BE49-F238E27FC236}">
-                <a16:creationId xmlns:a16="http://schemas.microsoft.com/office/drawing/2014/main" id="{E9DCB630-92EB-4243-96A6-3DDD58461B7F}"/>
+                <a16:creationId xmlns:a16="http://schemas.microsoft.com/office/drawing/2014/main" id="{050F3C66-7F26-4BE6-B2FB-2C80A7AE9F3F}"/>
               </a:ext>
             </a:extLst>
           </p:cNvPr>
@@ -27752,7 +27752,7 @@
     </p:spTree>
     <p:extLst>
       <p:ext uri="{BB962C8B-B14F-4D97-AF65-F5344CB8AC3E}">
-        <p14:creationId xmlns:p14="http://schemas.microsoft.com/office/powerpoint/2010/main" val="75553476"/>
+        <p14:creationId xmlns:p14="http://schemas.microsoft.com/office/powerpoint/2010/main" val="369891425"/>
       </p:ext>
     </p:extLst>
   </p:cSld>
@@ -27783,7 +27783,7 @@
           <p:cNvPr id="7" name="">
             <a:extLst xmlns:a="http://schemas.openxmlformats.org/drawingml/2006/main">
               <a:ext uri="{FF2B5EF4-FFF2-40B4-BE49-F238E27FC236}">
-                <a16:creationId xmlns:a16="http://schemas.microsoft.com/office/drawing/2014/main" id="{A8AA748C-33FA-4FB5-BC7D-C82B475017DB}"/>
+                <a16:creationId xmlns:a16="http://schemas.microsoft.com/office/drawing/2014/main" id="{48D716D8-B786-4908-A41B-69FB59FCA254}"/>
               </a:ext>
             </a:extLst>
           </p:cNvPr>
@@ -27939,7 +27939,7 @@
           <p:cNvPr id="2" name="">
             <a:extLst xmlns:a="http://schemas.openxmlformats.org/drawingml/2006/main">
               <a:ext uri="{FF2B5EF4-FFF2-40B4-BE49-F238E27FC236}">
-                <a16:creationId xmlns:a16="http://schemas.microsoft.com/office/drawing/2014/main" id="{E206736A-A604-44C0-B0B5-A13BB1618A78}"/>
+                <a16:creationId xmlns:a16="http://schemas.microsoft.com/office/drawing/2014/main" id="{7B05E20E-A63E-406F-B0BA-831121C9E5E4}"/>
               </a:ext>
             </a:extLst>
           </p:cNvPr>
@@ -28095,7 +28095,7 @@
           <p:cNvPr id="3" name="">
             <a:extLst xmlns:a="http://schemas.openxmlformats.org/drawingml/2006/main">
               <a:ext uri="{FF2B5EF4-FFF2-40B4-BE49-F238E27FC236}">
-                <a16:creationId xmlns:a16="http://schemas.microsoft.com/office/drawing/2014/main" id="{2868D5EF-C209-49EC-8863-BAF47E01FE3B}"/>
+                <a16:creationId xmlns:a16="http://schemas.microsoft.com/office/drawing/2014/main" id="{3803538A-FB02-4BA9-A6EE-BC0C10E167A0}"/>
               </a:ext>
             </a:extLst>
           </p:cNvPr>
@@ -28251,7 +28251,7 @@
           <p:cNvPr id="4" name="">
             <a:extLst xmlns:a="http://schemas.openxmlformats.org/drawingml/2006/main">
               <a:ext uri="{FF2B5EF4-FFF2-40B4-BE49-F238E27FC236}">
-                <a16:creationId xmlns:a16="http://schemas.microsoft.com/office/drawing/2014/main" id="{912A69B4-EF41-42E1-B835-371BA90D8C74}"/>
+                <a16:creationId xmlns:a16="http://schemas.microsoft.com/office/drawing/2014/main" id="{FA3E1C32-3AC1-4C09-9317-7C10FEA6B5F1}"/>
               </a:ext>
             </a:extLst>
           </p:cNvPr>
@@ -28407,7 +28407,7 @@
           <p:cNvPr id="5" name="">
             <a:extLst xmlns:a="http://schemas.openxmlformats.org/drawingml/2006/main">
               <a:ext uri="{FF2B5EF4-FFF2-40B4-BE49-F238E27FC236}">
-                <a16:creationId xmlns:a16="http://schemas.microsoft.com/office/drawing/2014/main" id="{532A25FF-64F5-4784-96FF-AF9112D5D8F1}"/>
+                <a16:creationId xmlns:a16="http://schemas.microsoft.com/office/drawing/2014/main" id="{94A16DFC-6BD0-4389-85F7-DE010F5E6C12}"/>
               </a:ext>
             </a:extLst>
           </p:cNvPr>
@@ -28847,7 +28847,7 @@
           <p:cNvPr id="6" name="">
             <a:extLst xmlns:a="http://schemas.openxmlformats.org/drawingml/2006/main">
               <a:ext uri="{FF2B5EF4-FFF2-40B4-BE49-F238E27FC236}">
-                <a16:creationId xmlns:a16="http://schemas.microsoft.com/office/drawing/2014/main" id="{34D2018D-7E3D-4603-B06E-0757ADEDECB8}"/>
+                <a16:creationId xmlns:a16="http://schemas.microsoft.com/office/drawing/2014/main" id="{AB521BCB-E146-41A8-8317-400626131BDF}"/>
               </a:ext>
             </a:extLst>
           </p:cNvPr>
@@ -29001,7 +29001,7 @@
     </p:spTree>
     <p:extLst>
       <p:ext uri="{BB962C8B-B14F-4D97-AF65-F5344CB8AC3E}">
-        <p14:creationId xmlns:p14="http://schemas.microsoft.com/office/powerpoint/2010/main" val="358803925"/>
+        <p14:creationId xmlns:p14="http://schemas.microsoft.com/office/powerpoint/2010/main" val="815388267"/>
       </p:ext>
     </p:extLst>
   </p:cSld>
@@ -29032,7 +29032,7 @@
           <p:cNvPr id="8" name="">
             <a:extLst xmlns:a="http://schemas.openxmlformats.org/drawingml/2006/main">
               <a:ext uri="{FF2B5EF4-FFF2-40B4-BE49-F238E27FC236}">
-                <a16:creationId xmlns:a16="http://schemas.microsoft.com/office/drawing/2014/main" id="{C112B43D-E078-4B52-8B85-3F69BE57AED5}"/>
+                <a16:creationId xmlns:a16="http://schemas.microsoft.com/office/drawing/2014/main" id="{365BE534-5CAF-440D-B142-71FA123E976D}"/>
               </a:ext>
             </a:extLst>
           </p:cNvPr>
@@ -29188,7 +29188,7 @@
           <p:cNvPr id="2" name="">
             <a:extLst xmlns:a="http://schemas.openxmlformats.org/drawingml/2006/main">
               <a:ext uri="{FF2B5EF4-FFF2-40B4-BE49-F238E27FC236}">
-                <a16:creationId xmlns:a16="http://schemas.microsoft.com/office/drawing/2014/main" id="{3A700E17-1F8E-4ECB-A1E6-FB3029187619}"/>
+                <a16:creationId xmlns:a16="http://schemas.microsoft.com/office/drawing/2014/main" id="{4DEFE0FE-0BCF-454E-A08A-C31EBAC307BD}"/>
               </a:ext>
             </a:extLst>
           </p:cNvPr>
@@ -29344,7 +29344,7 @@
           <p:cNvPr id="3" name="">
             <a:extLst xmlns:a="http://schemas.openxmlformats.org/drawingml/2006/main">
               <a:ext uri="{FF2B5EF4-FFF2-40B4-BE49-F238E27FC236}">
-                <a16:creationId xmlns:a16="http://schemas.microsoft.com/office/drawing/2014/main" id="{0F52FF24-35FF-4881-8321-F5F5F46C8699}"/>
+                <a16:creationId xmlns:a16="http://schemas.microsoft.com/office/drawing/2014/main" id="{53653CCB-EE4B-41DC-8908-E57BA80A4A84}"/>
               </a:ext>
             </a:extLst>
           </p:cNvPr>
@@ -29500,7 +29500,7 @@
           <p:cNvPr id="4" name="">
             <a:extLst xmlns:a="http://schemas.openxmlformats.org/drawingml/2006/main">
               <a:ext uri="{FF2B5EF4-FFF2-40B4-BE49-F238E27FC236}">
-                <a16:creationId xmlns:a16="http://schemas.microsoft.com/office/drawing/2014/main" id="{D0B1F25A-4E23-4E62-8945-A9E36458EB21}"/>
+                <a16:creationId xmlns:a16="http://schemas.microsoft.com/office/drawing/2014/main" id="{E83F7810-AF37-487D-9681-6AE1659CA64D}"/>
               </a:ext>
             </a:extLst>
           </p:cNvPr>
@@ -29656,7 +29656,7 @@
           <p:cNvPr id="5" name="">
             <a:extLst xmlns:a="http://schemas.openxmlformats.org/drawingml/2006/main">
               <a:ext uri="{FF2B5EF4-FFF2-40B4-BE49-F238E27FC236}">
-                <a16:creationId xmlns:a16="http://schemas.microsoft.com/office/drawing/2014/main" id="{CFFC70B8-8E12-4581-B7C9-415B7E593D25}"/>
+                <a16:creationId xmlns:a16="http://schemas.microsoft.com/office/drawing/2014/main" id="{F6FC8398-BC01-45AD-AD97-632F6A6E09E1}"/>
               </a:ext>
             </a:extLst>
           </p:cNvPr>
@@ -29881,7 +29881,7 @@
           <p:cNvPr id="6" name="">
             <a:extLst xmlns:a="http://schemas.openxmlformats.org/drawingml/2006/main">
               <a:ext uri="{FF2B5EF4-FFF2-40B4-BE49-F238E27FC236}">
-                <a16:creationId xmlns:a16="http://schemas.microsoft.com/office/drawing/2014/main" id="{058CC0FD-154D-44FC-84B6-51708552CF11}"/>
+                <a16:creationId xmlns:a16="http://schemas.microsoft.com/office/drawing/2014/main" id="{7475726F-5BF9-4009-8202-7D15F2159D14}"/>
               </a:ext>
             </a:extLst>
           </p:cNvPr>
@@ -30241,7 +30241,7 @@
           <p:cNvPr id="7" name="">
             <a:extLst xmlns:a="http://schemas.openxmlformats.org/drawingml/2006/main">
               <a:ext uri="{FF2B5EF4-FFF2-40B4-BE49-F238E27FC236}">
-                <a16:creationId xmlns:a16="http://schemas.microsoft.com/office/drawing/2014/main" id="{41616297-7253-423B-9220-A89566564C96}"/>
+                <a16:creationId xmlns:a16="http://schemas.microsoft.com/office/drawing/2014/main" id="{0D9C82F1-4FFA-4D80-9805-BF3120495686}"/>
               </a:ext>
             </a:extLst>
           </p:cNvPr>
@@ -30395,7 +30395,7 @@
     </p:spTree>
     <p:extLst>
       <p:ext uri="{BB962C8B-B14F-4D97-AF65-F5344CB8AC3E}">
-        <p14:creationId xmlns:p14="http://schemas.microsoft.com/office/powerpoint/2010/main" val="1559681177"/>
+        <p14:creationId xmlns:p14="http://schemas.microsoft.com/office/powerpoint/2010/main" val="1275405780"/>
       </p:ext>
     </p:extLst>
   </p:cSld>
@@ -30426,7 +30426,7 @@
           <p:cNvPr id="8" name="">
             <a:extLst xmlns:a="http://schemas.openxmlformats.org/drawingml/2006/main">
               <a:ext uri="{FF2B5EF4-FFF2-40B4-BE49-F238E27FC236}">
-                <a16:creationId xmlns:a16="http://schemas.microsoft.com/office/drawing/2014/main" id="{6786A7CB-C0F5-4E13-BAA6-71C4490ED3D6}"/>
+                <a16:creationId xmlns:a16="http://schemas.microsoft.com/office/drawing/2014/main" id="{80E0C594-44E1-4D61-A3AA-2463856E3A7E}"/>
               </a:ext>
             </a:extLst>
           </p:cNvPr>
@@ -30582,7 +30582,7 @@
           <p:cNvPr id="2" name="">
             <a:extLst xmlns:a="http://schemas.openxmlformats.org/drawingml/2006/main">
               <a:ext uri="{FF2B5EF4-FFF2-40B4-BE49-F238E27FC236}">
-                <a16:creationId xmlns:a16="http://schemas.microsoft.com/office/drawing/2014/main" id="{697577A2-FEAA-4EDF-A3BB-112563F2D4DD}"/>
+                <a16:creationId xmlns:a16="http://schemas.microsoft.com/office/drawing/2014/main" id="{063F8196-B8E2-4A36-A1C6-248FE488C9B4}"/>
               </a:ext>
             </a:extLst>
           </p:cNvPr>
@@ -30738,7 +30738,7 @@
           <p:cNvPr id="3" name="">
             <a:extLst xmlns:a="http://schemas.openxmlformats.org/drawingml/2006/main">
               <a:ext uri="{FF2B5EF4-FFF2-40B4-BE49-F238E27FC236}">
-                <a16:creationId xmlns:a16="http://schemas.microsoft.com/office/drawing/2014/main" id="{C7A89A51-6057-47A3-A610-ED2D3A8F4750}"/>
+                <a16:creationId xmlns:a16="http://schemas.microsoft.com/office/drawing/2014/main" id="{3D9BF4C4-B3D2-4D3B-84E1-7659269ED80D}"/>
               </a:ext>
             </a:extLst>
           </p:cNvPr>
@@ -30894,7 +30894,7 @@
           <p:cNvPr id="4" name="">
             <a:extLst xmlns:a="http://schemas.openxmlformats.org/drawingml/2006/main">
               <a:ext uri="{FF2B5EF4-FFF2-40B4-BE49-F238E27FC236}">
-                <a16:creationId xmlns:a16="http://schemas.microsoft.com/office/drawing/2014/main" id="{BCAC10AE-6621-4609-B6D6-20757667F0FE}"/>
+                <a16:creationId xmlns:a16="http://schemas.microsoft.com/office/drawing/2014/main" id="{32369704-BF3A-47E3-A303-DD445CF91BB4}"/>
               </a:ext>
             </a:extLst>
           </p:cNvPr>
@@ -31050,7 +31050,7 @@
           <p:cNvPr id="5" name="">
             <a:extLst xmlns:a="http://schemas.openxmlformats.org/drawingml/2006/main">
               <a:ext uri="{FF2B5EF4-FFF2-40B4-BE49-F238E27FC236}">
-                <a16:creationId xmlns:a16="http://schemas.microsoft.com/office/drawing/2014/main" id="{2F6BEB0F-0CB6-4653-9916-A1C7DD7907B0}"/>
+                <a16:creationId xmlns:a16="http://schemas.microsoft.com/office/drawing/2014/main" id="{66AEEEAF-15C1-42B2-AB65-C3E923183C9F}"/>
               </a:ext>
             </a:extLst>
           </p:cNvPr>
@@ -31252,7 +31252,7 @@
           <p:cNvPr id="6" name="">
             <a:extLst xmlns:a="http://schemas.openxmlformats.org/drawingml/2006/main">
               <a:ext uri="{FF2B5EF4-FFF2-40B4-BE49-F238E27FC236}">
-                <a16:creationId xmlns:a16="http://schemas.microsoft.com/office/drawing/2014/main" id="{AE2AC1A9-2B03-45C2-AB89-03EFE5CEE206}"/>
+                <a16:creationId xmlns:a16="http://schemas.microsoft.com/office/drawing/2014/main" id="{D8A1F74C-4421-4B0F-AB5C-29CA7EB2738C}"/>
               </a:ext>
             </a:extLst>
           </p:cNvPr>
@@ -31692,7 +31692,7 @@
           <p:cNvPr id="7" name="">
             <a:extLst xmlns:a="http://schemas.openxmlformats.org/drawingml/2006/main">
               <a:ext uri="{FF2B5EF4-FFF2-40B4-BE49-F238E27FC236}">
-                <a16:creationId xmlns:a16="http://schemas.microsoft.com/office/drawing/2014/main" id="{8DF10BD8-8B96-4F09-9DB2-2A7FF86D78F7}"/>
+                <a16:creationId xmlns:a16="http://schemas.microsoft.com/office/drawing/2014/main" id="{AF501D3C-3B04-4FF4-B22E-9200E5F93427}"/>
               </a:ext>
             </a:extLst>
           </p:cNvPr>
@@ -31846,7 +31846,7 @@
     </p:spTree>
     <p:extLst>
       <p:ext uri="{BB962C8B-B14F-4D97-AF65-F5344CB8AC3E}">
-        <p14:creationId xmlns:p14="http://schemas.microsoft.com/office/powerpoint/2010/main" val="2061189477"/>
+        <p14:creationId xmlns:p14="http://schemas.microsoft.com/office/powerpoint/2010/main" val="1055428996"/>
       </p:ext>
     </p:extLst>
   </p:cSld>
@@ -31877,7 +31877,7 @@
           <p:cNvPr id="8" name="">
             <a:extLst xmlns:a="http://schemas.openxmlformats.org/drawingml/2006/main">
               <a:ext uri="{FF2B5EF4-FFF2-40B4-BE49-F238E27FC236}">
-                <a16:creationId xmlns:a16="http://schemas.microsoft.com/office/drawing/2014/main" id="{E4AD2B35-8D2E-4600-A62A-6EF48DE53E28}"/>
+                <a16:creationId xmlns:a16="http://schemas.microsoft.com/office/drawing/2014/main" id="{50E4763D-F4CB-4B5D-A51F-C11FD5EFFC2D}"/>
               </a:ext>
             </a:extLst>
           </p:cNvPr>
@@ -32033,7 +32033,7 @@
           <p:cNvPr id="2" name="">
             <a:extLst xmlns:a="http://schemas.openxmlformats.org/drawingml/2006/main">
               <a:ext uri="{FF2B5EF4-FFF2-40B4-BE49-F238E27FC236}">
-                <a16:creationId xmlns:a16="http://schemas.microsoft.com/office/drawing/2014/main" id="{42EB1D58-A37F-40CD-9826-B55C732AAFD2}"/>
+                <a16:creationId xmlns:a16="http://schemas.microsoft.com/office/drawing/2014/main" id="{7B665878-BA99-4692-90BD-53F1CE2CE548}"/>
               </a:ext>
             </a:extLst>
           </p:cNvPr>
@@ -32189,7 +32189,7 @@
           <p:cNvPr id="3" name="">
             <a:extLst xmlns:a="http://schemas.openxmlformats.org/drawingml/2006/main">
               <a:ext uri="{FF2B5EF4-FFF2-40B4-BE49-F238E27FC236}">
-                <a16:creationId xmlns:a16="http://schemas.microsoft.com/office/drawing/2014/main" id="{0D73C0AD-0302-49C9-921B-C2A4261CB7EF}"/>
+                <a16:creationId xmlns:a16="http://schemas.microsoft.com/office/drawing/2014/main" id="{FAA8A7D4-4A5E-4B2F-80B1-38C34B3ADC22}"/>
               </a:ext>
             </a:extLst>
           </p:cNvPr>
@@ -32345,7 +32345,7 @@
           <p:cNvPr id="4" name="">
             <a:extLst xmlns:a="http://schemas.openxmlformats.org/drawingml/2006/main">
               <a:ext uri="{FF2B5EF4-FFF2-40B4-BE49-F238E27FC236}">
-                <a16:creationId xmlns:a16="http://schemas.microsoft.com/office/drawing/2014/main" id="{EFB91413-4C38-4FE0-BE18-F76351294EF7}"/>
+                <a16:creationId xmlns:a16="http://schemas.microsoft.com/office/drawing/2014/main" id="{0176673E-03DA-4502-9E74-33566891B7B7}"/>
               </a:ext>
             </a:extLst>
           </p:cNvPr>
@@ -32501,7 +32501,7 @@
           <p:cNvPr id="5" name="">
             <a:extLst xmlns:a="http://schemas.openxmlformats.org/drawingml/2006/main">
               <a:ext uri="{FF2B5EF4-FFF2-40B4-BE49-F238E27FC236}">
-                <a16:creationId xmlns:a16="http://schemas.microsoft.com/office/drawing/2014/main" id="{CB22A529-71E4-4E5C-AEF8-D857726AD55E}"/>
+                <a16:creationId xmlns:a16="http://schemas.microsoft.com/office/drawing/2014/main" id="{99527FF0-23BC-455A-947A-E79B727728D8}"/>
               </a:ext>
             </a:extLst>
           </p:cNvPr>
@@ -32861,7 +32861,7 @@
           <p:cNvPr id="6" name="">
             <a:extLst xmlns:a="http://schemas.openxmlformats.org/drawingml/2006/main">
               <a:ext uri="{FF2B5EF4-FFF2-40B4-BE49-F238E27FC236}">
-                <a16:creationId xmlns:a16="http://schemas.microsoft.com/office/drawing/2014/main" id="{D28BC5A5-F8EC-4DC7-BFC1-4F702DB4BFDF}"/>
+                <a16:creationId xmlns:a16="http://schemas.microsoft.com/office/drawing/2014/main" id="{51F6735D-4AD0-4B07-AD74-50B00F8813B3}"/>
               </a:ext>
             </a:extLst>
           </p:cNvPr>
@@ -33017,7 +33017,7 @@
           <p:cNvPr id="7" name="">
             <a:extLst xmlns:a="http://schemas.openxmlformats.org/drawingml/2006/main">
               <a:ext uri="{FF2B5EF4-FFF2-40B4-BE49-F238E27FC236}">
-                <a16:creationId xmlns:a16="http://schemas.microsoft.com/office/drawing/2014/main" id="{2EEEEED6-E107-498F-8D2D-D54DAC18E02E}"/>
+                <a16:creationId xmlns:a16="http://schemas.microsoft.com/office/drawing/2014/main" id="{2EC2DE2F-F14A-4680-BD81-76E499C818C7}"/>
               </a:ext>
             </a:extLst>
           </p:cNvPr>
@@ -33171,7 +33171,7 @@
     </p:spTree>
     <p:extLst>
       <p:ext uri="{BB962C8B-B14F-4D97-AF65-F5344CB8AC3E}">
-        <p14:creationId xmlns:p14="http://schemas.microsoft.com/office/powerpoint/2010/main" val="1849144566"/>
+        <p14:creationId xmlns:p14="http://schemas.microsoft.com/office/powerpoint/2010/main" val="2061143122"/>
       </p:ext>
     </p:extLst>
   </p:cSld>
@@ -33202,7 +33202,7 @@
           <p:cNvPr id="7" name="">
             <a:extLst xmlns:a="http://schemas.openxmlformats.org/drawingml/2006/main">
               <a:ext uri="{FF2B5EF4-FFF2-40B4-BE49-F238E27FC236}">
-                <a16:creationId xmlns:a16="http://schemas.microsoft.com/office/drawing/2014/main" id="{6034C4C4-39D1-4DF3-9480-948CB4C6DA86}"/>
+                <a16:creationId xmlns:a16="http://schemas.microsoft.com/office/drawing/2014/main" id="{F1CBFA29-A115-4021-B103-745DA45BECAD}"/>
               </a:ext>
             </a:extLst>
           </p:cNvPr>
@@ -33358,7 +33358,7 @@
           <p:cNvPr id="2" name="">
             <a:extLst xmlns:a="http://schemas.openxmlformats.org/drawingml/2006/main">
               <a:ext uri="{FF2B5EF4-FFF2-40B4-BE49-F238E27FC236}">
-                <a16:creationId xmlns:a16="http://schemas.microsoft.com/office/drawing/2014/main" id="{69C76543-BC26-4E63-B1BA-11D3C6B9E402}"/>
+                <a16:creationId xmlns:a16="http://schemas.microsoft.com/office/drawing/2014/main" id="{519C0FAF-BB0D-43C9-B7B7-5E8CFFB278D0}"/>
               </a:ext>
             </a:extLst>
           </p:cNvPr>
@@ -33514,7 +33514,7 @@
           <p:cNvPr id="3" name="">
             <a:extLst xmlns:a="http://schemas.openxmlformats.org/drawingml/2006/main">
               <a:ext uri="{FF2B5EF4-FFF2-40B4-BE49-F238E27FC236}">
-                <a16:creationId xmlns:a16="http://schemas.microsoft.com/office/drawing/2014/main" id="{5E8A3110-9CC0-4CBC-A830-3FA85E6E6B8D}"/>
+                <a16:creationId xmlns:a16="http://schemas.microsoft.com/office/drawing/2014/main" id="{A20D6A60-9791-44BC-8921-FC1A0354C274}"/>
               </a:ext>
             </a:extLst>
           </p:cNvPr>
@@ -33670,7 +33670,7 @@
           <p:cNvPr id="4" name="">
             <a:extLst xmlns:a="http://schemas.openxmlformats.org/drawingml/2006/main">
               <a:ext uri="{FF2B5EF4-FFF2-40B4-BE49-F238E27FC236}">
-                <a16:creationId xmlns:a16="http://schemas.microsoft.com/office/drawing/2014/main" id="{789367B8-7E84-4F49-A394-ECB172F29F29}"/>
+                <a16:creationId xmlns:a16="http://schemas.microsoft.com/office/drawing/2014/main" id="{96036A81-7662-4E04-9322-5323EACA9693}"/>
               </a:ext>
             </a:extLst>
           </p:cNvPr>
@@ -33826,7 +33826,7 @@
           <p:cNvPr id="5" name="">
             <a:extLst xmlns:a="http://schemas.openxmlformats.org/drawingml/2006/main">
               <a:ext uri="{FF2B5EF4-FFF2-40B4-BE49-F238E27FC236}">
-                <a16:creationId xmlns:a16="http://schemas.microsoft.com/office/drawing/2014/main" id="{13321637-10F6-4112-8F69-0ABD9CBCD4C0}"/>
+                <a16:creationId xmlns:a16="http://schemas.microsoft.com/office/drawing/2014/main" id="{4DE0F19D-8C69-4FD8-89FF-5ED8B0848A35}"/>
               </a:ext>
             </a:extLst>
           </p:cNvPr>
@@ -36806,7 +36806,7 @@
           <p:cNvPr id="6" name="">
             <a:extLst xmlns:a="http://schemas.openxmlformats.org/drawingml/2006/main">
               <a:ext uri="{FF2B5EF4-FFF2-40B4-BE49-F238E27FC236}">
-                <a16:creationId xmlns:a16="http://schemas.microsoft.com/office/drawing/2014/main" id="{F02E6B16-23A1-4D88-9B2E-654F30375A04}"/>
+                <a16:creationId xmlns:a16="http://schemas.microsoft.com/office/drawing/2014/main" id="{585BBF88-F5B2-4CBA-BAD1-ECF218DA87B9}"/>
               </a:ext>
             </a:extLst>
           </p:cNvPr>
@@ -36960,7 +36960,7 @@
     </p:spTree>
     <p:extLst>
       <p:ext uri="{BB962C8B-B14F-4D97-AF65-F5344CB8AC3E}">
-        <p14:creationId xmlns:p14="http://schemas.microsoft.com/office/powerpoint/2010/main" val="949561337"/>
+        <p14:creationId xmlns:p14="http://schemas.microsoft.com/office/powerpoint/2010/main" val="461966456"/>
       </p:ext>
     </p:extLst>
   </p:cSld>
@@ -36991,7 +36991,7 @@
           <p:cNvPr id="7" name="">
             <a:extLst xmlns:a="http://schemas.openxmlformats.org/drawingml/2006/main">
               <a:ext uri="{FF2B5EF4-FFF2-40B4-BE49-F238E27FC236}">
-                <a16:creationId xmlns:a16="http://schemas.microsoft.com/office/drawing/2014/main" id="{C1DFED23-9FD2-477A-9701-D48E6B40730C}"/>
+                <a16:creationId xmlns:a16="http://schemas.microsoft.com/office/drawing/2014/main" id="{A41A1FAF-B9BA-4C05-BD08-A6802E20BEB3}"/>
               </a:ext>
             </a:extLst>
           </p:cNvPr>
@@ -37147,7 +37147,7 @@
           <p:cNvPr id="2" name="">
             <a:extLst xmlns:a="http://schemas.openxmlformats.org/drawingml/2006/main">
               <a:ext uri="{FF2B5EF4-FFF2-40B4-BE49-F238E27FC236}">
-                <a16:creationId xmlns:a16="http://schemas.microsoft.com/office/drawing/2014/main" id="{72CD2267-34A3-47F8-B7DE-252EF28A3FB5}"/>
+                <a16:creationId xmlns:a16="http://schemas.microsoft.com/office/drawing/2014/main" id="{F804582F-77E6-4382-A052-7662BB2795DA}"/>
               </a:ext>
             </a:extLst>
           </p:cNvPr>
@@ -37303,7 +37303,7 @@
           <p:cNvPr id="3" name="">
             <a:extLst xmlns:a="http://schemas.openxmlformats.org/drawingml/2006/main">
               <a:ext uri="{FF2B5EF4-FFF2-40B4-BE49-F238E27FC236}">
-                <a16:creationId xmlns:a16="http://schemas.microsoft.com/office/drawing/2014/main" id="{AA448E44-ACA3-4A58-80B3-679C59D2076E}"/>
+                <a16:creationId xmlns:a16="http://schemas.microsoft.com/office/drawing/2014/main" id="{1E83EB86-AB96-406D-96C8-40E050854E4E}"/>
               </a:ext>
             </a:extLst>
           </p:cNvPr>
@@ -37459,7 +37459,7 @@
           <p:cNvPr id="4" name="">
             <a:extLst xmlns:a="http://schemas.openxmlformats.org/drawingml/2006/main">
               <a:ext uri="{FF2B5EF4-FFF2-40B4-BE49-F238E27FC236}">
-                <a16:creationId xmlns:a16="http://schemas.microsoft.com/office/drawing/2014/main" id="{6B841412-3967-495B-8502-E9541315BD90}"/>
+                <a16:creationId xmlns:a16="http://schemas.microsoft.com/office/drawing/2014/main" id="{8F3025BD-AC38-4ECF-B63A-DF68B5885C8C}"/>
               </a:ext>
             </a:extLst>
           </p:cNvPr>
@@ -37615,7 +37615,7 @@
           <p:cNvPr id="5" name="">
             <a:extLst xmlns:a="http://schemas.openxmlformats.org/drawingml/2006/main">
               <a:ext uri="{FF2B5EF4-FFF2-40B4-BE49-F238E27FC236}">
-                <a16:creationId xmlns:a16="http://schemas.microsoft.com/office/drawing/2014/main" id="{6940B7F3-AE33-4A0E-A722-4EBC68BDDA33}"/>
+                <a16:creationId xmlns:a16="http://schemas.microsoft.com/office/drawing/2014/main" id="{36E90141-870D-4954-BC40-845E14E62D20}"/>
               </a:ext>
             </a:extLst>
           </p:cNvPr>
@@ -38242,7 +38242,7 @@
           <p:cNvPr id="6" name="">
             <a:extLst xmlns:a="http://schemas.openxmlformats.org/drawingml/2006/main">
               <a:ext uri="{FF2B5EF4-FFF2-40B4-BE49-F238E27FC236}">
-                <a16:creationId xmlns:a16="http://schemas.microsoft.com/office/drawing/2014/main" id="{67B4CF2F-571B-4CA1-A710-F5E67E67B890}"/>
+                <a16:creationId xmlns:a16="http://schemas.microsoft.com/office/drawing/2014/main" id="{D268F0F2-4FDE-4079-AC32-7008BDA39D63}"/>
               </a:ext>
             </a:extLst>
           </p:cNvPr>
@@ -38396,7 +38396,7 @@
     </p:spTree>
     <p:extLst>
       <p:ext uri="{BB962C8B-B14F-4D97-AF65-F5344CB8AC3E}">
-        <p14:creationId xmlns:p14="http://schemas.microsoft.com/office/powerpoint/2010/main" val="1903284302"/>
+        <p14:creationId xmlns:p14="http://schemas.microsoft.com/office/powerpoint/2010/main" val="1354110307"/>
       </p:ext>
     </p:extLst>
   </p:cSld>
@@ -38427,7 +38427,7 @@
           <p:cNvPr id="6" name="">
             <a:extLst xmlns:a="http://schemas.openxmlformats.org/drawingml/2006/main">
               <a:ext uri="{FF2B5EF4-FFF2-40B4-BE49-F238E27FC236}">
-                <a16:creationId xmlns:a16="http://schemas.microsoft.com/office/drawing/2014/main" id="{1572EAFD-24A4-4D96-A07C-595539BBF9A1}"/>
+                <a16:creationId xmlns:a16="http://schemas.microsoft.com/office/drawing/2014/main" id="{D5802827-CCCF-4227-A866-31713960BA5A}"/>
               </a:ext>
             </a:extLst>
           </p:cNvPr>
@@ -38583,7 +38583,7 @@
           <p:cNvPr id="2" name="">
             <a:extLst xmlns:a="http://schemas.openxmlformats.org/drawingml/2006/main">
               <a:ext uri="{FF2B5EF4-FFF2-40B4-BE49-F238E27FC236}">
-                <a16:creationId xmlns:a16="http://schemas.microsoft.com/office/drawing/2014/main" id="{80165596-D054-4D0B-9F08-4ADF2BA996CA}"/>
+                <a16:creationId xmlns:a16="http://schemas.microsoft.com/office/drawing/2014/main" id="{55C31CE2-A000-4A43-A443-4CED99BEE123}"/>
               </a:ext>
             </a:extLst>
           </p:cNvPr>
@@ -38739,7 +38739,7 @@
           <p:cNvPr id="3" name="">
             <a:extLst xmlns:a="http://schemas.openxmlformats.org/drawingml/2006/main">
               <a:ext uri="{FF2B5EF4-FFF2-40B4-BE49-F238E27FC236}">
-                <a16:creationId xmlns:a16="http://schemas.microsoft.com/office/drawing/2014/main" id="{3D3779A6-A5CA-4CAC-A082-F97334C5CB28}"/>
+                <a16:creationId xmlns:a16="http://schemas.microsoft.com/office/drawing/2014/main" id="{76AF8244-EF02-4520-9A10-DD113EA5AB8F}"/>
               </a:ext>
             </a:extLst>
           </p:cNvPr>
@@ -38895,7 +38895,7 @@
           <p:cNvPr id="4" name="">
             <a:extLst xmlns:a="http://schemas.openxmlformats.org/drawingml/2006/main">
               <a:ext uri="{FF2B5EF4-FFF2-40B4-BE49-F238E27FC236}">
-                <a16:creationId xmlns:a16="http://schemas.microsoft.com/office/drawing/2014/main" id="{B2848610-37C5-4277-B971-3D5282F17E15}"/>
+                <a16:creationId xmlns:a16="http://schemas.microsoft.com/office/drawing/2014/main" id="{5C1F6071-9BD2-40B1-8C94-B84165E8C8FB}"/>
               </a:ext>
             </a:extLst>
           </p:cNvPr>
@@ -39051,7 +39051,7 @@
           <p:cNvPr id="5" name="">
             <a:extLst xmlns:a="http://schemas.openxmlformats.org/drawingml/2006/main">
               <a:ext uri="{FF2B5EF4-FFF2-40B4-BE49-F238E27FC236}">
-                <a16:creationId xmlns:a16="http://schemas.microsoft.com/office/drawing/2014/main" id="{382B1664-E410-4C73-BC6B-31A4A73702D9}"/>
+                <a16:creationId xmlns:a16="http://schemas.microsoft.com/office/drawing/2014/main" id="{44A3A067-ECBE-4BA2-85E4-1129FCFDFD87}"/>
               </a:ext>
             </a:extLst>
           </p:cNvPr>
@@ -39061,7 +39061,7 @@
           <p:nvPr/>
         </p:nvPicPr>
         <p:blipFill>
-          <a:blip xmlns:r="http://schemas.openxmlformats.org/officeDocument/2006/relationships" xmlns:a="http://schemas.openxmlformats.org/drawingml/2006/main" r:embed="R67e90dbe3a684cf5"/>
+          <a:blip xmlns:r="http://schemas.openxmlformats.org/officeDocument/2006/relationships" xmlns:a="http://schemas.openxmlformats.org/drawingml/2006/main" r:embed="R08392467eaf14c93"/>
           <a:stretch xmlns:a="http://schemas.openxmlformats.org/drawingml/2006/main"/>
         </p:blipFill>
         <p:spPr>
@@ -39077,7 +39077,7 @@
     </p:spTree>
     <p:extLst>
       <p:ext uri="{BB962C8B-B14F-4D97-AF65-F5344CB8AC3E}">
-        <p14:creationId xmlns:p14="http://schemas.microsoft.com/office/powerpoint/2010/main" val="456600485"/>
+        <p14:creationId xmlns:p14="http://schemas.microsoft.com/office/powerpoint/2010/main" val="1731409751"/>
       </p:ext>
     </p:extLst>
   </p:cSld>
@@ -39108,7 +39108,7 @@
           <p:cNvPr id="8" name="">
             <a:extLst xmlns:a="http://schemas.openxmlformats.org/drawingml/2006/main">
               <a:ext uri="{FF2B5EF4-FFF2-40B4-BE49-F238E27FC236}">
-                <a16:creationId xmlns:a16="http://schemas.microsoft.com/office/drawing/2014/main" id="{E47F10D4-76B5-4E24-A54F-A785137572C8}"/>
+                <a16:creationId xmlns:a16="http://schemas.microsoft.com/office/drawing/2014/main" id="{7EE4B53B-5AF4-4D10-9B1F-5DBCC7A1B46E}"/>
               </a:ext>
             </a:extLst>
           </p:cNvPr>
@@ -39264,7 +39264,7 @@
           <p:cNvPr id="2" name="">
             <a:extLst xmlns:a="http://schemas.openxmlformats.org/drawingml/2006/main">
               <a:ext uri="{FF2B5EF4-FFF2-40B4-BE49-F238E27FC236}">
-                <a16:creationId xmlns:a16="http://schemas.microsoft.com/office/drawing/2014/main" id="{59576E83-C170-4D8C-835B-6A9F66CED787}"/>
+                <a16:creationId xmlns:a16="http://schemas.microsoft.com/office/drawing/2014/main" id="{5A48D072-38E7-4DCC-8613-35C498F3C8C3}"/>
               </a:ext>
             </a:extLst>
           </p:cNvPr>
@@ -39420,7 +39420,7 @@
           <p:cNvPr id="3" name="">
             <a:extLst xmlns:a="http://schemas.openxmlformats.org/drawingml/2006/main">
               <a:ext uri="{FF2B5EF4-FFF2-40B4-BE49-F238E27FC236}">
-                <a16:creationId xmlns:a16="http://schemas.microsoft.com/office/drawing/2014/main" id="{6AA0B090-9E53-431A-B556-2B648352955B}"/>
+                <a16:creationId xmlns:a16="http://schemas.microsoft.com/office/drawing/2014/main" id="{8D2F2F0B-57A5-462A-A7B5-C5A27EC11FC0}"/>
               </a:ext>
             </a:extLst>
           </p:cNvPr>
@@ -39576,7 +39576,7 @@
           <p:cNvPr id="4" name="">
             <a:extLst xmlns:a="http://schemas.openxmlformats.org/drawingml/2006/main">
               <a:ext uri="{FF2B5EF4-FFF2-40B4-BE49-F238E27FC236}">
-                <a16:creationId xmlns:a16="http://schemas.microsoft.com/office/drawing/2014/main" id="{F848E53C-4BF8-492B-9CDE-66737595BDEF}"/>
+                <a16:creationId xmlns:a16="http://schemas.microsoft.com/office/drawing/2014/main" id="{1008EA11-64D6-4EDF-9CB4-45C8720D044B}"/>
               </a:ext>
             </a:extLst>
           </p:cNvPr>
@@ -39732,7 +39732,7 @@
           <p:cNvPr id="5" name="">
             <a:extLst xmlns:a="http://schemas.openxmlformats.org/drawingml/2006/main">
               <a:ext uri="{FF2B5EF4-FFF2-40B4-BE49-F238E27FC236}">
-                <a16:creationId xmlns:a16="http://schemas.microsoft.com/office/drawing/2014/main" id="{DDFE3C22-4572-47F1-B791-812C155A3D82}"/>
+                <a16:creationId xmlns:a16="http://schemas.microsoft.com/office/drawing/2014/main" id="{3DC92028-2FB6-4DD3-B06B-8D69E9B220D2}"/>
               </a:ext>
             </a:extLst>
           </p:cNvPr>
@@ -40243,7 +40243,7 @@
           <p:cNvPr id="6" name="">
             <a:extLst xmlns:a="http://schemas.openxmlformats.org/drawingml/2006/main">
               <a:ext uri="{FF2B5EF4-FFF2-40B4-BE49-F238E27FC236}">
-                <a16:creationId xmlns:a16="http://schemas.microsoft.com/office/drawing/2014/main" id="{DB54E91B-A1D6-4C80-AABD-7148B6200D52}"/>
+                <a16:creationId xmlns:a16="http://schemas.microsoft.com/office/drawing/2014/main" id="{9A3FCDAA-AE42-4C8B-82B7-A0CB07DA7EFA}"/>
               </a:ext>
             </a:extLst>
           </p:cNvPr>
@@ -40399,7 +40399,7 @@
           <p:cNvPr id="7" name="">
             <a:extLst xmlns:a="http://schemas.openxmlformats.org/drawingml/2006/main">
               <a:ext uri="{FF2B5EF4-FFF2-40B4-BE49-F238E27FC236}">
-                <a16:creationId xmlns:a16="http://schemas.microsoft.com/office/drawing/2014/main" id="{0629C0A6-2DF4-4745-BC0F-BDA5845A3053}"/>
+                <a16:creationId xmlns:a16="http://schemas.microsoft.com/office/drawing/2014/main" id="{79E0312F-7084-4858-81DD-3BBA3A4D9B61}"/>
               </a:ext>
             </a:extLst>
           </p:cNvPr>
@@ -40545,7 +40545,7 @@
                 <a:ea typeface="Helvetica Neue"/>
                 <a:cs typeface="Helvetica Neue"/>
               </a:rPr>
-              <a:t>This is not a 12,000-gene literature list. Embryonic presence does not establish developmental restriction.</a:t>
+              <a:t>The table counts association before adult restriction. Presence in a reproductive or developmental context does not establish restriction.</a:t>
             </a:r>
           </a:p>
         </p:txBody>
@@ -40553,7 +40553,7 @@
     </p:spTree>
     <p:extLst>
       <p:ext uri="{BB962C8B-B14F-4D97-AF65-F5344CB8AC3E}">
-        <p14:creationId xmlns:p14="http://schemas.microsoft.com/office/powerpoint/2010/main" val="858024114"/>
+        <p14:creationId xmlns:p14="http://schemas.microsoft.com/office/powerpoint/2010/main" val="900794627"/>
       </p:ext>
     </p:extLst>
   </p:cSld>
@@ -40584,7 +40584,7 @@
           <p:cNvPr id="7" name="">
             <a:extLst xmlns:a="http://schemas.openxmlformats.org/drawingml/2006/main">
               <a:ext uri="{FF2B5EF4-FFF2-40B4-BE49-F238E27FC236}">
-                <a16:creationId xmlns:a16="http://schemas.microsoft.com/office/drawing/2014/main" id="{0A4849A6-1E18-4118-8A41-1ACEC0736BAA}"/>
+                <a16:creationId xmlns:a16="http://schemas.microsoft.com/office/drawing/2014/main" id="{7F1F5021-1C4C-4253-9582-DE2FF7192963}"/>
               </a:ext>
             </a:extLst>
           </p:cNvPr>
@@ -40740,7 +40740,7 @@
           <p:cNvPr id="2" name="">
             <a:extLst xmlns:a="http://schemas.openxmlformats.org/drawingml/2006/main">
               <a:ext uri="{FF2B5EF4-FFF2-40B4-BE49-F238E27FC236}">
-                <a16:creationId xmlns:a16="http://schemas.microsoft.com/office/drawing/2014/main" id="{B2197DF1-8FFE-4C6A-A04C-003528FE85C1}"/>
+                <a16:creationId xmlns:a16="http://schemas.microsoft.com/office/drawing/2014/main" id="{AD093792-CE52-4C4F-B615-5CCBEA44B95A}"/>
               </a:ext>
             </a:extLst>
           </p:cNvPr>
@@ -40896,7 +40896,7 @@
           <p:cNvPr id="3" name="">
             <a:extLst xmlns:a="http://schemas.openxmlformats.org/drawingml/2006/main">
               <a:ext uri="{FF2B5EF4-FFF2-40B4-BE49-F238E27FC236}">
-                <a16:creationId xmlns:a16="http://schemas.microsoft.com/office/drawing/2014/main" id="{6A8EAAAA-867B-4D2C-BA4C-A78A768F0586}"/>
+                <a16:creationId xmlns:a16="http://schemas.microsoft.com/office/drawing/2014/main" id="{EEDF65D3-D52E-433A-A98A-BB6FB5263025}"/>
               </a:ext>
             </a:extLst>
           </p:cNvPr>
@@ -41052,7 +41052,7 @@
           <p:cNvPr id="4" name="">
             <a:extLst xmlns:a="http://schemas.openxmlformats.org/drawingml/2006/main">
               <a:ext uri="{FF2B5EF4-FFF2-40B4-BE49-F238E27FC236}">
-                <a16:creationId xmlns:a16="http://schemas.microsoft.com/office/drawing/2014/main" id="{DB560F31-08C5-4ECD-93C3-831FEB130B05}"/>
+                <a16:creationId xmlns:a16="http://schemas.microsoft.com/office/drawing/2014/main" id="{49CC2623-5B3F-4A47-A976-D224398F424E}"/>
               </a:ext>
             </a:extLst>
           </p:cNvPr>
@@ -41208,7 +41208,7 @@
           <p:cNvPr id="5" name="">
             <a:extLst xmlns:a="http://schemas.openxmlformats.org/drawingml/2006/main">
               <a:ext uri="{FF2B5EF4-FFF2-40B4-BE49-F238E27FC236}">
-                <a16:creationId xmlns:a16="http://schemas.microsoft.com/office/drawing/2014/main" id="{EB150F59-533D-410D-A046-A3751690C987}"/>
+                <a16:creationId xmlns:a16="http://schemas.microsoft.com/office/drawing/2014/main" id="{779EE1C9-5AC0-497D-BE76-AAA30C6254E6}"/>
               </a:ext>
             </a:extLst>
           </p:cNvPr>
@@ -42183,7 +42183,7 @@
           <p:cNvPr id="6" name="">
             <a:extLst xmlns:a="http://schemas.openxmlformats.org/drawingml/2006/main">
               <a:ext uri="{FF2B5EF4-FFF2-40B4-BE49-F238E27FC236}">
-                <a16:creationId xmlns:a16="http://schemas.microsoft.com/office/drawing/2014/main" id="{735E40CE-5AD3-446B-92F6-C46E38293396}"/>
+                <a16:creationId xmlns:a16="http://schemas.microsoft.com/office/drawing/2014/main" id="{FD5B6C34-8009-46CC-AC4F-C2290FA56795}"/>
               </a:ext>
             </a:extLst>
           </p:cNvPr>
@@ -42337,7 +42337,7 @@
     </p:spTree>
     <p:extLst>
       <p:ext uri="{BB962C8B-B14F-4D97-AF65-F5344CB8AC3E}">
-        <p14:creationId xmlns:p14="http://schemas.microsoft.com/office/powerpoint/2010/main" val="732733447"/>
+        <p14:creationId xmlns:p14="http://schemas.microsoft.com/office/powerpoint/2010/main" val="1578305816"/>
       </p:ext>
     </p:extLst>
   </p:cSld>
@@ -42368,7 +42368,7 @@
           <p:cNvPr id="8" name="">
             <a:extLst xmlns:a="http://schemas.openxmlformats.org/drawingml/2006/main">
               <a:ext uri="{FF2B5EF4-FFF2-40B4-BE49-F238E27FC236}">
-                <a16:creationId xmlns:a16="http://schemas.microsoft.com/office/drawing/2014/main" id="{C461B712-DDF4-471B-B553-7B90E8909849}"/>
+                <a16:creationId xmlns:a16="http://schemas.microsoft.com/office/drawing/2014/main" id="{7FA81938-2E1B-4108-A540-8BFDFE2A942D}"/>
               </a:ext>
             </a:extLst>
           </p:cNvPr>
@@ -42524,7 +42524,7 @@
           <p:cNvPr id="2" name="">
             <a:extLst xmlns:a="http://schemas.openxmlformats.org/drawingml/2006/main">
               <a:ext uri="{FF2B5EF4-FFF2-40B4-BE49-F238E27FC236}">
-                <a16:creationId xmlns:a16="http://schemas.microsoft.com/office/drawing/2014/main" id="{6494B21A-4B7E-4BEE-84A4-1E86DCF5EA46}"/>
+                <a16:creationId xmlns:a16="http://schemas.microsoft.com/office/drawing/2014/main" id="{52902BDD-E072-47F1-9107-62A71EAB3D76}"/>
               </a:ext>
             </a:extLst>
           </p:cNvPr>
@@ -42680,7 +42680,7 @@
           <p:cNvPr id="3" name="">
             <a:extLst xmlns:a="http://schemas.openxmlformats.org/drawingml/2006/main">
               <a:ext uri="{FF2B5EF4-FFF2-40B4-BE49-F238E27FC236}">
-                <a16:creationId xmlns:a16="http://schemas.microsoft.com/office/drawing/2014/main" id="{BF5FC59F-A84F-4CE4-9F78-EA5DDE416135}"/>
+                <a16:creationId xmlns:a16="http://schemas.microsoft.com/office/drawing/2014/main" id="{D1BB5727-78C5-4DA2-A4EA-E52268EE89A8}"/>
               </a:ext>
             </a:extLst>
           </p:cNvPr>
@@ -42836,7 +42836,7 @@
           <p:cNvPr id="4" name="">
             <a:extLst xmlns:a="http://schemas.openxmlformats.org/drawingml/2006/main">
               <a:ext uri="{FF2B5EF4-FFF2-40B4-BE49-F238E27FC236}">
-                <a16:creationId xmlns:a16="http://schemas.microsoft.com/office/drawing/2014/main" id="{AF1B0115-A516-4938-B2EE-F8446E373237}"/>
+                <a16:creationId xmlns:a16="http://schemas.microsoft.com/office/drawing/2014/main" id="{D675EBD4-4183-4FD3-8E9D-9DD81C54D312}"/>
               </a:ext>
             </a:extLst>
           </p:cNvPr>
@@ -42992,7 +42992,7 @@
           <p:cNvPr id="5" name="">
             <a:extLst xmlns:a="http://schemas.openxmlformats.org/drawingml/2006/main">
               <a:ext uri="{FF2B5EF4-FFF2-40B4-BE49-F238E27FC236}">
-                <a16:creationId xmlns:a16="http://schemas.microsoft.com/office/drawing/2014/main" id="{388EEFA8-4ADB-4DC3-8966-D7BD4D24F743}"/>
+                <a16:creationId xmlns:a16="http://schemas.microsoft.com/office/drawing/2014/main" id="{6A64322F-AD44-458E-A04F-7126CA1AF13F}"/>
               </a:ext>
             </a:extLst>
           </p:cNvPr>
@@ -43805,7 +43805,7 @@
           <p:cNvPr id="6" name="">
             <a:extLst xmlns:a="http://schemas.openxmlformats.org/drawingml/2006/main">
               <a:ext uri="{FF2B5EF4-FFF2-40B4-BE49-F238E27FC236}">
-                <a16:creationId xmlns:a16="http://schemas.microsoft.com/office/drawing/2014/main" id="{812D1E20-D73D-45B3-AC28-41B74BA60EAD}"/>
+                <a16:creationId xmlns:a16="http://schemas.microsoft.com/office/drawing/2014/main" id="{FE5B08F1-5951-4A5E-996D-3C373ADE6C7B}"/>
               </a:ext>
             </a:extLst>
           </p:cNvPr>
@@ -43961,7 +43961,7 @@
           <p:cNvPr id="7" name="">
             <a:extLst xmlns:a="http://schemas.openxmlformats.org/drawingml/2006/main">
               <a:ext uri="{FF2B5EF4-FFF2-40B4-BE49-F238E27FC236}">
-                <a16:creationId xmlns:a16="http://schemas.microsoft.com/office/drawing/2014/main" id="{4D09B99C-827B-4E40-9549-8265B3D32A1A}"/>
+                <a16:creationId xmlns:a16="http://schemas.microsoft.com/office/drawing/2014/main" id="{E9079D57-15F6-406D-915F-5A43C23D449A}"/>
               </a:ext>
             </a:extLst>
           </p:cNvPr>
@@ -44115,7 +44115,7 @@
     </p:spTree>
     <p:extLst>
       <p:ext uri="{BB962C8B-B14F-4D97-AF65-F5344CB8AC3E}">
-        <p14:creationId xmlns:p14="http://schemas.microsoft.com/office/powerpoint/2010/main" val="924630878"/>
+        <p14:creationId xmlns:p14="http://schemas.microsoft.com/office/powerpoint/2010/main" val="465251551"/>
       </p:ext>
     </p:extLst>
   </p:cSld>

</xml_diff>